<commit_message>
Fix shape-level hyperlink XML location so PowerPoint activates the link
The a:hlinkClick element belongs inside p:cNvPr (NonVisualDrawingProps)
per ECMA-376; when placed under p:nvPr (ApplicationNonVisualDrawingProps)
PowerPoint silently ignores it, so the rounded rectangles on gram tiles
looked linked but did not navigate to the Analysis Sheet on click.

Move both writers (mock_pptx.add_shape_level_hyperlink) and readers
(introspect_pptx, extract_to_csv, the mock test helper) to the correct
location, and regenerate the source/ corpus.
</commit_message>
<xml_diff>
--- a/source/Instructor Progress Final Assessment Grams/Instructor Progress Final Assessment Grams.pptx
+++ b/source/Instructor Progress Final Assessment Grams/Instructor Progress Final Assessment Grams.pptx
@@ -3143,11 +3143,11 @@
       </p:sp>
       <p:sp>
         <p:nvSpPr>
-          <p:cNvPr id="3" name="Rounded Rectangle 2"/>
+          <p:cNvPr id="3" name="Rounded Rectangle 2">
+            <a:hlinkClick r:id="rId2"/>
+          </p:cNvPr>
           <p:cNvSpPr/>
-          <p:nvPr>
-            <a:hlinkClick r:id="rId2"/>
-          </p:nvPr>
+          <p:nvPr/>
         </p:nvSpPr>
         <p:spPr>
           <a:xfrm>
@@ -3229,11 +3229,11 @@
       </p:sp>
       <p:sp>
         <p:nvSpPr>
-          <p:cNvPr id="5" name="Rounded Rectangle 4"/>
+          <p:cNvPr id="5" name="Rounded Rectangle 4">
+            <a:hlinkClick r:id="rId4"/>
+          </p:cNvPr>
           <p:cNvSpPr/>
-          <p:nvPr>
-            <a:hlinkClick r:id="rId4"/>
-          </p:nvPr>
+          <p:nvPr/>
         </p:nvSpPr>
         <p:spPr>
           <a:xfrm>
@@ -3331,11 +3331,11 @@
       </p:sp>
       <p:sp>
         <p:nvSpPr>
-          <p:cNvPr id="7" name="Rounded Rectangle 6"/>
+          <p:cNvPr id="7" name="Rounded Rectangle 6">
+            <a:hlinkClick r:id="rId8"/>
+          </p:cNvPr>
           <p:cNvSpPr/>
-          <p:nvPr>
-            <a:hlinkClick r:id="rId8"/>
-          </p:nvPr>
+          <p:nvPr/>
         </p:nvSpPr>
         <p:spPr>
           <a:xfrm>
@@ -3433,11 +3433,11 @@
       </p:sp>
       <p:sp>
         <p:nvSpPr>
-          <p:cNvPr id="9" name="Rounded Rectangle 8"/>
+          <p:cNvPr id="9" name="Rounded Rectangle 8">
+            <a:hlinkClick r:id="rId12"/>
+          </p:cNvPr>
           <p:cNvSpPr/>
-          <p:nvPr>
-            <a:hlinkClick r:id="rId12"/>
-          </p:nvPr>
+          <p:nvPr/>
         </p:nvSpPr>
         <p:spPr>
           <a:xfrm>
@@ -3535,11 +3535,11 @@
       </p:sp>
       <p:sp>
         <p:nvSpPr>
-          <p:cNvPr id="11" name="Rounded Rectangle 10"/>
+          <p:cNvPr id="11" name="Rounded Rectangle 10">
+            <a:hlinkClick r:id="rId16"/>
+          </p:cNvPr>
           <p:cNvSpPr/>
-          <p:nvPr>
-            <a:hlinkClick r:id="rId16"/>
-          </p:nvPr>
+          <p:nvPr/>
         </p:nvSpPr>
         <p:spPr>
           <a:xfrm>
@@ -3621,11 +3621,11 @@
       </p:sp>
       <p:sp>
         <p:nvSpPr>
-          <p:cNvPr id="13" name="Rounded Rectangle 12"/>
+          <p:cNvPr id="13" name="Rounded Rectangle 12">
+            <a:hlinkClick r:id="rId18"/>
+          </p:cNvPr>
           <p:cNvSpPr/>
-          <p:nvPr>
-            <a:hlinkClick r:id="rId18"/>
-          </p:nvPr>
+          <p:nvPr/>
         </p:nvSpPr>
         <p:spPr>
           <a:xfrm>
@@ -3731,11 +3731,11 @@
       </p:sp>
       <p:sp>
         <p:nvSpPr>
-          <p:cNvPr id="15" name="Rounded Rectangle 14"/>
+          <p:cNvPr id="15" name="Rounded Rectangle 14">
+            <a:hlinkClick r:id="rId23"/>
+          </p:cNvPr>
           <p:cNvSpPr/>
-          <p:nvPr>
-            <a:hlinkClick r:id="rId23"/>
-          </p:nvPr>
+          <p:nvPr/>
         </p:nvSpPr>
         <p:spPr>
           <a:xfrm>
@@ -3825,11 +3825,11 @@
       </p:sp>
       <p:sp>
         <p:nvSpPr>
-          <p:cNvPr id="17" name="Rounded Rectangle 16"/>
+          <p:cNvPr id="17" name="Rounded Rectangle 16">
+            <a:hlinkClick r:id="rId26"/>
+          </p:cNvPr>
           <p:cNvSpPr/>
-          <p:nvPr>
-            <a:hlinkClick r:id="rId26"/>
-          </p:nvPr>
+          <p:nvPr/>
         </p:nvSpPr>
         <p:spPr>
           <a:xfrm>
@@ -3911,11 +3911,11 @@
       </p:sp>
       <p:sp>
         <p:nvSpPr>
-          <p:cNvPr id="19" name="Rounded Rectangle 18"/>
+          <p:cNvPr id="19" name="Rounded Rectangle 18">
+            <a:hlinkClick r:id="rId28"/>
+          </p:cNvPr>
           <p:cNvSpPr/>
-          <p:nvPr>
-            <a:hlinkClick r:id="rId28"/>
-          </p:nvPr>
+          <p:nvPr/>
         </p:nvSpPr>
         <p:spPr>
           <a:xfrm>
@@ -3997,11 +3997,11 @@
       </p:sp>
       <p:sp>
         <p:nvSpPr>
-          <p:cNvPr id="21" name="Rounded Rectangle 20"/>
+          <p:cNvPr id="21" name="Rounded Rectangle 20">
+            <a:hlinkClick r:id="rId30"/>
+          </p:cNvPr>
           <p:cNvSpPr/>
-          <p:nvPr>
-            <a:hlinkClick r:id="rId30"/>
-          </p:nvPr>
+          <p:nvPr/>
         </p:nvSpPr>
         <p:spPr>
           <a:xfrm>
@@ -4107,11 +4107,11 @@
       </p:sp>
       <p:sp>
         <p:nvSpPr>
-          <p:cNvPr id="23" name="Rounded Rectangle 22"/>
+          <p:cNvPr id="23" name="Rounded Rectangle 22">
+            <a:hlinkClick r:id="rId35"/>
+          </p:cNvPr>
           <p:cNvSpPr/>
-          <p:nvPr>
-            <a:hlinkClick r:id="rId35"/>
-          </p:nvPr>
+          <p:nvPr/>
         </p:nvSpPr>
         <p:spPr>
           <a:xfrm>
@@ -4209,11 +4209,11 @@
       </p:sp>
       <p:sp>
         <p:nvSpPr>
-          <p:cNvPr id="25" name="Rounded Rectangle 24"/>
+          <p:cNvPr id="25" name="Rounded Rectangle 24">
+            <a:hlinkClick r:id="rId39"/>
+          </p:cNvPr>
           <p:cNvSpPr/>
-          <p:nvPr>
-            <a:hlinkClick r:id="rId39"/>
-          </p:nvPr>
+          <p:nvPr/>
         </p:nvSpPr>
         <p:spPr>
           <a:xfrm>
@@ -4319,11 +4319,11 @@
       </p:sp>
       <p:sp>
         <p:nvSpPr>
-          <p:cNvPr id="27" name="Rounded Rectangle 26"/>
+          <p:cNvPr id="27" name="Rounded Rectangle 26">
+            <a:hlinkClick r:id="rId44"/>
+          </p:cNvPr>
           <p:cNvSpPr/>
-          <p:nvPr>
-            <a:hlinkClick r:id="rId44"/>
-          </p:nvPr>
+          <p:nvPr/>
         </p:nvSpPr>
         <p:spPr>
           <a:xfrm>
@@ -4413,11 +4413,11 @@
       </p:sp>
       <p:sp>
         <p:nvSpPr>
-          <p:cNvPr id="29" name="Rounded Rectangle 28"/>
+          <p:cNvPr id="29" name="Rounded Rectangle 28">
+            <a:hlinkClick r:id="rId47"/>
+          </p:cNvPr>
           <p:cNvSpPr/>
-          <p:nvPr>
-            <a:hlinkClick r:id="rId47"/>
-          </p:nvPr>
+          <p:nvPr/>
         </p:nvSpPr>
         <p:spPr>
           <a:xfrm>
@@ -4515,11 +4515,11 @@
       </p:sp>
       <p:sp>
         <p:nvSpPr>
-          <p:cNvPr id="31" name="Rounded Rectangle 30"/>
+          <p:cNvPr id="31" name="Rounded Rectangle 30">
+            <a:hlinkClick r:id="rId51"/>
+          </p:cNvPr>
           <p:cNvSpPr/>
-          <p:nvPr>
-            <a:hlinkClick r:id="rId51"/>
-          </p:nvPr>
+          <p:nvPr/>
         </p:nvSpPr>
         <p:spPr>
           <a:xfrm>
@@ -4694,11 +4694,11 @@
       </p:sp>
       <p:sp>
         <p:nvSpPr>
-          <p:cNvPr id="3" name="Rounded Rectangle 2"/>
+          <p:cNvPr id="3" name="Rounded Rectangle 2">
+            <a:hlinkClick r:id="rId2"/>
+          </p:cNvPr>
           <p:cNvSpPr/>
-          <p:nvPr>
-            <a:hlinkClick r:id="rId2"/>
-          </p:nvPr>
+          <p:nvPr/>
         </p:nvSpPr>
         <p:spPr>
           <a:xfrm>
@@ -4788,11 +4788,11 @@
       </p:sp>
       <p:sp>
         <p:nvSpPr>
-          <p:cNvPr id="5" name="Rounded Rectangle 4"/>
+          <p:cNvPr id="5" name="Rounded Rectangle 4">
+            <a:hlinkClick r:id="rId5"/>
+          </p:cNvPr>
           <p:cNvSpPr/>
-          <p:nvPr>
-            <a:hlinkClick r:id="rId5"/>
-          </p:nvPr>
+          <p:nvPr/>
         </p:nvSpPr>
         <p:spPr>
           <a:xfrm>
@@ -4874,11 +4874,11 @@
       </p:sp>
       <p:sp>
         <p:nvSpPr>
-          <p:cNvPr id="7" name="Rounded Rectangle 6"/>
+          <p:cNvPr id="7" name="Rounded Rectangle 6">
+            <a:hlinkClick r:id="rId7"/>
+          </p:cNvPr>
           <p:cNvSpPr/>
-          <p:nvPr>
-            <a:hlinkClick r:id="rId7"/>
-          </p:nvPr>
+          <p:nvPr/>
         </p:nvSpPr>
         <p:spPr>
           <a:xfrm>
@@ -4976,11 +4976,11 @@
       </p:sp>
       <p:sp>
         <p:nvSpPr>
-          <p:cNvPr id="9" name="Rounded Rectangle 8"/>
+          <p:cNvPr id="9" name="Rounded Rectangle 8">
+            <a:hlinkClick r:id="rId11"/>
+          </p:cNvPr>
           <p:cNvSpPr/>
-          <p:nvPr>
-            <a:hlinkClick r:id="rId11"/>
-          </p:nvPr>
+          <p:nvPr/>
         </p:nvSpPr>
         <p:spPr>
           <a:xfrm>
@@ -5078,11 +5078,11 @@
       </p:sp>
       <p:sp>
         <p:nvSpPr>
-          <p:cNvPr id="11" name="Rounded Rectangle 10"/>
+          <p:cNvPr id="11" name="Rounded Rectangle 10">
+            <a:hlinkClick r:id="rId15"/>
+          </p:cNvPr>
           <p:cNvSpPr/>
-          <p:nvPr>
-            <a:hlinkClick r:id="rId15"/>
-          </p:nvPr>
+          <p:nvPr/>
         </p:nvSpPr>
         <p:spPr>
           <a:xfrm>
@@ -5164,11 +5164,11 @@
       </p:sp>
       <p:sp>
         <p:nvSpPr>
-          <p:cNvPr id="13" name="Rounded Rectangle 12"/>
+          <p:cNvPr id="13" name="Rounded Rectangle 12">
+            <a:hlinkClick r:id="rId17"/>
+          </p:cNvPr>
           <p:cNvSpPr/>
-          <p:nvPr>
-            <a:hlinkClick r:id="rId17"/>
-          </p:nvPr>
+          <p:nvPr/>
         </p:nvSpPr>
         <p:spPr>
           <a:xfrm>
@@ -5266,11 +5266,11 @@
       </p:sp>
       <p:sp>
         <p:nvSpPr>
-          <p:cNvPr id="15" name="Rounded Rectangle 14"/>
+          <p:cNvPr id="15" name="Rounded Rectangle 14">
+            <a:hlinkClick r:id="rId21"/>
+          </p:cNvPr>
           <p:cNvSpPr/>
-          <p:nvPr>
-            <a:hlinkClick r:id="rId21"/>
-          </p:nvPr>
+          <p:nvPr/>
         </p:nvSpPr>
         <p:spPr>
           <a:xfrm>
@@ -5360,11 +5360,11 @@
       </p:sp>
       <p:sp>
         <p:nvSpPr>
-          <p:cNvPr id="17" name="Rounded Rectangle 16"/>
+          <p:cNvPr id="17" name="Rounded Rectangle 16">
+            <a:hlinkClick r:id="rId24"/>
+          </p:cNvPr>
           <p:cNvSpPr/>
-          <p:nvPr>
-            <a:hlinkClick r:id="rId24"/>
-          </p:nvPr>
+          <p:nvPr/>
         </p:nvSpPr>
         <p:spPr>
           <a:xfrm>
@@ -5446,11 +5446,11 @@
       </p:sp>
       <p:sp>
         <p:nvSpPr>
-          <p:cNvPr id="19" name="Rounded Rectangle 18"/>
+          <p:cNvPr id="19" name="Rounded Rectangle 18">
+            <a:hlinkClick r:id="rId26"/>
+          </p:cNvPr>
           <p:cNvSpPr/>
-          <p:nvPr>
-            <a:hlinkClick r:id="rId26"/>
-          </p:nvPr>
+          <p:nvPr/>
         </p:nvSpPr>
         <p:spPr>
           <a:xfrm>
@@ -5532,11 +5532,11 @@
       </p:sp>
       <p:sp>
         <p:nvSpPr>
-          <p:cNvPr id="21" name="Rounded Rectangle 20"/>
+          <p:cNvPr id="21" name="Rounded Rectangle 20">
+            <a:hlinkClick r:id="rId28"/>
+          </p:cNvPr>
           <p:cNvSpPr/>
-          <p:nvPr>
-            <a:hlinkClick r:id="rId28"/>
-          </p:nvPr>
+          <p:nvPr/>
         </p:nvSpPr>
         <p:spPr>
           <a:xfrm>
@@ -5642,11 +5642,11 @@
       </p:sp>
       <p:sp>
         <p:nvSpPr>
-          <p:cNvPr id="23" name="Rounded Rectangle 22"/>
+          <p:cNvPr id="23" name="Rounded Rectangle 22">
+            <a:hlinkClick r:id="rId33"/>
+          </p:cNvPr>
           <p:cNvSpPr/>
-          <p:nvPr>
-            <a:hlinkClick r:id="rId33"/>
-          </p:nvPr>
+          <p:nvPr/>
         </p:nvSpPr>
         <p:spPr>
           <a:xfrm>
@@ -5744,11 +5744,11 @@
       </p:sp>
       <p:sp>
         <p:nvSpPr>
-          <p:cNvPr id="25" name="Rounded Rectangle 24"/>
+          <p:cNvPr id="25" name="Rounded Rectangle 24">
+            <a:hlinkClick r:id="rId37"/>
+          </p:cNvPr>
           <p:cNvSpPr/>
-          <p:nvPr>
-            <a:hlinkClick r:id="rId37"/>
-          </p:nvPr>
+          <p:nvPr/>
         </p:nvSpPr>
         <p:spPr>
           <a:xfrm>
@@ -5846,11 +5846,11 @@
       </p:sp>
       <p:sp>
         <p:nvSpPr>
-          <p:cNvPr id="27" name="Rounded Rectangle 26"/>
+          <p:cNvPr id="27" name="Rounded Rectangle 26">
+            <a:hlinkClick r:id="rId41"/>
+          </p:cNvPr>
           <p:cNvSpPr/>
-          <p:nvPr>
-            <a:hlinkClick r:id="rId41"/>
-          </p:nvPr>
+          <p:nvPr/>
         </p:nvSpPr>
         <p:spPr>
           <a:xfrm>
@@ -5956,11 +5956,11 @@
       </p:sp>
       <p:sp>
         <p:nvSpPr>
-          <p:cNvPr id="29" name="Rounded Rectangle 28"/>
+          <p:cNvPr id="29" name="Rounded Rectangle 28">
+            <a:hlinkClick r:id="rId46"/>
+          </p:cNvPr>
           <p:cNvSpPr/>
-          <p:nvPr>
-            <a:hlinkClick r:id="rId46"/>
-          </p:nvPr>
+          <p:nvPr/>
         </p:nvSpPr>
         <p:spPr>
           <a:xfrm>
@@ -6042,11 +6042,11 @@
       </p:sp>
       <p:sp>
         <p:nvSpPr>
-          <p:cNvPr id="31" name="Rounded Rectangle 30"/>
+          <p:cNvPr id="31" name="Rounded Rectangle 30">
+            <a:hlinkClick r:id="rId48"/>
+          </p:cNvPr>
           <p:cNvSpPr/>
-          <p:nvPr>
-            <a:hlinkClick r:id="rId48"/>
-          </p:nvPr>
+          <p:nvPr/>
         </p:nvSpPr>
         <p:spPr>
           <a:xfrm>
@@ -6197,11 +6197,11 @@
       </p:sp>
       <p:sp>
         <p:nvSpPr>
-          <p:cNvPr id="3" name="Rounded Rectangle 2"/>
+          <p:cNvPr id="3" name="Rounded Rectangle 2">
+            <a:hlinkClick r:id="rId2"/>
+          </p:cNvPr>
           <p:cNvSpPr/>
-          <p:nvPr>
-            <a:hlinkClick r:id="rId2"/>
-          </p:nvPr>
+          <p:nvPr/>
         </p:nvSpPr>
         <p:spPr>
           <a:xfrm>
@@ -6283,11 +6283,11 @@
       </p:sp>
       <p:sp>
         <p:nvSpPr>
-          <p:cNvPr id="5" name="Rounded Rectangle 4"/>
+          <p:cNvPr id="5" name="Rounded Rectangle 4">
+            <a:hlinkClick r:id="rId4"/>
+          </p:cNvPr>
           <p:cNvSpPr/>
-          <p:nvPr>
-            <a:hlinkClick r:id="rId4"/>
-          </p:nvPr>
+          <p:nvPr/>
         </p:nvSpPr>
         <p:spPr>
           <a:xfrm>
@@ -6385,11 +6385,11 @@
       </p:sp>
       <p:sp>
         <p:nvSpPr>
-          <p:cNvPr id="7" name="Rounded Rectangle 6"/>
+          <p:cNvPr id="7" name="Rounded Rectangle 6">
+            <a:hlinkClick r:id="rId8"/>
+          </p:cNvPr>
           <p:cNvSpPr/>
-          <p:nvPr>
-            <a:hlinkClick r:id="rId8"/>
-          </p:nvPr>
+          <p:nvPr/>
         </p:nvSpPr>
         <p:spPr>
           <a:xfrm>
@@ -6471,11 +6471,11 @@
       </p:sp>
       <p:sp>
         <p:nvSpPr>
-          <p:cNvPr id="9" name="Rounded Rectangle 8"/>
+          <p:cNvPr id="9" name="Rounded Rectangle 8">
+            <a:hlinkClick r:id="rId10"/>
+          </p:cNvPr>
           <p:cNvSpPr/>
-          <p:nvPr>
-            <a:hlinkClick r:id="rId10"/>
-          </p:nvPr>
+          <p:nvPr/>
         </p:nvSpPr>
         <p:spPr>
           <a:xfrm>
@@ -6565,11 +6565,11 @@
       </p:sp>
       <p:sp>
         <p:nvSpPr>
-          <p:cNvPr id="11" name="Rounded Rectangle 10"/>
+          <p:cNvPr id="11" name="Rounded Rectangle 10">
+            <a:hlinkClick r:id="rId13"/>
+          </p:cNvPr>
           <p:cNvSpPr/>
-          <p:nvPr>
-            <a:hlinkClick r:id="rId13"/>
-          </p:nvPr>
+          <p:nvPr/>
         </p:nvSpPr>
         <p:spPr>
           <a:xfrm>
@@ -6659,11 +6659,11 @@
       </p:sp>
       <p:sp>
         <p:nvSpPr>
-          <p:cNvPr id="13" name="Rounded Rectangle 12"/>
+          <p:cNvPr id="13" name="Rounded Rectangle 12">
+            <a:hlinkClick r:id="rId16"/>
+          </p:cNvPr>
           <p:cNvSpPr/>
-          <p:nvPr>
-            <a:hlinkClick r:id="rId16"/>
-          </p:nvPr>
+          <p:nvPr/>
         </p:nvSpPr>
         <p:spPr>
           <a:xfrm>
@@ -6769,11 +6769,11 @@
       </p:sp>
       <p:sp>
         <p:nvSpPr>
-          <p:cNvPr id="15" name="Rounded Rectangle 14"/>
+          <p:cNvPr id="15" name="Rounded Rectangle 14">
+            <a:hlinkClick r:id="rId21"/>
+          </p:cNvPr>
           <p:cNvSpPr/>
-          <p:nvPr>
-            <a:hlinkClick r:id="rId21"/>
-          </p:nvPr>
+          <p:nvPr/>
         </p:nvSpPr>
         <p:spPr>
           <a:xfrm>
@@ -6879,11 +6879,11 @@
       </p:sp>
       <p:sp>
         <p:nvSpPr>
-          <p:cNvPr id="17" name="Rounded Rectangle 16"/>
+          <p:cNvPr id="17" name="Rounded Rectangle 16">
+            <a:hlinkClick r:id="rId26"/>
+          </p:cNvPr>
           <p:cNvSpPr/>
-          <p:nvPr>
-            <a:hlinkClick r:id="rId26"/>
-          </p:nvPr>
+          <p:nvPr/>
         </p:nvSpPr>
         <p:spPr>
           <a:xfrm>
@@ -6973,11 +6973,11 @@
       </p:sp>
       <p:sp>
         <p:nvSpPr>
-          <p:cNvPr id="19" name="Rounded Rectangle 18"/>
+          <p:cNvPr id="19" name="Rounded Rectangle 18">
+            <a:hlinkClick r:id="rId29"/>
+          </p:cNvPr>
           <p:cNvSpPr/>
-          <p:nvPr>
-            <a:hlinkClick r:id="rId29"/>
-          </p:nvPr>
+          <p:nvPr/>
         </p:nvSpPr>
         <p:spPr>
           <a:xfrm>
@@ -7059,11 +7059,11 @@
       </p:sp>
       <p:sp>
         <p:nvSpPr>
-          <p:cNvPr id="21" name="Rounded Rectangle 20"/>
+          <p:cNvPr id="21" name="Rounded Rectangle 20">
+            <a:hlinkClick r:id="rId31"/>
+          </p:cNvPr>
           <p:cNvSpPr/>
-          <p:nvPr>
-            <a:hlinkClick r:id="rId31"/>
-          </p:nvPr>
+          <p:nvPr/>
         </p:nvSpPr>
         <p:spPr>
           <a:xfrm>

</xml_diff>

<commit_message>
Add welcome and exit slides to generated PPTX corpus
Bracket each publication's content slides with a welcome slide
("Welcome to <Publication>") and an exit slide ("End of <Publication>"),
both carrying the "Instructor Version" subtitle and no gram content.

Update extract_to_csv.py to detect framing slides by title prefix and
skip them so they never contribute CSV rows, and relax the introspector
deviation check to ignore slides 1 and N (the framing pair).
</commit_message>
<xml_diff>
--- a/source/Instructor Progress Final Assessment Grams/Instructor Progress Final Assessment Grams.pptx
+++ b/source/Instructor Progress Final Assessment Grams/Instructor Progress Final Assessment Grams.pptx
@@ -8,6 +8,8 @@
     <p:sldId id="256" r:id="rId7"/>
     <p:sldId id="257" r:id="rId8"/>
     <p:sldId id="258" r:id="rId9"/>
+    <p:sldId id="259" r:id="rId10"/>
+    <p:sldId id="260" r:id="rId11"/>
   </p:sldIdLst>
   <p:sldSz cx="12188952" cy="6858000" type="screen4x3"/>
   <p:notesSz cx="6858000" cy="9144000"/>
@@ -3092,120 +3094,48 @@
       <p:grpSpPr/>
       <p:sp>
         <p:nvSpPr>
-          <p:cNvPr id="2" name="Rectangle 1"/>
-          <p:cNvSpPr/>
+          <p:cNvPr id="2" name="TextBox 1"/>
+          <p:cNvSpPr txBox="1"/>
           <p:nvPr/>
         </p:nvSpPr>
         <p:spPr>
           <a:xfrm>
-            <a:off x="0" y="0"/>
-            <a:ext cx="12188952" cy="548640"/>
+            <a:off x="914400" y="2377440"/>
+            <a:ext cx="10360152" cy="1280160"/>
           </a:xfrm>
           <a:prstGeom prst="rect">
             <a:avLst/>
           </a:prstGeom>
-          <a:solidFill>
-            <a:srgbClr val="1F3A5F"/>
-          </a:solidFill>
-          <a:ln>
-            <a:noFill/>
-          </a:ln>
-        </p:spPr>
-        <p:style>
-          <a:lnRef idx="1">
-            <a:schemeClr val="accent1"/>
-          </a:lnRef>
-          <a:fillRef idx="3">
-            <a:schemeClr val="accent1"/>
-          </a:fillRef>
-          <a:effectRef idx="2">
-            <a:schemeClr val="accent1"/>
-          </a:effectRef>
-          <a:fontRef idx="minor">
-            <a:schemeClr val="lt1"/>
-          </a:fontRef>
-        </p:style>
-        <p:txBody>
-          <a:bodyPr rtlCol="0" anchor="ctr" lIns="182880" rIns="182880"/>
+          <a:noFill/>
+        </p:spPr>
+        <p:txBody>
+          <a:bodyPr wrap="square">
+            <a:spAutoFit/>
+          </a:bodyPr>
           <a:lstStyle/>
           <a:p>
             <a:pPr algn="ctr"/>
             <a:r>
-              <a:rPr sz="2000" b="1">
-                <a:solidFill>
-                  <a:srgbClr val="FFFFFF"/>
-                </a:solidFill>
-              </a:rPr>
-              <a:t>Instructor Progress Final Assessment Grams — Page 1 of 3</a:t>
-            </a:r>
-          </a:p>
-        </p:txBody>
-      </p:sp>
-      <p:sp>
-        <p:nvSpPr>
-          <p:cNvPr id="3" name="Rounded Rectangle 2"/>
-          <p:cNvSpPr/>
-          <p:nvPr>
-            <a:hlinkClick r:id="rId2"/>
-          </p:nvPr>
-        </p:nvSpPr>
-        <p:spPr>
-          <a:xfrm>
-            <a:off x="365760" y="731520"/>
-            <a:ext cx="2200046" cy="365760"/>
-          </a:xfrm>
-          <a:prstGeom prst="roundRect">
-            <a:avLst/>
-          </a:prstGeom>
-          <a:solidFill>
-            <a:srgbClr val="E8EEF7"/>
-          </a:solidFill>
-          <a:ln>
-            <a:solidFill>
-              <a:srgbClr val="1F3A5F"/>
-            </a:solidFill>
-          </a:ln>
-        </p:spPr>
-        <p:style>
-          <a:lnRef idx="1">
-            <a:schemeClr val="accent1"/>
-          </a:lnRef>
-          <a:fillRef idx="3">
-            <a:schemeClr val="accent1"/>
-          </a:fillRef>
-          <a:effectRef idx="2">
-            <a:schemeClr val="accent1"/>
-          </a:effectRef>
-          <a:fontRef idx="minor">
-            <a:schemeClr val="lt1"/>
-          </a:fontRef>
-        </p:style>
-        <p:txBody>
-          <a:bodyPr rtlCol="0" anchor="ctr" lIns="45720" rIns="45720"/>
-          <a:lstStyle/>
-          <a:p>
-            <a:pPr algn="ctr"/>
-            <a:r>
-              <a:rPr sz="900">
+              <a:rPr sz="4000" b="1">
                 <a:solidFill>
                   <a:srgbClr val="1F3A5F"/>
                 </a:solidFill>
               </a:rPr>
-              <a:t>Gram 1: FR TIE Bomber, Category 3, Tatooine</a:t>
-            </a:r>
-          </a:p>
-        </p:txBody>
-      </p:sp>
-      <p:sp>
-        <p:nvSpPr>
-          <p:cNvPr id="4" name="TextBox 3"/>
+              <a:t>Welcome to Instructor Progress Final Assessment Grams</a:t>
+            </a:r>
+          </a:p>
+        </p:txBody>
+      </p:sp>
+      <p:sp>
+        <p:nvSpPr>
+          <p:cNvPr id="3" name="TextBox 2"/>
           <p:cNvSpPr txBox="1"/>
           <p:nvPr/>
         </p:nvSpPr>
         <p:spPr>
           <a:xfrm>
-            <a:off x="365760" y="1115568"/>
-            <a:ext cx="2200046" cy="1447800"/>
+            <a:off x="914400" y="3840480"/>
+            <a:ext cx="10360152" cy="731520"/>
           </a:xfrm>
           <a:prstGeom prst="rect">
             <a:avLst/>
@@ -3213,1412 +3143,19 @@
           <a:noFill/>
         </p:spPr>
         <p:txBody>
-          <a:bodyPr wrap="square">
+          <a:bodyPr wrap="none">
             <a:spAutoFit/>
           </a:bodyPr>
           <a:lstStyle/>
           <a:p>
-            <a:r>
-              <a:rPr sz="800">
-                <a:hlinkClick r:id="rId3"/>
-              </a:rPr>
-              <a:t>Lofar 1</a:t>
-            </a:r>
-          </a:p>
-        </p:txBody>
-      </p:sp>
-      <p:sp>
-        <p:nvSpPr>
-          <p:cNvPr id="5" name="Rounded Rectangle 4"/>
-          <p:cNvSpPr/>
-          <p:nvPr>
-            <a:hlinkClick r:id="rId4"/>
-          </p:nvPr>
-        </p:nvSpPr>
-        <p:spPr>
-          <a:xfrm>
-            <a:off x="2657246" y="731520"/>
-            <a:ext cx="2200046" cy="365760"/>
-          </a:xfrm>
-          <a:prstGeom prst="roundRect">
-            <a:avLst/>
-          </a:prstGeom>
-          <a:solidFill>
-            <a:srgbClr val="E8EEF7"/>
-          </a:solidFill>
-          <a:ln>
-            <a:solidFill>
-              <a:srgbClr val="1F3A5F"/>
-            </a:solidFill>
-          </a:ln>
-        </p:spPr>
-        <p:style>
-          <a:lnRef idx="1">
-            <a:schemeClr val="accent1"/>
-          </a:lnRef>
-          <a:fillRef idx="3">
-            <a:schemeClr val="accent1"/>
-          </a:fillRef>
-          <a:effectRef idx="2">
-            <a:schemeClr val="accent1"/>
-          </a:effectRef>
-          <a:fontRef idx="minor">
-            <a:schemeClr val="lt1"/>
-          </a:fontRef>
-        </p:style>
-        <p:txBody>
-          <a:bodyPr rtlCol="0" anchor="ctr" lIns="45720" rIns="45720"/>
-          <a:lstStyle/>
-          <a:p>
             <a:pPr algn="ctr"/>
             <a:r>
-              <a:rPr sz="900">
+              <a:rPr sz="2400">
                 <a:solidFill>
                   <a:srgbClr val="1F3A5F"/>
                 </a:solidFill>
               </a:rPr>
-              <a:t>Gram 2: FR Sovereign-class, Category 1, Tatooine</a:t>
-            </a:r>
-          </a:p>
-        </p:txBody>
-      </p:sp>
-      <p:sp>
-        <p:nvSpPr>
-          <p:cNvPr id="6" name="TextBox 5"/>
-          <p:cNvSpPr txBox="1"/>
-          <p:nvPr/>
-        </p:nvSpPr>
-        <p:spPr>
-          <a:xfrm>
-            <a:off x="2657246" y="1115568"/>
-            <a:ext cx="2200046" cy="1447800"/>
-          </a:xfrm>
-          <a:prstGeom prst="rect">
-            <a:avLst/>
-          </a:prstGeom>
-          <a:noFill/>
-        </p:spPr>
-        <p:txBody>
-          <a:bodyPr wrap="square">
-            <a:spAutoFit/>
-          </a:bodyPr>
-          <a:lstStyle/>
-          <a:p>
-            <a:r>
-              <a:rPr sz="800">
-                <a:hlinkClick r:id="rId5"/>
-              </a:rPr>
-              <a:t>Lofar 1</a:t>
-            </a:r>
-          </a:p>
-          <a:p>
-            <a:r>
-              <a:rPr sz="800">
-                <a:hlinkClick r:id="rId6"/>
-              </a:rPr>
-              <a:t>Lofar 2</a:t>
-            </a:r>
-          </a:p>
-          <a:p>
-            <a:r>
-              <a:rPr sz="800">
-                <a:hlinkClick r:id="rId7"/>
-              </a:rPr>
-              <a:t>Lofar 3</a:t>
-            </a:r>
-          </a:p>
-        </p:txBody>
-      </p:sp>
-      <p:sp>
-        <p:nvSpPr>
-          <p:cNvPr id="7" name="Rounded Rectangle 6"/>
-          <p:cNvSpPr/>
-          <p:nvPr>
-            <a:hlinkClick r:id="rId8"/>
-          </p:nvPr>
-        </p:nvSpPr>
-        <p:spPr>
-          <a:xfrm>
-            <a:off x="4948732" y="731520"/>
-            <a:ext cx="2200046" cy="365760"/>
-          </a:xfrm>
-          <a:prstGeom prst="roundRect">
-            <a:avLst/>
-          </a:prstGeom>
-          <a:solidFill>
-            <a:srgbClr val="E8EEF7"/>
-          </a:solidFill>
-          <a:ln>
-            <a:solidFill>
-              <a:srgbClr val="1F3A5F"/>
-            </a:solidFill>
-          </a:ln>
-        </p:spPr>
-        <p:style>
-          <a:lnRef idx="1">
-            <a:schemeClr val="accent1"/>
-          </a:lnRef>
-          <a:fillRef idx="3">
-            <a:schemeClr val="accent1"/>
-          </a:fillRef>
-          <a:effectRef idx="2">
-            <a:schemeClr val="accent1"/>
-          </a:effectRef>
-          <a:fontRef idx="minor">
-            <a:schemeClr val="lt1"/>
-          </a:fontRef>
-        </p:style>
-        <p:txBody>
-          <a:bodyPr rtlCol="0" anchor="ctr" lIns="45720" rIns="45720"/>
-          <a:lstStyle/>
-          <a:p>
-            <a:pPr algn="ctr"/>
-            <a:r>
-              <a:rPr sz="900">
-                <a:solidFill>
-                  <a:srgbClr val="1F3A5F"/>
-                </a:solidFill>
-              </a:rPr>
-              <a:t>Gram 3: FR TIE Fighter, Category 4, Mustafar</a:t>
-            </a:r>
-          </a:p>
-        </p:txBody>
-      </p:sp>
-      <p:sp>
-        <p:nvSpPr>
-          <p:cNvPr id="8" name="TextBox 7"/>
-          <p:cNvSpPr txBox="1"/>
-          <p:nvPr/>
-        </p:nvSpPr>
-        <p:spPr>
-          <a:xfrm>
-            <a:off x="4948732" y="1115568"/>
-            <a:ext cx="2200046" cy="1447800"/>
-          </a:xfrm>
-          <a:prstGeom prst="rect">
-            <a:avLst/>
-          </a:prstGeom>
-          <a:noFill/>
-        </p:spPr>
-        <p:txBody>
-          <a:bodyPr wrap="square">
-            <a:spAutoFit/>
-          </a:bodyPr>
-          <a:lstStyle/>
-          <a:p>
-            <a:r>
-              <a:rPr sz="800">
-                <a:hlinkClick r:id="rId9"/>
-              </a:rPr>
-              <a:t>Lofar 1</a:t>
-            </a:r>
-          </a:p>
-          <a:p>
-            <a:r>
-              <a:rPr sz="800">
-                <a:hlinkClick r:id="rId10"/>
-              </a:rPr>
-              <a:t>Lofar 2</a:t>
-            </a:r>
-          </a:p>
-          <a:p>
-            <a:r>
-              <a:rPr sz="800">
-                <a:hlinkClick r:id="rId11"/>
-              </a:rPr>
-              <a:t>Lofar 3</a:t>
-            </a:r>
-          </a:p>
-        </p:txBody>
-      </p:sp>
-      <p:sp>
-        <p:nvSpPr>
-          <p:cNvPr id="9" name="Rounded Rectangle 8"/>
-          <p:cNvSpPr/>
-          <p:nvPr>
-            <a:hlinkClick r:id="rId12"/>
-          </p:nvPr>
-        </p:nvSpPr>
-        <p:spPr>
-          <a:xfrm>
-            <a:off x="7240219" y="731520"/>
-            <a:ext cx="2200046" cy="365760"/>
-          </a:xfrm>
-          <a:prstGeom prst="roundRect">
-            <a:avLst/>
-          </a:prstGeom>
-          <a:solidFill>
-            <a:srgbClr val="E8EEF7"/>
-          </a:solidFill>
-          <a:ln>
-            <a:solidFill>
-              <a:srgbClr val="1F3A5F"/>
-            </a:solidFill>
-          </a:ln>
-        </p:spPr>
-        <p:style>
-          <a:lnRef idx="1">
-            <a:schemeClr val="accent1"/>
-          </a:lnRef>
-          <a:fillRef idx="3">
-            <a:schemeClr val="accent1"/>
-          </a:fillRef>
-          <a:effectRef idx="2">
-            <a:schemeClr val="accent1"/>
-          </a:effectRef>
-          <a:fontRef idx="minor">
-            <a:schemeClr val="lt1"/>
-          </a:fontRef>
-        </p:style>
-        <p:txBody>
-          <a:bodyPr rtlCol="0" anchor="ctr" lIns="45720" rIns="45720"/>
-          <a:lstStyle/>
-          <a:p>
-            <a:pPr algn="ctr"/>
-            <a:r>
-              <a:rPr sz="900">
-                <a:solidFill>
-                  <a:srgbClr val="1F3A5F"/>
-                </a:solidFill>
-              </a:rPr>
-              <a:t>Gram 4: FR Intrepid-class, Category 4, Mustafar</a:t>
-            </a:r>
-          </a:p>
-        </p:txBody>
-      </p:sp>
-      <p:sp>
-        <p:nvSpPr>
-          <p:cNvPr id="10" name="TextBox 9"/>
-          <p:cNvSpPr txBox="1"/>
-          <p:nvPr/>
-        </p:nvSpPr>
-        <p:spPr>
-          <a:xfrm>
-            <a:off x="7240219" y="1115568"/>
-            <a:ext cx="2200046" cy="1447800"/>
-          </a:xfrm>
-          <a:prstGeom prst="rect">
-            <a:avLst/>
-          </a:prstGeom>
-          <a:noFill/>
-        </p:spPr>
-        <p:txBody>
-          <a:bodyPr wrap="square">
-            <a:spAutoFit/>
-          </a:bodyPr>
-          <a:lstStyle/>
-          <a:p>
-            <a:r>
-              <a:rPr sz="800">
-                <a:hlinkClick r:id="rId13"/>
-              </a:rPr>
-              <a:t>Lofar 1</a:t>
-            </a:r>
-          </a:p>
-          <a:p>
-            <a:r>
-              <a:rPr sz="800">
-                <a:hlinkClick r:id="rId14"/>
-              </a:rPr>
-              <a:t>Lofar 2</a:t>
-            </a:r>
-          </a:p>
-          <a:p>
-            <a:r>
-              <a:rPr sz="800">
-                <a:hlinkClick r:id="rId15"/>
-              </a:rPr>
-              <a:t>Lofar 3</a:t>
-            </a:r>
-          </a:p>
-        </p:txBody>
-      </p:sp>
-      <p:sp>
-        <p:nvSpPr>
-          <p:cNvPr id="11" name="Rounded Rectangle 10"/>
-          <p:cNvSpPr/>
-          <p:nvPr>
-            <a:hlinkClick r:id="rId16"/>
-          </p:nvPr>
-        </p:nvSpPr>
-        <p:spPr>
-          <a:xfrm>
-            <a:off x="9531705" y="731520"/>
-            <a:ext cx="2200046" cy="365760"/>
-          </a:xfrm>
-          <a:prstGeom prst="roundRect">
-            <a:avLst/>
-          </a:prstGeom>
-          <a:solidFill>
-            <a:srgbClr val="E8EEF7"/>
-          </a:solidFill>
-          <a:ln>
-            <a:solidFill>
-              <a:srgbClr val="1F3A5F"/>
-            </a:solidFill>
-          </a:ln>
-        </p:spPr>
-        <p:style>
-          <a:lnRef idx="1">
-            <a:schemeClr val="accent1"/>
-          </a:lnRef>
-          <a:fillRef idx="3">
-            <a:schemeClr val="accent1"/>
-          </a:fillRef>
-          <a:effectRef idx="2">
-            <a:schemeClr val="accent1"/>
-          </a:effectRef>
-          <a:fontRef idx="minor">
-            <a:schemeClr val="lt1"/>
-          </a:fontRef>
-        </p:style>
-        <p:txBody>
-          <a:bodyPr rtlCol="0" anchor="ctr" lIns="45720" rIns="45720"/>
-          <a:lstStyle/>
-          <a:p>
-            <a:pPr algn="ctr"/>
-            <a:r>
-              <a:rPr sz="900">
-                <a:solidFill>
-                  <a:srgbClr val="1F3A5F"/>
-                </a:solidFill>
-              </a:rPr>
-              <a:t>Gram 7: FR Discovery, Category 1, Dagobah</a:t>
-            </a:r>
-          </a:p>
-        </p:txBody>
-      </p:sp>
-      <p:sp>
-        <p:nvSpPr>
-          <p:cNvPr id="12" name="TextBox 11"/>
-          <p:cNvSpPr txBox="1"/>
-          <p:nvPr/>
-        </p:nvSpPr>
-        <p:spPr>
-          <a:xfrm>
-            <a:off x="9531705" y="1115568"/>
-            <a:ext cx="2200046" cy="1447800"/>
-          </a:xfrm>
-          <a:prstGeom prst="rect">
-            <a:avLst/>
-          </a:prstGeom>
-          <a:noFill/>
-        </p:spPr>
-        <p:txBody>
-          <a:bodyPr wrap="square">
-            <a:spAutoFit/>
-          </a:bodyPr>
-          <a:lstStyle/>
-          <a:p>
-            <a:r>
-              <a:rPr sz="800">
-                <a:hlinkClick r:id="rId17"/>
-              </a:rPr>
-              <a:t>Lofar 1</a:t>
-            </a:r>
-          </a:p>
-        </p:txBody>
-      </p:sp>
-      <p:sp>
-        <p:nvSpPr>
-          <p:cNvPr id="13" name="Rounded Rectangle 12"/>
-          <p:cNvSpPr/>
-          <p:nvPr>
-            <a:hlinkClick r:id="rId18"/>
-          </p:nvPr>
-        </p:nvSpPr>
-        <p:spPr>
-          <a:xfrm>
-            <a:off x="365760" y="2682240"/>
-            <a:ext cx="2200046" cy="365760"/>
-          </a:xfrm>
-          <a:prstGeom prst="roundRect">
-            <a:avLst/>
-          </a:prstGeom>
-          <a:solidFill>
-            <a:srgbClr val="E8EEF7"/>
-          </a:solidFill>
-          <a:ln>
-            <a:solidFill>
-              <a:srgbClr val="1F3A5F"/>
-            </a:solidFill>
-          </a:ln>
-        </p:spPr>
-        <p:style>
-          <a:lnRef idx="1">
-            <a:schemeClr val="accent1"/>
-          </a:lnRef>
-          <a:fillRef idx="3">
-            <a:schemeClr val="accent1"/>
-          </a:fillRef>
-          <a:effectRef idx="2">
-            <a:schemeClr val="accent1"/>
-          </a:effectRef>
-          <a:fontRef idx="minor">
-            <a:schemeClr val="lt1"/>
-          </a:fontRef>
-        </p:style>
-        <p:txBody>
-          <a:bodyPr rtlCol="0" anchor="ctr" lIns="45720" rIns="45720"/>
-          <a:lstStyle/>
-          <a:p>
-            <a:pPr algn="ctr"/>
-            <a:r>
-              <a:rPr sz="900">
-                <a:solidFill>
-                  <a:srgbClr val="1F3A5F"/>
-                </a:solidFill>
-              </a:rPr>
-              <a:t>Gram 8: Miranda-class contact bearing 288, codename Dank</a:t>
-            </a:r>
-          </a:p>
-        </p:txBody>
-      </p:sp>
-      <p:sp>
-        <p:nvSpPr>
-          <p:cNvPr id="14" name="TextBox 13"/>
-          <p:cNvSpPr txBox="1"/>
-          <p:nvPr/>
-        </p:nvSpPr>
-        <p:spPr>
-          <a:xfrm>
-            <a:off x="365760" y="3066288"/>
-            <a:ext cx="2200046" cy="1447800"/>
-          </a:xfrm>
-          <a:prstGeom prst="rect">
-            <a:avLst/>
-          </a:prstGeom>
-          <a:noFill/>
-        </p:spPr>
-        <p:txBody>
-          <a:bodyPr wrap="square">
-            <a:spAutoFit/>
-          </a:bodyPr>
-          <a:lstStyle/>
-          <a:p>
-            <a:r>
-              <a:rPr sz="800">
-                <a:hlinkClick r:id="rId19"/>
-              </a:rPr>
-              <a:t>Lofar 1</a:t>
-            </a:r>
-          </a:p>
-          <a:p>
-            <a:r>
-              <a:rPr sz="800">
-                <a:hlinkClick r:id="rId20"/>
-              </a:rPr>
-              <a:t>Lofar 2</a:t>
-            </a:r>
-          </a:p>
-          <a:p>
-            <a:r>
-              <a:rPr sz="800">
-                <a:hlinkClick r:id="rId21"/>
-              </a:rPr>
-              <a:t>Lofar 3</a:t>
-            </a:r>
-          </a:p>
-          <a:p>
-            <a:r>
-              <a:rPr sz="800">
-                <a:hlinkClick r:id="rId22"/>
-              </a:rPr>
-              <a:t>Lofar 4</a:t>
-            </a:r>
-          </a:p>
-        </p:txBody>
-      </p:sp>
-      <p:sp>
-        <p:nvSpPr>
-          <p:cNvPr id="15" name="Rounded Rectangle 14"/>
-          <p:cNvSpPr/>
-          <p:nvPr>
-            <a:hlinkClick r:id="rId23"/>
-          </p:nvPr>
-        </p:nvSpPr>
-        <p:spPr>
-          <a:xfrm>
-            <a:off x="2657246" y="2682240"/>
-            <a:ext cx="2200046" cy="365760"/>
-          </a:xfrm>
-          <a:prstGeom prst="roundRect">
-            <a:avLst/>
-          </a:prstGeom>
-          <a:solidFill>
-            <a:srgbClr val="E8EEF7"/>
-          </a:solidFill>
-          <a:ln>
-            <a:solidFill>
-              <a:srgbClr val="1F3A5F"/>
-            </a:solidFill>
-          </a:ln>
-        </p:spPr>
-        <p:style>
-          <a:lnRef idx="1">
-            <a:schemeClr val="accent1"/>
-          </a:lnRef>
-          <a:fillRef idx="3">
-            <a:schemeClr val="accent1"/>
-          </a:fillRef>
-          <a:effectRef idx="2">
-            <a:schemeClr val="accent1"/>
-          </a:effectRef>
-          <a:fontRef idx="minor">
-            <a:schemeClr val="lt1"/>
-          </a:fontRef>
-        </p:style>
-        <p:txBody>
-          <a:bodyPr rtlCol="0" anchor="ctr" lIns="45720" rIns="45720"/>
-          <a:lstStyle/>
-          <a:p>
-            <a:pPr algn="ctr"/>
-            <a:r>
-              <a:rPr sz="900">
-                <a:solidFill>
-                  <a:srgbClr val="1F3A5F"/>
-                </a:solidFill>
-              </a:rPr>
-              <a:t>Gram 9: Enterprise contact bearing 084, codename Yavin</a:t>
-            </a:r>
-          </a:p>
-        </p:txBody>
-      </p:sp>
-      <p:sp>
-        <p:nvSpPr>
-          <p:cNvPr id="16" name="TextBox 15"/>
-          <p:cNvSpPr txBox="1"/>
-          <p:nvPr/>
-        </p:nvSpPr>
-        <p:spPr>
-          <a:xfrm>
-            <a:off x="2657246" y="3066288"/>
-            <a:ext cx="2200046" cy="1447800"/>
-          </a:xfrm>
-          <a:prstGeom prst="rect">
-            <a:avLst/>
-          </a:prstGeom>
-          <a:noFill/>
-        </p:spPr>
-        <p:txBody>
-          <a:bodyPr wrap="square">
-            <a:spAutoFit/>
-          </a:bodyPr>
-          <a:lstStyle/>
-          <a:p>
-            <a:r>
-              <a:rPr sz="800">
-                <a:hlinkClick r:id="rId24"/>
-              </a:rPr>
-              <a:t>Lofar 1</a:t>
-            </a:r>
-          </a:p>
-          <a:p>
-            <a:r>
-              <a:rPr sz="800">
-                <a:hlinkClick r:id="rId25"/>
-              </a:rPr>
-              <a:t>Lofar 2</a:t>
-            </a:r>
-          </a:p>
-        </p:txBody>
-      </p:sp>
-      <p:sp>
-        <p:nvSpPr>
-          <p:cNvPr id="17" name="Rounded Rectangle 16"/>
-          <p:cNvSpPr/>
-          <p:nvPr>
-            <a:hlinkClick r:id="rId26"/>
-          </p:nvPr>
-        </p:nvSpPr>
-        <p:spPr>
-          <a:xfrm>
-            <a:off x="4948732" y="2682240"/>
-            <a:ext cx="2200046" cy="365760"/>
-          </a:xfrm>
-          <a:prstGeom prst="roundRect">
-            <a:avLst/>
-          </a:prstGeom>
-          <a:solidFill>
-            <a:srgbClr val="E8EEF7"/>
-          </a:solidFill>
-          <a:ln>
-            <a:solidFill>
-              <a:srgbClr val="1F3A5F"/>
-            </a:solidFill>
-          </a:ln>
-        </p:spPr>
-        <p:style>
-          <a:lnRef idx="1">
-            <a:schemeClr val="accent1"/>
-          </a:lnRef>
-          <a:fillRef idx="3">
-            <a:schemeClr val="accent1"/>
-          </a:fillRef>
-          <a:effectRef idx="2">
-            <a:schemeClr val="accent1"/>
-          </a:effectRef>
-          <a:fontRef idx="minor">
-            <a:schemeClr val="lt1"/>
-          </a:fontRef>
-        </p:style>
-        <p:txBody>
-          <a:bodyPr rtlCol="0" anchor="ctr" lIns="45720" rIns="45720"/>
-          <a:lstStyle/>
-          <a:p>
-            <a:pPr algn="ctr"/>
-            <a:r>
-              <a:rPr sz="900">
-                <a:solidFill>
-                  <a:srgbClr val="1F3A5F"/>
-                </a:solidFill>
-              </a:rPr>
-              <a:t>Gram 10: FR A-wing, Category 3, Risa</a:t>
-            </a:r>
-          </a:p>
-        </p:txBody>
-      </p:sp>
-      <p:sp>
-        <p:nvSpPr>
-          <p:cNvPr id="18" name="TextBox 17"/>
-          <p:cNvSpPr txBox="1"/>
-          <p:nvPr/>
-        </p:nvSpPr>
-        <p:spPr>
-          <a:xfrm>
-            <a:off x="4948732" y="3066288"/>
-            <a:ext cx="2200046" cy="1447800"/>
-          </a:xfrm>
-          <a:prstGeom prst="rect">
-            <a:avLst/>
-          </a:prstGeom>
-          <a:noFill/>
-        </p:spPr>
-        <p:txBody>
-          <a:bodyPr wrap="square">
-            <a:spAutoFit/>
-          </a:bodyPr>
-          <a:lstStyle/>
-          <a:p>
-            <a:r>
-              <a:rPr sz="800">
-                <a:hlinkClick r:id="rId27"/>
-              </a:rPr>
-              <a:t>Lofar 1</a:t>
-            </a:r>
-          </a:p>
-        </p:txBody>
-      </p:sp>
-      <p:sp>
-        <p:nvSpPr>
-          <p:cNvPr id="19" name="Rounded Rectangle 18"/>
-          <p:cNvSpPr/>
-          <p:nvPr>
-            <a:hlinkClick r:id="rId28"/>
-          </p:nvPr>
-        </p:nvSpPr>
-        <p:spPr>
-          <a:xfrm>
-            <a:off x="7240219" y="2682240"/>
-            <a:ext cx="2200046" cy="365760"/>
-          </a:xfrm>
-          <a:prstGeom prst="roundRect">
-            <a:avLst/>
-          </a:prstGeom>
-          <a:solidFill>
-            <a:srgbClr val="E8EEF7"/>
-          </a:solidFill>
-          <a:ln>
-            <a:solidFill>
-              <a:srgbClr val="1F3A5F"/>
-            </a:solidFill>
-          </a:ln>
-        </p:spPr>
-        <p:style>
-          <a:lnRef idx="1">
-            <a:schemeClr val="accent1"/>
-          </a:lnRef>
-          <a:fillRef idx="3">
-            <a:schemeClr val="accent1"/>
-          </a:fillRef>
-          <a:effectRef idx="2">
-            <a:schemeClr val="accent1"/>
-          </a:effectRef>
-          <a:fontRef idx="minor">
-            <a:schemeClr val="lt1"/>
-          </a:fontRef>
-        </p:style>
-        <p:txBody>
-          <a:bodyPr rtlCol="0" anchor="ctr" lIns="45720" rIns="45720"/>
-          <a:lstStyle/>
-          <a:p>
-            <a:pPr algn="ctr"/>
-            <a:r>
-              <a:rPr sz="900">
-                <a:solidFill>
-                  <a:srgbClr val="1F3A5F"/>
-                </a:solidFill>
-              </a:rPr>
-              <a:t>Gram 11: FR Star Destroyer, Category 1, Vulcan</a:t>
-            </a:r>
-          </a:p>
-        </p:txBody>
-      </p:sp>
-      <p:sp>
-        <p:nvSpPr>
-          <p:cNvPr id="20" name="TextBox 19"/>
-          <p:cNvSpPr txBox="1"/>
-          <p:nvPr/>
-        </p:nvSpPr>
-        <p:spPr>
-          <a:xfrm>
-            <a:off x="7240219" y="3066288"/>
-            <a:ext cx="2200046" cy="1447800"/>
-          </a:xfrm>
-          <a:prstGeom prst="rect">
-            <a:avLst/>
-          </a:prstGeom>
-          <a:noFill/>
-        </p:spPr>
-        <p:txBody>
-          <a:bodyPr wrap="square">
-            <a:spAutoFit/>
-          </a:bodyPr>
-          <a:lstStyle/>
-          <a:p>
-            <a:r>
-              <a:rPr sz="800">
-                <a:hlinkClick r:id="rId29"/>
-              </a:rPr>
-              <a:t>Lofar 1</a:t>
-            </a:r>
-          </a:p>
-        </p:txBody>
-      </p:sp>
-      <p:sp>
-        <p:nvSpPr>
-          <p:cNvPr id="21" name="Rounded Rectangle 20"/>
-          <p:cNvSpPr/>
-          <p:nvPr>
-            <a:hlinkClick r:id="rId30"/>
-          </p:nvPr>
-        </p:nvSpPr>
-        <p:spPr>
-          <a:xfrm>
-            <a:off x="9531705" y="2682240"/>
-            <a:ext cx="2200046" cy="365760"/>
-          </a:xfrm>
-          <a:prstGeom prst="roundRect">
-            <a:avLst/>
-          </a:prstGeom>
-          <a:solidFill>
-            <a:srgbClr val="E8EEF7"/>
-          </a:solidFill>
-          <a:ln>
-            <a:solidFill>
-              <a:srgbClr val="1F3A5F"/>
-            </a:solidFill>
-          </a:ln>
-        </p:spPr>
-        <p:style>
-          <a:lnRef idx="1">
-            <a:schemeClr val="accent1"/>
-          </a:lnRef>
-          <a:fillRef idx="3">
-            <a:schemeClr val="accent1"/>
-          </a:fillRef>
-          <a:effectRef idx="2">
-            <a:schemeClr val="accent1"/>
-          </a:effectRef>
-          <a:fontRef idx="minor">
-            <a:schemeClr val="lt1"/>
-          </a:fontRef>
-        </p:style>
-        <p:txBody>
-          <a:bodyPr rtlCol="0" anchor="ctr" lIns="45720" rIns="45720"/>
-          <a:lstStyle/>
-          <a:p>
-            <a:pPr algn="ctr"/>
-            <a:r>
-              <a:rPr sz="900">
-                <a:solidFill>
-                  <a:srgbClr val="1F3A5F"/>
-                </a:solidFill>
-              </a:rPr>
-              <a:t>Gram 12: Venator-class contact bearing 330, codename Dank</a:t>
-            </a:r>
-          </a:p>
-        </p:txBody>
-      </p:sp>
-      <p:sp>
-        <p:nvSpPr>
-          <p:cNvPr id="22" name="TextBox 21"/>
-          <p:cNvSpPr txBox="1"/>
-          <p:nvPr/>
-        </p:nvSpPr>
-        <p:spPr>
-          <a:xfrm>
-            <a:off x="9531705" y="3066288"/>
-            <a:ext cx="2200046" cy="1447800"/>
-          </a:xfrm>
-          <a:prstGeom prst="rect">
-            <a:avLst/>
-          </a:prstGeom>
-          <a:noFill/>
-        </p:spPr>
-        <p:txBody>
-          <a:bodyPr wrap="square">
-            <a:spAutoFit/>
-          </a:bodyPr>
-          <a:lstStyle/>
-          <a:p>
-            <a:r>
-              <a:rPr sz="800">
-                <a:hlinkClick r:id="rId31"/>
-              </a:rPr>
-              <a:t>Lofar 1</a:t>
-            </a:r>
-          </a:p>
-          <a:p>
-            <a:r>
-              <a:rPr sz="800">
-                <a:hlinkClick r:id="rId32"/>
-              </a:rPr>
-              <a:t>Lofar 2</a:t>
-            </a:r>
-          </a:p>
-          <a:p>
-            <a:r>
-              <a:rPr sz="800">
-                <a:hlinkClick r:id="rId33"/>
-              </a:rPr>
-              <a:t>Lofar 3</a:t>
-            </a:r>
-          </a:p>
-          <a:p>
-            <a:r>
-              <a:rPr sz="800">
-                <a:hlinkClick r:id="rId34"/>
-              </a:rPr>
-              <a:t>Lofar 4</a:t>
-            </a:r>
-          </a:p>
-        </p:txBody>
-      </p:sp>
-      <p:sp>
-        <p:nvSpPr>
-          <p:cNvPr id="23" name="Rounded Rectangle 22"/>
-          <p:cNvSpPr/>
-          <p:nvPr>
-            <a:hlinkClick r:id="rId35"/>
-          </p:nvPr>
-        </p:nvSpPr>
-        <p:spPr>
-          <a:xfrm>
-            <a:off x="365760" y="4632960"/>
-            <a:ext cx="2200046" cy="365760"/>
-          </a:xfrm>
-          <a:prstGeom prst="roundRect">
-            <a:avLst/>
-          </a:prstGeom>
-          <a:solidFill>
-            <a:srgbClr val="E8EEF7"/>
-          </a:solidFill>
-          <a:ln>
-            <a:solidFill>
-              <a:srgbClr val="1F3A5F"/>
-            </a:solidFill>
-          </a:ln>
-        </p:spPr>
-        <p:style>
-          <a:lnRef idx="1">
-            <a:schemeClr val="accent1"/>
-          </a:lnRef>
-          <a:fillRef idx="3">
-            <a:schemeClr val="accent1"/>
-          </a:fillRef>
-          <a:effectRef idx="2">
-            <a:schemeClr val="accent1"/>
-          </a:effectRef>
-          <a:fontRef idx="minor">
-            <a:schemeClr val="lt1"/>
-          </a:fontRef>
-        </p:style>
-        <p:txBody>
-          <a:bodyPr rtlCol="0" anchor="ctr" lIns="45720" rIns="45720"/>
-          <a:lstStyle/>
-          <a:p>
-            <a:pPr algn="ctr"/>
-            <a:r>
-              <a:rPr sz="900">
-                <a:solidFill>
-                  <a:srgbClr val="1F3A5F"/>
-                </a:solidFill>
-              </a:rPr>
-              <a:t>Gram 13: FR Outrider, Category 1, Coruscant</a:t>
-            </a:r>
-          </a:p>
-        </p:txBody>
-      </p:sp>
-      <p:sp>
-        <p:nvSpPr>
-          <p:cNvPr id="24" name="TextBox 23"/>
-          <p:cNvSpPr txBox="1"/>
-          <p:nvPr/>
-        </p:nvSpPr>
-        <p:spPr>
-          <a:xfrm>
-            <a:off x="365760" y="5017008"/>
-            <a:ext cx="2200046" cy="1447800"/>
-          </a:xfrm>
-          <a:prstGeom prst="rect">
-            <a:avLst/>
-          </a:prstGeom>
-          <a:noFill/>
-        </p:spPr>
-        <p:txBody>
-          <a:bodyPr wrap="square">
-            <a:spAutoFit/>
-          </a:bodyPr>
-          <a:lstStyle/>
-          <a:p>
-            <a:r>
-              <a:rPr sz="800">
-                <a:hlinkClick r:id="rId36"/>
-              </a:rPr>
-              <a:t>Lofar 1</a:t>
-            </a:r>
-          </a:p>
-          <a:p>
-            <a:r>
-              <a:rPr sz="800">
-                <a:hlinkClick r:id="rId37"/>
-              </a:rPr>
-              <a:t>Lofar 2</a:t>
-            </a:r>
-          </a:p>
-          <a:p>
-            <a:r>
-              <a:rPr sz="800">
-                <a:hlinkClick r:id="rId38"/>
-              </a:rPr>
-              <a:t>Lofar 3</a:t>
-            </a:r>
-          </a:p>
-        </p:txBody>
-      </p:sp>
-      <p:sp>
-        <p:nvSpPr>
-          <p:cNvPr id="25" name="Rounded Rectangle 24"/>
-          <p:cNvSpPr/>
-          <p:nvPr>
-            <a:hlinkClick r:id="rId39"/>
-          </p:nvPr>
-        </p:nvSpPr>
-        <p:spPr>
-          <a:xfrm>
-            <a:off x="2657246" y="4632960"/>
-            <a:ext cx="2200046" cy="365760"/>
-          </a:xfrm>
-          <a:prstGeom prst="roundRect">
-            <a:avLst/>
-          </a:prstGeom>
-          <a:solidFill>
-            <a:srgbClr val="E8EEF7"/>
-          </a:solidFill>
-          <a:ln>
-            <a:solidFill>
-              <a:srgbClr val="1F3A5F"/>
-            </a:solidFill>
-          </a:ln>
-        </p:spPr>
-        <p:style>
-          <a:lnRef idx="1">
-            <a:schemeClr val="accent1"/>
-          </a:lnRef>
-          <a:fillRef idx="3">
-            <a:schemeClr val="accent1"/>
-          </a:fillRef>
-          <a:effectRef idx="2">
-            <a:schemeClr val="accent1"/>
-          </a:effectRef>
-          <a:fontRef idx="minor">
-            <a:schemeClr val="lt1"/>
-          </a:fontRef>
-        </p:style>
-        <p:txBody>
-          <a:bodyPr rtlCol="0" anchor="ctr" lIns="45720" rIns="45720"/>
-          <a:lstStyle/>
-          <a:p>
-            <a:pPr algn="ctr"/>
-            <a:r>
-              <a:rPr sz="900">
-                <a:solidFill>
-                  <a:srgbClr val="1F3A5F"/>
-                </a:solidFill>
-              </a:rPr>
-              <a:t>Gram 14: Cerritos contact bearing 210, codename Betazed</a:t>
-            </a:r>
-          </a:p>
-        </p:txBody>
-      </p:sp>
-      <p:sp>
-        <p:nvSpPr>
-          <p:cNvPr id="26" name="TextBox 25"/>
-          <p:cNvSpPr txBox="1"/>
-          <p:nvPr/>
-        </p:nvSpPr>
-        <p:spPr>
-          <a:xfrm>
-            <a:off x="2657246" y="5017008"/>
-            <a:ext cx="2200046" cy="1447800"/>
-          </a:xfrm>
-          <a:prstGeom prst="rect">
-            <a:avLst/>
-          </a:prstGeom>
-          <a:noFill/>
-        </p:spPr>
-        <p:txBody>
-          <a:bodyPr wrap="square">
-            <a:spAutoFit/>
-          </a:bodyPr>
-          <a:lstStyle/>
-          <a:p>
-            <a:r>
-              <a:rPr sz="800">
-                <a:hlinkClick r:id="rId40"/>
-              </a:rPr>
-              <a:t>Lofar 1</a:t>
-            </a:r>
-          </a:p>
-          <a:p>
-            <a:r>
-              <a:rPr sz="800">
-                <a:hlinkClick r:id="rId41"/>
-              </a:rPr>
-              <a:t>Lofar 2</a:t>
-            </a:r>
-          </a:p>
-          <a:p>
-            <a:r>
-              <a:rPr sz="800">
-                <a:hlinkClick r:id="rId42"/>
-              </a:rPr>
-              <a:t>Lofar 3</a:t>
-            </a:r>
-          </a:p>
-          <a:p>
-            <a:r>
-              <a:rPr sz="800">
-                <a:hlinkClick r:id="rId43"/>
-              </a:rPr>
-              <a:t>Lofar 4</a:t>
-            </a:r>
-          </a:p>
-        </p:txBody>
-      </p:sp>
-      <p:sp>
-        <p:nvSpPr>
-          <p:cNvPr id="27" name="Rounded Rectangle 26"/>
-          <p:cNvSpPr/>
-          <p:nvPr>
-            <a:hlinkClick r:id="rId44"/>
-          </p:nvPr>
-        </p:nvSpPr>
-        <p:spPr>
-          <a:xfrm>
-            <a:off x="4948732" y="4632960"/>
-            <a:ext cx="2200046" cy="365760"/>
-          </a:xfrm>
-          <a:prstGeom prst="roundRect">
-            <a:avLst/>
-          </a:prstGeom>
-          <a:solidFill>
-            <a:srgbClr val="E8EEF7"/>
-          </a:solidFill>
-          <a:ln>
-            <a:solidFill>
-              <a:srgbClr val="1F3A5F"/>
-            </a:solidFill>
-          </a:ln>
-        </p:spPr>
-        <p:style>
-          <a:lnRef idx="1">
-            <a:schemeClr val="accent1"/>
-          </a:lnRef>
-          <a:fillRef idx="3">
-            <a:schemeClr val="accent1"/>
-          </a:fillRef>
-          <a:effectRef idx="2">
-            <a:schemeClr val="accent1"/>
-          </a:effectRef>
-          <a:fontRef idx="minor">
-            <a:schemeClr val="lt1"/>
-          </a:fontRef>
-        </p:style>
-        <p:txBody>
-          <a:bodyPr rtlCol="0" anchor="ctr" lIns="45720" rIns="45720"/>
-          <a:lstStyle/>
-          <a:p>
-            <a:pPr algn="ctr"/>
-            <a:r>
-              <a:rPr sz="900">
-                <a:solidFill>
-                  <a:srgbClr val="1F3A5F"/>
-                </a:solidFill>
-              </a:rPr>
-              <a:t>Gram 15: FR Voyager, Category 1, Gandalf</a:t>
-            </a:r>
-          </a:p>
-        </p:txBody>
-      </p:sp>
-      <p:sp>
-        <p:nvSpPr>
-          <p:cNvPr id="28" name="TextBox 27"/>
-          <p:cNvSpPr txBox="1"/>
-          <p:nvPr/>
-        </p:nvSpPr>
-        <p:spPr>
-          <a:xfrm>
-            <a:off x="4948732" y="5017008"/>
-            <a:ext cx="2200046" cy="1447800"/>
-          </a:xfrm>
-          <a:prstGeom prst="rect">
-            <a:avLst/>
-          </a:prstGeom>
-          <a:noFill/>
-        </p:spPr>
-        <p:txBody>
-          <a:bodyPr wrap="square">
-            <a:spAutoFit/>
-          </a:bodyPr>
-          <a:lstStyle/>
-          <a:p>
-            <a:r>
-              <a:rPr sz="800">
-                <a:hlinkClick r:id="rId45"/>
-              </a:rPr>
-              <a:t>Lofar 1</a:t>
-            </a:r>
-          </a:p>
-          <a:p>
-            <a:r>
-              <a:rPr sz="800">
-                <a:hlinkClick r:id="rId46"/>
-              </a:rPr>
-              <a:t>Lofar 2</a:t>
-            </a:r>
-          </a:p>
-        </p:txBody>
-      </p:sp>
-      <p:sp>
-        <p:nvSpPr>
-          <p:cNvPr id="29" name="Rounded Rectangle 28"/>
-          <p:cNvSpPr/>
-          <p:nvPr>
-            <a:hlinkClick r:id="rId47"/>
-          </p:nvPr>
-        </p:nvSpPr>
-        <p:spPr>
-          <a:xfrm>
-            <a:off x="7240219" y="4632960"/>
-            <a:ext cx="2200046" cy="365760"/>
-          </a:xfrm>
-          <a:prstGeom prst="roundRect">
-            <a:avLst/>
-          </a:prstGeom>
-          <a:solidFill>
-            <a:srgbClr val="E8EEF7"/>
-          </a:solidFill>
-          <a:ln>
-            <a:solidFill>
-              <a:srgbClr val="1F3A5F"/>
-            </a:solidFill>
-          </a:ln>
-        </p:spPr>
-        <p:style>
-          <a:lnRef idx="1">
-            <a:schemeClr val="accent1"/>
-          </a:lnRef>
-          <a:fillRef idx="3">
-            <a:schemeClr val="accent1"/>
-          </a:fillRef>
-          <a:effectRef idx="2">
-            <a:schemeClr val="accent1"/>
-          </a:effectRef>
-          <a:fontRef idx="minor">
-            <a:schemeClr val="lt1"/>
-          </a:fontRef>
-        </p:style>
-        <p:txBody>
-          <a:bodyPr rtlCol="0" anchor="ctr" lIns="45720" rIns="45720"/>
-          <a:lstStyle/>
-          <a:p>
-            <a:pPr algn="ctr"/>
-            <a:r>
-              <a:rPr sz="900">
-                <a:solidFill>
-                  <a:srgbClr val="1F3A5F"/>
-                </a:solidFill>
-              </a:rPr>
-              <a:t>Gram 16: FR Intrepid-class, Category 2, Tatooine</a:t>
-            </a:r>
-          </a:p>
-        </p:txBody>
-      </p:sp>
-      <p:sp>
-        <p:nvSpPr>
-          <p:cNvPr id="30" name="TextBox 29"/>
-          <p:cNvSpPr txBox="1"/>
-          <p:nvPr/>
-        </p:nvSpPr>
-        <p:spPr>
-          <a:xfrm>
-            <a:off x="7240219" y="5017008"/>
-            <a:ext cx="2200046" cy="1447800"/>
-          </a:xfrm>
-          <a:prstGeom prst="rect">
-            <a:avLst/>
-          </a:prstGeom>
-          <a:noFill/>
-        </p:spPr>
-        <p:txBody>
-          <a:bodyPr wrap="square">
-            <a:spAutoFit/>
-          </a:bodyPr>
-          <a:lstStyle/>
-          <a:p>
-            <a:r>
-              <a:rPr sz="800">
-                <a:hlinkClick r:id="rId48"/>
-              </a:rPr>
-              <a:t>Lofar 1</a:t>
-            </a:r>
-          </a:p>
-          <a:p>
-            <a:r>
-              <a:rPr sz="800">
-                <a:hlinkClick r:id="rId49"/>
-              </a:rPr>
-              <a:t>Lofar 2</a:t>
-            </a:r>
-          </a:p>
-          <a:p>
-            <a:r>
-              <a:rPr sz="800">
-                <a:hlinkClick r:id="rId50"/>
-              </a:rPr>
-              <a:t>Lofar 3</a:t>
-            </a:r>
-          </a:p>
-        </p:txBody>
-      </p:sp>
-      <p:sp>
-        <p:nvSpPr>
-          <p:cNvPr id="31" name="Rounded Rectangle 30"/>
-          <p:cNvSpPr/>
-          <p:nvPr>
-            <a:hlinkClick r:id="rId51"/>
-          </p:nvPr>
-        </p:nvSpPr>
-        <p:spPr>
-          <a:xfrm>
-            <a:off x="9531705" y="4632960"/>
-            <a:ext cx="2200046" cy="365760"/>
-          </a:xfrm>
-          <a:prstGeom prst="roundRect">
-            <a:avLst/>
-          </a:prstGeom>
-          <a:solidFill>
-            <a:srgbClr val="E8EEF7"/>
-          </a:solidFill>
-          <a:ln>
-            <a:solidFill>
-              <a:srgbClr val="1F3A5F"/>
-            </a:solidFill>
-          </a:ln>
-        </p:spPr>
-        <p:style>
-          <a:lnRef idx="1">
-            <a:schemeClr val="accent1"/>
-          </a:lnRef>
-          <a:fillRef idx="3">
-            <a:schemeClr val="accent1"/>
-          </a:fillRef>
-          <a:effectRef idx="2">
-            <a:schemeClr val="accent1"/>
-          </a:effectRef>
-          <a:fontRef idx="minor">
-            <a:schemeClr val="lt1"/>
-          </a:fontRef>
-        </p:style>
-        <p:txBody>
-          <a:bodyPr rtlCol="0" anchor="ctr" lIns="45720" rIns="45720"/>
-          <a:lstStyle/>
-          <a:p>
-            <a:pPr algn="ctr"/>
-            <a:r>
-              <a:rPr sz="900">
-                <a:solidFill>
-                  <a:srgbClr val="1F3A5F"/>
-                </a:solidFill>
-              </a:rPr>
-              <a:t>Gram 18: FR B-wing, Category 3, Mustafar</a:t>
-            </a:r>
-          </a:p>
-        </p:txBody>
-      </p:sp>
-      <p:sp>
-        <p:nvSpPr>
-          <p:cNvPr id="32" name="TextBox 31"/>
-          <p:cNvSpPr txBox="1"/>
-          <p:nvPr/>
-        </p:nvSpPr>
-        <p:spPr>
-          <a:xfrm>
-            <a:off x="9531705" y="5017008"/>
-            <a:ext cx="2200046" cy="1447800"/>
-          </a:xfrm>
-          <a:prstGeom prst="rect">
-            <a:avLst/>
-          </a:prstGeom>
-          <a:noFill/>
-        </p:spPr>
-        <p:txBody>
-          <a:bodyPr wrap="square">
-            <a:spAutoFit/>
-          </a:bodyPr>
-          <a:lstStyle/>
-          <a:p>
-            <a:r>
-              <a:rPr sz="800">
-                <a:hlinkClick r:id="rId52"/>
-              </a:rPr>
-              <a:t>Lofar 1</a:t>
-            </a:r>
-          </a:p>
-          <a:p>
-            <a:r>
-              <a:rPr sz="800">
-                <a:hlinkClick r:id="rId53"/>
-              </a:rPr>
-              <a:t>Lofar 2</a:t>
-            </a:r>
-          </a:p>
-          <a:p>
-            <a:r>
-              <a:rPr sz="800">
-                <a:hlinkClick r:id="rId54"/>
-              </a:rPr>
-              <a:t>Lofar 3</a:t>
-            </a:r>
-          </a:p>
-          <a:p>
-            <a:r>
-              <a:rPr sz="800">
-                <a:hlinkClick r:id="rId55"/>
-              </a:rPr>
-              <a:t>Lofar 4</a:t>
+              <a:t>Instructor Version</a:t>
             </a:r>
           </a:p>
         </p:txBody>
@@ -4687,7 +3224,7 @@
                   <a:srgbClr val="FFFFFF"/>
                 </a:solidFill>
               </a:rPr>
-              <a:t>Instructor Progress Final Assessment Grams — Page 2 of 3</a:t>
+              <a:t>Instructor Progress Final Assessment Grams — Page 1 of 3</a:t>
             </a:r>
           </a:p>
         </p:txBody>
@@ -4742,7 +3279,7 @@
                   <a:srgbClr val="1F3A5F"/>
                 </a:solidFill>
               </a:rPr>
-              <a:t>Gram 19: FR X-wing, Category 3, Dagobah</a:t>
+              <a:t>Gram 1: FR TIE Bomber, Category 3, Tatooine</a:t>
             </a:r>
           </a:p>
         </p:txBody>
@@ -4776,14 +3313,6 @@
               <a:t>Lofar 1</a:t>
             </a:r>
           </a:p>
-          <a:p>
-            <a:r>
-              <a:rPr sz="800">
-                <a:hlinkClick r:id="rId4"/>
-              </a:rPr>
-              <a:t>Lofar 2</a:t>
-            </a:r>
-          </a:p>
         </p:txBody>
       </p:sp>
       <p:sp>
@@ -4791,7 +3320,7 @@
           <p:cNvPr id="5" name="Rounded Rectangle 4"/>
           <p:cNvSpPr/>
           <p:nvPr>
-            <a:hlinkClick r:id="rId5"/>
+            <a:hlinkClick r:id="rId4"/>
           </p:nvPr>
         </p:nvSpPr>
         <p:spPr>
@@ -4836,7 +3365,7 @@
                   <a:srgbClr val="1F3A5F"/>
                 </a:solidFill>
               </a:rPr>
-              <a:t>Gram 22: FR Razor Crest, Category 4, Dank</a:t>
+              <a:t>Gram 2: FR Sovereign-class, Category 1, Tatooine</a:t>
             </a:r>
           </a:p>
         </p:txBody>
@@ -4865,9 +3394,25 @@
           <a:p>
             <a:r>
               <a:rPr sz="800">
+                <a:hlinkClick r:id="rId5"/>
+              </a:rPr>
+              <a:t>Lofar 1</a:t>
+            </a:r>
+          </a:p>
+          <a:p>
+            <a:r>
+              <a:rPr sz="800">
                 <a:hlinkClick r:id="rId6"/>
               </a:rPr>
-              <a:t>Lofar 1</a:t>
+              <a:t>Lofar 2</a:t>
+            </a:r>
+          </a:p>
+          <a:p>
+            <a:r>
+              <a:rPr sz="800">
+                <a:hlinkClick r:id="rId7"/>
+              </a:rPr>
+              <a:t>Lofar 3</a:t>
             </a:r>
           </a:p>
         </p:txBody>
@@ -4877,7 +3422,7 @@
           <p:cNvPr id="7" name="Rounded Rectangle 6"/>
           <p:cNvSpPr/>
           <p:nvPr>
-            <a:hlinkClick r:id="rId7"/>
+            <a:hlinkClick r:id="rId8"/>
           </p:nvPr>
         </p:nvSpPr>
         <p:spPr>
@@ -4922,7 +3467,7 @@
                   <a:srgbClr val="1F3A5F"/>
                 </a:solidFill>
               </a:rPr>
-              <a:t>Gram 23: FR Outrider, Category 3, Cardassia</a:t>
+              <a:t>Gram 3: FR TIE Fighter, Category 4, Mustafar</a:t>
             </a:r>
           </a:p>
         </p:txBody>
@@ -4951,7 +3496,7 @@
           <a:p>
             <a:r>
               <a:rPr sz="800">
-                <a:hlinkClick r:id="rId8"/>
+                <a:hlinkClick r:id="rId9"/>
               </a:rPr>
               <a:t>Lofar 1</a:t>
             </a:r>
@@ -4959,7 +3504,7 @@
           <a:p>
             <a:r>
               <a:rPr sz="800">
-                <a:hlinkClick r:id="rId9"/>
+                <a:hlinkClick r:id="rId10"/>
               </a:rPr>
               <a:t>Lofar 2</a:t>
             </a:r>
@@ -4967,7 +3512,7 @@
           <a:p>
             <a:r>
               <a:rPr sz="800">
-                <a:hlinkClick r:id="rId10"/>
+                <a:hlinkClick r:id="rId11"/>
               </a:rPr>
               <a:t>Lofar 3</a:t>
             </a:r>
@@ -4979,7 +3524,7 @@
           <p:cNvPr id="9" name="Rounded Rectangle 8"/>
           <p:cNvSpPr/>
           <p:nvPr>
-            <a:hlinkClick r:id="rId11"/>
+            <a:hlinkClick r:id="rId12"/>
           </p:nvPr>
         </p:nvSpPr>
         <p:spPr>
@@ -5024,7 +3569,7 @@
                   <a:srgbClr val="1F3A5F"/>
                 </a:solidFill>
               </a:rPr>
-              <a:t>Gram 25: FR Ghost, Category 3, Trill</a:t>
+              <a:t>Gram 4: FR Intrepid-class, Category 4, Mustafar</a:t>
             </a:r>
           </a:p>
         </p:txBody>
@@ -5053,7 +3598,7 @@
           <a:p>
             <a:r>
               <a:rPr sz="800">
-                <a:hlinkClick r:id="rId12"/>
+                <a:hlinkClick r:id="rId13"/>
               </a:rPr>
               <a:t>Lofar 1</a:t>
             </a:r>
@@ -5061,7 +3606,7 @@
           <a:p>
             <a:r>
               <a:rPr sz="800">
-                <a:hlinkClick r:id="rId13"/>
+                <a:hlinkClick r:id="rId14"/>
               </a:rPr>
               <a:t>Lofar 2</a:t>
             </a:r>
@@ -5069,7 +3614,7 @@
           <a:p>
             <a:r>
               <a:rPr sz="800">
-                <a:hlinkClick r:id="rId14"/>
+                <a:hlinkClick r:id="rId15"/>
               </a:rPr>
               <a:t>Lofar 3</a:t>
             </a:r>
@@ -5081,7 +3626,7 @@
           <p:cNvPr id="11" name="Rounded Rectangle 10"/>
           <p:cNvSpPr/>
           <p:nvPr>
-            <a:hlinkClick r:id="rId15"/>
+            <a:hlinkClick r:id="rId16"/>
           </p:nvPr>
         </p:nvSpPr>
         <p:spPr>
@@ -5126,7 +3671,7 @@
                   <a:srgbClr val="1F3A5F"/>
                 </a:solidFill>
               </a:rPr>
-              <a:t>Gram 26: FR Ghost, Category 1, Trill</a:t>
+              <a:t>Gram 7: FR Discovery, Category 1, Dagobah</a:t>
             </a:r>
           </a:p>
         </p:txBody>
@@ -5155,7 +3700,7 @@
           <a:p>
             <a:r>
               <a:rPr sz="800">
-                <a:hlinkClick r:id="rId16"/>
+                <a:hlinkClick r:id="rId17"/>
               </a:rPr>
               <a:t>Lofar 1</a:t>
             </a:r>
@@ -5167,7 +3712,7 @@
           <p:cNvPr id="13" name="Rounded Rectangle 12"/>
           <p:cNvSpPr/>
           <p:nvPr>
-            <a:hlinkClick r:id="rId17"/>
+            <a:hlinkClick r:id="rId18"/>
           </p:nvPr>
         </p:nvSpPr>
         <p:spPr>
@@ -5212,7 +3757,7 @@
                   <a:srgbClr val="1F3A5F"/>
                 </a:solidFill>
               </a:rPr>
-              <a:t>Gram 27: Cerritos contact bearing 270, codename Vulcan</a:t>
+              <a:t>Gram 8: Miranda-class contact bearing 288, codename Dank</a:t>
             </a:r>
           </a:p>
         </p:txBody>
@@ -5241,7 +3786,7 @@
           <a:p>
             <a:r>
               <a:rPr sz="800">
-                <a:hlinkClick r:id="rId18"/>
+                <a:hlinkClick r:id="rId19"/>
               </a:rPr>
               <a:t>Lofar 1</a:t>
             </a:r>
@@ -5249,7 +3794,7 @@
           <a:p>
             <a:r>
               <a:rPr sz="800">
-                <a:hlinkClick r:id="rId19"/>
+                <a:hlinkClick r:id="rId20"/>
               </a:rPr>
               <a:t>Lofar 2</a:t>
             </a:r>
@@ -5257,9 +3802,17 @@
           <a:p>
             <a:r>
               <a:rPr sz="800">
-                <a:hlinkClick r:id="rId20"/>
+                <a:hlinkClick r:id="rId21"/>
               </a:rPr>
               <a:t>Lofar 3</a:t>
+            </a:r>
+          </a:p>
+          <a:p>
+            <a:r>
+              <a:rPr sz="800">
+                <a:hlinkClick r:id="rId22"/>
+              </a:rPr>
+              <a:t>Lofar 4</a:t>
             </a:r>
           </a:p>
         </p:txBody>
@@ -5269,7 +3822,7 @@
           <p:cNvPr id="15" name="Rounded Rectangle 14"/>
           <p:cNvSpPr/>
           <p:nvPr>
-            <a:hlinkClick r:id="rId21"/>
+            <a:hlinkClick r:id="rId23"/>
           </p:nvPr>
         </p:nvSpPr>
         <p:spPr>
@@ -5314,7 +3867,7 @@
                   <a:srgbClr val="1F3A5F"/>
                 </a:solidFill>
               </a:rPr>
-              <a:t>Gram 28: Defiant contact bearing 357, codename Vulcan</a:t>
+              <a:t>Gram 9: Enterprise contact bearing 084, codename Yavin</a:t>
             </a:r>
           </a:p>
         </p:txBody>
@@ -5343,7 +3896,7 @@
           <a:p>
             <a:r>
               <a:rPr sz="800">
-                <a:hlinkClick r:id="rId22"/>
+                <a:hlinkClick r:id="rId24"/>
               </a:rPr>
               <a:t>Lofar 1</a:t>
             </a:r>
@@ -5351,7 +3904,7 @@
           <a:p>
             <a:r>
               <a:rPr sz="800">
-                <a:hlinkClick r:id="rId23"/>
+                <a:hlinkClick r:id="rId25"/>
               </a:rPr>
               <a:t>Lofar 2</a:t>
             </a:r>
@@ -5363,7 +3916,7 @@
           <p:cNvPr id="17" name="Rounded Rectangle 16"/>
           <p:cNvSpPr/>
           <p:nvPr>
-            <a:hlinkClick r:id="rId24"/>
+            <a:hlinkClick r:id="rId26"/>
           </p:nvPr>
         </p:nvSpPr>
         <p:spPr>
@@ -5408,7 +3961,7 @@
                   <a:srgbClr val="1F3A5F"/>
                 </a:solidFill>
               </a:rPr>
-              <a:t>Gram 29: Imperial-class contact bearing 080, codename Gandalf</a:t>
+              <a:t>Gram 10: FR A-wing, Category 3, Risa</a:t>
             </a:r>
           </a:p>
         </p:txBody>
@@ -5437,7 +3990,7 @@
           <a:p>
             <a:r>
               <a:rPr sz="800">
-                <a:hlinkClick r:id="rId25"/>
+                <a:hlinkClick r:id="rId27"/>
               </a:rPr>
               <a:t>Lofar 1</a:t>
             </a:r>
@@ -5449,7 +4002,7 @@
           <p:cNvPr id="19" name="Rounded Rectangle 18"/>
           <p:cNvSpPr/>
           <p:nvPr>
-            <a:hlinkClick r:id="rId26"/>
+            <a:hlinkClick r:id="rId28"/>
           </p:nvPr>
         </p:nvSpPr>
         <p:spPr>
@@ -5494,7 +4047,7 @@
                   <a:srgbClr val="1F3A5F"/>
                 </a:solidFill>
               </a:rPr>
-              <a:t>Gram 30: Excelsior contact bearing 009, codename Cardassia</a:t>
+              <a:t>Gram 11: FR Star Destroyer, Category 1, Vulcan</a:t>
             </a:r>
           </a:p>
         </p:txBody>
@@ -5523,7 +4076,7 @@
           <a:p>
             <a:r>
               <a:rPr sz="800">
-                <a:hlinkClick r:id="rId27"/>
+                <a:hlinkClick r:id="rId29"/>
               </a:rPr>
               <a:t>Lofar 1</a:t>
             </a:r>
@@ -5535,7 +4088,7 @@
           <p:cNvPr id="21" name="Rounded Rectangle 20"/>
           <p:cNvSpPr/>
           <p:nvPr>
-            <a:hlinkClick r:id="rId28"/>
+            <a:hlinkClick r:id="rId30"/>
           </p:nvPr>
         </p:nvSpPr>
         <p:spPr>
@@ -5580,7 +4133,7 @@
                   <a:srgbClr val="1F3A5F"/>
                 </a:solidFill>
               </a:rPr>
-              <a:t>Gram 31: FR Rebel One, Category 1, Endor</a:t>
+              <a:t>Gram 12: Venator-class contact bearing 330, codename Dank</a:t>
             </a:r>
           </a:p>
         </p:txBody>
@@ -5609,7 +4162,7 @@
           <a:p>
             <a:r>
               <a:rPr sz="800">
-                <a:hlinkClick r:id="rId29"/>
+                <a:hlinkClick r:id="rId31"/>
               </a:rPr>
               <a:t>Lofar 1</a:t>
             </a:r>
@@ -5617,7 +4170,7 @@
           <a:p>
             <a:r>
               <a:rPr sz="800">
-                <a:hlinkClick r:id="rId30"/>
+                <a:hlinkClick r:id="rId32"/>
               </a:rPr>
               <a:t>Lofar 2</a:t>
             </a:r>
@@ -5625,7 +4178,7 @@
           <a:p>
             <a:r>
               <a:rPr sz="800">
-                <a:hlinkClick r:id="rId31"/>
+                <a:hlinkClick r:id="rId33"/>
               </a:rPr>
               <a:t>Lofar 3</a:t>
             </a:r>
@@ -5633,7 +4186,7 @@
           <a:p>
             <a:r>
               <a:rPr sz="800">
-                <a:hlinkClick r:id="rId32"/>
+                <a:hlinkClick r:id="rId34"/>
               </a:rPr>
               <a:t>Lofar 4</a:t>
             </a:r>
@@ -5645,7 +4198,7 @@
           <p:cNvPr id="23" name="Rounded Rectangle 22"/>
           <p:cNvSpPr/>
           <p:nvPr>
-            <a:hlinkClick r:id="rId33"/>
+            <a:hlinkClick r:id="rId35"/>
           </p:nvPr>
         </p:nvSpPr>
         <p:spPr>
@@ -5690,7 +4243,7 @@
                   <a:srgbClr val="1F3A5F"/>
                 </a:solidFill>
               </a:rPr>
-              <a:t>Gram 33: FR Galaxy-class, Category 2, Mustafar</a:t>
+              <a:t>Gram 13: FR Outrider, Category 1, Coruscant</a:t>
             </a:r>
           </a:p>
         </p:txBody>
@@ -5719,7 +4272,7 @@
           <a:p>
             <a:r>
               <a:rPr sz="800">
-                <a:hlinkClick r:id="rId34"/>
+                <a:hlinkClick r:id="rId36"/>
               </a:rPr>
               <a:t>Lofar 1</a:t>
             </a:r>
@@ -5727,7 +4280,7 @@
           <a:p>
             <a:r>
               <a:rPr sz="800">
-                <a:hlinkClick r:id="rId35"/>
+                <a:hlinkClick r:id="rId37"/>
               </a:rPr>
               <a:t>Lofar 2</a:t>
             </a:r>
@@ -5735,7 +4288,7 @@
           <a:p>
             <a:r>
               <a:rPr sz="800">
-                <a:hlinkClick r:id="rId36"/>
+                <a:hlinkClick r:id="rId38"/>
               </a:rPr>
               <a:t>Lofar 3</a:t>
             </a:r>
@@ -5747,7 +4300,7 @@
           <p:cNvPr id="25" name="Rounded Rectangle 24"/>
           <p:cNvSpPr/>
           <p:nvPr>
-            <a:hlinkClick r:id="rId37"/>
+            <a:hlinkClick r:id="rId39"/>
           </p:nvPr>
         </p:nvSpPr>
         <p:spPr>
@@ -5792,7 +4345,7 @@
                   <a:srgbClr val="1F3A5F"/>
                 </a:solidFill>
               </a:rPr>
-              <a:t>Gram 34: Reliant contact bearing 192, codename Romulus</a:t>
+              <a:t>Gram 14: Cerritos contact bearing 210, codename Betazed</a:t>
             </a:r>
           </a:p>
         </p:txBody>
@@ -5821,7 +4374,7 @@
           <a:p>
             <a:r>
               <a:rPr sz="800">
-                <a:hlinkClick r:id="rId38"/>
+                <a:hlinkClick r:id="rId40"/>
               </a:rPr>
               <a:t>Lofar 1</a:t>
             </a:r>
@@ -5829,7 +4382,7 @@
           <a:p>
             <a:r>
               <a:rPr sz="800">
-                <a:hlinkClick r:id="rId39"/>
+                <a:hlinkClick r:id="rId41"/>
               </a:rPr>
               <a:t>Lofar 2</a:t>
             </a:r>
@@ -5837,9 +4390,17 @@
           <a:p>
             <a:r>
               <a:rPr sz="800">
-                <a:hlinkClick r:id="rId40"/>
+                <a:hlinkClick r:id="rId42"/>
               </a:rPr>
               <a:t>Lofar 3</a:t>
+            </a:r>
+          </a:p>
+          <a:p>
+            <a:r>
+              <a:rPr sz="800">
+                <a:hlinkClick r:id="rId43"/>
+              </a:rPr>
+              <a:t>Lofar 4</a:t>
             </a:r>
           </a:p>
         </p:txBody>
@@ -5849,7 +4410,7 @@
           <p:cNvPr id="27" name="Rounded Rectangle 26"/>
           <p:cNvSpPr/>
           <p:nvPr>
-            <a:hlinkClick r:id="rId41"/>
+            <a:hlinkClick r:id="rId44"/>
           </p:nvPr>
         </p:nvSpPr>
         <p:spPr>
@@ -5894,7 +4455,7 @@
                   <a:srgbClr val="1F3A5F"/>
                 </a:solidFill>
               </a:rPr>
-              <a:t>Gram 35: FR Imperial-class, Category 2, Bajor</a:t>
+              <a:t>Gram 15: FR Voyager, Category 1, Gandalf</a:t>
             </a:r>
           </a:p>
         </p:txBody>
@@ -5923,7 +4484,7 @@
           <a:p>
             <a:r>
               <a:rPr sz="800">
-                <a:hlinkClick r:id="rId42"/>
+                <a:hlinkClick r:id="rId45"/>
               </a:rPr>
               <a:t>Lofar 1</a:t>
             </a:r>
@@ -5931,25 +4492,9 @@
           <a:p>
             <a:r>
               <a:rPr sz="800">
-                <a:hlinkClick r:id="rId43"/>
+                <a:hlinkClick r:id="rId46"/>
               </a:rPr>
               <a:t>Lofar 2</a:t>
-            </a:r>
-          </a:p>
-          <a:p>
-            <a:r>
-              <a:rPr sz="800">
-                <a:hlinkClick r:id="rId44"/>
-              </a:rPr>
-              <a:t>Lofar 3</a:t>
-            </a:r>
-          </a:p>
-          <a:p>
-            <a:r>
-              <a:rPr sz="800">
-                <a:hlinkClick r:id="rId45"/>
-              </a:rPr>
-              <a:t>Lofar 4</a:t>
             </a:r>
           </a:p>
         </p:txBody>
@@ -5959,7 +4504,7 @@
           <p:cNvPr id="29" name="Rounded Rectangle 28"/>
           <p:cNvSpPr/>
           <p:nvPr>
-            <a:hlinkClick r:id="rId46"/>
+            <a:hlinkClick r:id="rId47"/>
           </p:nvPr>
         </p:nvSpPr>
         <p:spPr>
@@ -6004,7 +4549,7 @@
                   <a:srgbClr val="1F3A5F"/>
                 </a:solidFill>
               </a:rPr>
-              <a:t>Gram 36: FR Venator-class, Category 4, Defiant</a:t>
+              <a:t>Gram 16: FR Intrepid-class, Category 2, Tatooine</a:t>
             </a:r>
           </a:p>
         </p:txBody>
@@ -6033,9 +4578,25 @@
           <a:p>
             <a:r>
               <a:rPr sz="800">
-                <a:hlinkClick r:id="rId47"/>
+                <a:hlinkClick r:id="rId48"/>
               </a:rPr>
               <a:t>Lofar 1</a:t>
+            </a:r>
+          </a:p>
+          <a:p>
+            <a:r>
+              <a:rPr sz="800">
+                <a:hlinkClick r:id="rId49"/>
+              </a:rPr>
+              <a:t>Lofar 2</a:t>
+            </a:r>
+          </a:p>
+          <a:p>
+            <a:r>
+              <a:rPr sz="800">
+                <a:hlinkClick r:id="rId50"/>
+              </a:rPr>
+              <a:t>Lofar 3</a:t>
             </a:r>
           </a:p>
         </p:txBody>
@@ -6045,7 +4606,7 @@
           <p:cNvPr id="31" name="Rounded Rectangle 30"/>
           <p:cNvSpPr/>
           <p:nvPr>
-            <a:hlinkClick r:id="rId48"/>
+            <a:hlinkClick r:id="rId51"/>
           </p:nvPr>
         </p:nvSpPr>
         <p:spPr>
@@ -6090,7 +4651,7 @@
                   <a:srgbClr val="1F3A5F"/>
                 </a:solidFill>
               </a:rPr>
-              <a:t>Gram 37: FR Devastator, Category 2, Tatooine</a:t>
+              <a:t>Gram 18: FR B-wing, Category 3, Mustafar</a:t>
             </a:r>
           </a:p>
         </p:txBody>
@@ -6119,9 +4680,33 @@
           <a:p>
             <a:r>
               <a:rPr sz="800">
-                <a:hlinkClick r:id="rId49"/>
+                <a:hlinkClick r:id="rId52"/>
               </a:rPr>
               <a:t>Lofar 1</a:t>
+            </a:r>
+          </a:p>
+          <a:p>
+            <a:r>
+              <a:rPr sz="800">
+                <a:hlinkClick r:id="rId53"/>
+              </a:rPr>
+              <a:t>Lofar 2</a:t>
+            </a:r>
+          </a:p>
+          <a:p>
+            <a:r>
+              <a:rPr sz="800">
+                <a:hlinkClick r:id="rId54"/>
+              </a:rPr>
+              <a:t>Lofar 3</a:t>
+            </a:r>
+          </a:p>
+          <a:p>
+            <a:r>
+              <a:rPr sz="800">
+                <a:hlinkClick r:id="rId55"/>
+              </a:rPr>
+              <a:t>Lofar 4</a:t>
             </a:r>
           </a:p>
         </p:txBody>
@@ -6190,7 +4775,7 @@
                   <a:srgbClr val="FFFFFF"/>
                 </a:solidFill>
               </a:rPr>
-              <a:t>Instructor Progress Final Assessment Grams — Page 3 of 3</a:t>
+              <a:t>Instructor Progress Final Assessment Grams — Page 2 of 3</a:t>
             </a:r>
           </a:p>
         </p:txBody>
@@ -6245,7 +4830,7 @@
                   <a:srgbClr val="1F3A5F"/>
                 </a:solidFill>
               </a:rPr>
-              <a:t>Gram 38: FR Outrider, Category 3, Coruscant</a:t>
+              <a:t>Gram 19: FR X-wing, Category 3, Dagobah</a:t>
             </a:r>
           </a:p>
         </p:txBody>
@@ -6279,6 +4864,14 @@
               <a:t>Lofar 1</a:t>
             </a:r>
           </a:p>
+          <a:p>
+            <a:r>
+              <a:rPr sz="800">
+                <a:hlinkClick r:id="rId4"/>
+              </a:rPr>
+              <a:t>Lofar 2</a:t>
+            </a:r>
+          </a:p>
         </p:txBody>
       </p:sp>
       <p:sp>
@@ -6286,7 +4879,7 @@
           <p:cNvPr id="5" name="Rounded Rectangle 4"/>
           <p:cNvSpPr/>
           <p:nvPr>
-            <a:hlinkClick r:id="rId4"/>
+            <a:hlinkClick r:id="rId5"/>
           </p:nvPr>
         </p:nvSpPr>
         <p:spPr>
@@ -6331,7 +4924,7 @@
                   <a:srgbClr val="1F3A5F"/>
                 </a:solidFill>
               </a:rPr>
-              <a:t>Gram 39: Galaxy-class contact bearing 083, codename Betazed</a:t>
+              <a:t>Gram 22: FR Razor Crest, Category 4, Dank</a:t>
             </a:r>
           </a:p>
         </p:txBody>
@@ -6360,25 +4953,9 @@
           <a:p>
             <a:r>
               <a:rPr sz="800">
-                <a:hlinkClick r:id="rId5"/>
+                <a:hlinkClick r:id="rId6"/>
               </a:rPr>
               <a:t>Lofar 1</a:t>
-            </a:r>
-          </a:p>
-          <a:p>
-            <a:r>
-              <a:rPr sz="800">
-                <a:hlinkClick r:id="rId6"/>
-              </a:rPr>
-              <a:t>Lofar 2</a:t>
-            </a:r>
-          </a:p>
-          <a:p>
-            <a:r>
-              <a:rPr sz="800">
-                <a:hlinkClick r:id="rId7"/>
-              </a:rPr>
-              <a:t>Lofar 3</a:t>
             </a:r>
           </a:p>
         </p:txBody>
@@ -6388,7 +4965,7 @@
           <p:cNvPr id="7" name="Rounded Rectangle 6"/>
           <p:cNvSpPr/>
           <p:nvPr>
-            <a:hlinkClick r:id="rId8"/>
+            <a:hlinkClick r:id="rId7"/>
           </p:nvPr>
         </p:nvSpPr>
         <p:spPr>
@@ -6433,7 +5010,7 @@
                   <a:srgbClr val="1F3A5F"/>
                 </a:solidFill>
               </a:rPr>
-              <a:t>Gram 40: FR Corellian Corvette, Category 1, Tantive</a:t>
+              <a:t>Gram 23: FR Outrider, Category 3, Cardassia</a:t>
             </a:r>
           </a:p>
         </p:txBody>
@@ -6462,9 +5039,25 @@
           <a:p>
             <a:r>
               <a:rPr sz="800">
+                <a:hlinkClick r:id="rId8"/>
+              </a:rPr>
+              <a:t>Lofar 1</a:t>
+            </a:r>
+          </a:p>
+          <a:p>
+            <a:r>
+              <a:rPr sz="800">
                 <a:hlinkClick r:id="rId9"/>
               </a:rPr>
-              <a:t>Lofar 1</a:t>
+              <a:t>Lofar 2</a:t>
+            </a:r>
+          </a:p>
+          <a:p>
+            <a:r>
+              <a:rPr sz="800">
+                <a:hlinkClick r:id="rId10"/>
+              </a:rPr>
+              <a:t>Lofar 3</a:t>
             </a:r>
           </a:p>
         </p:txBody>
@@ -6474,7 +5067,7 @@
           <p:cNvPr id="9" name="Rounded Rectangle 8"/>
           <p:cNvSpPr/>
           <p:nvPr>
-            <a:hlinkClick r:id="rId10"/>
+            <a:hlinkClick r:id="rId11"/>
           </p:nvPr>
         </p:nvSpPr>
         <p:spPr>
@@ -6519,7 +5112,7 @@
                   <a:srgbClr val="1F3A5F"/>
                 </a:solidFill>
               </a:rPr>
-              <a:t>Gram 41: FR Millennium Falcon, Category 1, Gandalf</a:t>
+              <a:t>Gram 25: FR Ghost, Category 3, Trill</a:t>
             </a:r>
           </a:p>
         </p:txBody>
@@ -6548,7 +5141,7 @@
           <a:p>
             <a:r>
               <a:rPr sz="800">
-                <a:hlinkClick r:id="rId11"/>
+                <a:hlinkClick r:id="rId12"/>
               </a:rPr>
               <a:t>Lofar 1</a:t>
             </a:r>
@@ -6556,9 +5149,17 @@
           <a:p>
             <a:r>
               <a:rPr sz="800">
-                <a:hlinkClick r:id="rId12"/>
+                <a:hlinkClick r:id="rId13"/>
               </a:rPr>
               <a:t>Lofar 2</a:t>
+            </a:r>
+          </a:p>
+          <a:p>
+            <a:r>
+              <a:rPr sz="800">
+                <a:hlinkClick r:id="rId14"/>
+              </a:rPr>
+              <a:t>Lofar 3</a:t>
             </a:r>
           </a:p>
         </p:txBody>
@@ -6568,7 +5169,7 @@
           <p:cNvPr id="11" name="Rounded Rectangle 10"/>
           <p:cNvSpPr/>
           <p:nvPr>
-            <a:hlinkClick r:id="rId13"/>
+            <a:hlinkClick r:id="rId15"/>
           </p:nvPr>
         </p:nvSpPr>
         <p:spPr>
@@ -6613,7 +5214,7 @@
                   <a:srgbClr val="1F3A5F"/>
                 </a:solidFill>
               </a:rPr>
-              <a:t>Gram 42: FR Venator-class, Category 2, Yavin</a:t>
+              <a:t>Gram 26: FR Ghost, Category 1, Trill</a:t>
             </a:r>
           </a:p>
         </p:txBody>
@@ -6642,17 +5243,9 @@
           <a:p>
             <a:r>
               <a:rPr sz="800">
-                <a:hlinkClick r:id="rId14"/>
+                <a:hlinkClick r:id="rId16"/>
               </a:rPr>
               <a:t>Lofar 1</a:t>
-            </a:r>
-          </a:p>
-          <a:p>
-            <a:r>
-              <a:rPr sz="800">
-                <a:hlinkClick r:id="rId15"/>
-              </a:rPr>
-              <a:t>Lofar 2</a:t>
             </a:r>
           </a:p>
         </p:txBody>
@@ -6662,7 +5255,7 @@
           <p:cNvPr id="13" name="Rounded Rectangle 12"/>
           <p:cNvSpPr/>
           <p:nvPr>
-            <a:hlinkClick r:id="rId16"/>
+            <a:hlinkClick r:id="rId17"/>
           </p:nvPr>
         </p:nvSpPr>
         <p:spPr>
@@ -6707,7 +5300,7 @@
                   <a:srgbClr val="1F3A5F"/>
                 </a:solidFill>
               </a:rPr>
-              <a:t>Gram 43: FR Excelsior, Category 4, Vulcan</a:t>
+              <a:t>Gram 27: Cerritos contact bearing 270, codename Vulcan</a:t>
             </a:r>
           </a:p>
         </p:txBody>
@@ -6736,7 +5329,7 @@
           <a:p>
             <a:r>
               <a:rPr sz="800">
-                <a:hlinkClick r:id="rId17"/>
+                <a:hlinkClick r:id="rId18"/>
               </a:rPr>
               <a:t>Lofar 1</a:t>
             </a:r>
@@ -6744,7 +5337,7 @@
           <a:p>
             <a:r>
               <a:rPr sz="800">
-                <a:hlinkClick r:id="rId18"/>
+                <a:hlinkClick r:id="rId19"/>
               </a:rPr>
               <a:t>Lofar 2</a:t>
             </a:r>
@@ -6752,17 +5345,9 @@
           <a:p>
             <a:r>
               <a:rPr sz="800">
-                <a:hlinkClick r:id="rId19"/>
+                <a:hlinkClick r:id="rId20"/>
               </a:rPr>
               <a:t>Lofar 3</a:t>
-            </a:r>
-          </a:p>
-          <a:p>
-            <a:r>
-              <a:rPr sz="800">
-                <a:hlinkClick r:id="rId20"/>
-              </a:rPr>
-              <a:t>Lofar 4</a:t>
             </a:r>
           </a:p>
         </p:txBody>
@@ -6817,7 +5402,7 @@
                   <a:srgbClr val="1F3A5F"/>
                 </a:solidFill>
               </a:rPr>
-              <a:t>Gram 44: B-wing contact bearing 024, codename Hoth</a:t>
+              <a:t>Gram 28: Defiant contact bearing 357, codename Vulcan</a:t>
             </a:r>
           </a:p>
         </p:txBody>
@@ -6859,22 +5444,6 @@
               <a:t>Lofar 2</a:t>
             </a:r>
           </a:p>
-          <a:p>
-            <a:r>
-              <a:rPr sz="800">
-                <a:hlinkClick r:id="rId24"/>
-              </a:rPr>
-              <a:t>Lofar 3</a:t>
-            </a:r>
-          </a:p>
-          <a:p>
-            <a:r>
-              <a:rPr sz="800">
-                <a:hlinkClick r:id="rId25"/>
-              </a:rPr>
-              <a:t>Lofar 4</a:t>
-            </a:r>
-          </a:p>
         </p:txBody>
       </p:sp>
       <p:sp>
@@ -6882,7 +5451,7 @@
           <p:cNvPr id="17" name="Rounded Rectangle 16"/>
           <p:cNvSpPr/>
           <p:nvPr>
-            <a:hlinkClick r:id="rId26"/>
+            <a:hlinkClick r:id="rId24"/>
           </p:nvPr>
         </p:nvSpPr>
         <p:spPr>
@@ -6927,7 +5496,7 @@
                   <a:srgbClr val="1F3A5F"/>
                 </a:solidFill>
               </a:rPr>
-              <a:t>Gram 46: Stargazer contact bearing 059, codename Hoth</a:t>
+              <a:t>Gram 29: Imperial-class contact bearing 080, codename Gandalf</a:t>
             </a:r>
           </a:p>
         </p:txBody>
@@ -6956,17 +5525,9 @@
           <a:p>
             <a:r>
               <a:rPr sz="800">
-                <a:hlinkClick r:id="rId27"/>
+                <a:hlinkClick r:id="rId25"/>
               </a:rPr>
               <a:t>Lofar 1</a:t>
-            </a:r>
-          </a:p>
-          <a:p>
-            <a:r>
-              <a:rPr sz="800">
-                <a:hlinkClick r:id="rId28"/>
-              </a:rPr>
-              <a:t>Lofar 2</a:t>
             </a:r>
           </a:p>
         </p:txBody>
@@ -6976,7 +5537,7 @@
           <p:cNvPr id="19" name="Rounded Rectangle 18"/>
           <p:cNvSpPr/>
           <p:nvPr>
-            <a:hlinkClick r:id="rId29"/>
+            <a:hlinkClick r:id="rId26"/>
           </p:nvPr>
         </p:nvSpPr>
         <p:spPr>
@@ -7021,7 +5582,7 @@
                   <a:srgbClr val="1F3A5F"/>
                 </a:solidFill>
               </a:rPr>
-              <a:t>Gram 47: FR Discovery, Category 4, Risa</a:t>
+              <a:t>Gram 30: Excelsior contact bearing 009, codename Cardassia</a:t>
             </a:r>
           </a:p>
         </p:txBody>
@@ -7050,7 +5611,7 @@
           <a:p>
             <a:r>
               <a:rPr sz="800">
-                <a:hlinkClick r:id="rId30"/>
+                <a:hlinkClick r:id="rId27"/>
               </a:rPr>
               <a:t>Lofar 1</a:t>
             </a:r>
@@ -7062,7 +5623,7 @@
           <p:cNvPr id="21" name="Rounded Rectangle 20"/>
           <p:cNvSpPr/>
           <p:nvPr>
-            <a:hlinkClick r:id="rId31"/>
+            <a:hlinkClick r:id="rId28"/>
           </p:nvPr>
         </p:nvSpPr>
         <p:spPr>
@@ -7107,7 +5668,7 @@
                   <a:srgbClr val="1F3A5F"/>
                 </a:solidFill>
               </a:rPr>
-              <a:t>Gram 48: FR Discovery, Category 4, Kronos</a:t>
+              <a:t>Gram 31: FR Rebel One, Category 1, Endor</a:t>
             </a:r>
           </a:p>
         </p:txBody>
@@ -7136,17 +5697,1630 @@
           <a:p>
             <a:r>
               <a:rPr sz="800">
+                <a:hlinkClick r:id="rId29"/>
+              </a:rPr>
+              <a:t>Lofar 1</a:t>
+            </a:r>
+          </a:p>
+          <a:p>
+            <a:r>
+              <a:rPr sz="800">
+                <a:hlinkClick r:id="rId30"/>
+              </a:rPr>
+              <a:t>Lofar 2</a:t>
+            </a:r>
+          </a:p>
+          <a:p>
+            <a:r>
+              <a:rPr sz="800">
+                <a:hlinkClick r:id="rId31"/>
+              </a:rPr>
+              <a:t>Lofar 3</a:t>
+            </a:r>
+          </a:p>
+          <a:p>
+            <a:r>
+              <a:rPr sz="800">
                 <a:hlinkClick r:id="rId32"/>
               </a:rPr>
+              <a:t>Lofar 4</a:t>
+            </a:r>
+          </a:p>
+        </p:txBody>
+      </p:sp>
+      <p:sp>
+        <p:nvSpPr>
+          <p:cNvPr id="23" name="Rounded Rectangle 22"/>
+          <p:cNvSpPr/>
+          <p:nvPr>
+            <a:hlinkClick r:id="rId33"/>
+          </p:nvPr>
+        </p:nvSpPr>
+        <p:spPr>
+          <a:xfrm>
+            <a:off x="365760" y="4632960"/>
+            <a:ext cx="2200046" cy="365760"/>
+          </a:xfrm>
+          <a:prstGeom prst="roundRect">
+            <a:avLst/>
+          </a:prstGeom>
+          <a:solidFill>
+            <a:srgbClr val="E8EEF7"/>
+          </a:solidFill>
+          <a:ln>
+            <a:solidFill>
+              <a:srgbClr val="1F3A5F"/>
+            </a:solidFill>
+          </a:ln>
+        </p:spPr>
+        <p:style>
+          <a:lnRef idx="1">
+            <a:schemeClr val="accent1"/>
+          </a:lnRef>
+          <a:fillRef idx="3">
+            <a:schemeClr val="accent1"/>
+          </a:fillRef>
+          <a:effectRef idx="2">
+            <a:schemeClr val="accent1"/>
+          </a:effectRef>
+          <a:fontRef idx="minor">
+            <a:schemeClr val="lt1"/>
+          </a:fontRef>
+        </p:style>
+        <p:txBody>
+          <a:bodyPr rtlCol="0" anchor="ctr" lIns="45720" rIns="45720"/>
+          <a:lstStyle/>
+          <a:p>
+            <a:pPr algn="ctr"/>
+            <a:r>
+              <a:rPr sz="900">
+                <a:solidFill>
+                  <a:srgbClr val="1F3A5F"/>
+                </a:solidFill>
+              </a:rPr>
+              <a:t>Gram 33: FR Galaxy-class, Category 2, Mustafar</a:t>
+            </a:r>
+          </a:p>
+        </p:txBody>
+      </p:sp>
+      <p:sp>
+        <p:nvSpPr>
+          <p:cNvPr id="24" name="TextBox 23"/>
+          <p:cNvSpPr txBox="1"/>
+          <p:nvPr/>
+        </p:nvSpPr>
+        <p:spPr>
+          <a:xfrm>
+            <a:off x="365760" y="5017008"/>
+            <a:ext cx="2200046" cy="1447800"/>
+          </a:xfrm>
+          <a:prstGeom prst="rect">
+            <a:avLst/>
+          </a:prstGeom>
+          <a:noFill/>
+        </p:spPr>
+        <p:txBody>
+          <a:bodyPr wrap="square">
+            <a:spAutoFit/>
+          </a:bodyPr>
+          <a:lstStyle/>
+          <a:p>
+            <a:r>
+              <a:rPr sz="800">
+                <a:hlinkClick r:id="rId34"/>
+              </a:rPr>
               <a:t>Lofar 1</a:t>
             </a:r>
           </a:p>
           <a:p>
             <a:r>
               <a:rPr sz="800">
+                <a:hlinkClick r:id="rId35"/>
+              </a:rPr>
+              <a:t>Lofar 2</a:t>
+            </a:r>
+          </a:p>
+          <a:p>
+            <a:r>
+              <a:rPr sz="800">
+                <a:hlinkClick r:id="rId36"/>
+              </a:rPr>
+              <a:t>Lofar 3</a:t>
+            </a:r>
+          </a:p>
+        </p:txBody>
+      </p:sp>
+      <p:sp>
+        <p:nvSpPr>
+          <p:cNvPr id="25" name="Rounded Rectangle 24"/>
+          <p:cNvSpPr/>
+          <p:nvPr>
+            <a:hlinkClick r:id="rId37"/>
+          </p:nvPr>
+        </p:nvSpPr>
+        <p:spPr>
+          <a:xfrm>
+            <a:off x="2657246" y="4632960"/>
+            <a:ext cx="2200046" cy="365760"/>
+          </a:xfrm>
+          <a:prstGeom prst="roundRect">
+            <a:avLst/>
+          </a:prstGeom>
+          <a:solidFill>
+            <a:srgbClr val="E8EEF7"/>
+          </a:solidFill>
+          <a:ln>
+            <a:solidFill>
+              <a:srgbClr val="1F3A5F"/>
+            </a:solidFill>
+          </a:ln>
+        </p:spPr>
+        <p:style>
+          <a:lnRef idx="1">
+            <a:schemeClr val="accent1"/>
+          </a:lnRef>
+          <a:fillRef idx="3">
+            <a:schemeClr val="accent1"/>
+          </a:fillRef>
+          <a:effectRef idx="2">
+            <a:schemeClr val="accent1"/>
+          </a:effectRef>
+          <a:fontRef idx="minor">
+            <a:schemeClr val="lt1"/>
+          </a:fontRef>
+        </p:style>
+        <p:txBody>
+          <a:bodyPr rtlCol="0" anchor="ctr" lIns="45720" rIns="45720"/>
+          <a:lstStyle/>
+          <a:p>
+            <a:pPr algn="ctr"/>
+            <a:r>
+              <a:rPr sz="900">
+                <a:solidFill>
+                  <a:srgbClr val="1F3A5F"/>
+                </a:solidFill>
+              </a:rPr>
+              <a:t>Gram 34: Reliant contact bearing 192, codename Romulus</a:t>
+            </a:r>
+          </a:p>
+        </p:txBody>
+      </p:sp>
+      <p:sp>
+        <p:nvSpPr>
+          <p:cNvPr id="26" name="TextBox 25"/>
+          <p:cNvSpPr txBox="1"/>
+          <p:nvPr/>
+        </p:nvSpPr>
+        <p:spPr>
+          <a:xfrm>
+            <a:off x="2657246" y="5017008"/>
+            <a:ext cx="2200046" cy="1447800"/>
+          </a:xfrm>
+          <a:prstGeom prst="rect">
+            <a:avLst/>
+          </a:prstGeom>
+          <a:noFill/>
+        </p:spPr>
+        <p:txBody>
+          <a:bodyPr wrap="square">
+            <a:spAutoFit/>
+          </a:bodyPr>
+          <a:lstStyle/>
+          <a:p>
+            <a:r>
+              <a:rPr sz="800">
+                <a:hlinkClick r:id="rId38"/>
+              </a:rPr>
+              <a:t>Lofar 1</a:t>
+            </a:r>
+          </a:p>
+          <a:p>
+            <a:r>
+              <a:rPr sz="800">
+                <a:hlinkClick r:id="rId39"/>
+              </a:rPr>
+              <a:t>Lofar 2</a:t>
+            </a:r>
+          </a:p>
+          <a:p>
+            <a:r>
+              <a:rPr sz="800">
+                <a:hlinkClick r:id="rId40"/>
+              </a:rPr>
+              <a:t>Lofar 3</a:t>
+            </a:r>
+          </a:p>
+        </p:txBody>
+      </p:sp>
+      <p:sp>
+        <p:nvSpPr>
+          <p:cNvPr id="27" name="Rounded Rectangle 26"/>
+          <p:cNvSpPr/>
+          <p:nvPr>
+            <a:hlinkClick r:id="rId41"/>
+          </p:nvPr>
+        </p:nvSpPr>
+        <p:spPr>
+          <a:xfrm>
+            <a:off x="4948732" y="4632960"/>
+            <a:ext cx="2200046" cy="365760"/>
+          </a:xfrm>
+          <a:prstGeom prst="roundRect">
+            <a:avLst/>
+          </a:prstGeom>
+          <a:solidFill>
+            <a:srgbClr val="E8EEF7"/>
+          </a:solidFill>
+          <a:ln>
+            <a:solidFill>
+              <a:srgbClr val="1F3A5F"/>
+            </a:solidFill>
+          </a:ln>
+        </p:spPr>
+        <p:style>
+          <a:lnRef idx="1">
+            <a:schemeClr val="accent1"/>
+          </a:lnRef>
+          <a:fillRef idx="3">
+            <a:schemeClr val="accent1"/>
+          </a:fillRef>
+          <a:effectRef idx="2">
+            <a:schemeClr val="accent1"/>
+          </a:effectRef>
+          <a:fontRef idx="minor">
+            <a:schemeClr val="lt1"/>
+          </a:fontRef>
+        </p:style>
+        <p:txBody>
+          <a:bodyPr rtlCol="0" anchor="ctr" lIns="45720" rIns="45720"/>
+          <a:lstStyle/>
+          <a:p>
+            <a:pPr algn="ctr"/>
+            <a:r>
+              <a:rPr sz="900">
+                <a:solidFill>
+                  <a:srgbClr val="1F3A5F"/>
+                </a:solidFill>
+              </a:rPr>
+              <a:t>Gram 35: FR Imperial-class, Category 2, Bajor</a:t>
+            </a:r>
+          </a:p>
+        </p:txBody>
+      </p:sp>
+      <p:sp>
+        <p:nvSpPr>
+          <p:cNvPr id="28" name="TextBox 27"/>
+          <p:cNvSpPr txBox="1"/>
+          <p:nvPr/>
+        </p:nvSpPr>
+        <p:spPr>
+          <a:xfrm>
+            <a:off x="4948732" y="5017008"/>
+            <a:ext cx="2200046" cy="1447800"/>
+          </a:xfrm>
+          <a:prstGeom prst="rect">
+            <a:avLst/>
+          </a:prstGeom>
+          <a:noFill/>
+        </p:spPr>
+        <p:txBody>
+          <a:bodyPr wrap="square">
+            <a:spAutoFit/>
+          </a:bodyPr>
+          <a:lstStyle/>
+          <a:p>
+            <a:r>
+              <a:rPr sz="800">
+                <a:hlinkClick r:id="rId42"/>
+              </a:rPr>
+              <a:t>Lofar 1</a:t>
+            </a:r>
+          </a:p>
+          <a:p>
+            <a:r>
+              <a:rPr sz="800">
+                <a:hlinkClick r:id="rId43"/>
+              </a:rPr>
+              <a:t>Lofar 2</a:t>
+            </a:r>
+          </a:p>
+          <a:p>
+            <a:r>
+              <a:rPr sz="800">
+                <a:hlinkClick r:id="rId44"/>
+              </a:rPr>
+              <a:t>Lofar 3</a:t>
+            </a:r>
+          </a:p>
+          <a:p>
+            <a:r>
+              <a:rPr sz="800">
+                <a:hlinkClick r:id="rId45"/>
+              </a:rPr>
+              <a:t>Lofar 4</a:t>
+            </a:r>
+          </a:p>
+        </p:txBody>
+      </p:sp>
+      <p:sp>
+        <p:nvSpPr>
+          <p:cNvPr id="29" name="Rounded Rectangle 28"/>
+          <p:cNvSpPr/>
+          <p:nvPr>
+            <a:hlinkClick r:id="rId46"/>
+          </p:nvPr>
+        </p:nvSpPr>
+        <p:spPr>
+          <a:xfrm>
+            <a:off x="7240219" y="4632960"/>
+            <a:ext cx="2200046" cy="365760"/>
+          </a:xfrm>
+          <a:prstGeom prst="roundRect">
+            <a:avLst/>
+          </a:prstGeom>
+          <a:solidFill>
+            <a:srgbClr val="E8EEF7"/>
+          </a:solidFill>
+          <a:ln>
+            <a:solidFill>
+              <a:srgbClr val="1F3A5F"/>
+            </a:solidFill>
+          </a:ln>
+        </p:spPr>
+        <p:style>
+          <a:lnRef idx="1">
+            <a:schemeClr val="accent1"/>
+          </a:lnRef>
+          <a:fillRef idx="3">
+            <a:schemeClr val="accent1"/>
+          </a:fillRef>
+          <a:effectRef idx="2">
+            <a:schemeClr val="accent1"/>
+          </a:effectRef>
+          <a:fontRef idx="minor">
+            <a:schemeClr val="lt1"/>
+          </a:fontRef>
+        </p:style>
+        <p:txBody>
+          <a:bodyPr rtlCol="0" anchor="ctr" lIns="45720" rIns="45720"/>
+          <a:lstStyle/>
+          <a:p>
+            <a:pPr algn="ctr"/>
+            <a:r>
+              <a:rPr sz="900">
+                <a:solidFill>
+                  <a:srgbClr val="1F3A5F"/>
+                </a:solidFill>
+              </a:rPr>
+              <a:t>Gram 36: FR Venator-class, Category 4, Defiant</a:t>
+            </a:r>
+          </a:p>
+        </p:txBody>
+      </p:sp>
+      <p:sp>
+        <p:nvSpPr>
+          <p:cNvPr id="30" name="TextBox 29"/>
+          <p:cNvSpPr txBox="1"/>
+          <p:nvPr/>
+        </p:nvSpPr>
+        <p:spPr>
+          <a:xfrm>
+            <a:off x="7240219" y="5017008"/>
+            <a:ext cx="2200046" cy="1447800"/>
+          </a:xfrm>
+          <a:prstGeom prst="rect">
+            <a:avLst/>
+          </a:prstGeom>
+          <a:noFill/>
+        </p:spPr>
+        <p:txBody>
+          <a:bodyPr wrap="square">
+            <a:spAutoFit/>
+          </a:bodyPr>
+          <a:lstStyle/>
+          <a:p>
+            <a:r>
+              <a:rPr sz="800">
+                <a:hlinkClick r:id="rId47"/>
+              </a:rPr>
+              <a:t>Lofar 1</a:t>
+            </a:r>
+          </a:p>
+        </p:txBody>
+      </p:sp>
+      <p:sp>
+        <p:nvSpPr>
+          <p:cNvPr id="31" name="Rounded Rectangle 30"/>
+          <p:cNvSpPr/>
+          <p:nvPr>
+            <a:hlinkClick r:id="rId48"/>
+          </p:nvPr>
+        </p:nvSpPr>
+        <p:spPr>
+          <a:xfrm>
+            <a:off x="9531705" y="4632960"/>
+            <a:ext cx="2200046" cy="365760"/>
+          </a:xfrm>
+          <a:prstGeom prst="roundRect">
+            <a:avLst/>
+          </a:prstGeom>
+          <a:solidFill>
+            <a:srgbClr val="E8EEF7"/>
+          </a:solidFill>
+          <a:ln>
+            <a:solidFill>
+              <a:srgbClr val="1F3A5F"/>
+            </a:solidFill>
+          </a:ln>
+        </p:spPr>
+        <p:style>
+          <a:lnRef idx="1">
+            <a:schemeClr val="accent1"/>
+          </a:lnRef>
+          <a:fillRef idx="3">
+            <a:schemeClr val="accent1"/>
+          </a:fillRef>
+          <a:effectRef idx="2">
+            <a:schemeClr val="accent1"/>
+          </a:effectRef>
+          <a:fontRef idx="minor">
+            <a:schemeClr val="lt1"/>
+          </a:fontRef>
+        </p:style>
+        <p:txBody>
+          <a:bodyPr rtlCol="0" anchor="ctr" lIns="45720" rIns="45720"/>
+          <a:lstStyle/>
+          <a:p>
+            <a:pPr algn="ctr"/>
+            <a:r>
+              <a:rPr sz="900">
+                <a:solidFill>
+                  <a:srgbClr val="1F3A5F"/>
+                </a:solidFill>
+              </a:rPr>
+              <a:t>Gram 37: FR Devastator, Category 2, Tatooine</a:t>
+            </a:r>
+          </a:p>
+        </p:txBody>
+      </p:sp>
+      <p:sp>
+        <p:nvSpPr>
+          <p:cNvPr id="32" name="TextBox 31"/>
+          <p:cNvSpPr txBox="1"/>
+          <p:nvPr/>
+        </p:nvSpPr>
+        <p:spPr>
+          <a:xfrm>
+            <a:off x="9531705" y="5017008"/>
+            <a:ext cx="2200046" cy="1447800"/>
+          </a:xfrm>
+          <a:prstGeom prst="rect">
+            <a:avLst/>
+          </a:prstGeom>
+          <a:noFill/>
+        </p:spPr>
+        <p:txBody>
+          <a:bodyPr wrap="square">
+            <a:spAutoFit/>
+          </a:bodyPr>
+          <a:lstStyle/>
+          <a:p>
+            <a:r>
+              <a:rPr sz="800">
+                <a:hlinkClick r:id="rId49"/>
+              </a:rPr>
+              <a:t>Lofar 1</a:t>
+            </a:r>
+          </a:p>
+        </p:txBody>
+      </p:sp>
+    </p:spTree>
+  </p:cSld>
+  <p:clrMapOvr>
+    <a:masterClrMapping/>
+  </p:clrMapOvr>
+</p:sld>
+</file>
+
+<file path=ppt/slides/slide4.xml><?xml version="1.0" encoding="utf-8"?>
+<p:sld xmlns:a="http://schemas.openxmlformats.org/drawingml/2006/main" xmlns:p="http://schemas.openxmlformats.org/presentationml/2006/main" xmlns:r="http://schemas.openxmlformats.org/officeDocument/2006/relationships">
+  <p:cSld>
+    <p:spTree>
+      <p:nvGrpSpPr>
+        <p:cNvPr id="1" name=""/>
+        <p:cNvGrpSpPr/>
+        <p:nvPr/>
+      </p:nvGrpSpPr>
+      <p:grpSpPr/>
+      <p:sp>
+        <p:nvSpPr>
+          <p:cNvPr id="2" name="Rectangle 1"/>
+          <p:cNvSpPr/>
+          <p:nvPr/>
+        </p:nvSpPr>
+        <p:spPr>
+          <a:xfrm>
+            <a:off x="0" y="0"/>
+            <a:ext cx="12188952" cy="548640"/>
+          </a:xfrm>
+          <a:prstGeom prst="rect">
+            <a:avLst/>
+          </a:prstGeom>
+          <a:solidFill>
+            <a:srgbClr val="1F3A5F"/>
+          </a:solidFill>
+          <a:ln>
+            <a:noFill/>
+          </a:ln>
+        </p:spPr>
+        <p:style>
+          <a:lnRef idx="1">
+            <a:schemeClr val="accent1"/>
+          </a:lnRef>
+          <a:fillRef idx="3">
+            <a:schemeClr val="accent1"/>
+          </a:fillRef>
+          <a:effectRef idx="2">
+            <a:schemeClr val="accent1"/>
+          </a:effectRef>
+          <a:fontRef idx="minor">
+            <a:schemeClr val="lt1"/>
+          </a:fontRef>
+        </p:style>
+        <p:txBody>
+          <a:bodyPr rtlCol="0" anchor="ctr" lIns="182880" rIns="182880"/>
+          <a:lstStyle/>
+          <a:p>
+            <a:pPr algn="ctr"/>
+            <a:r>
+              <a:rPr sz="2000" b="1">
+                <a:solidFill>
+                  <a:srgbClr val="FFFFFF"/>
+                </a:solidFill>
+              </a:rPr>
+              <a:t>Instructor Progress Final Assessment Grams — Page 3 of 3</a:t>
+            </a:r>
+          </a:p>
+        </p:txBody>
+      </p:sp>
+      <p:sp>
+        <p:nvSpPr>
+          <p:cNvPr id="3" name="Rounded Rectangle 2"/>
+          <p:cNvSpPr/>
+          <p:nvPr>
+            <a:hlinkClick r:id="rId2"/>
+          </p:nvPr>
+        </p:nvSpPr>
+        <p:spPr>
+          <a:xfrm>
+            <a:off x="365760" y="731520"/>
+            <a:ext cx="2200046" cy="365760"/>
+          </a:xfrm>
+          <a:prstGeom prst="roundRect">
+            <a:avLst/>
+          </a:prstGeom>
+          <a:solidFill>
+            <a:srgbClr val="E8EEF7"/>
+          </a:solidFill>
+          <a:ln>
+            <a:solidFill>
+              <a:srgbClr val="1F3A5F"/>
+            </a:solidFill>
+          </a:ln>
+        </p:spPr>
+        <p:style>
+          <a:lnRef idx="1">
+            <a:schemeClr val="accent1"/>
+          </a:lnRef>
+          <a:fillRef idx="3">
+            <a:schemeClr val="accent1"/>
+          </a:fillRef>
+          <a:effectRef idx="2">
+            <a:schemeClr val="accent1"/>
+          </a:effectRef>
+          <a:fontRef idx="minor">
+            <a:schemeClr val="lt1"/>
+          </a:fontRef>
+        </p:style>
+        <p:txBody>
+          <a:bodyPr rtlCol="0" anchor="ctr" lIns="45720" rIns="45720"/>
+          <a:lstStyle/>
+          <a:p>
+            <a:pPr algn="ctr"/>
+            <a:r>
+              <a:rPr sz="900">
+                <a:solidFill>
+                  <a:srgbClr val="1F3A5F"/>
+                </a:solidFill>
+              </a:rPr>
+              <a:t>Gram 38: FR Outrider, Category 3, Coruscant</a:t>
+            </a:r>
+          </a:p>
+        </p:txBody>
+      </p:sp>
+      <p:sp>
+        <p:nvSpPr>
+          <p:cNvPr id="4" name="TextBox 3"/>
+          <p:cNvSpPr txBox="1"/>
+          <p:nvPr/>
+        </p:nvSpPr>
+        <p:spPr>
+          <a:xfrm>
+            <a:off x="365760" y="1115568"/>
+            <a:ext cx="2200046" cy="1447800"/>
+          </a:xfrm>
+          <a:prstGeom prst="rect">
+            <a:avLst/>
+          </a:prstGeom>
+          <a:noFill/>
+        </p:spPr>
+        <p:txBody>
+          <a:bodyPr wrap="square">
+            <a:spAutoFit/>
+          </a:bodyPr>
+          <a:lstStyle/>
+          <a:p>
+            <a:r>
+              <a:rPr sz="800">
+                <a:hlinkClick r:id="rId3"/>
+              </a:rPr>
+              <a:t>Lofar 1</a:t>
+            </a:r>
+          </a:p>
+        </p:txBody>
+      </p:sp>
+      <p:sp>
+        <p:nvSpPr>
+          <p:cNvPr id="5" name="Rounded Rectangle 4"/>
+          <p:cNvSpPr/>
+          <p:nvPr>
+            <a:hlinkClick r:id="rId4"/>
+          </p:nvPr>
+        </p:nvSpPr>
+        <p:spPr>
+          <a:xfrm>
+            <a:off x="2657246" y="731520"/>
+            <a:ext cx="2200046" cy="365760"/>
+          </a:xfrm>
+          <a:prstGeom prst="roundRect">
+            <a:avLst/>
+          </a:prstGeom>
+          <a:solidFill>
+            <a:srgbClr val="E8EEF7"/>
+          </a:solidFill>
+          <a:ln>
+            <a:solidFill>
+              <a:srgbClr val="1F3A5F"/>
+            </a:solidFill>
+          </a:ln>
+        </p:spPr>
+        <p:style>
+          <a:lnRef idx="1">
+            <a:schemeClr val="accent1"/>
+          </a:lnRef>
+          <a:fillRef idx="3">
+            <a:schemeClr val="accent1"/>
+          </a:fillRef>
+          <a:effectRef idx="2">
+            <a:schemeClr val="accent1"/>
+          </a:effectRef>
+          <a:fontRef idx="minor">
+            <a:schemeClr val="lt1"/>
+          </a:fontRef>
+        </p:style>
+        <p:txBody>
+          <a:bodyPr rtlCol="0" anchor="ctr" lIns="45720" rIns="45720"/>
+          <a:lstStyle/>
+          <a:p>
+            <a:pPr algn="ctr"/>
+            <a:r>
+              <a:rPr sz="900">
+                <a:solidFill>
+                  <a:srgbClr val="1F3A5F"/>
+                </a:solidFill>
+              </a:rPr>
+              <a:t>Gram 39: Galaxy-class contact bearing 083, codename Betazed</a:t>
+            </a:r>
+          </a:p>
+        </p:txBody>
+      </p:sp>
+      <p:sp>
+        <p:nvSpPr>
+          <p:cNvPr id="6" name="TextBox 5"/>
+          <p:cNvSpPr txBox="1"/>
+          <p:nvPr/>
+        </p:nvSpPr>
+        <p:spPr>
+          <a:xfrm>
+            <a:off x="2657246" y="1115568"/>
+            <a:ext cx="2200046" cy="1447800"/>
+          </a:xfrm>
+          <a:prstGeom prst="rect">
+            <a:avLst/>
+          </a:prstGeom>
+          <a:noFill/>
+        </p:spPr>
+        <p:txBody>
+          <a:bodyPr wrap="square">
+            <a:spAutoFit/>
+          </a:bodyPr>
+          <a:lstStyle/>
+          <a:p>
+            <a:r>
+              <a:rPr sz="800">
+                <a:hlinkClick r:id="rId5"/>
+              </a:rPr>
+              <a:t>Lofar 1</a:t>
+            </a:r>
+          </a:p>
+          <a:p>
+            <a:r>
+              <a:rPr sz="800">
+                <a:hlinkClick r:id="rId6"/>
+              </a:rPr>
+              <a:t>Lofar 2</a:t>
+            </a:r>
+          </a:p>
+          <a:p>
+            <a:r>
+              <a:rPr sz="800">
+                <a:hlinkClick r:id="rId7"/>
+              </a:rPr>
+              <a:t>Lofar 3</a:t>
+            </a:r>
+          </a:p>
+        </p:txBody>
+      </p:sp>
+      <p:sp>
+        <p:nvSpPr>
+          <p:cNvPr id="7" name="Rounded Rectangle 6"/>
+          <p:cNvSpPr/>
+          <p:nvPr>
+            <a:hlinkClick r:id="rId8"/>
+          </p:nvPr>
+        </p:nvSpPr>
+        <p:spPr>
+          <a:xfrm>
+            <a:off x="4948732" y="731520"/>
+            <a:ext cx="2200046" cy="365760"/>
+          </a:xfrm>
+          <a:prstGeom prst="roundRect">
+            <a:avLst/>
+          </a:prstGeom>
+          <a:solidFill>
+            <a:srgbClr val="E8EEF7"/>
+          </a:solidFill>
+          <a:ln>
+            <a:solidFill>
+              <a:srgbClr val="1F3A5F"/>
+            </a:solidFill>
+          </a:ln>
+        </p:spPr>
+        <p:style>
+          <a:lnRef idx="1">
+            <a:schemeClr val="accent1"/>
+          </a:lnRef>
+          <a:fillRef idx="3">
+            <a:schemeClr val="accent1"/>
+          </a:fillRef>
+          <a:effectRef idx="2">
+            <a:schemeClr val="accent1"/>
+          </a:effectRef>
+          <a:fontRef idx="minor">
+            <a:schemeClr val="lt1"/>
+          </a:fontRef>
+        </p:style>
+        <p:txBody>
+          <a:bodyPr rtlCol="0" anchor="ctr" lIns="45720" rIns="45720"/>
+          <a:lstStyle/>
+          <a:p>
+            <a:pPr algn="ctr"/>
+            <a:r>
+              <a:rPr sz="900">
+                <a:solidFill>
+                  <a:srgbClr val="1F3A5F"/>
+                </a:solidFill>
+              </a:rPr>
+              <a:t>Gram 40: FR Corellian Corvette, Category 1, Tantive</a:t>
+            </a:r>
+          </a:p>
+        </p:txBody>
+      </p:sp>
+      <p:sp>
+        <p:nvSpPr>
+          <p:cNvPr id="8" name="TextBox 7"/>
+          <p:cNvSpPr txBox="1"/>
+          <p:nvPr/>
+        </p:nvSpPr>
+        <p:spPr>
+          <a:xfrm>
+            <a:off x="4948732" y="1115568"/>
+            <a:ext cx="2200046" cy="1447800"/>
+          </a:xfrm>
+          <a:prstGeom prst="rect">
+            <a:avLst/>
+          </a:prstGeom>
+          <a:noFill/>
+        </p:spPr>
+        <p:txBody>
+          <a:bodyPr wrap="square">
+            <a:spAutoFit/>
+          </a:bodyPr>
+          <a:lstStyle/>
+          <a:p>
+            <a:r>
+              <a:rPr sz="800">
+                <a:hlinkClick r:id="rId9"/>
+              </a:rPr>
+              <a:t>Lofar 1</a:t>
+            </a:r>
+          </a:p>
+        </p:txBody>
+      </p:sp>
+      <p:sp>
+        <p:nvSpPr>
+          <p:cNvPr id="9" name="Rounded Rectangle 8"/>
+          <p:cNvSpPr/>
+          <p:nvPr>
+            <a:hlinkClick r:id="rId10"/>
+          </p:nvPr>
+        </p:nvSpPr>
+        <p:spPr>
+          <a:xfrm>
+            <a:off x="7240219" y="731520"/>
+            <a:ext cx="2200046" cy="365760"/>
+          </a:xfrm>
+          <a:prstGeom prst="roundRect">
+            <a:avLst/>
+          </a:prstGeom>
+          <a:solidFill>
+            <a:srgbClr val="E8EEF7"/>
+          </a:solidFill>
+          <a:ln>
+            <a:solidFill>
+              <a:srgbClr val="1F3A5F"/>
+            </a:solidFill>
+          </a:ln>
+        </p:spPr>
+        <p:style>
+          <a:lnRef idx="1">
+            <a:schemeClr val="accent1"/>
+          </a:lnRef>
+          <a:fillRef idx="3">
+            <a:schemeClr val="accent1"/>
+          </a:fillRef>
+          <a:effectRef idx="2">
+            <a:schemeClr val="accent1"/>
+          </a:effectRef>
+          <a:fontRef idx="minor">
+            <a:schemeClr val="lt1"/>
+          </a:fontRef>
+        </p:style>
+        <p:txBody>
+          <a:bodyPr rtlCol="0" anchor="ctr" lIns="45720" rIns="45720"/>
+          <a:lstStyle/>
+          <a:p>
+            <a:pPr algn="ctr"/>
+            <a:r>
+              <a:rPr sz="900">
+                <a:solidFill>
+                  <a:srgbClr val="1F3A5F"/>
+                </a:solidFill>
+              </a:rPr>
+              <a:t>Gram 41: FR Millennium Falcon, Category 1, Gandalf</a:t>
+            </a:r>
+          </a:p>
+        </p:txBody>
+      </p:sp>
+      <p:sp>
+        <p:nvSpPr>
+          <p:cNvPr id="10" name="TextBox 9"/>
+          <p:cNvSpPr txBox="1"/>
+          <p:nvPr/>
+        </p:nvSpPr>
+        <p:spPr>
+          <a:xfrm>
+            <a:off x="7240219" y="1115568"/>
+            <a:ext cx="2200046" cy="1447800"/>
+          </a:xfrm>
+          <a:prstGeom prst="rect">
+            <a:avLst/>
+          </a:prstGeom>
+          <a:noFill/>
+        </p:spPr>
+        <p:txBody>
+          <a:bodyPr wrap="square">
+            <a:spAutoFit/>
+          </a:bodyPr>
+          <a:lstStyle/>
+          <a:p>
+            <a:r>
+              <a:rPr sz="800">
+                <a:hlinkClick r:id="rId11"/>
+              </a:rPr>
+              <a:t>Lofar 1</a:t>
+            </a:r>
+          </a:p>
+          <a:p>
+            <a:r>
+              <a:rPr sz="800">
+                <a:hlinkClick r:id="rId12"/>
+              </a:rPr>
+              <a:t>Lofar 2</a:t>
+            </a:r>
+          </a:p>
+        </p:txBody>
+      </p:sp>
+      <p:sp>
+        <p:nvSpPr>
+          <p:cNvPr id="11" name="Rounded Rectangle 10"/>
+          <p:cNvSpPr/>
+          <p:nvPr>
+            <a:hlinkClick r:id="rId13"/>
+          </p:nvPr>
+        </p:nvSpPr>
+        <p:spPr>
+          <a:xfrm>
+            <a:off x="9531705" y="731520"/>
+            <a:ext cx="2200046" cy="365760"/>
+          </a:xfrm>
+          <a:prstGeom prst="roundRect">
+            <a:avLst/>
+          </a:prstGeom>
+          <a:solidFill>
+            <a:srgbClr val="E8EEF7"/>
+          </a:solidFill>
+          <a:ln>
+            <a:solidFill>
+              <a:srgbClr val="1F3A5F"/>
+            </a:solidFill>
+          </a:ln>
+        </p:spPr>
+        <p:style>
+          <a:lnRef idx="1">
+            <a:schemeClr val="accent1"/>
+          </a:lnRef>
+          <a:fillRef idx="3">
+            <a:schemeClr val="accent1"/>
+          </a:fillRef>
+          <a:effectRef idx="2">
+            <a:schemeClr val="accent1"/>
+          </a:effectRef>
+          <a:fontRef idx="minor">
+            <a:schemeClr val="lt1"/>
+          </a:fontRef>
+        </p:style>
+        <p:txBody>
+          <a:bodyPr rtlCol="0" anchor="ctr" lIns="45720" rIns="45720"/>
+          <a:lstStyle/>
+          <a:p>
+            <a:pPr algn="ctr"/>
+            <a:r>
+              <a:rPr sz="900">
+                <a:solidFill>
+                  <a:srgbClr val="1F3A5F"/>
+                </a:solidFill>
+              </a:rPr>
+              <a:t>Gram 42: FR Venator-class, Category 2, Yavin</a:t>
+            </a:r>
+          </a:p>
+        </p:txBody>
+      </p:sp>
+      <p:sp>
+        <p:nvSpPr>
+          <p:cNvPr id="12" name="TextBox 11"/>
+          <p:cNvSpPr txBox="1"/>
+          <p:nvPr/>
+        </p:nvSpPr>
+        <p:spPr>
+          <a:xfrm>
+            <a:off x="9531705" y="1115568"/>
+            <a:ext cx="2200046" cy="1447800"/>
+          </a:xfrm>
+          <a:prstGeom prst="rect">
+            <a:avLst/>
+          </a:prstGeom>
+          <a:noFill/>
+        </p:spPr>
+        <p:txBody>
+          <a:bodyPr wrap="square">
+            <a:spAutoFit/>
+          </a:bodyPr>
+          <a:lstStyle/>
+          <a:p>
+            <a:r>
+              <a:rPr sz="800">
+                <a:hlinkClick r:id="rId14"/>
+              </a:rPr>
+              <a:t>Lofar 1</a:t>
+            </a:r>
+          </a:p>
+          <a:p>
+            <a:r>
+              <a:rPr sz="800">
+                <a:hlinkClick r:id="rId15"/>
+              </a:rPr>
+              <a:t>Lofar 2</a:t>
+            </a:r>
+          </a:p>
+        </p:txBody>
+      </p:sp>
+      <p:sp>
+        <p:nvSpPr>
+          <p:cNvPr id="13" name="Rounded Rectangle 12"/>
+          <p:cNvSpPr/>
+          <p:nvPr>
+            <a:hlinkClick r:id="rId16"/>
+          </p:nvPr>
+        </p:nvSpPr>
+        <p:spPr>
+          <a:xfrm>
+            <a:off x="365760" y="2682240"/>
+            <a:ext cx="2200046" cy="365760"/>
+          </a:xfrm>
+          <a:prstGeom prst="roundRect">
+            <a:avLst/>
+          </a:prstGeom>
+          <a:solidFill>
+            <a:srgbClr val="E8EEF7"/>
+          </a:solidFill>
+          <a:ln>
+            <a:solidFill>
+              <a:srgbClr val="1F3A5F"/>
+            </a:solidFill>
+          </a:ln>
+        </p:spPr>
+        <p:style>
+          <a:lnRef idx="1">
+            <a:schemeClr val="accent1"/>
+          </a:lnRef>
+          <a:fillRef idx="3">
+            <a:schemeClr val="accent1"/>
+          </a:fillRef>
+          <a:effectRef idx="2">
+            <a:schemeClr val="accent1"/>
+          </a:effectRef>
+          <a:fontRef idx="minor">
+            <a:schemeClr val="lt1"/>
+          </a:fontRef>
+        </p:style>
+        <p:txBody>
+          <a:bodyPr rtlCol="0" anchor="ctr" lIns="45720" rIns="45720"/>
+          <a:lstStyle/>
+          <a:p>
+            <a:pPr algn="ctr"/>
+            <a:r>
+              <a:rPr sz="900">
+                <a:solidFill>
+                  <a:srgbClr val="1F3A5F"/>
+                </a:solidFill>
+              </a:rPr>
+              <a:t>Gram 43: FR Excelsior, Category 4, Vulcan</a:t>
+            </a:r>
+          </a:p>
+        </p:txBody>
+      </p:sp>
+      <p:sp>
+        <p:nvSpPr>
+          <p:cNvPr id="14" name="TextBox 13"/>
+          <p:cNvSpPr txBox="1"/>
+          <p:nvPr/>
+        </p:nvSpPr>
+        <p:spPr>
+          <a:xfrm>
+            <a:off x="365760" y="3066288"/>
+            <a:ext cx="2200046" cy="1447800"/>
+          </a:xfrm>
+          <a:prstGeom prst="rect">
+            <a:avLst/>
+          </a:prstGeom>
+          <a:noFill/>
+        </p:spPr>
+        <p:txBody>
+          <a:bodyPr wrap="square">
+            <a:spAutoFit/>
+          </a:bodyPr>
+          <a:lstStyle/>
+          <a:p>
+            <a:r>
+              <a:rPr sz="800">
+                <a:hlinkClick r:id="rId17"/>
+              </a:rPr>
+              <a:t>Lofar 1</a:t>
+            </a:r>
+          </a:p>
+          <a:p>
+            <a:r>
+              <a:rPr sz="800">
+                <a:hlinkClick r:id="rId18"/>
+              </a:rPr>
+              <a:t>Lofar 2</a:t>
+            </a:r>
+          </a:p>
+          <a:p>
+            <a:r>
+              <a:rPr sz="800">
+                <a:hlinkClick r:id="rId19"/>
+              </a:rPr>
+              <a:t>Lofar 3</a:t>
+            </a:r>
+          </a:p>
+          <a:p>
+            <a:r>
+              <a:rPr sz="800">
+                <a:hlinkClick r:id="rId20"/>
+              </a:rPr>
+              <a:t>Lofar 4</a:t>
+            </a:r>
+          </a:p>
+        </p:txBody>
+      </p:sp>
+      <p:sp>
+        <p:nvSpPr>
+          <p:cNvPr id="15" name="Rounded Rectangle 14"/>
+          <p:cNvSpPr/>
+          <p:nvPr>
+            <a:hlinkClick r:id="rId21"/>
+          </p:nvPr>
+        </p:nvSpPr>
+        <p:spPr>
+          <a:xfrm>
+            <a:off x="2657246" y="2682240"/>
+            <a:ext cx="2200046" cy="365760"/>
+          </a:xfrm>
+          <a:prstGeom prst="roundRect">
+            <a:avLst/>
+          </a:prstGeom>
+          <a:solidFill>
+            <a:srgbClr val="E8EEF7"/>
+          </a:solidFill>
+          <a:ln>
+            <a:solidFill>
+              <a:srgbClr val="1F3A5F"/>
+            </a:solidFill>
+          </a:ln>
+        </p:spPr>
+        <p:style>
+          <a:lnRef idx="1">
+            <a:schemeClr val="accent1"/>
+          </a:lnRef>
+          <a:fillRef idx="3">
+            <a:schemeClr val="accent1"/>
+          </a:fillRef>
+          <a:effectRef idx="2">
+            <a:schemeClr val="accent1"/>
+          </a:effectRef>
+          <a:fontRef idx="minor">
+            <a:schemeClr val="lt1"/>
+          </a:fontRef>
+        </p:style>
+        <p:txBody>
+          <a:bodyPr rtlCol="0" anchor="ctr" lIns="45720" rIns="45720"/>
+          <a:lstStyle/>
+          <a:p>
+            <a:pPr algn="ctr"/>
+            <a:r>
+              <a:rPr sz="900">
+                <a:solidFill>
+                  <a:srgbClr val="1F3A5F"/>
+                </a:solidFill>
+              </a:rPr>
+              <a:t>Gram 44: B-wing contact bearing 024, codename Hoth</a:t>
+            </a:r>
+          </a:p>
+        </p:txBody>
+      </p:sp>
+      <p:sp>
+        <p:nvSpPr>
+          <p:cNvPr id="16" name="TextBox 15"/>
+          <p:cNvSpPr txBox="1"/>
+          <p:nvPr/>
+        </p:nvSpPr>
+        <p:spPr>
+          <a:xfrm>
+            <a:off x="2657246" y="3066288"/>
+            <a:ext cx="2200046" cy="1447800"/>
+          </a:xfrm>
+          <a:prstGeom prst="rect">
+            <a:avLst/>
+          </a:prstGeom>
+          <a:noFill/>
+        </p:spPr>
+        <p:txBody>
+          <a:bodyPr wrap="square">
+            <a:spAutoFit/>
+          </a:bodyPr>
+          <a:lstStyle/>
+          <a:p>
+            <a:r>
+              <a:rPr sz="800">
+                <a:hlinkClick r:id="rId22"/>
+              </a:rPr>
+              <a:t>Lofar 1</a:t>
+            </a:r>
+          </a:p>
+          <a:p>
+            <a:r>
+              <a:rPr sz="800">
+                <a:hlinkClick r:id="rId23"/>
+              </a:rPr>
+              <a:t>Lofar 2</a:t>
+            </a:r>
+          </a:p>
+          <a:p>
+            <a:r>
+              <a:rPr sz="800">
+                <a:hlinkClick r:id="rId24"/>
+              </a:rPr>
+              <a:t>Lofar 3</a:t>
+            </a:r>
+          </a:p>
+          <a:p>
+            <a:r>
+              <a:rPr sz="800">
+                <a:hlinkClick r:id="rId25"/>
+              </a:rPr>
+              <a:t>Lofar 4</a:t>
+            </a:r>
+          </a:p>
+        </p:txBody>
+      </p:sp>
+      <p:sp>
+        <p:nvSpPr>
+          <p:cNvPr id="17" name="Rounded Rectangle 16"/>
+          <p:cNvSpPr/>
+          <p:nvPr>
+            <a:hlinkClick r:id="rId26"/>
+          </p:nvPr>
+        </p:nvSpPr>
+        <p:spPr>
+          <a:xfrm>
+            <a:off x="4948732" y="2682240"/>
+            <a:ext cx="2200046" cy="365760"/>
+          </a:xfrm>
+          <a:prstGeom prst="roundRect">
+            <a:avLst/>
+          </a:prstGeom>
+          <a:solidFill>
+            <a:srgbClr val="E8EEF7"/>
+          </a:solidFill>
+          <a:ln>
+            <a:solidFill>
+              <a:srgbClr val="1F3A5F"/>
+            </a:solidFill>
+          </a:ln>
+        </p:spPr>
+        <p:style>
+          <a:lnRef idx="1">
+            <a:schemeClr val="accent1"/>
+          </a:lnRef>
+          <a:fillRef idx="3">
+            <a:schemeClr val="accent1"/>
+          </a:fillRef>
+          <a:effectRef idx="2">
+            <a:schemeClr val="accent1"/>
+          </a:effectRef>
+          <a:fontRef idx="minor">
+            <a:schemeClr val="lt1"/>
+          </a:fontRef>
+        </p:style>
+        <p:txBody>
+          <a:bodyPr rtlCol="0" anchor="ctr" lIns="45720" rIns="45720"/>
+          <a:lstStyle/>
+          <a:p>
+            <a:pPr algn="ctr"/>
+            <a:r>
+              <a:rPr sz="900">
+                <a:solidFill>
+                  <a:srgbClr val="1F3A5F"/>
+                </a:solidFill>
+              </a:rPr>
+              <a:t>Gram 46: Stargazer contact bearing 059, codename Hoth</a:t>
+            </a:r>
+          </a:p>
+        </p:txBody>
+      </p:sp>
+      <p:sp>
+        <p:nvSpPr>
+          <p:cNvPr id="18" name="TextBox 17"/>
+          <p:cNvSpPr txBox="1"/>
+          <p:nvPr/>
+        </p:nvSpPr>
+        <p:spPr>
+          <a:xfrm>
+            <a:off x="4948732" y="3066288"/>
+            <a:ext cx="2200046" cy="1447800"/>
+          </a:xfrm>
+          <a:prstGeom prst="rect">
+            <a:avLst/>
+          </a:prstGeom>
+          <a:noFill/>
+        </p:spPr>
+        <p:txBody>
+          <a:bodyPr wrap="square">
+            <a:spAutoFit/>
+          </a:bodyPr>
+          <a:lstStyle/>
+          <a:p>
+            <a:r>
+              <a:rPr sz="800">
+                <a:hlinkClick r:id="rId27"/>
+              </a:rPr>
+              <a:t>Lofar 1</a:t>
+            </a:r>
+          </a:p>
+          <a:p>
+            <a:r>
+              <a:rPr sz="800">
+                <a:hlinkClick r:id="rId28"/>
+              </a:rPr>
+              <a:t>Lofar 2</a:t>
+            </a:r>
+          </a:p>
+        </p:txBody>
+      </p:sp>
+      <p:sp>
+        <p:nvSpPr>
+          <p:cNvPr id="19" name="Rounded Rectangle 18"/>
+          <p:cNvSpPr/>
+          <p:nvPr>
+            <a:hlinkClick r:id="rId29"/>
+          </p:nvPr>
+        </p:nvSpPr>
+        <p:spPr>
+          <a:xfrm>
+            <a:off x="7240219" y="2682240"/>
+            <a:ext cx="2200046" cy="365760"/>
+          </a:xfrm>
+          <a:prstGeom prst="roundRect">
+            <a:avLst/>
+          </a:prstGeom>
+          <a:solidFill>
+            <a:srgbClr val="E8EEF7"/>
+          </a:solidFill>
+          <a:ln>
+            <a:solidFill>
+              <a:srgbClr val="1F3A5F"/>
+            </a:solidFill>
+          </a:ln>
+        </p:spPr>
+        <p:style>
+          <a:lnRef idx="1">
+            <a:schemeClr val="accent1"/>
+          </a:lnRef>
+          <a:fillRef idx="3">
+            <a:schemeClr val="accent1"/>
+          </a:fillRef>
+          <a:effectRef idx="2">
+            <a:schemeClr val="accent1"/>
+          </a:effectRef>
+          <a:fontRef idx="minor">
+            <a:schemeClr val="lt1"/>
+          </a:fontRef>
+        </p:style>
+        <p:txBody>
+          <a:bodyPr rtlCol="0" anchor="ctr" lIns="45720" rIns="45720"/>
+          <a:lstStyle/>
+          <a:p>
+            <a:pPr algn="ctr"/>
+            <a:r>
+              <a:rPr sz="900">
+                <a:solidFill>
+                  <a:srgbClr val="1F3A5F"/>
+                </a:solidFill>
+              </a:rPr>
+              <a:t>Gram 47: FR Discovery, Category 4, Risa</a:t>
+            </a:r>
+          </a:p>
+        </p:txBody>
+      </p:sp>
+      <p:sp>
+        <p:nvSpPr>
+          <p:cNvPr id="20" name="TextBox 19"/>
+          <p:cNvSpPr txBox="1"/>
+          <p:nvPr/>
+        </p:nvSpPr>
+        <p:spPr>
+          <a:xfrm>
+            <a:off x="7240219" y="3066288"/>
+            <a:ext cx="2200046" cy="1447800"/>
+          </a:xfrm>
+          <a:prstGeom prst="rect">
+            <a:avLst/>
+          </a:prstGeom>
+          <a:noFill/>
+        </p:spPr>
+        <p:txBody>
+          <a:bodyPr wrap="square">
+            <a:spAutoFit/>
+          </a:bodyPr>
+          <a:lstStyle/>
+          <a:p>
+            <a:r>
+              <a:rPr sz="800">
+                <a:hlinkClick r:id="rId30"/>
+              </a:rPr>
+              <a:t>Lofar 1</a:t>
+            </a:r>
+          </a:p>
+        </p:txBody>
+      </p:sp>
+      <p:sp>
+        <p:nvSpPr>
+          <p:cNvPr id="21" name="Rounded Rectangle 20"/>
+          <p:cNvSpPr/>
+          <p:nvPr>
+            <a:hlinkClick r:id="rId31"/>
+          </p:nvPr>
+        </p:nvSpPr>
+        <p:spPr>
+          <a:xfrm>
+            <a:off x="9531705" y="2682240"/>
+            <a:ext cx="2200046" cy="365760"/>
+          </a:xfrm>
+          <a:prstGeom prst="roundRect">
+            <a:avLst/>
+          </a:prstGeom>
+          <a:solidFill>
+            <a:srgbClr val="E8EEF7"/>
+          </a:solidFill>
+          <a:ln>
+            <a:solidFill>
+              <a:srgbClr val="1F3A5F"/>
+            </a:solidFill>
+          </a:ln>
+        </p:spPr>
+        <p:style>
+          <a:lnRef idx="1">
+            <a:schemeClr val="accent1"/>
+          </a:lnRef>
+          <a:fillRef idx="3">
+            <a:schemeClr val="accent1"/>
+          </a:fillRef>
+          <a:effectRef idx="2">
+            <a:schemeClr val="accent1"/>
+          </a:effectRef>
+          <a:fontRef idx="minor">
+            <a:schemeClr val="lt1"/>
+          </a:fontRef>
+        </p:style>
+        <p:txBody>
+          <a:bodyPr rtlCol="0" anchor="ctr" lIns="45720" rIns="45720"/>
+          <a:lstStyle/>
+          <a:p>
+            <a:pPr algn="ctr"/>
+            <a:r>
+              <a:rPr sz="900">
+                <a:solidFill>
+                  <a:srgbClr val="1F3A5F"/>
+                </a:solidFill>
+              </a:rPr>
+              <a:t>Gram 48: FR Discovery, Category 4, Kronos</a:t>
+            </a:r>
+          </a:p>
+        </p:txBody>
+      </p:sp>
+      <p:sp>
+        <p:nvSpPr>
+          <p:cNvPr id="22" name="TextBox 21"/>
+          <p:cNvSpPr txBox="1"/>
+          <p:nvPr/>
+        </p:nvSpPr>
+        <p:spPr>
+          <a:xfrm>
+            <a:off x="9531705" y="3066288"/>
+            <a:ext cx="2200046" cy="1447800"/>
+          </a:xfrm>
+          <a:prstGeom prst="rect">
+            <a:avLst/>
+          </a:prstGeom>
+          <a:noFill/>
+        </p:spPr>
+        <p:txBody>
+          <a:bodyPr wrap="square">
+            <a:spAutoFit/>
+          </a:bodyPr>
+          <a:lstStyle/>
+          <a:p>
+            <a:r>
+              <a:rPr sz="800">
+                <a:hlinkClick r:id="rId32"/>
+              </a:rPr>
+              <a:t>Lofar 1</a:t>
+            </a:r>
+          </a:p>
+          <a:p>
+            <a:r>
+              <a:rPr sz="800">
                 <a:hlinkClick r:id="rId33"/>
               </a:rPr>
               <a:t>Lofar 2</a:t>
+            </a:r>
+          </a:p>
+        </p:txBody>
+      </p:sp>
+    </p:spTree>
+  </p:cSld>
+  <p:clrMapOvr>
+    <a:masterClrMapping/>
+  </p:clrMapOvr>
+</p:sld>
+</file>
+
+<file path=ppt/slides/slide5.xml><?xml version="1.0" encoding="utf-8"?>
+<p:sld xmlns:a="http://schemas.openxmlformats.org/drawingml/2006/main" xmlns:p="http://schemas.openxmlformats.org/presentationml/2006/main" xmlns:r="http://schemas.openxmlformats.org/officeDocument/2006/relationships">
+  <p:cSld>
+    <p:spTree>
+      <p:nvGrpSpPr>
+        <p:cNvPr id="1" name=""/>
+        <p:cNvGrpSpPr/>
+        <p:nvPr/>
+      </p:nvGrpSpPr>
+      <p:grpSpPr/>
+      <p:sp>
+        <p:nvSpPr>
+          <p:cNvPr id="2" name="TextBox 1"/>
+          <p:cNvSpPr txBox="1"/>
+          <p:nvPr/>
+        </p:nvSpPr>
+        <p:spPr>
+          <a:xfrm>
+            <a:off x="914400" y="2377440"/>
+            <a:ext cx="10360152" cy="1280160"/>
+          </a:xfrm>
+          <a:prstGeom prst="rect">
+            <a:avLst/>
+          </a:prstGeom>
+          <a:noFill/>
+        </p:spPr>
+        <p:txBody>
+          <a:bodyPr wrap="square">
+            <a:spAutoFit/>
+          </a:bodyPr>
+          <a:lstStyle/>
+          <a:p>
+            <a:pPr algn="ctr"/>
+            <a:r>
+              <a:rPr sz="4000" b="1">
+                <a:solidFill>
+                  <a:srgbClr val="1F3A5F"/>
+                </a:solidFill>
+              </a:rPr>
+              <a:t>End of Instructor Progress Final Assessment Grams</a:t>
+            </a:r>
+          </a:p>
+        </p:txBody>
+      </p:sp>
+      <p:sp>
+        <p:nvSpPr>
+          <p:cNvPr id="3" name="TextBox 2"/>
+          <p:cNvSpPr txBox="1"/>
+          <p:nvPr/>
+        </p:nvSpPr>
+        <p:spPr>
+          <a:xfrm>
+            <a:off x="914400" y="3840480"/>
+            <a:ext cx="10360152" cy="731520"/>
+          </a:xfrm>
+          <a:prstGeom prst="rect">
+            <a:avLst/>
+          </a:prstGeom>
+          <a:noFill/>
+        </p:spPr>
+        <p:txBody>
+          <a:bodyPr wrap="none">
+            <a:spAutoFit/>
+          </a:bodyPr>
+          <a:lstStyle/>
+          <a:p>
+            <a:pPr algn="ctr"/>
+            <a:r>
+              <a:rPr sz="2400">
+                <a:solidFill>
+                  <a:srgbClr val="1F3A5F"/>
+                </a:solidFill>
+              </a:rPr>
+              <a:t>Instructor Version</a:t>
             </a:r>
           </a:p>
         </p:txBody>

</xml_diff>

<commit_message>
Revert generated PPTX binaries before merging main
</commit_message>
<xml_diff>
--- a/source/Instructor Progress Final Assessment Grams/Instructor Progress Final Assessment Grams.pptx
+++ b/source/Instructor Progress Final Assessment Grams/Instructor Progress Final Assessment Grams.pptx
@@ -8,8 +8,6 @@
     <p:sldId id="256" r:id="rId7"/>
     <p:sldId id="257" r:id="rId8"/>
     <p:sldId id="258" r:id="rId9"/>
-    <p:sldId id="259" r:id="rId10"/>
-    <p:sldId id="260" r:id="rId11"/>
   </p:sldIdLst>
   <p:sldSz cx="12188952" cy="6858000" type="screen4x3"/>
   <p:notesSz cx="6858000" cy="9144000"/>
@@ -3094,14 +3092,120 @@
       <p:grpSpPr/>
       <p:sp>
         <p:nvSpPr>
-          <p:cNvPr id="2" name="TextBox 1"/>
+          <p:cNvPr id="2" name="Rectangle 1"/>
+          <p:cNvSpPr/>
+          <p:nvPr/>
+        </p:nvSpPr>
+        <p:spPr>
+          <a:xfrm>
+            <a:off x="0" y="0"/>
+            <a:ext cx="12188952" cy="548640"/>
+          </a:xfrm>
+          <a:prstGeom prst="rect">
+            <a:avLst/>
+          </a:prstGeom>
+          <a:solidFill>
+            <a:srgbClr val="1F3A5F"/>
+          </a:solidFill>
+          <a:ln>
+            <a:noFill/>
+          </a:ln>
+        </p:spPr>
+        <p:style>
+          <a:lnRef idx="1">
+            <a:schemeClr val="accent1"/>
+          </a:lnRef>
+          <a:fillRef idx="3">
+            <a:schemeClr val="accent1"/>
+          </a:fillRef>
+          <a:effectRef idx="2">
+            <a:schemeClr val="accent1"/>
+          </a:effectRef>
+          <a:fontRef idx="minor">
+            <a:schemeClr val="lt1"/>
+          </a:fontRef>
+        </p:style>
+        <p:txBody>
+          <a:bodyPr rtlCol="0" anchor="ctr" lIns="182880" rIns="182880"/>
+          <a:lstStyle/>
+          <a:p>
+            <a:pPr algn="ctr"/>
+            <a:r>
+              <a:rPr sz="2000" b="1">
+                <a:solidFill>
+                  <a:srgbClr val="FFFFFF"/>
+                </a:solidFill>
+              </a:rPr>
+              <a:t>Instructor Progress Final Assessment Grams — Page 1 of 3</a:t>
+            </a:r>
+          </a:p>
+        </p:txBody>
+      </p:sp>
+      <p:sp>
+        <p:nvSpPr>
+          <p:cNvPr id="3" name="Rounded Rectangle 2">
+            <a:hlinkClick r:id="rId2"/>
+          </p:cNvPr>
+          <p:cNvSpPr/>
+          <p:nvPr/>
+        </p:nvSpPr>
+        <p:spPr>
+          <a:xfrm>
+            <a:off x="365760" y="731520"/>
+            <a:ext cx="2200046" cy="365760"/>
+          </a:xfrm>
+          <a:prstGeom prst="roundRect">
+            <a:avLst/>
+          </a:prstGeom>
+          <a:solidFill>
+            <a:srgbClr val="E8EEF7"/>
+          </a:solidFill>
+          <a:ln>
+            <a:solidFill>
+              <a:srgbClr val="1F3A5F"/>
+            </a:solidFill>
+          </a:ln>
+        </p:spPr>
+        <p:style>
+          <a:lnRef idx="1">
+            <a:schemeClr val="accent1"/>
+          </a:lnRef>
+          <a:fillRef idx="3">
+            <a:schemeClr val="accent1"/>
+          </a:fillRef>
+          <a:effectRef idx="2">
+            <a:schemeClr val="accent1"/>
+          </a:effectRef>
+          <a:fontRef idx="minor">
+            <a:schemeClr val="lt1"/>
+          </a:fontRef>
+        </p:style>
+        <p:txBody>
+          <a:bodyPr rtlCol="0" anchor="ctr" lIns="45720" rIns="45720"/>
+          <a:lstStyle/>
+          <a:p>
+            <a:pPr algn="ctr"/>
+            <a:r>
+              <a:rPr sz="900">
+                <a:solidFill>
+                  <a:srgbClr val="1F3A5F"/>
+                </a:solidFill>
+              </a:rPr>
+              <a:t>Gram 1: FR TIE Bomber, Category 3, Tatooine</a:t>
+            </a:r>
+          </a:p>
+        </p:txBody>
+      </p:sp>
+      <p:sp>
+        <p:nvSpPr>
+          <p:cNvPr id="4" name="TextBox 3"/>
           <p:cNvSpPr txBox="1"/>
           <p:nvPr/>
         </p:nvSpPr>
         <p:spPr>
           <a:xfrm>
-            <a:off x="914400" y="2377440"/>
-            <a:ext cx="10360152" cy="1280160"/>
+            <a:off x="365760" y="1115568"/>
+            <a:ext cx="2200046" cy="1447800"/>
           </a:xfrm>
           <a:prstGeom prst="rect">
             <a:avLst/>
@@ -3114,28 +3218,80 @@
           </a:bodyPr>
           <a:lstStyle/>
           <a:p>
+            <a:r>
+              <a:rPr sz="800">
+                <a:hlinkClick r:id="rId3"/>
+              </a:rPr>
+              <a:t>Lofar 1</a:t>
+            </a:r>
+          </a:p>
+        </p:txBody>
+      </p:sp>
+      <p:sp>
+        <p:nvSpPr>
+          <p:cNvPr id="5" name="Rounded Rectangle 4">
+            <a:hlinkClick r:id="rId4"/>
+          </p:cNvPr>
+          <p:cNvSpPr/>
+          <p:nvPr/>
+        </p:nvSpPr>
+        <p:spPr>
+          <a:xfrm>
+            <a:off x="2657246" y="731520"/>
+            <a:ext cx="2200046" cy="365760"/>
+          </a:xfrm>
+          <a:prstGeom prst="roundRect">
+            <a:avLst/>
+          </a:prstGeom>
+          <a:solidFill>
+            <a:srgbClr val="E8EEF7"/>
+          </a:solidFill>
+          <a:ln>
+            <a:solidFill>
+              <a:srgbClr val="1F3A5F"/>
+            </a:solidFill>
+          </a:ln>
+        </p:spPr>
+        <p:style>
+          <a:lnRef idx="1">
+            <a:schemeClr val="accent1"/>
+          </a:lnRef>
+          <a:fillRef idx="3">
+            <a:schemeClr val="accent1"/>
+          </a:fillRef>
+          <a:effectRef idx="2">
+            <a:schemeClr val="accent1"/>
+          </a:effectRef>
+          <a:fontRef idx="minor">
+            <a:schemeClr val="lt1"/>
+          </a:fontRef>
+        </p:style>
+        <p:txBody>
+          <a:bodyPr rtlCol="0" anchor="ctr" lIns="45720" rIns="45720"/>
+          <a:lstStyle/>
+          <a:p>
             <a:pPr algn="ctr"/>
             <a:r>
-              <a:rPr sz="4000" b="1">
+              <a:rPr sz="900">
                 <a:solidFill>
                   <a:srgbClr val="1F3A5F"/>
                 </a:solidFill>
               </a:rPr>
-              <a:t>Welcome to Instructor Progress Final Assessment Grams</a:t>
-            </a:r>
-          </a:p>
-        </p:txBody>
-      </p:sp>
-      <p:sp>
-        <p:nvSpPr>
-          <p:cNvPr id="3" name="TextBox 2"/>
+              <a:t>Gram 2: FR Sovereign-class, Category 1, Tatooine</a:t>
+            </a:r>
+          </a:p>
+        </p:txBody>
+      </p:sp>
+      <p:sp>
+        <p:nvSpPr>
+          <p:cNvPr id="6" name="TextBox 5"/>
           <p:cNvSpPr txBox="1"/>
           <p:nvPr/>
         </p:nvSpPr>
         <p:spPr>
           <a:xfrm>
-            <a:off x="914400" y="3840480"/>
-            <a:ext cx="10360152" cy="731520"/>
+            <a:off x="2657246" y="1115568"/>
+            <a:ext cx="2200046" cy="1447800"/>
           </a:xfrm>
           <a:prstGeom prst="rect">
             <a:avLst/>
@@ -3143,19 +3299,1326 @@
           <a:noFill/>
         </p:spPr>
         <p:txBody>
-          <a:bodyPr wrap="none">
+          <a:bodyPr wrap="square">
             <a:spAutoFit/>
           </a:bodyPr>
           <a:lstStyle/>
           <a:p>
+            <a:r>
+              <a:rPr sz="800">
+                <a:hlinkClick r:id="rId5"/>
+              </a:rPr>
+              <a:t>Lofar 1</a:t>
+            </a:r>
+          </a:p>
+          <a:p>
+            <a:r>
+              <a:rPr sz="800">
+                <a:hlinkClick r:id="rId6"/>
+              </a:rPr>
+              <a:t>Lofar 2</a:t>
+            </a:r>
+          </a:p>
+          <a:p>
+            <a:r>
+              <a:rPr sz="800">
+                <a:hlinkClick r:id="rId7"/>
+              </a:rPr>
+              <a:t>Lofar 3</a:t>
+            </a:r>
+          </a:p>
+        </p:txBody>
+      </p:sp>
+      <p:sp>
+        <p:nvSpPr>
+          <p:cNvPr id="7" name="Rounded Rectangle 6">
+            <a:hlinkClick r:id="rId8"/>
+          </p:cNvPr>
+          <p:cNvSpPr/>
+          <p:nvPr/>
+        </p:nvSpPr>
+        <p:spPr>
+          <a:xfrm>
+            <a:off x="4948732" y="731520"/>
+            <a:ext cx="2200046" cy="365760"/>
+          </a:xfrm>
+          <a:prstGeom prst="roundRect">
+            <a:avLst/>
+          </a:prstGeom>
+          <a:solidFill>
+            <a:srgbClr val="E8EEF7"/>
+          </a:solidFill>
+          <a:ln>
+            <a:solidFill>
+              <a:srgbClr val="1F3A5F"/>
+            </a:solidFill>
+          </a:ln>
+        </p:spPr>
+        <p:style>
+          <a:lnRef idx="1">
+            <a:schemeClr val="accent1"/>
+          </a:lnRef>
+          <a:fillRef idx="3">
+            <a:schemeClr val="accent1"/>
+          </a:fillRef>
+          <a:effectRef idx="2">
+            <a:schemeClr val="accent1"/>
+          </a:effectRef>
+          <a:fontRef idx="minor">
+            <a:schemeClr val="lt1"/>
+          </a:fontRef>
+        </p:style>
+        <p:txBody>
+          <a:bodyPr rtlCol="0" anchor="ctr" lIns="45720" rIns="45720"/>
+          <a:lstStyle/>
+          <a:p>
             <a:pPr algn="ctr"/>
             <a:r>
-              <a:rPr sz="2400">
+              <a:rPr sz="900">
                 <a:solidFill>
                   <a:srgbClr val="1F3A5F"/>
                 </a:solidFill>
               </a:rPr>
-              <a:t>Instructor Version</a:t>
+              <a:t>Gram 3: FR TIE Fighter, Category 4, Mustafar</a:t>
+            </a:r>
+          </a:p>
+        </p:txBody>
+      </p:sp>
+      <p:sp>
+        <p:nvSpPr>
+          <p:cNvPr id="8" name="TextBox 7"/>
+          <p:cNvSpPr txBox="1"/>
+          <p:nvPr/>
+        </p:nvSpPr>
+        <p:spPr>
+          <a:xfrm>
+            <a:off x="4948732" y="1115568"/>
+            <a:ext cx="2200046" cy="1447800"/>
+          </a:xfrm>
+          <a:prstGeom prst="rect">
+            <a:avLst/>
+          </a:prstGeom>
+          <a:noFill/>
+        </p:spPr>
+        <p:txBody>
+          <a:bodyPr wrap="square">
+            <a:spAutoFit/>
+          </a:bodyPr>
+          <a:lstStyle/>
+          <a:p>
+            <a:r>
+              <a:rPr sz="800">
+                <a:hlinkClick r:id="rId9"/>
+              </a:rPr>
+              <a:t>Lofar 1</a:t>
+            </a:r>
+          </a:p>
+          <a:p>
+            <a:r>
+              <a:rPr sz="800">
+                <a:hlinkClick r:id="rId10"/>
+              </a:rPr>
+              <a:t>Lofar 2</a:t>
+            </a:r>
+          </a:p>
+          <a:p>
+            <a:r>
+              <a:rPr sz="800">
+                <a:hlinkClick r:id="rId11"/>
+              </a:rPr>
+              <a:t>Lofar 3</a:t>
+            </a:r>
+          </a:p>
+        </p:txBody>
+      </p:sp>
+      <p:sp>
+        <p:nvSpPr>
+          <p:cNvPr id="9" name="Rounded Rectangle 8">
+            <a:hlinkClick r:id="rId12"/>
+          </p:cNvPr>
+          <p:cNvSpPr/>
+          <p:nvPr/>
+        </p:nvSpPr>
+        <p:spPr>
+          <a:xfrm>
+            <a:off x="7240219" y="731520"/>
+            <a:ext cx="2200046" cy="365760"/>
+          </a:xfrm>
+          <a:prstGeom prst="roundRect">
+            <a:avLst/>
+          </a:prstGeom>
+          <a:solidFill>
+            <a:srgbClr val="E8EEF7"/>
+          </a:solidFill>
+          <a:ln>
+            <a:solidFill>
+              <a:srgbClr val="1F3A5F"/>
+            </a:solidFill>
+          </a:ln>
+        </p:spPr>
+        <p:style>
+          <a:lnRef idx="1">
+            <a:schemeClr val="accent1"/>
+          </a:lnRef>
+          <a:fillRef idx="3">
+            <a:schemeClr val="accent1"/>
+          </a:fillRef>
+          <a:effectRef idx="2">
+            <a:schemeClr val="accent1"/>
+          </a:effectRef>
+          <a:fontRef idx="minor">
+            <a:schemeClr val="lt1"/>
+          </a:fontRef>
+        </p:style>
+        <p:txBody>
+          <a:bodyPr rtlCol="0" anchor="ctr" lIns="45720" rIns="45720"/>
+          <a:lstStyle/>
+          <a:p>
+            <a:pPr algn="ctr"/>
+            <a:r>
+              <a:rPr sz="900">
+                <a:solidFill>
+                  <a:srgbClr val="1F3A5F"/>
+                </a:solidFill>
+              </a:rPr>
+              <a:t>Gram 4: FR Intrepid-class, Category 4, Mustafar</a:t>
+            </a:r>
+          </a:p>
+        </p:txBody>
+      </p:sp>
+      <p:sp>
+        <p:nvSpPr>
+          <p:cNvPr id="10" name="TextBox 9"/>
+          <p:cNvSpPr txBox="1"/>
+          <p:nvPr/>
+        </p:nvSpPr>
+        <p:spPr>
+          <a:xfrm>
+            <a:off x="7240219" y="1115568"/>
+            <a:ext cx="2200046" cy="1447800"/>
+          </a:xfrm>
+          <a:prstGeom prst="rect">
+            <a:avLst/>
+          </a:prstGeom>
+          <a:noFill/>
+        </p:spPr>
+        <p:txBody>
+          <a:bodyPr wrap="square">
+            <a:spAutoFit/>
+          </a:bodyPr>
+          <a:lstStyle/>
+          <a:p>
+            <a:r>
+              <a:rPr sz="800">
+                <a:hlinkClick r:id="rId13"/>
+              </a:rPr>
+              <a:t>Lofar 1</a:t>
+            </a:r>
+          </a:p>
+          <a:p>
+            <a:r>
+              <a:rPr sz="800">
+                <a:hlinkClick r:id="rId14"/>
+              </a:rPr>
+              <a:t>Lofar 2</a:t>
+            </a:r>
+          </a:p>
+          <a:p>
+            <a:r>
+              <a:rPr sz="800">
+                <a:hlinkClick r:id="rId15"/>
+              </a:rPr>
+              <a:t>Lofar 3</a:t>
+            </a:r>
+          </a:p>
+        </p:txBody>
+      </p:sp>
+      <p:sp>
+        <p:nvSpPr>
+          <p:cNvPr id="11" name="Rounded Rectangle 10">
+            <a:hlinkClick r:id="rId16"/>
+          </p:cNvPr>
+          <p:cNvSpPr/>
+          <p:nvPr/>
+        </p:nvSpPr>
+        <p:spPr>
+          <a:xfrm>
+            <a:off x="9531705" y="731520"/>
+            <a:ext cx="2200046" cy="365760"/>
+          </a:xfrm>
+          <a:prstGeom prst="roundRect">
+            <a:avLst/>
+          </a:prstGeom>
+          <a:solidFill>
+            <a:srgbClr val="E8EEF7"/>
+          </a:solidFill>
+          <a:ln>
+            <a:solidFill>
+              <a:srgbClr val="1F3A5F"/>
+            </a:solidFill>
+          </a:ln>
+        </p:spPr>
+        <p:style>
+          <a:lnRef idx="1">
+            <a:schemeClr val="accent1"/>
+          </a:lnRef>
+          <a:fillRef idx="3">
+            <a:schemeClr val="accent1"/>
+          </a:fillRef>
+          <a:effectRef idx="2">
+            <a:schemeClr val="accent1"/>
+          </a:effectRef>
+          <a:fontRef idx="minor">
+            <a:schemeClr val="lt1"/>
+          </a:fontRef>
+        </p:style>
+        <p:txBody>
+          <a:bodyPr rtlCol="0" anchor="ctr" lIns="45720" rIns="45720"/>
+          <a:lstStyle/>
+          <a:p>
+            <a:pPr algn="ctr"/>
+            <a:r>
+              <a:rPr sz="900">
+                <a:solidFill>
+                  <a:srgbClr val="1F3A5F"/>
+                </a:solidFill>
+              </a:rPr>
+              <a:t>Gram 7: FR Discovery, Category 1, Dagobah</a:t>
+            </a:r>
+          </a:p>
+        </p:txBody>
+      </p:sp>
+      <p:sp>
+        <p:nvSpPr>
+          <p:cNvPr id="12" name="TextBox 11"/>
+          <p:cNvSpPr txBox="1"/>
+          <p:nvPr/>
+        </p:nvSpPr>
+        <p:spPr>
+          <a:xfrm>
+            <a:off x="9531705" y="1115568"/>
+            <a:ext cx="2200046" cy="1447800"/>
+          </a:xfrm>
+          <a:prstGeom prst="rect">
+            <a:avLst/>
+          </a:prstGeom>
+          <a:noFill/>
+        </p:spPr>
+        <p:txBody>
+          <a:bodyPr wrap="square">
+            <a:spAutoFit/>
+          </a:bodyPr>
+          <a:lstStyle/>
+          <a:p>
+            <a:r>
+              <a:rPr sz="800">
+                <a:hlinkClick r:id="rId17"/>
+              </a:rPr>
+              <a:t>Lofar 1</a:t>
+            </a:r>
+          </a:p>
+        </p:txBody>
+      </p:sp>
+      <p:sp>
+        <p:nvSpPr>
+          <p:cNvPr id="13" name="Rounded Rectangle 12">
+            <a:hlinkClick r:id="rId18"/>
+          </p:cNvPr>
+          <p:cNvSpPr/>
+          <p:nvPr/>
+        </p:nvSpPr>
+        <p:spPr>
+          <a:xfrm>
+            <a:off x="365760" y="2682240"/>
+            <a:ext cx="2200046" cy="365760"/>
+          </a:xfrm>
+          <a:prstGeom prst="roundRect">
+            <a:avLst/>
+          </a:prstGeom>
+          <a:solidFill>
+            <a:srgbClr val="E8EEF7"/>
+          </a:solidFill>
+          <a:ln>
+            <a:solidFill>
+              <a:srgbClr val="1F3A5F"/>
+            </a:solidFill>
+          </a:ln>
+        </p:spPr>
+        <p:style>
+          <a:lnRef idx="1">
+            <a:schemeClr val="accent1"/>
+          </a:lnRef>
+          <a:fillRef idx="3">
+            <a:schemeClr val="accent1"/>
+          </a:fillRef>
+          <a:effectRef idx="2">
+            <a:schemeClr val="accent1"/>
+          </a:effectRef>
+          <a:fontRef idx="minor">
+            <a:schemeClr val="lt1"/>
+          </a:fontRef>
+        </p:style>
+        <p:txBody>
+          <a:bodyPr rtlCol="0" anchor="ctr" lIns="45720" rIns="45720"/>
+          <a:lstStyle/>
+          <a:p>
+            <a:pPr algn="ctr"/>
+            <a:r>
+              <a:rPr sz="900">
+                <a:solidFill>
+                  <a:srgbClr val="1F3A5F"/>
+                </a:solidFill>
+              </a:rPr>
+              <a:t>Gram 8: Miranda-class contact bearing 288, codename Dank</a:t>
+            </a:r>
+          </a:p>
+        </p:txBody>
+      </p:sp>
+      <p:sp>
+        <p:nvSpPr>
+          <p:cNvPr id="14" name="TextBox 13"/>
+          <p:cNvSpPr txBox="1"/>
+          <p:nvPr/>
+        </p:nvSpPr>
+        <p:spPr>
+          <a:xfrm>
+            <a:off x="365760" y="3066288"/>
+            <a:ext cx="2200046" cy="1447800"/>
+          </a:xfrm>
+          <a:prstGeom prst="rect">
+            <a:avLst/>
+          </a:prstGeom>
+          <a:noFill/>
+        </p:spPr>
+        <p:txBody>
+          <a:bodyPr wrap="square">
+            <a:spAutoFit/>
+          </a:bodyPr>
+          <a:lstStyle/>
+          <a:p>
+            <a:r>
+              <a:rPr sz="800">
+                <a:hlinkClick r:id="rId19"/>
+              </a:rPr>
+              <a:t>Lofar 1</a:t>
+            </a:r>
+          </a:p>
+          <a:p>
+            <a:r>
+              <a:rPr sz="800">
+                <a:hlinkClick r:id="rId20"/>
+              </a:rPr>
+              <a:t>Lofar 2</a:t>
+            </a:r>
+          </a:p>
+          <a:p>
+            <a:r>
+              <a:rPr sz="800">
+                <a:hlinkClick r:id="rId21"/>
+              </a:rPr>
+              <a:t>Lofar 3</a:t>
+            </a:r>
+          </a:p>
+          <a:p>
+            <a:r>
+              <a:rPr sz="800">
+                <a:hlinkClick r:id="rId22"/>
+              </a:rPr>
+              <a:t>Lofar 4</a:t>
+            </a:r>
+          </a:p>
+        </p:txBody>
+      </p:sp>
+      <p:sp>
+        <p:nvSpPr>
+          <p:cNvPr id="15" name="Rounded Rectangle 14">
+            <a:hlinkClick r:id="rId23"/>
+          </p:cNvPr>
+          <p:cNvSpPr/>
+          <p:nvPr/>
+        </p:nvSpPr>
+        <p:spPr>
+          <a:xfrm>
+            <a:off x="2657246" y="2682240"/>
+            <a:ext cx="2200046" cy="365760"/>
+          </a:xfrm>
+          <a:prstGeom prst="roundRect">
+            <a:avLst/>
+          </a:prstGeom>
+          <a:solidFill>
+            <a:srgbClr val="E8EEF7"/>
+          </a:solidFill>
+          <a:ln>
+            <a:solidFill>
+              <a:srgbClr val="1F3A5F"/>
+            </a:solidFill>
+          </a:ln>
+        </p:spPr>
+        <p:style>
+          <a:lnRef idx="1">
+            <a:schemeClr val="accent1"/>
+          </a:lnRef>
+          <a:fillRef idx="3">
+            <a:schemeClr val="accent1"/>
+          </a:fillRef>
+          <a:effectRef idx="2">
+            <a:schemeClr val="accent1"/>
+          </a:effectRef>
+          <a:fontRef idx="minor">
+            <a:schemeClr val="lt1"/>
+          </a:fontRef>
+        </p:style>
+        <p:txBody>
+          <a:bodyPr rtlCol="0" anchor="ctr" lIns="45720" rIns="45720"/>
+          <a:lstStyle/>
+          <a:p>
+            <a:pPr algn="ctr"/>
+            <a:r>
+              <a:rPr sz="900">
+                <a:solidFill>
+                  <a:srgbClr val="1F3A5F"/>
+                </a:solidFill>
+              </a:rPr>
+              <a:t>Gram 9: Enterprise contact bearing 084, codename Yavin</a:t>
+            </a:r>
+          </a:p>
+        </p:txBody>
+      </p:sp>
+      <p:sp>
+        <p:nvSpPr>
+          <p:cNvPr id="16" name="TextBox 15"/>
+          <p:cNvSpPr txBox="1"/>
+          <p:nvPr/>
+        </p:nvSpPr>
+        <p:spPr>
+          <a:xfrm>
+            <a:off x="2657246" y="3066288"/>
+            <a:ext cx="2200046" cy="1447800"/>
+          </a:xfrm>
+          <a:prstGeom prst="rect">
+            <a:avLst/>
+          </a:prstGeom>
+          <a:noFill/>
+        </p:spPr>
+        <p:txBody>
+          <a:bodyPr wrap="square">
+            <a:spAutoFit/>
+          </a:bodyPr>
+          <a:lstStyle/>
+          <a:p>
+            <a:r>
+              <a:rPr sz="800">
+                <a:hlinkClick r:id="rId24"/>
+              </a:rPr>
+              <a:t>Lofar 1</a:t>
+            </a:r>
+          </a:p>
+          <a:p>
+            <a:r>
+              <a:rPr sz="800">
+                <a:hlinkClick r:id="rId25"/>
+              </a:rPr>
+              <a:t>Lofar 2</a:t>
+            </a:r>
+          </a:p>
+        </p:txBody>
+      </p:sp>
+      <p:sp>
+        <p:nvSpPr>
+          <p:cNvPr id="17" name="Rounded Rectangle 16">
+            <a:hlinkClick r:id="rId26"/>
+          </p:cNvPr>
+          <p:cNvSpPr/>
+          <p:nvPr/>
+        </p:nvSpPr>
+        <p:spPr>
+          <a:xfrm>
+            <a:off x="4948732" y="2682240"/>
+            <a:ext cx="2200046" cy="365760"/>
+          </a:xfrm>
+          <a:prstGeom prst="roundRect">
+            <a:avLst/>
+          </a:prstGeom>
+          <a:solidFill>
+            <a:srgbClr val="E8EEF7"/>
+          </a:solidFill>
+          <a:ln>
+            <a:solidFill>
+              <a:srgbClr val="1F3A5F"/>
+            </a:solidFill>
+          </a:ln>
+        </p:spPr>
+        <p:style>
+          <a:lnRef idx="1">
+            <a:schemeClr val="accent1"/>
+          </a:lnRef>
+          <a:fillRef idx="3">
+            <a:schemeClr val="accent1"/>
+          </a:fillRef>
+          <a:effectRef idx="2">
+            <a:schemeClr val="accent1"/>
+          </a:effectRef>
+          <a:fontRef idx="minor">
+            <a:schemeClr val="lt1"/>
+          </a:fontRef>
+        </p:style>
+        <p:txBody>
+          <a:bodyPr rtlCol="0" anchor="ctr" lIns="45720" rIns="45720"/>
+          <a:lstStyle/>
+          <a:p>
+            <a:pPr algn="ctr"/>
+            <a:r>
+              <a:rPr sz="900">
+                <a:solidFill>
+                  <a:srgbClr val="1F3A5F"/>
+                </a:solidFill>
+              </a:rPr>
+              <a:t>Gram 10: FR A-wing, Category 3, Risa</a:t>
+            </a:r>
+          </a:p>
+        </p:txBody>
+      </p:sp>
+      <p:sp>
+        <p:nvSpPr>
+          <p:cNvPr id="18" name="TextBox 17"/>
+          <p:cNvSpPr txBox="1"/>
+          <p:nvPr/>
+        </p:nvSpPr>
+        <p:spPr>
+          <a:xfrm>
+            <a:off x="4948732" y="3066288"/>
+            <a:ext cx="2200046" cy="1447800"/>
+          </a:xfrm>
+          <a:prstGeom prst="rect">
+            <a:avLst/>
+          </a:prstGeom>
+          <a:noFill/>
+        </p:spPr>
+        <p:txBody>
+          <a:bodyPr wrap="square">
+            <a:spAutoFit/>
+          </a:bodyPr>
+          <a:lstStyle/>
+          <a:p>
+            <a:r>
+              <a:rPr sz="800">
+                <a:hlinkClick r:id="rId27"/>
+              </a:rPr>
+              <a:t>Lofar 1</a:t>
+            </a:r>
+          </a:p>
+        </p:txBody>
+      </p:sp>
+      <p:sp>
+        <p:nvSpPr>
+          <p:cNvPr id="19" name="Rounded Rectangle 18">
+            <a:hlinkClick r:id="rId28"/>
+          </p:cNvPr>
+          <p:cNvSpPr/>
+          <p:nvPr/>
+        </p:nvSpPr>
+        <p:spPr>
+          <a:xfrm>
+            <a:off x="7240219" y="2682240"/>
+            <a:ext cx="2200046" cy="365760"/>
+          </a:xfrm>
+          <a:prstGeom prst="roundRect">
+            <a:avLst/>
+          </a:prstGeom>
+          <a:solidFill>
+            <a:srgbClr val="E8EEF7"/>
+          </a:solidFill>
+          <a:ln>
+            <a:solidFill>
+              <a:srgbClr val="1F3A5F"/>
+            </a:solidFill>
+          </a:ln>
+        </p:spPr>
+        <p:style>
+          <a:lnRef idx="1">
+            <a:schemeClr val="accent1"/>
+          </a:lnRef>
+          <a:fillRef idx="3">
+            <a:schemeClr val="accent1"/>
+          </a:fillRef>
+          <a:effectRef idx="2">
+            <a:schemeClr val="accent1"/>
+          </a:effectRef>
+          <a:fontRef idx="minor">
+            <a:schemeClr val="lt1"/>
+          </a:fontRef>
+        </p:style>
+        <p:txBody>
+          <a:bodyPr rtlCol="0" anchor="ctr" lIns="45720" rIns="45720"/>
+          <a:lstStyle/>
+          <a:p>
+            <a:pPr algn="ctr"/>
+            <a:r>
+              <a:rPr sz="900">
+                <a:solidFill>
+                  <a:srgbClr val="1F3A5F"/>
+                </a:solidFill>
+              </a:rPr>
+              <a:t>Gram 11: FR Star Destroyer, Category 1, Vulcan</a:t>
+            </a:r>
+          </a:p>
+        </p:txBody>
+      </p:sp>
+      <p:sp>
+        <p:nvSpPr>
+          <p:cNvPr id="20" name="TextBox 19"/>
+          <p:cNvSpPr txBox="1"/>
+          <p:nvPr/>
+        </p:nvSpPr>
+        <p:spPr>
+          <a:xfrm>
+            <a:off x="7240219" y="3066288"/>
+            <a:ext cx="2200046" cy="1447800"/>
+          </a:xfrm>
+          <a:prstGeom prst="rect">
+            <a:avLst/>
+          </a:prstGeom>
+          <a:noFill/>
+        </p:spPr>
+        <p:txBody>
+          <a:bodyPr wrap="square">
+            <a:spAutoFit/>
+          </a:bodyPr>
+          <a:lstStyle/>
+          <a:p>
+            <a:r>
+              <a:rPr sz="800">
+                <a:hlinkClick r:id="rId29"/>
+              </a:rPr>
+              <a:t>Lofar 1</a:t>
+            </a:r>
+          </a:p>
+        </p:txBody>
+      </p:sp>
+      <p:sp>
+        <p:nvSpPr>
+          <p:cNvPr id="21" name="Rounded Rectangle 20">
+            <a:hlinkClick r:id="rId30"/>
+          </p:cNvPr>
+          <p:cNvSpPr/>
+          <p:nvPr/>
+        </p:nvSpPr>
+        <p:spPr>
+          <a:xfrm>
+            <a:off x="9531705" y="2682240"/>
+            <a:ext cx="2200046" cy="365760"/>
+          </a:xfrm>
+          <a:prstGeom prst="roundRect">
+            <a:avLst/>
+          </a:prstGeom>
+          <a:solidFill>
+            <a:srgbClr val="E8EEF7"/>
+          </a:solidFill>
+          <a:ln>
+            <a:solidFill>
+              <a:srgbClr val="1F3A5F"/>
+            </a:solidFill>
+          </a:ln>
+        </p:spPr>
+        <p:style>
+          <a:lnRef idx="1">
+            <a:schemeClr val="accent1"/>
+          </a:lnRef>
+          <a:fillRef idx="3">
+            <a:schemeClr val="accent1"/>
+          </a:fillRef>
+          <a:effectRef idx="2">
+            <a:schemeClr val="accent1"/>
+          </a:effectRef>
+          <a:fontRef idx="minor">
+            <a:schemeClr val="lt1"/>
+          </a:fontRef>
+        </p:style>
+        <p:txBody>
+          <a:bodyPr rtlCol="0" anchor="ctr" lIns="45720" rIns="45720"/>
+          <a:lstStyle/>
+          <a:p>
+            <a:pPr algn="ctr"/>
+            <a:r>
+              <a:rPr sz="900">
+                <a:solidFill>
+                  <a:srgbClr val="1F3A5F"/>
+                </a:solidFill>
+              </a:rPr>
+              <a:t>Gram 12: Venator-class contact bearing 330, codename Dank</a:t>
+            </a:r>
+          </a:p>
+        </p:txBody>
+      </p:sp>
+      <p:sp>
+        <p:nvSpPr>
+          <p:cNvPr id="22" name="TextBox 21"/>
+          <p:cNvSpPr txBox="1"/>
+          <p:nvPr/>
+        </p:nvSpPr>
+        <p:spPr>
+          <a:xfrm>
+            <a:off x="9531705" y="3066288"/>
+            <a:ext cx="2200046" cy="1447800"/>
+          </a:xfrm>
+          <a:prstGeom prst="rect">
+            <a:avLst/>
+          </a:prstGeom>
+          <a:noFill/>
+        </p:spPr>
+        <p:txBody>
+          <a:bodyPr wrap="square">
+            <a:spAutoFit/>
+          </a:bodyPr>
+          <a:lstStyle/>
+          <a:p>
+            <a:r>
+              <a:rPr sz="800">
+                <a:hlinkClick r:id="rId31"/>
+              </a:rPr>
+              <a:t>Lofar 1</a:t>
+            </a:r>
+          </a:p>
+          <a:p>
+            <a:r>
+              <a:rPr sz="800">
+                <a:hlinkClick r:id="rId32"/>
+              </a:rPr>
+              <a:t>Lofar 2</a:t>
+            </a:r>
+          </a:p>
+          <a:p>
+            <a:r>
+              <a:rPr sz="800">
+                <a:hlinkClick r:id="rId33"/>
+              </a:rPr>
+              <a:t>Lofar 3</a:t>
+            </a:r>
+          </a:p>
+          <a:p>
+            <a:r>
+              <a:rPr sz="800">
+                <a:hlinkClick r:id="rId34"/>
+              </a:rPr>
+              <a:t>Lofar 4</a:t>
+            </a:r>
+          </a:p>
+        </p:txBody>
+      </p:sp>
+      <p:sp>
+        <p:nvSpPr>
+          <p:cNvPr id="23" name="Rounded Rectangle 22">
+            <a:hlinkClick r:id="rId35"/>
+          </p:cNvPr>
+          <p:cNvSpPr/>
+          <p:nvPr/>
+        </p:nvSpPr>
+        <p:spPr>
+          <a:xfrm>
+            <a:off x="365760" y="4632960"/>
+            <a:ext cx="2200046" cy="365760"/>
+          </a:xfrm>
+          <a:prstGeom prst="roundRect">
+            <a:avLst/>
+          </a:prstGeom>
+          <a:solidFill>
+            <a:srgbClr val="E8EEF7"/>
+          </a:solidFill>
+          <a:ln>
+            <a:solidFill>
+              <a:srgbClr val="1F3A5F"/>
+            </a:solidFill>
+          </a:ln>
+        </p:spPr>
+        <p:style>
+          <a:lnRef idx="1">
+            <a:schemeClr val="accent1"/>
+          </a:lnRef>
+          <a:fillRef idx="3">
+            <a:schemeClr val="accent1"/>
+          </a:fillRef>
+          <a:effectRef idx="2">
+            <a:schemeClr val="accent1"/>
+          </a:effectRef>
+          <a:fontRef idx="minor">
+            <a:schemeClr val="lt1"/>
+          </a:fontRef>
+        </p:style>
+        <p:txBody>
+          <a:bodyPr rtlCol="0" anchor="ctr" lIns="45720" rIns="45720"/>
+          <a:lstStyle/>
+          <a:p>
+            <a:pPr algn="ctr"/>
+            <a:r>
+              <a:rPr sz="900">
+                <a:solidFill>
+                  <a:srgbClr val="1F3A5F"/>
+                </a:solidFill>
+              </a:rPr>
+              <a:t>Gram 13: FR Outrider, Category 1, Coruscant</a:t>
+            </a:r>
+          </a:p>
+        </p:txBody>
+      </p:sp>
+      <p:sp>
+        <p:nvSpPr>
+          <p:cNvPr id="24" name="TextBox 23"/>
+          <p:cNvSpPr txBox="1"/>
+          <p:nvPr/>
+        </p:nvSpPr>
+        <p:spPr>
+          <a:xfrm>
+            <a:off x="365760" y="5017008"/>
+            <a:ext cx="2200046" cy="1447800"/>
+          </a:xfrm>
+          <a:prstGeom prst="rect">
+            <a:avLst/>
+          </a:prstGeom>
+          <a:noFill/>
+        </p:spPr>
+        <p:txBody>
+          <a:bodyPr wrap="square">
+            <a:spAutoFit/>
+          </a:bodyPr>
+          <a:lstStyle/>
+          <a:p>
+            <a:r>
+              <a:rPr sz="800">
+                <a:hlinkClick r:id="rId36"/>
+              </a:rPr>
+              <a:t>Lofar 1</a:t>
+            </a:r>
+          </a:p>
+          <a:p>
+            <a:r>
+              <a:rPr sz="800">
+                <a:hlinkClick r:id="rId37"/>
+              </a:rPr>
+              <a:t>Lofar 2</a:t>
+            </a:r>
+          </a:p>
+          <a:p>
+            <a:r>
+              <a:rPr sz="800">
+                <a:hlinkClick r:id="rId38"/>
+              </a:rPr>
+              <a:t>Lofar 3</a:t>
+            </a:r>
+          </a:p>
+        </p:txBody>
+      </p:sp>
+      <p:sp>
+        <p:nvSpPr>
+          <p:cNvPr id="25" name="Rounded Rectangle 24">
+            <a:hlinkClick r:id="rId39"/>
+          </p:cNvPr>
+          <p:cNvSpPr/>
+          <p:nvPr/>
+        </p:nvSpPr>
+        <p:spPr>
+          <a:xfrm>
+            <a:off x="2657246" y="4632960"/>
+            <a:ext cx="2200046" cy="365760"/>
+          </a:xfrm>
+          <a:prstGeom prst="roundRect">
+            <a:avLst/>
+          </a:prstGeom>
+          <a:solidFill>
+            <a:srgbClr val="E8EEF7"/>
+          </a:solidFill>
+          <a:ln>
+            <a:solidFill>
+              <a:srgbClr val="1F3A5F"/>
+            </a:solidFill>
+          </a:ln>
+        </p:spPr>
+        <p:style>
+          <a:lnRef idx="1">
+            <a:schemeClr val="accent1"/>
+          </a:lnRef>
+          <a:fillRef idx="3">
+            <a:schemeClr val="accent1"/>
+          </a:fillRef>
+          <a:effectRef idx="2">
+            <a:schemeClr val="accent1"/>
+          </a:effectRef>
+          <a:fontRef idx="minor">
+            <a:schemeClr val="lt1"/>
+          </a:fontRef>
+        </p:style>
+        <p:txBody>
+          <a:bodyPr rtlCol="0" anchor="ctr" lIns="45720" rIns="45720"/>
+          <a:lstStyle/>
+          <a:p>
+            <a:pPr algn="ctr"/>
+            <a:r>
+              <a:rPr sz="900">
+                <a:solidFill>
+                  <a:srgbClr val="1F3A5F"/>
+                </a:solidFill>
+              </a:rPr>
+              <a:t>Gram 14: Cerritos contact bearing 210, codename Betazed</a:t>
+            </a:r>
+          </a:p>
+        </p:txBody>
+      </p:sp>
+      <p:sp>
+        <p:nvSpPr>
+          <p:cNvPr id="26" name="TextBox 25"/>
+          <p:cNvSpPr txBox="1"/>
+          <p:nvPr/>
+        </p:nvSpPr>
+        <p:spPr>
+          <a:xfrm>
+            <a:off x="2657246" y="5017008"/>
+            <a:ext cx="2200046" cy="1447800"/>
+          </a:xfrm>
+          <a:prstGeom prst="rect">
+            <a:avLst/>
+          </a:prstGeom>
+          <a:noFill/>
+        </p:spPr>
+        <p:txBody>
+          <a:bodyPr wrap="square">
+            <a:spAutoFit/>
+          </a:bodyPr>
+          <a:lstStyle/>
+          <a:p>
+            <a:r>
+              <a:rPr sz="800">
+                <a:hlinkClick r:id="rId40"/>
+              </a:rPr>
+              <a:t>Lofar 1</a:t>
+            </a:r>
+          </a:p>
+          <a:p>
+            <a:r>
+              <a:rPr sz="800">
+                <a:hlinkClick r:id="rId41"/>
+              </a:rPr>
+              <a:t>Lofar 2</a:t>
+            </a:r>
+          </a:p>
+          <a:p>
+            <a:r>
+              <a:rPr sz="800">
+                <a:hlinkClick r:id="rId42"/>
+              </a:rPr>
+              <a:t>Lofar 3</a:t>
+            </a:r>
+          </a:p>
+          <a:p>
+            <a:r>
+              <a:rPr sz="800">
+                <a:hlinkClick r:id="rId43"/>
+              </a:rPr>
+              <a:t>Lofar 4</a:t>
+            </a:r>
+          </a:p>
+        </p:txBody>
+      </p:sp>
+      <p:sp>
+        <p:nvSpPr>
+          <p:cNvPr id="27" name="Rounded Rectangle 26">
+            <a:hlinkClick r:id="rId44"/>
+          </p:cNvPr>
+          <p:cNvSpPr/>
+          <p:nvPr/>
+        </p:nvSpPr>
+        <p:spPr>
+          <a:xfrm>
+            <a:off x="4948732" y="4632960"/>
+            <a:ext cx="2200046" cy="365760"/>
+          </a:xfrm>
+          <a:prstGeom prst="roundRect">
+            <a:avLst/>
+          </a:prstGeom>
+          <a:solidFill>
+            <a:srgbClr val="E8EEF7"/>
+          </a:solidFill>
+          <a:ln>
+            <a:solidFill>
+              <a:srgbClr val="1F3A5F"/>
+            </a:solidFill>
+          </a:ln>
+        </p:spPr>
+        <p:style>
+          <a:lnRef idx="1">
+            <a:schemeClr val="accent1"/>
+          </a:lnRef>
+          <a:fillRef idx="3">
+            <a:schemeClr val="accent1"/>
+          </a:fillRef>
+          <a:effectRef idx="2">
+            <a:schemeClr val="accent1"/>
+          </a:effectRef>
+          <a:fontRef idx="minor">
+            <a:schemeClr val="lt1"/>
+          </a:fontRef>
+        </p:style>
+        <p:txBody>
+          <a:bodyPr rtlCol="0" anchor="ctr" lIns="45720" rIns="45720"/>
+          <a:lstStyle/>
+          <a:p>
+            <a:pPr algn="ctr"/>
+            <a:r>
+              <a:rPr sz="900">
+                <a:solidFill>
+                  <a:srgbClr val="1F3A5F"/>
+                </a:solidFill>
+              </a:rPr>
+              <a:t>Gram 15: FR Voyager, Category 1, Gandalf</a:t>
+            </a:r>
+          </a:p>
+        </p:txBody>
+      </p:sp>
+      <p:sp>
+        <p:nvSpPr>
+          <p:cNvPr id="28" name="TextBox 27"/>
+          <p:cNvSpPr txBox="1"/>
+          <p:nvPr/>
+        </p:nvSpPr>
+        <p:spPr>
+          <a:xfrm>
+            <a:off x="4948732" y="5017008"/>
+            <a:ext cx="2200046" cy="1447800"/>
+          </a:xfrm>
+          <a:prstGeom prst="rect">
+            <a:avLst/>
+          </a:prstGeom>
+          <a:noFill/>
+        </p:spPr>
+        <p:txBody>
+          <a:bodyPr wrap="square">
+            <a:spAutoFit/>
+          </a:bodyPr>
+          <a:lstStyle/>
+          <a:p>
+            <a:r>
+              <a:rPr sz="800">
+                <a:hlinkClick r:id="rId45"/>
+              </a:rPr>
+              <a:t>Lofar 1</a:t>
+            </a:r>
+          </a:p>
+          <a:p>
+            <a:r>
+              <a:rPr sz="800">
+                <a:hlinkClick r:id="rId46"/>
+              </a:rPr>
+              <a:t>Lofar 2</a:t>
+            </a:r>
+          </a:p>
+        </p:txBody>
+      </p:sp>
+      <p:sp>
+        <p:nvSpPr>
+          <p:cNvPr id="29" name="Rounded Rectangle 28">
+            <a:hlinkClick r:id="rId47"/>
+          </p:cNvPr>
+          <p:cNvSpPr/>
+          <p:nvPr/>
+        </p:nvSpPr>
+        <p:spPr>
+          <a:xfrm>
+            <a:off x="7240219" y="4632960"/>
+            <a:ext cx="2200046" cy="365760"/>
+          </a:xfrm>
+          <a:prstGeom prst="roundRect">
+            <a:avLst/>
+          </a:prstGeom>
+          <a:solidFill>
+            <a:srgbClr val="E8EEF7"/>
+          </a:solidFill>
+          <a:ln>
+            <a:solidFill>
+              <a:srgbClr val="1F3A5F"/>
+            </a:solidFill>
+          </a:ln>
+        </p:spPr>
+        <p:style>
+          <a:lnRef idx="1">
+            <a:schemeClr val="accent1"/>
+          </a:lnRef>
+          <a:fillRef idx="3">
+            <a:schemeClr val="accent1"/>
+          </a:fillRef>
+          <a:effectRef idx="2">
+            <a:schemeClr val="accent1"/>
+          </a:effectRef>
+          <a:fontRef idx="minor">
+            <a:schemeClr val="lt1"/>
+          </a:fontRef>
+        </p:style>
+        <p:txBody>
+          <a:bodyPr rtlCol="0" anchor="ctr" lIns="45720" rIns="45720"/>
+          <a:lstStyle/>
+          <a:p>
+            <a:pPr algn="ctr"/>
+            <a:r>
+              <a:rPr sz="900">
+                <a:solidFill>
+                  <a:srgbClr val="1F3A5F"/>
+                </a:solidFill>
+              </a:rPr>
+              <a:t>Gram 16: FR Intrepid-class, Category 2, Tatooine</a:t>
+            </a:r>
+          </a:p>
+        </p:txBody>
+      </p:sp>
+      <p:sp>
+        <p:nvSpPr>
+          <p:cNvPr id="30" name="TextBox 29"/>
+          <p:cNvSpPr txBox="1"/>
+          <p:nvPr/>
+        </p:nvSpPr>
+        <p:spPr>
+          <a:xfrm>
+            <a:off x="7240219" y="5017008"/>
+            <a:ext cx="2200046" cy="1447800"/>
+          </a:xfrm>
+          <a:prstGeom prst="rect">
+            <a:avLst/>
+          </a:prstGeom>
+          <a:noFill/>
+        </p:spPr>
+        <p:txBody>
+          <a:bodyPr wrap="square">
+            <a:spAutoFit/>
+          </a:bodyPr>
+          <a:lstStyle/>
+          <a:p>
+            <a:r>
+              <a:rPr sz="800">
+                <a:hlinkClick r:id="rId48"/>
+              </a:rPr>
+              <a:t>Lofar 1</a:t>
+            </a:r>
+          </a:p>
+          <a:p>
+            <a:r>
+              <a:rPr sz="800">
+                <a:hlinkClick r:id="rId49"/>
+              </a:rPr>
+              <a:t>Lofar 2</a:t>
+            </a:r>
+          </a:p>
+          <a:p>
+            <a:r>
+              <a:rPr sz="800">
+                <a:hlinkClick r:id="rId50"/>
+              </a:rPr>
+              <a:t>Lofar 3</a:t>
+            </a:r>
+          </a:p>
+        </p:txBody>
+      </p:sp>
+      <p:sp>
+        <p:nvSpPr>
+          <p:cNvPr id="31" name="Rounded Rectangle 30">
+            <a:hlinkClick r:id="rId51"/>
+          </p:cNvPr>
+          <p:cNvSpPr/>
+          <p:nvPr/>
+        </p:nvSpPr>
+        <p:spPr>
+          <a:xfrm>
+            <a:off x="9531705" y="4632960"/>
+            <a:ext cx="2200046" cy="365760"/>
+          </a:xfrm>
+          <a:prstGeom prst="roundRect">
+            <a:avLst/>
+          </a:prstGeom>
+          <a:solidFill>
+            <a:srgbClr val="E8EEF7"/>
+          </a:solidFill>
+          <a:ln>
+            <a:solidFill>
+              <a:srgbClr val="1F3A5F"/>
+            </a:solidFill>
+          </a:ln>
+        </p:spPr>
+        <p:style>
+          <a:lnRef idx="1">
+            <a:schemeClr val="accent1"/>
+          </a:lnRef>
+          <a:fillRef idx="3">
+            <a:schemeClr val="accent1"/>
+          </a:fillRef>
+          <a:effectRef idx="2">
+            <a:schemeClr val="accent1"/>
+          </a:effectRef>
+          <a:fontRef idx="minor">
+            <a:schemeClr val="lt1"/>
+          </a:fontRef>
+        </p:style>
+        <p:txBody>
+          <a:bodyPr rtlCol="0" anchor="ctr" lIns="45720" rIns="45720"/>
+          <a:lstStyle/>
+          <a:p>
+            <a:pPr algn="ctr"/>
+            <a:r>
+              <a:rPr sz="900">
+                <a:solidFill>
+                  <a:srgbClr val="1F3A5F"/>
+                </a:solidFill>
+              </a:rPr>
+              <a:t>Gram 18: FR B-wing, Category 3, Mustafar</a:t>
+            </a:r>
+          </a:p>
+        </p:txBody>
+      </p:sp>
+      <p:sp>
+        <p:nvSpPr>
+          <p:cNvPr id="32" name="TextBox 31"/>
+          <p:cNvSpPr txBox="1"/>
+          <p:nvPr/>
+        </p:nvSpPr>
+        <p:spPr>
+          <a:xfrm>
+            <a:off x="9531705" y="5017008"/>
+            <a:ext cx="2200046" cy="1447800"/>
+          </a:xfrm>
+          <a:prstGeom prst="rect">
+            <a:avLst/>
+          </a:prstGeom>
+          <a:noFill/>
+        </p:spPr>
+        <p:txBody>
+          <a:bodyPr wrap="square">
+            <a:spAutoFit/>
+          </a:bodyPr>
+          <a:lstStyle/>
+          <a:p>
+            <a:r>
+              <a:rPr sz="800">
+                <a:hlinkClick r:id="rId52"/>
+              </a:rPr>
+              <a:t>Lofar 1</a:t>
+            </a:r>
+          </a:p>
+          <a:p>
+            <a:r>
+              <a:rPr sz="800">
+                <a:hlinkClick r:id="rId53"/>
+              </a:rPr>
+              <a:t>Lofar 2</a:t>
+            </a:r>
+          </a:p>
+          <a:p>
+            <a:r>
+              <a:rPr sz="800">
+                <a:hlinkClick r:id="rId54"/>
+              </a:rPr>
+              <a:t>Lofar 3</a:t>
+            </a:r>
+          </a:p>
+          <a:p>
+            <a:r>
+              <a:rPr sz="800">
+                <a:hlinkClick r:id="rId55"/>
+              </a:rPr>
+              <a:t>Lofar 4</a:t>
             </a:r>
           </a:p>
         </p:txBody>
@@ -3224,18 +4687,18 @@
                   <a:srgbClr val="FFFFFF"/>
                 </a:solidFill>
               </a:rPr>
-              <a:t>Instructor Progress Final Assessment Grams — Page 1 of 3</a:t>
-            </a:r>
-          </a:p>
-        </p:txBody>
-      </p:sp>
-      <p:sp>
-        <p:nvSpPr>
-          <p:cNvPr id="3" name="Rounded Rectangle 2"/>
+              <a:t>Instructor Progress Final Assessment Grams — Page 2 of 3</a:t>
+            </a:r>
+          </a:p>
+        </p:txBody>
+      </p:sp>
+      <p:sp>
+        <p:nvSpPr>
+          <p:cNvPr id="3" name="Rounded Rectangle 2">
+            <a:hlinkClick r:id="rId2"/>
+          </p:cNvPr>
           <p:cNvSpPr/>
-          <p:nvPr>
-            <a:hlinkClick r:id="rId2"/>
-          </p:nvPr>
+          <p:nvPr/>
         </p:nvSpPr>
         <p:spPr>
           <a:xfrm>
@@ -3279,7 +4742,7 @@
                   <a:srgbClr val="1F3A5F"/>
                 </a:solidFill>
               </a:rPr>
-              <a:t>Gram 1: FR TIE Bomber, Category 3, Tatooine</a:t>
+              <a:t>Gram 19: FR X-wing, Category 3, Dagobah</a:t>
             </a:r>
           </a:p>
         </p:txBody>
@@ -3313,15 +4776,23 @@
               <a:t>Lofar 1</a:t>
             </a:r>
           </a:p>
-        </p:txBody>
-      </p:sp>
-      <p:sp>
-        <p:nvSpPr>
-          <p:cNvPr id="5" name="Rounded Rectangle 4"/>
+          <a:p>
+            <a:r>
+              <a:rPr sz="800">
+                <a:hlinkClick r:id="rId4"/>
+              </a:rPr>
+              <a:t>Lofar 2</a:t>
+            </a:r>
+          </a:p>
+        </p:txBody>
+      </p:sp>
+      <p:sp>
+        <p:nvSpPr>
+          <p:cNvPr id="5" name="Rounded Rectangle 4">
+            <a:hlinkClick r:id="rId5"/>
+          </p:cNvPr>
           <p:cNvSpPr/>
-          <p:nvPr>
-            <a:hlinkClick r:id="rId4"/>
-          </p:nvPr>
+          <p:nvPr/>
         </p:nvSpPr>
         <p:spPr>
           <a:xfrm>
@@ -3365,7 +4836,7 @@
                   <a:srgbClr val="1F3A5F"/>
                 </a:solidFill>
               </a:rPr>
-              <a:t>Gram 2: FR Sovereign-class, Category 1, Tatooine</a:t>
+              <a:t>Gram 22: FR Razor Crest, Category 4, Dank</a:t>
             </a:r>
           </a:p>
         </p:txBody>
@@ -3394,36 +4865,20 @@
           <a:p>
             <a:r>
               <a:rPr sz="800">
-                <a:hlinkClick r:id="rId5"/>
+                <a:hlinkClick r:id="rId6"/>
               </a:rPr>
               <a:t>Lofar 1</a:t>
             </a:r>
           </a:p>
-          <a:p>
-            <a:r>
-              <a:rPr sz="800">
-                <a:hlinkClick r:id="rId6"/>
-              </a:rPr>
-              <a:t>Lofar 2</a:t>
-            </a:r>
-          </a:p>
-          <a:p>
-            <a:r>
-              <a:rPr sz="800">
-                <a:hlinkClick r:id="rId7"/>
-              </a:rPr>
-              <a:t>Lofar 3</a:t>
-            </a:r>
-          </a:p>
-        </p:txBody>
-      </p:sp>
-      <p:sp>
-        <p:nvSpPr>
-          <p:cNvPr id="7" name="Rounded Rectangle 6"/>
+        </p:txBody>
+      </p:sp>
+      <p:sp>
+        <p:nvSpPr>
+          <p:cNvPr id="7" name="Rounded Rectangle 6">
+            <a:hlinkClick r:id="rId7"/>
+          </p:cNvPr>
           <p:cNvSpPr/>
-          <p:nvPr>
-            <a:hlinkClick r:id="rId8"/>
-          </p:nvPr>
+          <p:nvPr/>
         </p:nvSpPr>
         <p:spPr>
           <a:xfrm>
@@ -3467,7 +4922,7 @@
                   <a:srgbClr val="1F3A5F"/>
                 </a:solidFill>
               </a:rPr>
-              <a:t>Gram 3: FR TIE Fighter, Category 4, Mustafar</a:t>
+              <a:t>Gram 23: FR Outrider, Category 3, Cardassia</a:t>
             </a:r>
           </a:p>
         </p:txBody>
@@ -3496,9 +4951,17 @@
           <a:p>
             <a:r>
               <a:rPr sz="800">
+                <a:hlinkClick r:id="rId8"/>
+              </a:rPr>
+              <a:t>Lofar 1</a:t>
+            </a:r>
+          </a:p>
+          <a:p>
+            <a:r>
+              <a:rPr sz="800">
                 <a:hlinkClick r:id="rId9"/>
               </a:rPr>
-              <a:t>Lofar 1</a:t>
+              <a:t>Lofar 2</a:t>
             </a:r>
           </a:p>
           <a:p>
@@ -3506,14 +4969,6 @@
               <a:rPr sz="800">
                 <a:hlinkClick r:id="rId10"/>
               </a:rPr>
-              <a:t>Lofar 2</a:t>
-            </a:r>
-          </a:p>
-          <a:p>
-            <a:r>
-              <a:rPr sz="800">
-                <a:hlinkClick r:id="rId11"/>
-              </a:rPr>
               <a:t>Lofar 3</a:t>
             </a:r>
           </a:p>
@@ -3521,11 +4976,11 @@
       </p:sp>
       <p:sp>
         <p:nvSpPr>
-          <p:cNvPr id="9" name="Rounded Rectangle 8"/>
+          <p:cNvPr id="9" name="Rounded Rectangle 8">
+            <a:hlinkClick r:id="rId11"/>
+          </p:cNvPr>
           <p:cNvSpPr/>
-          <p:nvPr>
-            <a:hlinkClick r:id="rId12"/>
-          </p:nvPr>
+          <p:nvPr/>
         </p:nvSpPr>
         <p:spPr>
           <a:xfrm>
@@ -3569,7 +5024,7 @@
                   <a:srgbClr val="1F3A5F"/>
                 </a:solidFill>
               </a:rPr>
-              <a:t>Gram 4: FR Intrepid-class, Category 4, Mustafar</a:t>
+              <a:t>Gram 25: FR Ghost, Category 3, Trill</a:t>
             </a:r>
           </a:p>
         </p:txBody>
@@ -3598,9 +5053,17 @@
           <a:p>
             <a:r>
               <a:rPr sz="800">
+                <a:hlinkClick r:id="rId12"/>
+              </a:rPr>
+              <a:t>Lofar 1</a:t>
+            </a:r>
+          </a:p>
+          <a:p>
+            <a:r>
+              <a:rPr sz="800">
                 <a:hlinkClick r:id="rId13"/>
               </a:rPr>
-              <a:t>Lofar 1</a:t>
+              <a:t>Lofar 2</a:t>
             </a:r>
           </a:p>
           <a:p>
@@ -3608,14 +5071,6 @@
               <a:rPr sz="800">
                 <a:hlinkClick r:id="rId14"/>
               </a:rPr>
-              <a:t>Lofar 2</a:t>
-            </a:r>
-          </a:p>
-          <a:p>
-            <a:r>
-              <a:rPr sz="800">
-                <a:hlinkClick r:id="rId15"/>
-              </a:rPr>
               <a:t>Lofar 3</a:t>
             </a:r>
           </a:p>
@@ -3623,11 +5078,11 @@
       </p:sp>
       <p:sp>
         <p:nvSpPr>
-          <p:cNvPr id="11" name="Rounded Rectangle 10"/>
+          <p:cNvPr id="11" name="Rounded Rectangle 10">
+            <a:hlinkClick r:id="rId15"/>
+          </p:cNvPr>
           <p:cNvSpPr/>
-          <p:nvPr>
-            <a:hlinkClick r:id="rId16"/>
-          </p:nvPr>
+          <p:nvPr/>
         </p:nvSpPr>
         <p:spPr>
           <a:xfrm>
@@ -3671,7 +5126,7 @@
                   <a:srgbClr val="1F3A5F"/>
                 </a:solidFill>
               </a:rPr>
-              <a:t>Gram 7: FR Discovery, Category 1, Dagobah</a:t>
+              <a:t>Gram 26: FR Ghost, Category 1, Trill</a:t>
             </a:r>
           </a:p>
         </p:txBody>
@@ -3700,7 +5155,7 @@
           <a:p>
             <a:r>
               <a:rPr sz="800">
-                <a:hlinkClick r:id="rId17"/>
+                <a:hlinkClick r:id="rId16"/>
               </a:rPr>
               <a:t>Lofar 1</a:t>
             </a:r>
@@ -3709,11 +5164,11 @@
       </p:sp>
       <p:sp>
         <p:nvSpPr>
-          <p:cNvPr id="13" name="Rounded Rectangle 12"/>
+          <p:cNvPr id="13" name="Rounded Rectangle 12">
+            <a:hlinkClick r:id="rId17"/>
+          </p:cNvPr>
           <p:cNvSpPr/>
-          <p:nvPr>
-            <a:hlinkClick r:id="rId18"/>
-          </p:nvPr>
+          <p:nvPr/>
         </p:nvSpPr>
         <p:spPr>
           <a:xfrm>
@@ -3757,7 +5212,7 @@
                   <a:srgbClr val="1F3A5F"/>
                 </a:solidFill>
               </a:rPr>
-              <a:t>Gram 8: Miranda-class contact bearing 288, codename Dank</a:t>
+              <a:t>Gram 27: Cerritos contact bearing 270, codename Vulcan</a:t>
             </a:r>
           </a:p>
         </p:txBody>
@@ -3786,9 +5241,17 @@
           <a:p>
             <a:r>
               <a:rPr sz="800">
+                <a:hlinkClick r:id="rId18"/>
+              </a:rPr>
+              <a:t>Lofar 1</a:t>
+            </a:r>
+          </a:p>
+          <a:p>
+            <a:r>
+              <a:rPr sz="800">
                 <a:hlinkClick r:id="rId19"/>
               </a:rPr>
-              <a:t>Lofar 1</a:t>
+              <a:t>Lofar 2</a:t>
             </a:r>
           </a:p>
           <a:p>
@@ -3796,34 +5259,18 @@
               <a:rPr sz="800">
                 <a:hlinkClick r:id="rId20"/>
               </a:rPr>
-              <a:t>Lofar 2</a:t>
-            </a:r>
-          </a:p>
-          <a:p>
-            <a:r>
-              <a:rPr sz="800">
-                <a:hlinkClick r:id="rId21"/>
-              </a:rPr>
               <a:t>Lofar 3</a:t>
             </a:r>
           </a:p>
-          <a:p>
-            <a:r>
-              <a:rPr sz="800">
-                <a:hlinkClick r:id="rId22"/>
-              </a:rPr>
-              <a:t>Lofar 4</a:t>
-            </a:r>
-          </a:p>
-        </p:txBody>
-      </p:sp>
-      <p:sp>
-        <p:nvSpPr>
-          <p:cNvPr id="15" name="Rounded Rectangle 14"/>
+        </p:txBody>
+      </p:sp>
+      <p:sp>
+        <p:nvSpPr>
+          <p:cNvPr id="15" name="Rounded Rectangle 14">
+            <a:hlinkClick r:id="rId21"/>
+          </p:cNvPr>
           <p:cNvSpPr/>
-          <p:nvPr>
-            <a:hlinkClick r:id="rId23"/>
-          </p:nvPr>
+          <p:nvPr/>
         </p:nvSpPr>
         <p:spPr>
           <a:xfrm>
@@ -3867,7 +5314,7 @@
                   <a:srgbClr val="1F3A5F"/>
                 </a:solidFill>
               </a:rPr>
-              <a:t>Gram 9: Enterprise contact bearing 084, codename Yavin</a:t>
+              <a:t>Gram 28: Defiant contact bearing 357, codename Vulcan</a:t>
             </a:r>
           </a:p>
         </p:txBody>
@@ -3896,7 +5343,7 @@
           <a:p>
             <a:r>
               <a:rPr sz="800">
-                <a:hlinkClick r:id="rId24"/>
+                <a:hlinkClick r:id="rId22"/>
               </a:rPr>
               <a:t>Lofar 1</a:t>
             </a:r>
@@ -3904,7 +5351,7 @@
           <a:p>
             <a:r>
               <a:rPr sz="800">
-                <a:hlinkClick r:id="rId25"/>
+                <a:hlinkClick r:id="rId23"/>
               </a:rPr>
               <a:t>Lofar 2</a:t>
             </a:r>
@@ -3913,11 +5360,11 @@
       </p:sp>
       <p:sp>
         <p:nvSpPr>
-          <p:cNvPr id="17" name="Rounded Rectangle 16"/>
+          <p:cNvPr id="17" name="Rounded Rectangle 16">
+            <a:hlinkClick r:id="rId24"/>
+          </p:cNvPr>
           <p:cNvSpPr/>
-          <p:nvPr>
-            <a:hlinkClick r:id="rId26"/>
-          </p:nvPr>
+          <p:nvPr/>
         </p:nvSpPr>
         <p:spPr>
           <a:xfrm>
@@ -3961,7 +5408,7 @@
                   <a:srgbClr val="1F3A5F"/>
                 </a:solidFill>
               </a:rPr>
-              <a:t>Gram 10: FR A-wing, Category 3, Risa</a:t>
+              <a:t>Gram 29: Imperial-class contact bearing 080, codename Gandalf</a:t>
             </a:r>
           </a:p>
         </p:txBody>
@@ -3990,7 +5437,7 @@
           <a:p>
             <a:r>
               <a:rPr sz="800">
-                <a:hlinkClick r:id="rId27"/>
+                <a:hlinkClick r:id="rId25"/>
               </a:rPr>
               <a:t>Lofar 1</a:t>
             </a:r>
@@ -3999,11 +5446,11 @@
       </p:sp>
       <p:sp>
         <p:nvSpPr>
-          <p:cNvPr id="19" name="Rounded Rectangle 18"/>
+          <p:cNvPr id="19" name="Rounded Rectangle 18">
+            <a:hlinkClick r:id="rId26"/>
+          </p:cNvPr>
           <p:cNvSpPr/>
-          <p:nvPr>
-            <a:hlinkClick r:id="rId28"/>
-          </p:nvPr>
+          <p:nvPr/>
         </p:nvSpPr>
         <p:spPr>
           <a:xfrm>
@@ -4047,7 +5494,7 @@
                   <a:srgbClr val="1F3A5F"/>
                 </a:solidFill>
               </a:rPr>
-              <a:t>Gram 11: FR Star Destroyer, Category 1, Vulcan</a:t>
+              <a:t>Gram 30: Excelsior contact bearing 009, codename Cardassia</a:t>
             </a:r>
           </a:p>
         </p:txBody>
@@ -4076,7 +5523,7 @@
           <a:p>
             <a:r>
               <a:rPr sz="800">
-                <a:hlinkClick r:id="rId29"/>
+                <a:hlinkClick r:id="rId27"/>
               </a:rPr>
               <a:t>Lofar 1</a:t>
             </a:r>
@@ -4085,11 +5532,11 @@
       </p:sp>
       <p:sp>
         <p:nvSpPr>
-          <p:cNvPr id="21" name="Rounded Rectangle 20"/>
+          <p:cNvPr id="21" name="Rounded Rectangle 20">
+            <a:hlinkClick r:id="rId28"/>
+          </p:cNvPr>
           <p:cNvSpPr/>
-          <p:nvPr>
-            <a:hlinkClick r:id="rId30"/>
-          </p:nvPr>
+          <p:nvPr/>
         </p:nvSpPr>
         <p:spPr>
           <a:xfrm>
@@ -4133,7 +5580,7 @@
                   <a:srgbClr val="1F3A5F"/>
                 </a:solidFill>
               </a:rPr>
-              <a:t>Gram 12: Venator-class contact bearing 330, codename Dank</a:t>
+              <a:t>Gram 31: FR Rebel One, Category 1, Endor</a:t>
             </a:r>
           </a:p>
         </p:txBody>
@@ -4162,9 +5609,25 @@
           <a:p>
             <a:r>
               <a:rPr sz="800">
+                <a:hlinkClick r:id="rId29"/>
+              </a:rPr>
+              <a:t>Lofar 1</a:t>
+            </a:r>
+          </a:p>
+          <a:p>
+            <a:r>
+              <a:rPr sz="800">
+                <a:hlinkClick r:id="rId30"/>
+              </a:rPr>
+              <a:t>Lofar 2</a:t>
+            </a:r>
+          </a:p>
+          <a:p>
+            <a:r>
+              <a:rPr sz="800">
                 <a:hlinkClick r:id="rId31"/>
               </a:rPr>
-              <a:t>Lofar 1</a:t>
+              <a:t>Lofar 3</a:t>
             </a:r>
           </a:p>
           <a:p>
@@ -4172,22 +5635,6 @@
               <a:rPr sz="800">
                 <a:hlinkClick r:id="rId32"/>
               </a:rPr>
-              <a:t>Lofar 2</a:t>
-            </a:r>
-          </a:p>
-          <a:p>
-            <a:r>
-              <a:rPr sz="800">
-                <a:hlinkClick r:id="rId33"/>
-              </a:rPr>
-              <a:t>Lofar 3</a:t>
-            </a:r>
-          </a:p>
-          <a:p>
-            <a:r>
-              <a:rPr sz="800">
-                <a:hlinkClick r:id="rId34"/>
-              </a:rPr>
               <a:t>Lofar 4</a:t>
             </a:r>
           </a:p>
@@ -4195,11 +5642,11 @@
       </p:sp>
       <p:sp>
         <p:nvSpPr>
-          <p:cNvPr id="23" name="Rounded Rectangle 22"/>
+          <p:cNvPr id="23" name="Rounded Rectangle 22">
+            <a:hlinkClick r:id="rId33"/>
+          </p:cNvPr>
           <p:cNvSpPr/>
-          <p:nvPr>
-            <a:hlinkClick r:id="rId35"/>
-          </p:nvPr>
+          <p:nvPr/>
         </p:nvSpPr>
         <p:spPr>
           <a:xfrm>
@@ -4243,7 +5690,7 @@
                   <a:srgbClr val="1F3A5F"/>
                 </a:solidFill>
               </a:rPr>
-              <a:t>Gram 13: FR Outrider, Category 1, Coruscant</a:t>
+              <a:t>Gram 33: FR Galaxy-class, Category 2, Mustafar</a:t>
             </a:r>
           </a:p>
         </p:txBody>
@@ -4272,24 +5719,24 @@
           <a:p>
             <a:r>
               <a:rPr sz="800">
+                <a:hlinkClick r:id="rId34"/>
+              </a:rPr>
+              <a:t>Lofar 1</a:t>
+            </a:r>
+          </a:p>
+          <a:p>
+            <a:r>
+              <a:rPr sz="800">
+                <a:hlinkClick r:id="rId35"/>
+              </a:rPr>
+              <a:t>Lofar 2</a:t>
+            </a:r>
+          </a:p>
+          <a:p>
+            <a:r>
+              <a:rPr sz="800">
                 <a:hlinkClick r:id="rId36"/>
               </a:rPr>
-              <a:t>Lofar 1</a:t>
-            </a:r>
-          </a:p>
-          <a:p>
-            <a:r>
-              <a:rPr sz="800">
-                <a:hlinkClick r:id="rId37"/>
-              </a:rPr>
-              <a:t>Lofar 2</a:t>
-            </a:r>
-          </a:p>
-          <a:p>
-            <a:r>
-              <a:rPr sz="800">
-                <a:hlinkClick r:id="rId38"/>
-              </a:rPr>
               <a:t>Lofar 3</a:t>
             </a:r>
           </a:p>
@@ -4297,11 +5744,11 @@
       </p:sp>
       <p:sp>
         <p:nvSpPr>
-          <p:cNvPr id="25" name="Rounded Rectangle 24"/>
+          <p:cNvPr id="25" name="Rounded Rectangle 24">
+            <a:hlinkClick r:id="rId37"/>
+          </p:cNvPr>
           <p:cNvSpPr/>
-          <p:nvPr>
-            <a:hlinkClick r:id="rId39"/>
-          </p:nvPr>
+          <p:nvPr/>
         </p:nvSpPr>
         <p:spPr>
           <a:xfrm>
@@ -4345,7 +5792,7 @@
                   <a:srgbClr val="1F3A5F"/>
                 </a:solidFill>
               </a:rPr>
-              <a:t>Gram 14: Cerritos contact bearing 210, codename Betazed</a:t>
+              <a:t>Gram 34: Reliant contact bearing 192, codename Romulus</a:t>
             </a:r>
           </a:p>
         </p:txBody>
@@ -4374,44 +5821,36 @@
           <a:p>
             <a:r>
               <a:rPr sz="800">
+                <a:hlinkClick r:id="rId38"/>
+              </a:rPr>
+              <a:t>Lofar 1</a:t>
+            </a:r>
+          </a:p>
+          <a:p>
+            <a:r>
+              <a:rPr sz="800">
+                <a:hlinkClick r:id="rId39"/>
+              </a:rPr>
+              <a:t>Lofar 2</a:t>
+            </a:r>
+          </a:p>
+          <a:p>
+            <a:r>
+              <a:rPr sz="800">
                 <a:hlinkClick r:id="rId40"/>
               </a:rPr>
-              <a:t>Lofar 1</a:t>
-            </a:r>
-          </a:p>
-          <a:p>
-            <a:r>
-              <a:rPr sz="800">
-                <a:hlinkClick r:id="rId41"/>
-              </a:rPr>
-              <a:t>Lofar 2</a:t>
-            </a:r>
-          </a:p>
-          <a:p>
-            <a:r>
-              <a:rPr sz="800">
-                <a:hlinkClick r:id="rId42"/>
-              </a:rPr>
               <a:t>Lofar 3</a:t>
             </a:r>
           </a:p>
-          <a:p>
-            <a:r>
-              <a:rPr sz="800">
-                <a:hlinkClick r:id="rId43"/>
-              </a:rPr>
-              <a:t>Lofar 4</a:t>
-            </a:r>
-          </a:p>
-        </p:txBody>
-      </p:sp>
-      <p:sp>
-        <p:nvSpPr>
-          <p:cNvPr id="27" name="Rounded Rectangle 26"/>
+        </p:txBody>
+      </p:sp>
+      <p:sp>
+        <p:nvSpPr>
+          <p:cNvPr id="27" name="Rounded Rectangle 26">
+            <a:hlinkClick r:id="rId41"/>
+          </p:cNvPr>
           <p:cNvSpPr/>
-          <p:nvPr>
-            <a:hlinkClick r:id="rId44"/>
-          </p:nvPr>
+          <p:nvPr/>
         </p:nvSpPr>
         <p:spPr>
           <a:xfrm>
@@ -4455,7 +5894,7 @@
                   <a:srgbClr val="1F3A5F"/>
                 </a:solidFill>
               </a:rPr>
-              <a:t>Gram 15: FR Voyager, Category 1, Gandalf</a:t>
+              <a:t>Gram 35: FR Imperial-class, Category 2, Bajor</a:t>
             </a:r>
           </a:p>
         </p:txBody>
@@ -4484,28 +5923,44 @@
           <a:p>
             <a:r>
               <a:rPr sz="800">
+                <a:hlinkClick r:id="rId42"/>
+              </a:rPr>
+              <a:t>Lofar 1</a:t>
+            </a:r>
+          </a:p>
+          <a:p>
+            <a:r>
+              <a:rPr sz="800">
+                <a:hlinkClick r:id="rId43"/>
+              </a:rPr>
+              <a:t>Lofar 2</a:t>
+            </a:r>
+          </a:p>
+          <a:p>
+            <a:r>
+              <a:rPr sz="800">
+                <a:hlinkClick r:id="rId44"/>
+              </a:rPr>
+              <a:t>Lofar 3</a:t>
+            </a:r>
+          </a:p>
+          <a:p>
+            <a:r>
+              <a:rPr sz="800">
                 <a:hlinkClick r:id="rId45"/>
               </a:rPr>
-              <a:t>Lofar 1</a:t>
-            </a:r>
-          </a:p>
-          <a:p>
-            <a:r>
-              <a:rPr sz="800">
-                <a:hlinkClick r:id="rId46"/>
-              </a:rPr>
-              <a:t>Lofar 2</a:t>
-            </a:r>
-          </a:p>
-        </p:txBody>
-      </p:sp>
-      <p:sp>
-        <p:nvSpPr>
-          <p:cNvPr id="29" name="Rounded Rectangle 28"/>
+              <a:t>Lofar 4</a:t>
+            </a:r>
+          </a:p>
+        </p:txBody>
+      </p:sp>
+      <p:sp>
+        <p:nvSpPr>
+          <p:cNvPr id="29" name="Rounded Rectangle 28">
+            <a:hlinkClick r:id="rId46"/>
+          </p:cNvPr>
           <p:cNvSpPr/>
-          <p:nvPr>
-            <a:hlinkClick r:id="rId47"/>
-          </p:nvPr>
+          <p:nvPr/>
         </p:nvSpPr>
         <p:spPr>
           <a:xfrm>
@@ -4549,7 +6004,7 @@
                   <a:srgbClr val="1F3A5F"/>
                 </a:solidFill>
               </a:rPr>
-              <a:t>Gram 16: FR Intrepid-class, Category 2, Tatooine</a:t>
+              <a:t>Gram 36: FR Venator-class, Category 4, Defiant</a:t>
             </a:r>
           </a:p>
         </p:txBody>
@@ -4578,36 +6033,20 @@
           <a:p>
             <a:r>
               <a:rPr sz="800">
-                <a:hlinkClick r:id="rId48"/>
+                <a:hlinkClick r:id="rId47"/>
               </a:rPr>
               <a:t>Lofar 1</a:t>
             </a:r>
           </a:p>
-          <a:p>
-            <a:r>
-              <a:rPr sz="800">
-                <a:hlinkClick r:id="rId49"/>
-              </a:rPr>
-              <a:t>Lofar 2</a:t>
-            </a:r>
-          </a:p>
-          <a:p>
-            <a:r>
-              <a:rPr sz="800">
-                <a:hlinkClick r:id="rId50"/>
-              </a:rPr>
-              <a:t>Lofar 3</a:t>
-            </a:r>
-          </a:p>
-        </p:txBody>
-      </p:sp>
-      <p:sp>
-        <p:nvSpPr>
-          <p:cNvPr id="31" name="Rounded Rectangle 30"/>
+        </p:txBody>
+      </p:sp>
+      <p:sp>
+        <p:nvSpPr>
+          <p:cNvPr id="31" name="Rounded Rectangle 30">
+            <a:hlinkClick r:id="rId48"/>
+          </p:cNvPr>
           <p:cNvSpPr/>
-          <p:nvPr>
-            <a:hlinkClick r:id="rId51"/>
-          </p:nvPr>
+          <p:nvPr/>
         </p:nvSpPr>
         <p:spPr>
           <a:xfrm>
@@ -4651,7 +6090,7 @@
                   <a:srgbClr val="1F3A5F"/>
                 </a:solidFill>
               </a:rPr>
-              <a:t>Gram 18: FR B-wing, Category 3, Mustafar</a:t>
+              <a:t>Gram 37: FR Devastator, Category 2, Tatooine</a:t>
             </a:r>
           </a:p>
         </p:txBody>
@@ -4680,33 +6119,9 @@
           <a:p>
             <a:r>
               <a:rPr sz="800">
-                <a:hlinkClick r:id="rId52"/>
+                <a:hlinkClick r:id="rId49"/>
               </a:rPr>
               <a:t>Lofar 1</a:t>
-            </a:r>
-          </a:p>
-          <a:p>
-            <a:r>
-              <a:rPr sz="800">
-                <a:hlinkClick r:id="rId53"/>
-              </a:rPr>
-              <a:t>Lofar 2</a:t>
-            </a:r>
-          </a:p>
-          <a:p>
-            <a:r>
-              <a:rPr sz="800">
-                <a:hlinkClick r:id="rId54"/>
-              </a:rPr>
-              <a:t>Lofar 3</a:t>
-            </a:r>
-          </a:p>
-          <a:p>
-            <a:r>
-              <a:rPr sz="800">
-                <a:hlinkClick r:id="rId55"/>
-              </a:rPr>
-              <a:t>Lofar 4</a:t>
             </a:r>
           </a:p>
         </p:txBody>
@@ -4775,18 +6190,18 @@
                   <a:srgbClr val="FFFFFF"/>
                 </a:solidFill>
               </a:rPr>
-              <a:t>Instructor Progress Final Assessment Grams — Page 2 of 3</a:t>
-            </a:r>
-          </a:p>
-        </p:txBody>
-      </p:sp>
-      <p:sp>
-        <p:nvSpPr>
-          <p:cNvPr id="3" name="Rounded Rectangle 2"/>
+              <a:t>Instructor Progress Final Assessment Grams — Page 3 of 3</a:t>
+            </a:r>
+          </a:p>
+        </p:txBody>
+      </p:sp>
+      <p:sp>
+        <p:nvSpPr>
+          <p:cNvPr id="3" name="Rounded Rectangle 2">
+            <a:hlinkClick r:id="rId2"/>
+          </p:cNvPr>
           <p:cNvSpPr/>
-          <p:nvPr>
-            <a:hlinkClick r:id="rId2"/>
-          </p:nvPr>
+          <p:nvPr/>
         </p:nvSpPr>
         <p:spPr>
           <a:xfrm>
@@ -4830,7 +6245,7 @@
                   <a:srgbClr val="1F3A5F"/>
                 </a:solidFill>
               </a:rPr>
-              <a:t>Gram 19: FR X-wing, Category 3, Dagobah</a:t>
+              <a:t>Gram 38: FR Outrider, Category 3, Coruscant</a:t>
             </a:r>
           </a:p>
         </p:txBody>
@@ -4864,23 +6279,15 @@
               <a:t>Lofar 1</a:t>
             </a:r>
           </a:p>
-          <a:p>
-            <a:r>
-              <a:rPr sz="800">
-                <a:hlinkClick r:id="rId4"/>
-              </a:rPr>
-              <a:t>Lofar 2</a:t>
-            </a:r>
-          </a:p>
-        </p:txBody>
-      </p:sp>
-      <p:sp>
-        <p:nvSpPr>
-          <p:cNvPr id="5" name="Rounded Rectangle 4"/>
+        </p:txBody>
+      </p:sp>
+      <p:sp>
+        <p:nvSpPr>
+          <p:cNvPr id="5" name="Rounded Rectangle 4">
+            <a:hlinkClick r:id="rId4"/>
+          </p:cNvPr>
           <p:cNvSpPr/>
-          <p:nvPr>
-            <a:hlinkClick r:id="rId5"/>
-          </p:nvPr>
+          <p:nvPr/>
         </p:nvSpPr>
         <p:spPr>
           <a:xfrm>
@@ -4924,7 +6331,7 @@
                   <a:srgbClr val="1F3A5F"/>
                 </a:solidFill>
               </a:rPr>
-              <a:t>Gram 22: FR Razor Crest, Category 4, Dank</a:t>
+              <a:t>Gram 39: Galaxy-class contact bearing 083, codename Betazed</a:t>
             </a:r>
           </a:p>
         </p:txBody>
@@ -4953,20 +6360,36 @@
           <a:p>
             <a:r>
               <a:rPr sz="800">
+                <a:hlinkClick r:id="rId5"/>
+              </a:rPr>
+              <a:t>Lofar 1</a:t>
+            </a:r>
+          </a:p>
+          <a:p>
+            <a:r>
+              <a:rPr sz="800">
                 <a:hlinkClick r:id="rId6"/>
               </a:rPr>
-              <a:t>Lofar 1</a:t>
-            </a:r>
-          </a:p>
-        </p:txBody>
-      </p:sp>
-      <p:sp>
-        <p:nvSpPr>
-          <p:cNvPr id="7" name="Rounded Rectangle 6"/>
+              <a:t>Lofar 2</a:t>
+            </a:r>
+          </a:p>
+          <a:p>
+            <a:r>
+              <a:rPr sz="800">
+                <a:hlinkClick r:id="rId7"/>
+              </a:rPr>
+              <a:t>Lofar 3</a:t>
+            </a:r>
+          </a:p>
+        </p:txBody>
+      </p:sp>
+      <p:sp>
+        <p:nvSpPr>
+          <p:cNvPr id="7" name="Rounded Rectangle 6">
+            <a:hlinkClick r:id="rId8"/>
+          </p:cNvPr>
           <p:cNvSpPr/>
-          <p:nvPr>
-            <a:hlinkClick r:id="rId7"/>
-          </p:nvPr>
+          <p:nvPr/>
         </p:nvSpPr>
         <p:spPr>
           <a:xfrm>
@@ -5010,7 +6433,7 @@
                   <a:srgbClr val="1F3A5F"/>
                 </a:solidFill>
               </a:rPr>
-              <a:t>Gram 23: FR Outrider, Category 3, Cardassia</a:t>
+              <a:t>Gram 40: FR Corellian Corvette, Category 1, Tantive</a:t>
             </a:r>
           </a:p>
         </p:txBody>
@@ -5039,36 +6462,20 @@
           <a:p>
             <a:r>
               <a:rPr sz="800">
-                <a:hlinkClick r:id="rId8"/>
+                <a:hlinkClick r:id="rId9"/>
               </a:rPr>
               <a:t>Lofar 1</a:t>
             </a:r>
           </a:p>
-          <a:p>
-            <a:r>
-              <a:rPr sz="800">
-                <a:hlinkClick r:id="rId9"/>
-              </a:rPr>
-              <a:t>Lofar 2</a:t>
-            </a:r>
-          </a:p>
-          <a:p>
-            <a:r>
-              <a:rPr sz="800">
-                <a:hlinkClick r:id="rId10"/>
-              </a:rPr>
-              <a:t>Lofar 3</a:t>
-            </a:r>
-          </a:p>
-        </p:txBody>
-      </p:sp>
-      <p:sp>
-        <p:nvSpPr>
-          <p:cNvPr id="9" name="Rounded Rectangle 8"/>
+        </p:txBody>
+      </p:sp>
+      <p:sp>
+        <p:nvSpPr>
+          <p:cNvPr id="9" name="Rounded Rectangle 8">
+            <a:hlinkClick r:id="rId10"/>
+          </p:cNvPr>
           <p:cNvSpPr/>
-          <p:nvPr>
-            <a:hlinkClick r:id="rId11"/>
-          </p:nvPr>
+          <p:nvPr/>
         </p:nvSpPr>
         <p:spPr>
           <a:xfrm>
@@ -5112,7 +6519,7 @@
                   <a:srgbClr val="1F3A5F"/>
                 </a:solidFill>
               </a:rPr>
-              <a:t>Gram 25: FR Ghost, Category 3, Trill</a:t>
+              <a:t>Gram 41: FR Millennium Falcon, Category 1, Gandalf</a:t>
             </a:r>
           </a:p>
         </p:txBody>
@@ -5141,36 +6548,28 @@
           <a:p>
             <a:r>
               <a:rPr sz="800">
+                <a:hlinkClick r:id="rId11"/>
+              </a:rPr>
+              <a:t>Lofar 1</a:t>
+            </a:r>
+          </a:p>
+          <a:p>
+            <a:r>
+              <a:rPr sz="800">
                 <a:hlinkClick r:id="rId12"/>
               </a:rPr>
-              <a:t>Lofar 1</a:t>
-            </a:r>
-          </a:p>
-          <a:p>
-            <a:r>
-              <a:rPr sz="800">
-                <a:hlinkClick r:id="rId13"/>
-              </a:rPr>
               <a:t>Lofar 2</a:t>
             </a:r>
           </a:p>
-          <a:p>
-            <a:r>
-              <a:rPr sz="800">
-                <a:hlinkClick r:id="rId14"/>
-              </a:rPr>
-              <a:t>Lofar 3</a:t>
-            </a:r>
-          </a:p>
-        </p:txBody>
-      </p:sp>
-      <p:sp>
-        <p:nvSpPr>
-          <p:cNvPr id="11" name="Rounded Rectangle 10"/>
+        </p:txBody>
+      </p:sp>
+      <p:sp>
+        <p:nvSpPr>
+          <p:cNvPr id="11" name="Rounded Rectangle 10">
+            <a:hlinkClick r:id="rId13"/>
+          </p:cNvPr>
           <p:cNvSpPr/>
-          <p:nvPr>
-            <a:hlinkClick r:id="rId15"/>
-          </p:nvPr>
+          <p:nvPr/>
         </p:nvSpPr>
         <p:spPr>
           <a:xfrm>
@@ -5214,7 +6613,7 @@
                   <a:srgbClr val="1F3A5F"/>
                 </a:solidFill>
               </a:rPr>
-              <a:t>Gram 26: FR Ghost, Category 1, Trill</a:t>
+              <a:t>Gram 42: FR Venator-class, Category 2, Yavin</a:t>
             </a:r>
           </a:p>
         </p:txBody>
@@ -5243,20 +6642,28 @@
           <a:p>
             <a:r>
               <a:rPr sz="800">
-                <a:hlinkClick r:id="rId16"/>
+                <a:hlinkClick r:id="rId14"/>
               </a:rPr>
               <a:t>Lofar 1</a:t>
             </a:r>
           </a:p>
-        </p:txBody>
-      </p:sp>
-      <p:sp>
-        <p:nvSpPr>
-          <p:cNvPr id="13" name="Rounded Rectangle 12"/>
+          <a:p>
+            <a:r>
+              <a:rPr sz="800">
+                <a:hlinkClick r:id="rId15"/>
+              </a:rPr>
+              <a:t>Lofar 2</a:t>
+            </a:r>
+          </a:p>
+        </p:txBody>
+      </p:sp>
+      <p:sp>
+        <p:nvSpPr>
+          <p:cNvPr id="13" name="Rounded Rectangle 12">
+            <a:hlinkClick r:id="rId16"/>
+          </p:cNvPr>
           <p:cNvSpPr/>
-          <p:nvPr>
-            <a:hlinkClick r:id="rId17"/>
-          </p:nvPr>
+          <p:nvPr/>
         </p:nvSpPr>
         <p:spPr>
           <a:xfrm>
@@ -5300,7 +6707,7 @@
                   <a:srgbClr val="1F3A5F"/>
                 </a:solidFill>
               </a:rPr>
-              <a:t>Gram 27: Cerritos contact bearing 270, codename Vulcan</a:t>
+              <a:t>Gram 43: FR Excelsior, Category 4, Vulcan</a:t>
             </a:r>
           </a:p>
         </p:txBody>
@@ -5329,9 +6736,17 @@
           <a:p>
             <a:r>
               <a:rPr sz="800">
+                <a:hlinkClick r:id="rId17"/>
+              </a:rPr>
+              <a:t>Lofar 1</a:t>
+            </a:r>
+          </a:p>
+          <a:p>
+            <a:r>
+              <a:rPr sz="800">
                 <a:hlinkClick r:id="rId18"/>
               </a:rPr>
-              <a:t>Lofar 1</a:t>
+              <a:t>Lofar 2</a:t>
             </a:r>
           </a:p>
           <a:p>
@@ -5339,7 +6754,7 @@
               <a:rPr sz="800">
                 <a:hlinkClick r:id="rId19"/>
               </a:rPr>
-              <a:t>Lofar 2</a:t>
+              <a:t>Lofar 3</a:t>
             </a:r>
           </a:p>
           <a:p>
@@ -5347,18 +6762,18 @@
               <a:rPr sz="800">
                 <a:hlinkClick r:id="rId20"/>
               </a:rPr>
-              <a:t>Lofar 3</a:t>
-            </a:r>
-          </a:p>
-        </p:txBody>
-      </p:sp>
-      <p:sp>
-        <p:nvSpPr>
-          <p:cNvPr id="15" name="Rounded Rectangle 14"/>
+              <a:t>Lofar 4</a:t>
+            </a:r>
+          </a:p>
+        </p:txBody>
+      </p:sp>
+      <p:sp>
+        <p:nvSpPr>
+          <p:cNvPr id="15" name="Rounded Rectangle 14">
+            <a:hlinkClick r:id="rId21"/>
+          </p:cNvPr>
           <p:cNvSpPr/>
-          <p:nvPr>
-            <a:hlinkClick r:id="rId21"/>
-          </p:nvPr>
+          <p:nvPr/>
         </p:nvSpPr>
         <p:spPr>
           <a:xfrm>
@@ -5402,7 +6817,7 @@
                   <a:srgbClr val="1F3A5F"/>
                 </a:solidFill>
               </a:rPr>
-              <a:t>Gram 28: Defiant contact bearing 357, codename Vulcan</a:t>
+              <a:t>Gram 44: B-wing contact bearing 024, codename Hoth</a:t>
             </a:r>
           </a:p>
         </p:txBody>
@@ -5444,15 +6859,31 @@
               <a:t>Lofar 2</a:t>
             </a:r>
           </a:p>
-        </p:txBody>
-      </p:sp>
-      <p:sp>
-        <p:nvSpPr>
-          <p:cNvPr id="17" name="Rounded Rectangle 16"/>
+          <a:p>
+            <a:r>
+              <a:rPr sz="800">
+                <a:hlinkClick r:id="rId24"/>
+              </a:rPr>
+              <a:t>Lofar 3</a:t>
+            </a:r>
+          </a:p>
+          <a:p>
+            <a:r>
+              <a:rPr sz="800">
+                <a:hlinkClick r:id="rId25"/>
+              </a:rPr>
+              <a:t>Lofar 4</a:t>
+            </a:r>
+          </a:p>
+        </p:txBody>
+      </p:sp>
+      <p:sp>
+        <p:nvSpPr>
+          <p:cNvPr id="17" name="Rounded Rectangle 16">
+            <a:hlinkClick r:id="rId26"/>
+          </p:cNvPr>
           <p:cNvSpPr/>
-          <p:nvPr>
-            <a:hlinkClick r:id="rId24"/>
-          </p:nvPr>
+          <p:nvPr/>
         </p:nvSpPr>
         <p:spPr>
           <a:xfrm>
@@ -5496,7 +6927,7 @@
                   <a:srgbClr val="1F3A5F"/>
                 </a:solidFill>
               </a:rPr>
-              <a:t>Gram 29: Imperial-class contact bearing 080, codename Gandalf</a:t>
+              <a:t>Gram 46: Stargazer contact bearing 059, codename Hoth</a:t>
             </a:r>
           </a:p>
         </p:txBody>
@@ -5525,20 +6956,28 @@
           <a:p>
             <a:r>
               <a:rPr sz="800">
-                <a:hlinkClick r:id="rId25"/>
+                <a:hlinkClick r:id="rId27"/>
               </a:rPr>
               <a:t>Lofar 1</a:t>
             </a:r>
           </a:p>
-        </p:txBody>
-      </p:sp>
-      <p:sp>
-        <p:nvSpPr>
-          <p:cNvPr id="19" name="Rounded Rectangle 18"/>
+          <a:p>
+            <a:r>
+              <a:rPr sz="800">
+                <a:hlinkClick r:id="rId28"/>
+              </a:rPr>
+              <a:t>Lofar 2</a:t>
+            </a:r>
+          </a:p>
+        </p:txBody>
+      </p:sp>
+      <p:sp>
+        <p:nvSpPr>
+          <p:cNvPr id="19" name="Rounded Rectangle 18">
+            <a:hlinkClick r:id="rId29"/>
+          </p:cNvPr>
           <p:cNvSpPr/>
-          <p:nvPr>
-            <a:hlinkClick r:id="rId26"/>
-          </p:nvPr>
+          <p:nvPr/>
         </p:nvSpPr>
         <p:spPr>
           <a:xfrm>
@@ -5582,7 +7021,7 @@
                   <a:srgbClr val="1F3A5F"/>
                 </a:solidFill>
               </a:rPr>
-              <a:t>Gram 30: Excelsior contact bearing 009, codename Cardassia</a:t>
+              <a:t>Gram 47: FR Discovery, Category 4, Risa</a:t>
             </a:r>
           </a:p>
         </p:txBody>
@@ -5611,7 +7050,7 @@
           <a:p>
             <a:r>
               <a:rPr sz="800">
-                <a:hlinkClick r:id="rId27"/>
+                <a:hlinkClick r:id="rId30"/>
               </a:rPr>
               <a:t>Lofar 1</a:t>
             </a:r>
@@ -5620,11 +7059,11 @@
       </p:sp>
       <p:sp>
         <p:nvSpPr>
-          <p:cNvPr id="21" name="Rounded Rectangle 20"/>
+          <p:cNvPr id="21" name="Rounded Rectangle 20">
+            <a:hlinkClick r:id="rId31"/>
+          </p:cNvPr>
           <p:cNvSpPr/>
-          <p:nvPr>
-            <a:hlinkClick r:id="rId28"/>
-          </p:nvPr>
+          <p:nvPr/>
         </p:nvSpPr>
         <p:spPr>
           <a:xfrm>
@@ -5668,7 +7107,7 @@
                   <a:srgbClr val="1F3A5F"/>
                 </a:solidFill>
               </a:rPr>
-              <a:t>Gram 31: FR Rebel One, Category 1, Endor</a:t>
+              <a:t>Gram 48: FR Discovery, Category 4, Kronos</a:t>
             </a:r>
           </a:p>
         </p:txBody>
@@ -5697,7 +7136,7 @@
           <a:p>
             <a:r>
               <a:rPr sz="800">
-                <a:hlinkClick r:id="rId29"/>
+                <a:hlinkClick r:id="rId32"/>
               </a:rPr>
               <a:t>Lofar 1</a:t>
             </a:r>
@@ -5705,1622 +7144,9 @@
           <a:p>
             <a:r>
               <a:rPr sz="800">
-                <a:hlinkClick r:id="rId30"/>
+                <a:hlinkClick r:id="rId33"/>
               </a:rPr>
               <a:t>Lofar 2</a:t>
-            </a:r>
-          </a:p>
-          <a:p>
-            <a:r>
-              <a:rPr sz="800">
-                <a:hlinkClick r:id="rId31"/>
-              </a:rPr>
-              <a:t>Lofar 3</a:t>
-            </a:r>
-          </a:p>
-          <a:p>
-            <a:r>
-              <a:rPr sz="800">
-                <a:hlinkClick r:id="rId32"/>
-              </a:rPr>
-              <a:t>Lofar 4</a:t>
-            </a:r>
-          </a:p>
-        </p:txBody>
-      </p:sp>
-      <p:sp>
-        <p:nvSpPr>
-          <p:cNvPr id="23" name="Rounded Rectangle 22"/>
-          <p:cNvSpPr/>
-          <p:nvPr>
-            <a:hlinkClick r:id="rId33"/>
-          </p:nvPr>
-        </p:nvSpPr>
-        <p:spPr>
-          <a:xfrm>
-            <a:off x="365760" y="4632960"/>
-            <a:ext cx="2200046" cy="365760"/>
-          </a:xfrm>
-          <a:prstGeom prst="roundRect">
-            <a:avLst/>
-          </a:prstGeom>
-          <a:solidFill>
-            <a:srgbClr val="E8EEF7"/>
-          </a:solidFill>
-          <a:ln>
-            <a:solidFill>
-              <a:srgbClr val="1F3A5F"/>
-            </a:solidFill>
-          </a:ln>
-        </p:spPr>
-        <p:style>
-          <a:lnRef idx="1">
-            <a:schemeClr val="accent1"/>
-          </a:lnRef>
-          <a:fillRef idx="3">
-            <a:schemeClr val="accent1"/>
-          </a:fillRef>
-          <a:effectRef idx="2">
-            <a:schemeClr val="accent1"/>
-          </a:effectRef>
-          <a:fontRef idx="minor">
-            <a:schemeClr val="lt1"/>
-          </a:fontRef>
-        </p:style>
-        <p:txBody>
-          <a:bodyPr rtlCol="0" anchor="ctr" lIns="45720" rIns="45720"/>
-          <a:lstStyle/>
-          <a:p>
-            <a:pPr algn="ctr"/>
-            <a:r>
-              <a:rPr sz="900">
-                <a:solidFill>
-                  <a:srgbClr val="1F3A5F"/>
-                </a:solidFill>
-              </a:rPr>
-              <a:t>Gram 33: FR Galaxy-class, Category 2, Mustafar</a:t>
-            </a:r>
-          </a:p>
-        </p:txBody>
-      </p:sp>
-      <p:sp>
-        <p:nvSpPr>
-          <p:cNvPr id="24" name="TextBox 23"/>
-          <p:cNvSpPr txBox="1"/>
-          <p:nvPr/>
-        </p:nvSpPr>
-        <p:spPr>
-          <a:xfrm>
-            <a:off x="365760" y="5017008"/>
-            <a:ext cx="2200046" cy="1447800"/>
-          </a:xfrm>
-          <a:prstGeom prst="rect">
-            <a:avLst/>
-          </a:prstGeom>
-          <a:noFill/>
-        </p:spPr>
-        <p:txBody>
-          <a:bodyPr wrap="square">
-            <a:spAutoFit/>
-          </a:bodyPr>
-          <a:lstStyle/>
-          <a:p>
-            <a:r>
-              <a:rPr sz="800">
-                <a:hlinkClick r:id="rId34"/>
-              </a:rPr>
-              <a:t>Lofar 1</a:t>
-            </a:r>
-          </a:p>
-          <a:p>
-            <a:r>
-              <a:rPr sz="800">
-                <a:hlinkClick r:id="rId35"/>
-              </a:rPr>
-              <a:t>Lofar 2</a:t>
-            </a:r>
-          </a:p>
-          <a:p>
-            <a:r>
-              <a:rPr sz="800">
-                <a:hlinkClick r:id="rId36"/>
-              </a:rPr>
-              <a:t>Lofar 3</a:t>
-            </a:r>
-          </a:p>
-        </p:txBody>
-      </p:sp>
-      <p:sp>
-        <p:nvSpPr>
-          <p:cNvPr id="25" name="Rounded Rectangle 24"/>
-          <p:cNvSpPr/>
-          <p:nvPr>
-            <a:hlinkClick r:id="rId37"/>
-          </p:nvPr>
-        </p:nvSpPr>
-        <p:spPr>
-          <a:xfrm>
-            <a:off x="2657246" y="4632960"/>
-            <a:ext cx="2200046" cy="365760"/>
-          </a:xfrm>
-          <a:prstGeom prst="roundRect">
-            <a:avLst/>
-          </a:prstGeom>
-          <a:solidFill>
-            <a:srgbClr val="E8EEF7"/>
-          </a:solidFill>
-          <a:ln>
-            <a:solidFill>
-              <a:srgbClr val="1F3A5F"/>
-            </a:solidFill>
-          </a:ln>
-        </p:spPr>
-        <p:style>
-          <a:lnRef idx="1">
-            <a:schemeClr val="accent1"/>
-          </a:lnRef>
-          <a:fillRef idx="3">
-            <a:schemeClr val="accent1"/>
-          </a:fillRef>
-          <a:effectRef idx="2">
-            <a:schemeClr val="accent1"/>
-          </a:effectRef>
-          <a:fontRef idx="minor">
-            <a:schemeClr val="lt1"/>
-          </a:fontRef>
-        </p:style>
-        <p:txBody>
-          <a:bodyPr rtlCol="0" anchor="ctr" lIns="45720" rIns="45720"/>
-          <a:lstStyle/>
-          <a:p>
-            <a:pPr algn="ctr"/>
-            <a:r>
-              <a:rPr sz="900">
-                <a:solidFill>
-                  <a:srgbClr val="1F3A5F"/>
-                </a:solidFill>
-              </a:rPr>
-              <a:t>Gram 34: Reliant contact bearing 192, codename Romulus</a:t>
-            </a:r>
-          </a:p>
-        </p:txBody>
-      </p:sp>
-      <p:sp>
-        <p:nvSpPr>
-          <p:cNvPr id="26" name="TextBox 25"/>
-          <p:cNvSpPr txBox="1"/>
-          <p:nvPr/>
-        </p:nvSpPr>
-        <p:spPr>
-          <a:xfrm>
-            <a:off x="2657246" y="5017008"/>
-            <a:ext cx="2200046" cy="1447800"/>
-          </a:xfrm>
-          <a:prstGeom prst="rect">
-            <a:avLst/>
-          </a:prstGeom>
-          <a:noFill/>
-        </p:spPr>
-        <p:txBody>
-          <a:bodyPr wrap="square">
-            <a:spAutoFit/>
-          </a:bodyPr>
-          <a:lstStyle/>
-          <a:p>
-            <a:r>
-              <a:rPr sz="800">
-                <a:hlinkClick r:id="rId38"/>
-              </a:rPr>
-              <a:t>Lofar 1</a:t>
-            </a:r>
-          </a:p>
-          <a:p>
-            <a:r>
-              <a:rPr sz="800">
-                <a:hlinkClick r:id="rId39"/>
-              </a:rPr>
-              <a:t>Lofar 2</a:t>
-            </a:r>
-          </a:p>
-          <a:p>
-            <a:r>
-              <a:rPr sz="800">
-                <a:hlinkClick r:id="rId40"/>
-              </a:rPr>
-              <a:t>Lofar 3</a:t>
-            </a:r>
-          </a:p>
-        </p:txBody>
-      </p:sp>
-      <p:sp>
-        <p:nvSpPr>
-          <p:cNvPr id="27" name="Rounded Rectangle 26"/>
-          <p:cNvSpPr/>
-          <p:nvPr>
-            <a:hlinkClick r:id="rId41"/>
-          </p:nvPr>
-        </p:nvSpPr>
-        <p:spPr>
-          <a:xfrm>
-            <a:off x="4948732" y="4632960"/>
-            <a:ext cx="2200046" cy="365760"/>
-          </a:xfrm>
-          <a:prstGeom prst="roundRect">
-            <a:avLst/>
-          </a:prstGeom>
-          <a:solidFill>
-            <a:srgbClr val="E8EEF7"/>
-          </a:solidFill>
-          <a:ln>
-            <a:solidFill>
-              <a:srgbClr val="1F3A5F"/>
-            </a:solidFill>
-          </a:ln>
-        </p:spPr>
-        <p:style>
-          <a:lnRef idx="1">
-            <a:schemeClr val="accent1"/>
-          </a:lnRef>
-          <a:fillRef idx="3">
-            <a:schemeClr val="accent1"/>
-          </a:fillRef>
-          <a:effectRef idx="2">
-            <a:schemeClr val="accent1"/>
-          </a:effectRef>
-          <a:fontRef idx="minor">
-            <a:schemeClr val="lt1"/>
-          </a:fontRef>
-        </p:style>
-        <p:txBody>
-          <a:bodyPr rtlCol="0" anchor="ctr" lIns="45720" rIns="45720"/>
-          <a:lstStyle/>
-          <a:p>
-            <a:pPr algn="ctr"/>
-            <a:r>
-              <a:rPr sz="900">
-                <a:solidFill>
-                  <a:srgbClr val="1F3A5F"/>
-                </a:solidFill>
-              </a:rPr>
-              <a:t>Gram 35: FR Imperial-class, Category 2, Bajor</a:t>
-            </a:r>
-          </a:p>
-        </p:txBody>
-      </p:sp>
-      <p:sp>
-        <p:nvSpPr>
-          <p:cNvPr id="28" name="TextBox 27"/>
-          <p:cNvSpPr txBox="1"/>
-          <p:nvPr/>
-        </p:nvSpPr>
-        <p:spPr>
-          <a:xfrm>
-            <a:off x="4948732" y="5017008"/>
-            <a:ext cx="2200046" cy="1447800"/>
-          </a:xfrm>
-          <a:prstGeom prst="rect">
-            <a:avLst/>
-          </a:prstGeom>
-          <a:noFill/>
-        </p:spPr>
-        <p:txBody>
-          <a:bodyPr wrap="square">
-            <a:spAutoFit/>
-          </a:bodyPr>
-          <a:lstStyle/>
-          <a:p>
-            <a:r>
-              <a:rPr sz="800">
-                <a:hlinkClick r:id="rId42"/>
-              </a:rPr>
-              <a:t>Lofar 1</a:t>
-            </a:r>
-          </a:p>
-          <a:p>
-            <a:r>
-              <a:rPr sz="800">
-                <a:hlinkClick r:id="rId43"/>
-              </a:rPr>
-              <a:t>Lofar 2</a:t>
-            </a:r>
-          </a:p>
-          <a:p>
-            <a:r>
-              <a:rPr sz="800">
-                <a:hlinkClick r:id="rId44"/>
-              </a:rPr>
-              <a:t>Lofar 3</a:t>
-            </a:r>
-          </a:p>
-          <a:p>
-            <a:r>
-              <a:rPr sz="800">
-                <a:hlinkClick r:id="rId45"/>
-              </a:rPr>
-              <a:t>Lofar 4</a:t>
-            </a:r>
-          </a:p>
-        </p:txBody>
-      </p:sp>
-      <p:sp>
-        <p:nvSpPr>
-          <p:cNvPr id="29" name="Rounded Rectangle 28"/>
-          <p:cNvSpPr/>
-          <p:nvPr>
-            <a:hlinkClick r:id="rId46"/>
-          </p:nvPr>
-        </p:nvSpPr>
-        <p:spPr>
-          <a:xfrm>
-            <a:off x="7240219" y="4632960"/>
-            <a:ext cx="2200046" cy="365760"/>
-          </a:xfrm>
-          <a:prstGeom prst="roundRect">
-            <a:avLst/>
-          </a:prstGeom>
-          <a:solidFill>
-            <a:srgbClr val="E8EEF7"/>
-          </a:solidFill>
-          <a:ln>
-            <a:solidFill>
-              <a:srgbClr val="1F3A5F"/>
-            </a:solidFill>
-          </a:ln>
-        </p:spPr>
-        <p:style>
-          <a:lnRef idx="1">
-            <a:schemeClr val="accent1"/>
-          </a:lnRef>
-          <a:fillRef idx="3">
-            <a:schemeClr val="accent1"/>
-          </a:fillRef>
-          <a:effectRef idx="2">
-            <a:schemeClr val="accent1"/>
-          </a:effectRef>
-          <a:fontRef idx="minor">
-            <a:schemeClr val="lt1"/>
-          </a:fontRef>
-        </p:style>
-        <p:txBody>
-          <a:bodyPr rtlCol="0" anchor="ctr" lIns="45720" rIns="45720"/>
-          <a:lstStyle/>
-          <a:p>
-            <a:pPr algn="ctr"/>
-            <a:r>
-              <a:rPr sz="900">
-                <a:solidFill>
-                  <a:srgbClr val="1F3A5F"/>
-                </a:solidFill>
-              </a:rPr>
-              <a:t>Gram 36: FR Venator-class, Category 4, Defiant</a:t>
-            </a:r>
-          </a:p>
-        </p:txBody>
-      </p:sp>
-      <p:sp>
-        <p:nvSpPr>
-          <p:cNvPr id="30" name="TextBox 29"/>
-          <p:cNvSpPr txBox="1"/>
-          <p:nvPr/>
-        </p:nvSpPr>
-        <p:spPr>
-          <a:xfrm>
-            <a:off x="7240219" y="5017008"/>
-            <a:ext cx="2200046" cy="1447800"/>
-          </a:xfrm>
-          <a:prstGeom prst="rect">
-            <a:avLst/>
-          </a:prstGeom>
-          <a:noFill/>
-        </p:spPr>
-        <p:txBody>
-          <a:bodyPr wrap="square">
-            <a:spAutoFit/>
-          </a:bodyPr>
-          <a:lstStyle/>
-          <a:p>
-            <a:r>
-              <a:rPr sz="800">
-                <a:hlinkClick r:id="rId47"/>
-              </a:rPr>
-              <a:t>Lofar 1</a:t>
-            </a:r>
-          </a:p>
-        </p:txBody>
-      </p:sp>
-      <p:sp>
-        <p:nvSpPr>
-          <p:cNvPr id="31" name="Rounded Rectangle 30"/>
-          <p:cNvSpPr/>
-          <p:nvPr>
-            <a:hlinkClick r:id="rId48"/>
-          </p:nvPr>
-        </p:nvSpPr>
-        <p:spPr>
-          <a:xfrm>
-            <a:off x="9531705" y="4632960"/>
-            <a:ext cx="2200046" cy="365760"/>
-          </a:xfrm>
-          <a:prstGeom prst="roundRect">
-            <a:avLst/>
-          </a:prstGeom>
-          <a:solidFill>
-            <a:srgbClr val="E8EEF7"/>
-          </a:solidFill>
-          <a:ln>
-            <a:solidFill>
-              <a:srgbClr val="1F3A5F"/>
-            </a:solidFill>
-          </a:ln>
-        </p:spPr>
-        <p:style>
-          <a:lnRef idx="1">
-            <a:schemeClr val="accent1"/>
-          </a:lnRef>
-          <a:fillRef idx="3">
-            <a:schemeClr val="accent1"/>
-          </a:fillRef>
-          <a:effectRef idx="2">
-            <a:schemeClr val="accent1"/>
-          </a:effectRef>
-          <a:fontRef idx="minor">
-            <a:schemeClr val="lt1"/>
-          </a:fontRef>
-        </p:style>
-        <p:txBody>
-          <a:bodyPr rtlCol="0" anchor="ctr" lIns="45720" rIns="45720"/>
-          <a:lstStyle/>
-          <a:p>
-            <a:pPr algn="ctr"/>
-            <a:r>
-              <a:rPr sz="900">
-                <a:solidFill>
-                  <a:srgbClr val="1F3A5F"/>
-                </a:solidFill>
-              </a:rPr>
-              <a:t>Gram 37: FR Devastator, Category 2, Tatooine</a:t>
-            </a:r>
-          </a:p>
-        </p:txBody>
-      </p:sp>
-      <p:sp>
-        <p:nvSpPr>
-          <p:cNvPr id="32" name="TextBox 31"/>
-          <p:cNvSpPr txBox="1"/>
-          <p:nvPr/>
-        </p:nvSpPr>
-        <p:spPr>
-          <a:xfrm>
-            <a:off x="9531705" y="5017008"/>
-            <a:ext cx="2200046" cy="1447800"/>
-          </a:xfrm>
-          <a:prstGeom prst="rect">
-            <a:avLst/>
-          </a:prstGeom>
-          <a:noFill/>
-        </p:spPr>
-        <p:txBody>
-          <a:bodyPr wrap="square">
-            <a:spAutoFit/>
-          </a:bodyPr>
-          <a:lstStyle/>
-          <a:p>
-            <a:r>
-              <a:rPr sz="800">
-                <a:hlinkClick r:id="rId49"/>
-              </a:rPr>
-              <a:t>Lofar 1</a:t>
-            </a:r>
-          </a:p>
-        </p:txBody>
-      </p:sp>
-    </p:spTree>
-  </p:cSld>
-  <p:clrMapOvr>
-    <a:masterClrMapping/>
-  </p:clrMapOvr>
-</p:sld>
-</file>
-
-<file path=ppt/slides/slide4.xml><?xml version="1.0" encoding="utf-8"?>
-<p:sld xmlns:a="http://schemas.openxmlformats.org/drawingml/2006/main" xmlns:p="http://schemas.openxmlformats.org/presentationml/2006/main" xmlns:r="http://schemas.openxmlformats.org/officeDocument/2006/relationships">
-  <p:cSld>
-    <p:spTree>
-      <p:nvGrpSpPr>
-        <p:cNvPr id="1" name=""/>
-        <p:cNvGrpSpPr/>
-        <p:nvPr/>
-      </p:nvGrpSpPr>
-      <p:grpSpPr/>
-      <p:sp>
-        <p:nvSpPr>
-          <p:cNvPr id="2" name="Rectangle 1"/>
-          <p:cNvSpPr/>
-          <p:nvPr/>
-        </p:nvSpPr>
-        <p:spPr>
-          <a:xfrm>
-            <a:off x="0" y="0"/>
-            <a:ext cx="12188952" cy="548640"/>
-          </a:xfrm>
-          <a:prstGeom prst="rect">
-            <a:avLst/>
-          </a:prstGeom>
-          <a:solidFill>
-            <a:srgbClr val="1F3A5F"/>
-          </a:solidFill>
-          <a:ln>
-            <a:noFill/>
-          </a:ln>
-        </p:spPr>
-        <p:style>
-          <a:lnRef idx="1">
-            <a:schemeClr val="accent1"/>
-          </a:lnRef>
-          <a:fillRef idx="3">
-            <a:schemeClr val="accent1"/>
-          </a:fillRef>
-          <a:effectRef idx="2">
-            <a:schemeClr val="accent1"/>
-          </a:effectRef>
-          <a:fontRef idx="minor">
-            <a:schemeClr val="lt1"/>
-          </a:fontRef>
-        </p:style>
-        <p:txBody>
-          <a:bodyPr rtlCol="0" anchor="ctr" lIns="182880" rIns="182880"/>
-          <a:lstStyle/>
-          <a:p>
-            <a:pPr algn="ctr"/>
-            <a:r>
-              <a:rPr sz="2000" b="1">
-                <a:solidFill>
-                  <a:srgbClr val="FFFFFF"/>
-                </a:solidFill>
-              </a:rPr>
-              <a:t>Instructor Progress Final Assessment Grams — Page 3 of 3</a:t>
-            </a:r>
-          </a:p>
-        </p:txBody>
-      </p:sp>
-      <p:sp>
-        <p:nvSpPr>
-          <p:cNvPr id="3" name="Rounded Rectangle 2"/>
-          <p:cNvSpPr/>
-          <p:nvPr>
-            <a:hlinkClick r:id="rId2"/>
-          </p:nvPr>
-        </p:nvSpPr>
-        <p:spPr>
-          <a:xfrm>
-            <a:off x="365760" y="731520"/>
-            <a:ext cx="2200046" cy="365760"/>
-          </a:xfrm>
-          <a:prstGeom prst="roundRect">
-            <a:avLst/>
-          </a:prstGeom>
-          <a:solidFill>
-            <a:srgbClr val="E8EEF7"/>
-          </a:solidFill>
-          <a:ln>
-            <a:solidFill>
-              <a:srgbClr val="1F3A5F"/>
-            </a:solidFill>
-          </a:ln>
-        </p:spPr>
-        <p:style>
-          <a:lnRef idx="1">
-            <a:schemeClr val="accent1"/>
-          </a:lnRef>
-          <a:fillRef idx="3">
-            <a:schemeClr val="accent1"/>
-          </a:fillRef>
-          <a:effectRef idx="2">
-            <a:schemeClr val="accent1"/>
-          </a:effectRef>
-          <a:fontRef idx="minor">
-            <a:schemeClr val="lt1"/>
-          </a:fontRef>
-        </p:style>
-        <p:txBody>
-          <a:bodyPr rtlCol="0" anchor="ctr" lIns="45720" rIns="45720"/>
-          <a:lstStyle/>
-          <a:p>
-            <a:pPr algn="ctr"/>
-            <a:r>
-              <a:rPr sz="900">
-                <a:solidFill>
-                  <a:srgbClr val="1F3A5F"/>
-                </a:solidFill>
-              </a:rPr>
-              <a:t>Gram 38: FR Outrider, Category 3, Coruscant</a:t>
-            </a:r>
-          </a:p>
-        </p:txBody>
-      </p:sp>
-      <p:sp>
-        <p:nvSpPr>
-          <p:cNvPr id="4" name="TextBox 3"/>
-          <p:cNvSpPr txBox="1"/>
-          <p:nvPr/>
-        </p:nvSpPr>
-        <p:spPr>
-          <a:xfrm>
-            <a:off x="365760" y="1115568"/>
-            <a:ext cx="2200046" cy="1447800"/>
-          </a:xfrm>
-          <a:prstGeom prst="rect">
-            <a:avLst/>
-          </a:prstGeom>
-          <a:noFill/>
-        </p:spPr>
-        <p:txBody>
-          <a:bodyPr wrap="square">
-            <a:spAutoFit/>
-          </a:bodyPr>
-          <a:lstStyle/>
-          <a:p>
-            <a:r>
-              <a:rPr sz="800">
-                <a:hlinkClick r:id="rId3"/>
-              </a:rPr>
-              <a:t>Lofar 1</a:t>
-            </a:r>
-          </a:p>
-        </p:txBody>
-      </p:sp>
-      <p:sp>
-        <p:nvSpPr>
-          <p:cNvPr id="5" name="Rounded Rectangle 4"/>
-          <p:cNvSpPr/>
-          <p:nvPr>
-            <a:hlinkClick r:id="rId4"/>
-          </p:nvPr>
-        </p:nvSpPr>
-        <p:spPr>
-          <a:xfrm>
-            <a:off x="2657246" y="731520"/>
-            <a:ext cx="2200046" cy="365760"/>
-          </a:xfrm>
-          <a:prstGeom prst="roundRect">
-            <a:avLst/>
-          </a:prstGeom>
-          <a:solidFill>
-            <a:srgbClr val="E8EEF7"/>
-          </a:solidFill>
-          <a:ln>
-            <a:solidFill>
-              <a:srgbClr val="1F3A5F"/>
-            </a:solidFill>
-          </a:ln>
-        </p:spPr>
-        <p:style>
-          <a:lnRef idx="1">
-            <a:schemeClr val="accent1"/>
-          </a:lnRef>
-          <a:fillRef idx="3">
-            <a:schemeClr val="accent1"/>
-          </a:fillRef>
-          <a:effectRef idx="2">
-            <a:schemeClr val="accent1"/>
-          </a:effectRef>
-          <a:fontRef idx="minor">
-            <a:schemeClr val="lt1"/>
-          </a:fontRef>
-        </p:style>
-        <p:txBody>
-          <a:bodyPr rtlCol="0" anchor="ctr" lIns="45720" rIns="45720"/>
-          <a:lstStyle/>
-          <a:p>
-            <a:pPr algn="ctr"/>
-            <a:r>
-              <a:rPr sz="900">
-                <a:solidFill>
-                  <a:srgbClr val="1F3A5F"/>
-                </a:solidFill>
-              </a:rPr>
-              <a:t>Gram 39: Galaxy-class contact bearing 083, codename Betazed</a:t>
-            </a:r>
-          </a:p>
-        </p:txBody>
-      </p:sp>
-      <p:sp>
-        <p:nvSpPr>
-          <p:cNvPr id="6" name="TextBox 5"/>
-          <p:cNvSpPr txBox="1"/>
-          <p:nvPr/>
-        </p:nvSpPr>
-        <p:spPr>
-          <a:xfrm>
-            <a:off x="2657246" y="1115568"/>
-            <a:ext cx="2200046" cy="1447800"/>
-          </a:xfrm>
-          <a:prstGeom prst="rect">
-            <a:avLst/>
-          </a:prstGeom>
-          <a:noFill/>
-        </p:spPr>
-        <p:txBody>
-          <a:bodyPr wrap="square">
-            <a:spAutoFit/>
-          </a:bodyPr>
-          <a:lstStyle/>
-          <a:p>
-            <a:r>
-              <a:rPr sz="800">
-                <a:hlinkClick r:id="rId5"/>
-              </a:rPr>
-              <a:t>Lofar 1</a:t>
-            </a:r>
-          </a:p>
-          <a:p>
-            <a:r>
-              <a:rPr sz="800">
-                <a:hlinkClick r:id="rId6"/>
-              </a:rPr>
-              <a:t>Lofar 2</a:t>
-            </a:r>
-          </a:p>
-          <a:p>
-            <a:r>
-              <a:rPr sz="800">
-                <a:hlinkClick r:id="rId7"/>
-              </a:rPr>
-              <a:t>Lofar 3</a:t>
-            </a:r>
-          </a:p>
-        </p:txBody>
-      </p:sp>
-      <p:sp>
-        <p:nvSpPr>
-          <p:cNvPr id="7" name="Rounded Rectangle 6"/>
-          <p:cNvSpPr/>
-          <p:nvPr>
-            <a:hlinkClick r:id="rId8"/>
-          </p:nvPr>
-        </p:nvSpPr>
-        <p:spPr>
-          <a:xfrm>
-            <a:off x="4948732" y="731520"/>
-            <a:ext cx="2200046" cy="365760"/>
-          </a:xfrm>
-          <a:prstGeom prst="roundRect">
-            <a:avLst/>
-          </a:prstGeom>
-          <a:solidFill>
-            <a:srgbClr val="E8EEF7"/>
-          </a:solidFill>
-          <a:ln>
-            <a:solidFill>
-              <a:srgbClr val="1F3A5F"/>
-            </a:solidFill>
-          </a:ln>
-        </p:spPr>
-        <p:style>
-          <a:lnRef idx="1">
-            <a:schemeClr val="accent1"/>
-          </a:lnRef>
-          <a:fillRef idx="3">
-            <a:schemeClr val="accent1"/>
-          </a:fillRef>
-          <a:effectRef idx="2">
-            <a:schemeClr val="accent1"/>
-          </a:effectRef>
-          <a:fontRef idx="minor">
-            <a:schemeClr val="lt1"/>
-          </a:fontRef>
-        </p:style>
-        <p:txBody>
-          <a:bodyPr rtlCol="0" anchor="ctr" lIns="45720" rIns="45720"/>
-          <a:lstStyle/>
-          <a:p>
-            <a:pPr algn="ctr"/>
-            <a:r>
-              <a:rPr sz="900">
-                <a:solidFill>
-                  <a:srgbClr val="1F3A5F"/>
-                </a:solidFill>
-              </a:rPr>
-              <a:t>Gram 40: FR Corellian Corvette, Category 1, Tantive</a:t>
-            </a:r>
-          </a:p>
-        </p:txBody>
-      </p:sp>
-      <p:sp>
-        <p:nvSpPr>
-          <p:cNvPr id="8" name="TextBox 7"/>
-          <p:cNvSpPr txBox="1"/>
-          <p:nvPr/>
-        </p:nvSpPr>
-        <p:spPr>
-          <a:xfrm>
-            <a:off x="4948732" y="1115568"/>
-            <a:ext cx="2200046" cy="1447800"/>
-          </a:xfrm>
-          <a:prstGeom prst="rect">
-            <a:avLst/>
-          </a:prstGeom>
-          <a:noFill/>
-        </p:spPr>
-        <p:txBody>
-          <a:bodyPr wrap="square">
-            <a:spAutoFit/>
-          </a:bodyPr>
-          <a:lstStyle/>
-          <a:p>
-            <a:r>
-              <a:rPr sz="800">
-                <a:hlinkClick r:id="rId9"/>
-              </a:rPr>
-              <a:t>Lofar 1</a:t>
-            </a:r>
-          </a:p>
-        </p:txBody>
-      </p:sp>
-      <p:sp>
-        <p:nvSpPr>
-          <p:cNvPr id="9" name="Rounded Rectangle 8"/>
-          <p:cNvSpPr/>
-          <p:nvPr>
-            <a:hlinkClick r:id="rId10"/>
-          </p:nvPr>
-        </p:nvSpPr>
-        <p:spPr>
-          <a:xfrm>
-            <a:off x="7240219" y="731520"/>
-            <a:ext cx="2200046" cy="365760"/>
-          </a:xfrm>
-          <a:prstGeom prst="roundRect">
-            <a:avLst/>
-          </a:prstGeom>
-          <a:solidFill>
-            <a:srgbClr val="E8EEF7"/>
-          </a:solidFill>
-          <a:ln>
-            <a:solidFill>
-              <a:srgbClr val="1F3A5F"/>
-            </a:solidFill>
-          </a:ln>
-        </p:spPr>
-        <p:style>
-          <a:lnRef idx="1">
-            <a:schemeClr val="accent1"/>
-          </a:lnRef>
-          <a:fillRef idx="3">
-            <a:schemeClr val="accent1"/>
-          </a:fillRef>
-          <a:effectRef idx="2">
-            <a:schemeClr val="accent1"/>
-          </a:effectRef>
-          <a:fontRef idx="minor">
-            <a:schemeClr val="lt1"/>
-          </a:fontRef>
-        </p:style>
-        <p:txBody>
-          <a:bodyPr rtlCol="0" anchor="ctr" lIns="45720" rIns="45720"/>
-          <a:lstStyle/>
-          <a:p>
-            <a:pPr algn="ctr"/>
-            <a:r>
-              <a:rPr sz="900">
-                <a:solidFill>
-                  <a:srgbClr val="1F3A5F"/>
-                </a:solidFill>
-              </a:rPr>
-              <a:t>Gram 41: FR Millennium Falcon, Category 1, Gandalf</a:t>
-            </a:r>
-          </a:p>
-        </p:txBody>
-      </p:sp>
-      <p:sp>
-        <p:nvSpPr>
-          <p:cNvPr id="10" name="TextBox 9"/>
-          <p:cNvSpPr txBox="1"/>
-          <p:nvPr/>
-        </p:nvSpPr>
-        <p:spPr>
-          <a:xfrm>
-            <a:off x="7240219" y="1115568"/>
-            <a:ext cx="2200046" cy="1447800"/>
-          </a:xfrm>
-          <a:prstGeom prst="rect">
-            <a:avLst/>
-          </a:prstGeom>
-          <a:noFill/>
-        </p:spPr>
-        <p:txBody>
-          <a:bodyPr wrap="square">
-            <a:spAutoFit/>
-          </a:bodyPr>
-          <a:lstStyle/>
-          <a:p>
-            <a:r>
-              <a:rPr sz="800">
-                <a:hlinkClick r:id="rId11"/>
-              </a:rPr>
-              <a:t>Lofar 1</a:t>
-            </a:r>
-          </a:p>
-          <a:p>
-            <a:r>
-              <a:rPr sz="800">
-                <a:hlinkClick r:id="rId12"/>
-              </a:rPr>
-              <a:t>Lofar 2</a:t>
-            </a:r>
-          </a:p>
-        </p:txBody>
-      </p:sp>
-      <p:sp>
-        <p:nvSpPr>
-          <p:cNvPr id="11" name="Rounded Rectangle 10"/>
-          <p:cNvSpPr/>
-          <p:nvPr>
-            <a:hlinkClick r:id="rId13"/>
-          </p:nvPr>
-        </p:nvSpPr>
-        <p:spPr>
-          <a:xfrm>
-            <a:off x="9531705" y="731520"/>
-            <a:ext cx="2200046" cy="365760"/>
-          </a:xfrm>
-          <a:prstGeom prst="roundRect">
-            <a:avLst/>
-          </a:prstGeom>
-          <a:solidFill>
-            <a:srgbClr val="E8EEF7"/>
-          </a:solidFill>
-          <a:ln>
-            <a:solidFill>
-              <a:srgbClr val="1F3A5F"/>
-            </a:solidFill>
-          </a:ln>
-        </p:spPr>
-        <p:style>
-          <a:lnRef idx="1">
-            <a:schemeClr val="accent1"/>
-          </a:lnRef>
-          <a:fillRef idx="3">
-            <a:schemeClr val="accent1"/>
-          </a:fillRef>
-          <a:effectRef idx="2">
-            <a:schemeClr val="accent1"/>
-          </a:effectRef>
-          <a:fontRef idx="minor">
-            <a:schemeClr val="lt1"/>
-          </a:fontRef>
-        </p:style>
-        <p:txBody>
-          <a:bodyPr rtlCol="0" anchor="ctr" lIns="45720" rIns="45720"/>
-          <a:lstStyle/>
-          <a:p>
-            <a:pPr algn="ctr"/>
-            <a:r>
-              <a:rPr sz="900">
-                <a:solidFill>
-                  <a:srgbClr val="1F3A5F"/>
-                </a:solidFill>
-              </a:rPr>
-              <a:t>Gram 42: FR Venator-class, Category 2, Yavin</a:t>
-            </a:r>
-          </a:p>
-        </p:txBody>
-      </p:sp>
-      <p:sp>
-        <p:nvSpPr>
-          <p:cNvPr id="12" name="TextBox 11"/>
-          <p:cNvSpPr txBox="1"/>
-          <p:nvPr/>
-        </p:nvSpPr>
-        <p:spPr>
-          <a:xfrm>
-            <a:off x="9531705" y="1115568"/>
-            <a:ext cx="2200046" cy="1447800"/>
-          </a:xfrm>
-          <a:prstGeom prst="rect">
-            <a:avLst/>
-          </a:prstGeom>
-          <a:noFill/>
-        </p:spPr>
-        <p:txBody>
-          <a:bodyPr wrap="square">
-            <a:spAutoFit/>
-          </a:bodyPr>
-          <a:lstStyle/>
-          <a:p>
-            <a:r>
-              <a:rPr sz="800">
-                <a:hlinkClick r:id="rId14"/>
-              </a:rPr>
-              <a:t>Lofar 1</a:t>
-            </a:r>
-          </a:p>
-          <a:p>
-            <a:r>
-              <a:rPr sz="800">
-                <a:hlinkClick r:id="rId15"/>
-              </a:rPr>
-              <a:t>Lofar 2</a:t>
-            </a:r>
-          </a:p>
-        </p:txBody>
-      </p:sp>
-      <p:sp>
-        <p:nvSpPr>
-          <p:cNvPr id="13" name="Rounded Rectangle 12"/>
-          <p:cNvSpPr/>
-          <p:nvPr>
-            <a:hlinkClick r:id="rId16"/>
-          </p:nvPr>
-        </p:nvSpPr>
-        <p:spPr>
-          <a:xfrm>
-            <a:off x="365760" y="2682240"/>
-            <a:ext cx="2200046" cy="365760"/>
-          </a:xfrm>
-          <a:prstGeom prst="roundRect">
-            <a:avLst/>
-          </a:prstGeom>
-          <a:solidFill>
-            <a:srgbClr val="E8EEF7"/>
-          </a:solidFill>
-          <a:ln>
-            <a:solidFill>
-              <a:srgbClr val="1F3A5F"/>
-            </a:solidFill>
-          </a:ln>
-        </p:spPr>
-        <p:style>
-          <a:lnRef idx="1">
-            <a:schemeClr val="accent1"/>
-          </a:lnRef>
-          <a:fillRef idx="3">
-            <a:schemeClr val="accent1"/>
-          </a:fillRef>
-          <a:effectRef idx="2">
-            <a:schemeClr val="accent1"/>
-          </a:effectRef>
-          <a:fontRef idx="minor">
-            <a:schemeClr val="lt1"/>
-          </a:fontRef>
-        </p:style>
-        <p:txBody>
-          <a:bodyPr rtlCol="0" anchor="ctr" lIns="45720" rIns="45720"/>
-          <a:lstStyle/>
-          <a:p>
-            <a:pPr algn="ctr"/>
-            <a:r>
-              <a:rPr sz="900">
-                <a:solidFill>
-                  <a:srgbClr val="1F3A5F"/>
-                </a:solidFill>
-              </a:rPr>
-              <a:t>Gram 43: FR Excelsior, Category 4, Vulcan</a:t>
-            </a:r>
-          </a:p>
-        </p:txBody>
-      </p:sp>
-      <p:sp>
-        <p:nvSpPr>
-          <p:cNvPr id="14" name="TextBox 13"/>
-          <p:cNvSpPr txBox="1"/>
-          <p:nvPr/>
-        </p:nvSpPr>
-        <p:spPr>
-          <a:xfrm>
-            <a:off x="365760" y="3066288"/>
-            <a:ext cx="2200046" cy="1447800"/>
-          </a:xfrm>
-          <a:prstGeom prst="rect">
-            <a:avLst/>
-          </a:prstGeom>
-          <a:noFill/>
-        </p:spPr>
-        <p:txBody>
-          <a:bodyPr wrap="square">
-            <a:spAutoFit/>
-          </a:bodyPr>
-          <a:lstStyle/>
-          <a:p>
-            <a:r>
-              <a:rPr sz="800">
-                <a:hlinkClick r:id="rId17"/>
-              </a:rPr>
-              <a:t>Lofar 1</a:t>
-            </a:r>
-          </a:p>
-          <a:p>
-            <a:r>
-              <a:rPr sz="800">
-                <a:hlinkClick r:id="rId18"/>
-              </a:rPr>
-              <a:t>Lofar 2</a:t>
-            </a:r>
-          </a:p>
-          <a:p>
-            <a:r>
-              <a:rPr sz="800">
-                <a:hlinkClick r:id="rId19"/>
-              </a:rPr>
-              <a:t>Lofar 3</a:t>
-            </a:r>
-          </a:p>
-          <a:p>
-            <a:r>
-              <a:rPr sz="800">
-                <a:hlinkClick r:id="rId20"/>
-              </a:rPr>
-              <a:t>Lofar 4</a:t>
-            </a:r>
-          </a:p>
-        </p:txBody>
-      </p:sp>
-      <p:sp>
-        <p:nvSpPr>
-          <p:cNvPr id="15" name="Rounded Rectangle 14"/>
-          <p:cNvSpPr/>
-          <p:nvPr>
-            <a:hlinkClick r:id="rId21"/>
-          </p:nvPr>
-        </p:nvSpPr>
-        <p:spPr>
-          <a:xfrm>
-            <a:off x="2657246" y="2682240"/>
-            <a:ext cx="2200046" cy="365760"/>
-          </a:xfrm>
-          <a:prstGeom prst="roundRect">
-            <a:avLst/>
-          </a:prstGeom>
-          <a:solidFill>
-            <a:srgbClr val="E8EEF7"/>
-          </a:solidFill>
-          <a:ln>
-            <a:solidFill>
-              <a:srgbClr val="1F3A5F"/>
-            </a:solidFill>
-          </a:ln>
-        </p:spPr>
-        <p:style>
-          <a:lnRef idx="1">
-            <a:schemeClr val="accent1"/>
-          </a:lnRef>
-          <a:fillRef idx="3">
-            <a:schemeClr val="accent1"/>
-          </a:fillRef>
-          <a:effectRef idx="2">
-            <a:schemeClr val="accent1"/>
-          </a:effectRef>
-          <a:fontRef idx="minor">
-            <a:schemeClr val="lt1"/>
-          </a:fontRef>
-        </p:style>
-        <p:txBody>
-          <a:bodyPr rtlCol="0" anchor="ctr" lIns="45720" rIns="45720"/>
-          <a:lstStyle/>
-          <a:p>
-            <a:pPr algn="ctr"/>
-            <a:r>
-              <a:rPr sz="900">
-                <a:solidFill>
-                  <a:srgbClr val="1F3A5F"/>
-                </a:solidFill>
-              </a:rPr>
-              <a:t>Gram 44: B-wing contact bearing 024, codename Hoth</a:t>
-            </a:r>
-          </a:p>
-        </p:txBody>
-      </p:sp>
-      <p:sp>
-        <p:nvSpPr>
-          <p:cNvPr id="16" name="TextBox 15"/>
-          <p:cNvSpPr txBox="1"/>
-          <p:nvPr/>
-        </p:nvSpPr>
-        <p:spPr>
-          <a:xfrm>
-            <a:off x="2657246" y="3066288"/>
-            <a:ext cx="2200046" cy="1447800"/>
-          </a:xfrm>
-          <a:prstGeom prst="rect">
-            <a:avLst/>
-          </a:prstGeom>
-          <a:noFill/>
-        </p:spPr>
-        <p:txBody>
-          <a:bodyPr wrap="square">
-            <a:spAutoFit/>
-          </a:bodyPr>
-          <a:lstStyle/>
-          <a:p>
-            <a:r>
-              <a:rPr sz="800">
-                <a:hlinkClick r:id="rId22"/>
-              </a:rPr>
-              <a:t>Lofar 1</a:t>
-            </a:r>
-          </a:p>
-          <a:p>
-            <a:r>
-              <a:rPr sz="800">
-                <a:hlinkClick r:id="rId23"/>
-              </a:rPr>
-              <a:t>Lofar 2</a:t>
-            </a:r>
-          </a:p>
-          <a:p>
-            <a:r>
-              <a:rPr sz="800">
-                <a:hlinkClick r:id="rId24"/>
-              </a:rPr>
-              <a:t>Lofar 3</a:t>
-            </a:r>
-          </a:p>
-          <a:p>
-            <a:r>
-              <a:rPr sz="800">
-                <a:hlinkClick r:id="rId25"/>
-              </a:rPr>
-              <a:t>Lofar 4</a:t>
-            </a:r>
-          </a:p>
-        </p:txBody>
-      </p:sp>
-      <p:sp>
-        <p:nvSpPr>
-          <p:cNvPr id="17" name="Rounded Rectangle 16"/>
-          <p:cNvSpPr/>
-          <p:nvPr>
-            <a:hlinkClick r:id="rId26"/>
-          </p:nvPr>
-        </p:nvSpPr>
-        <p:spPr>
-          <a:xfrm>
-            <a:off x="4948732" y="2682240"/>
-            <a:ext cx="2200046" cy="365760"/>
-          </a:xfrm>
-          <a:prstGeom prst="roundRect">
-            <a:avLst/>
-          </a:prstGeom>
-          <a:solidFill>
-            <a:srgbClr val="E8EEF7"/>
-          </a:solidFill>
-          <a:ln>
-            <a:solidFill>
-              <a:srgbClr val="1F3A5F"/>
-            </a:solidFill>
-          </a:ln>
-        </p:spPr>
-        <p:style>
-          <a:lnRef idx="1">
-            <a:schemeClr val="accent1"/>
-          </a:lnRef>
-          <a:fillRef idx="3">
-            <a:schemeClr val="accent1"/>
-          </a:fillRef>
-          <a:effectRef idx="2">
-            <a:schemeClr val="accent1"/>
-          </a:effectRef>
-          <a:fontRef idx="minor">
-            <a:schemeClr val="lt1"/>
-          </a:fontRef>
-        </p:style>
-        <p:txBody>
-          <a:bodyPr rtlCol="0" anchor="ctr" lIns="45720" rIns="45720"/>
-          <a:lstStyle/>
-          <a:p>
-            <a:pPr algn="ctr"/>
-            <a:r>
-              <a:rPr sz="900">
-                <a:solidFill>
-                  <a:srgbClr val="1F3A5F"/>
-                </a:solidFill>
-              </a:rPr>
-              <a:t>Gram 46: Stargazer contact bearing 059, codename Hoth</a:t>
-            </a:r>
-          </a:p>
-        </p:txBody>
-      </p:sp>
-      <p:sp>
-        <p:nvSpPr>
-          <p:cNvPr id="18" name="TextBox 17"/>
-          <p:cNvSpPr txBox="1"/>
-          <p:nvPr/>
-        </p:nvSpPr>
-        <p:spPr>
-          <a:xfrm>
-            <a:off x="4948732" y="3066288"/>
-            <a:ext cx="2200046" cy="1447800"/>
-          </a:xfrm>
-          <a:prstGeom prst="rect">
-            <a:avLst/>
-          </a:prstGeom>
-          <a:noFill/>
-        </p:spPr>
-        <p:txBody>
-          <a:bodyPr wrap="square">
-            <a:spAutoFit/>
-          </a:bodyPr>
-          <a:lstStyle/>
-          <a:p>
-            <a:r>
-              <a:rPr sz="800">
-                <a:hlinkClick r:id="rId27"/>
-              </a:rPr>
-              <a:t>Lofar 1</a:t>
-            </a:r>
-          </a:p>
-          <a:p>
-            <a:r>
-              <a:rPr sz="800">
-                <a:hlinkClick r:id="rId28"/>
-              </a:rPr>
-              <a:t>Lofar 2</a:t>
-            </a:r>
-          </a:p>
-        </p:txBody>
-      </p:sp>
-      <p:sp>
-        <p:nvSpPr>
-          <p:cNvPr id="19" name="Rounded Rectangle 18"/>
-          <p:cNvSpPr/>
-          <p:nvPr>
-            <a:hlinkClick r:id="rId29"/>
-          </p:nvPr>
-        </p:nvSpPr>
-        <p:spPr>
-          <a:xfrm>
-            <a:off x="7240219" y="2682240"/>
-            <a:ext cx="2200046" cy="365760"/>
-          </a:xfrm>
-          <a:prstGeom prst="roundRect">
-            <a:avLst/>
-          </a:prstGeom>
-          <a:solidFill>
-            <a:srgbClr val="E8EEF7"/>
-          </a:solidFill>
-          <a:ln>
-            <a:solidFill>
-              <a:srgbClr val="1F3A5F"/>
-            </a:solidFill>
-          </a:ln>
-        </p:spPr>
-        <p:style>
-          <a:lnRef idx="1">
-            <a:schemeClr val="accent1"/>
-          </a:lnRef>
-          <a:fillRef idx="3">
-            <a:schemeClr val="accent1"/>
-          </a:fillRef>
-          <a:effectRef idx="2">
-            <a:schemeClr val="accent1"/>
-          </a:effectRef>
-          <a:fontRef idx="minor">
-            <a:schemeClr val="lt1"/>
-          </a:fontRef>
-        </p:style>
-        <p:txBody>
-          <a:bodyPr rtlCol="0" anchor="ctr" lIns="45720" rIns="45720"/>
-          <a:lstStyle/>
-          <a:p>
-            <a:pPr algn="ctr"/>
-            <a:r>
-              <a:rPr sz="900">
-                <a:solidFill>
-                  <a:srgbClr val="1F3A5F"/>
-                </a:solidFill>
-              </a:rPr>
-              <a:t>Gram 47: FR Discovery, Category 4, Risa</a:t>
-            </a:r>
-          </a:p>
-        </p:txBody>
-      </p:sp>
-      <p:sp>
-        <p:nvSpPr>
-          <p:cNvPr id="20" name="TextBox 19"/>
-          <p:cNvSpPr txBox="1"/>
-          <p:nvPr/>
-        </p:nvSpPr>
-        <p:spPr>
-          <a:xfrm>
-            <a:off x="7240219" y="3066288"/>
-            <a:ext cx="2200046" cy="1447800"/>
-          </a:xfrm>
-          <a:prstGeom prst="rect">
-            <a:avLst/>
-          </a:prstGeom>
-          <a:noFill/>
-        </p:spPr>
-        <p:txBody>
-          <a:bodyPr wrap="square">
-            <a:spAutoFit/>
-          </a:bodyPr>
-          <a:lstStyle/>
-          <a:p>
-            <a:r>
-              <a:rPr sz="800">
-                <a:hlinkClick r:id="rId30"/>
-              </a:rPr>
-              <a:t>Lofar 1</a:t>
-            </a:r>
-          </a:p>
-        </p:txBody>
-      </p:sp>
-      <p:sp>
-        <p:nvSpPr>
-          <p:cNvPr id="21" name="Rounded Rectangle 20"/>
-          <p:cNvSpPr/>
-          <p:nvPr>
-            <a:hlinkClick r:id="rId31"/>
-          </p:nvPr>
-        </p:nvSpPr>
-        <p:spPr>
-          <a:xfrm>
-            <a:off x="9531705" y="2682240"/>
-            <a:ext cx="2200046" cy="365760"/>
-          </a:xfrm>
-          <a:prstGeom prst="roundRect">
-            <a:avLst/>
-          </a:prstGeom>
-          <a:solidFill>
-            <a:srgbClr val="E8EEF7"/>
-          </a:solidFill>
-          <a:ln>
-            <a:solidFill>
-              <a:srgbClr val="1F3A5F"/>
-            </a:solidFill>
-          </a:ln>
-        </p:spPr>
-        <p:style>
-          <a:lnRef idx="1">
-            <a:schemeClr val="accent1"/>
-          </a:lnRef>
-          <a:fillRef idx="3">
-            <a:schemeClr val="accent1"/>
-          </a:fillRef>
-          <a:effectRef idx="2">
-            <a:schemeClr val="accent1"/>
-          </a:effectRef>
-          <a:fontRef idx="minor">
-            <a:schemeClr val="lt1"/>
-          </a:fontRef>
-        </p:style>
-        <p:txBody>
-          <a:bodyPr rtlCol="0" anchor="ctr" lIns="45720" rIns="45720"/>
-          <a:lstStyle/>
-          <a:p>
-            <a:pPr algn="ctr"/>
-            <a:r>
-              <a:rPr sz="900">
-                <a:solidFill>
-                  <a:srgbClr val="1F3A5F"/>
-                </a:solidFill>
-              </a:rPr>
-              <a:t>Gram 48: FR Discovery, Category 4, Kronos</a:t>
-            </a:r>
-          </a:p>
-        </p:txBody>
-      </p:sp>
-      <p:sp>
-        <p:nvSpPr>
-          <p:cNvPr id="22" name="TextBox 21"/>
-          <p:cNvSpPr txBox="1"/>
-          <p:nvPr/>
-        </p:nvSpPr>
-        <p:spPr>
-          <a:xfrm>
-            <a:off x="9531705" y="3066288"/>
-            <a:ext cx="2200046" cy="1447800"/>
-          </a:xfrm>
-          <a:prstGeom prst="rect">
-            <a:avLst/>
-          </a:prstGeom>
-          <a:noFill/>
-        </p:spPr>
-        <p:txBody>
-          <a:bodyPr wrap="square">
-            <a:spAutoFit/>
-          </a:bodyPr>
-          <a:lstStyle/>
-          <a:p>
-            <a:r>
-              <a:rPr sz="800">
-                <a:hlinkClick r:id="rId32"/>
-              </a:rPr>
-              <a:t>Lofar 1</a:t>
-            </a:r>
-          </a:p>
-          <a:p>
-            <a:r>
-              <a:rPr sz="800">
-                <a:hlinkClick r:id="rId33"/>
-              </a:rPr>
-              <a:t>Lofar 2</a:t>
-            </a:r>
-          </a:p>
-        </p:txBody>
-      </p:sp>
-    </p:spTree>
-  </p:cSld>
-  <p:clrMapOvr>
-    <a:masterClrMapping/>
-  </p:clrMapOvr>
-</p:sld>
-</file>
-
-<file path=ppt/slides/slide5.xml><?xml version="1.0" encoding="utf-8"?>
-<p:sld xmlns:a="http://schemas.openxmlformats.org/drawingml/2006/main" xmlns:p="http://schemas.openxmlformats.org/presentationml/2006/main" xmlns:r="http://schemas.openxmlformats.org/officeDocument/2006/relationships">
-  <p:cSld>
-    <p:spTree>
-      <p:nvGrpSpPr>
-        <p:cNvPr id="1" name=""/>
-        <p:cNvGrpSpPr/>
-        <p:nvPr/>
-      </p:nvGrpSpPr>
-      <p:grpSpPr/>
-      <p:sp>
-        <p:nvSpPr>
-          <p:cNvPr id="2" name="TextBox 1"/>
-          <p:cNvSpPr txBox="1"/>
-          <p:nvPr/>
-        </p:nvSpPr>
-        <p:spPr>
-          <a:xfrm>
-            <a:off x="914400" y="2377440"/>
-            <a:ext cx="10360152" cy="1280160"/>
-          </a:xfrm>
-          <a:prstGeom prst="rect">
-            <a:avLst/>
-          </a:prstGeom>
-          <a:noFill/>
-        </p:spPr>
-        <p:txBody>
-          <a:bodyPr wrap="square">
-            <a:spAutoFit/>
-          </a:bodyPr>
-          <a:lstStyle/>
-          <a:p>
-            <a:pPr algn="ctr"/>
-            <a:r>
-              <a:rPr sz="4000" b="1">
-                <a:solidFill>
-                  <a:srgbClr val="1F3A5F"/>
-                </a:solidFill>
-              </a:rPr>
-              <a:t>End of Instructor Progress Final Assessment Grams</a:t>
-            </a:r>
-          </a:p>
-        </p:txBody>
-      </p:sp>
-      <p:sp>
-        <p:nvSpPr>
-          <p:cNvPr id="3" name="TextBox 2"/>
-          <p:cNvSpPr txBox="1"/>
-          <p:nvPr/>
-        </p:nvSpPr>
-        <p:spPr>
-          <a:xfrm>
-            <a:off x="914400" y="3840480"/>
-            <a:ext cx="10360152" cy="731520"/>
-          </a:xfrm>
-          <a:prstGeom prst="rect">
-            <a:avLst/>
-          </a:prstGeom>
-          <a:noFill/>
-        </p:spPr>
-        <p:txBody>
-          <a:bodyPr wrap="none">
-            <a:spAutoFit/>
-          </a:bodyPr>
-          <a:lstStyle/>
-          <a:p>
-            <a:pPr algn="ctr"/>
-            <a:r>
-              <a:rPr sz="2400">
-                <a:solidFill>
-                  <a:srgbClr val="1F3A5F"/>
-                </a:solidFill>
-              </a:rPr>
-              <a:t>Instructor Version</a:t>
             </a:r>
           </a:p>
         </p:txBody>

</xml_diff>

<commit_message>
Regenerate PPTX corpus with welcome/exit slides on merged base
</commit_message>
<xml_diff>
--- a/source/Instructor Progress Final Assessment Grams/Instructor Progress Final Assessment Grams.pptx
+++ b/source/Instructor Progress Final Assessment Grams/Instructor Progress Final Assessment Grams.pptx
@@ -8,6 +8,8 @@
     <p:sldId id="256" r:id="rId7"/>
     <p:sldId id="257" r:id="rId8"/>
     <p:sldId id="258" r:id="rId9"/>
+    <p:sldId id="259" r:id="rId10"/>
+    <p:sldId id="260" r:id="rId11"/>
   </p:sldIdLst>
   <p:sldSz cx="12188952" cy="6858000" type="screen4x3"/>
   <p:notesSz cx="6858000" cy="9144000"/>
@@ -3092,120 +3094,48 @@
       <p:grpSpPr/>
       <p:sp>
         <p:nvSpPr>
-          <p:cNvPr id="2" name="Rectangle 1"/>
-          <p:cNvSpPr/>
-          <p:nvPr/>
-        </p:nvSpPr>
-        <p:spPr>
-          <a:xfrm>
-            <a:off x="0" y="0"/>
-            <a:ext cx="12188952" cy="548640"/>
+          <p:cNvPr id="2" name="TextBox 1"/>
+          <p:cNvSpPr txBox="1"/>
+          <p:nvPr/>
+        </p:nvSpPr>
+        <p:spPr>
+          <a:xfrm>
+            <a:off x="914400" y="2377440"/>
+            <a:ext cx="10360152" cy="1280160"/>
           </a:xfrm>
           <a:prstGeom prst="rect">
             <a:avLst/>
           </a:prstGeom>
-          <a:solidFill>
-            <a:srgbClr val="1F3A5F"/>
-          </a:solidFill>
-          <a:ln>
-            <a:noFill/>
-          </a:ln>
-        </p:spPr>
-        <p:style>
-          <a:lnRef idx="1">
-            <a:schemeClr val="accent1"/>
-          </a:lnRef>
-          <a:fillRef idx="3">
-            <a:schemeClr val="accent1"/>
-          </a:fillRef>
-          <a:effectRef idx="2">
-            <a:schemeClr val="accent1"/>
-          </a:effectRef>
-          <a:fontRef idx="minor">
-            <a:schemeClr val="lt1"/>
-          </a:fontRef>
-        </p:style>
-        <p:txBody>
-          <a:bodyPr rtlCol="0" anchor="ctr" lIns="182880" rIns="182880"/>
+          <a:noFill/>
+        </p:spPr>
+        <p:txBody>
+          <a:bodyPr wrap="square">
+            <a:spAutoFit/>
+          </a:bodyPr>
           <a:lstStyle/>
           <a:p>
             <a:pPr algn="ctr"/>
             <a:r>
-              <a:rPr sz="2000" b="1">
-                <a:solidFill>
-                  <a:srgbClr val="FFFFFF"/>
-                </a:solidFill>
-              </a:rPr>
-              <a:t>Instructor Progress Final Assessment Grams — Page 1 of 3</a:t>
-            </a:r>
-          </a:p>
-        </p:txBody>
-      </p:sp>
-      <p:sp>
-        <p:nvSpPr>
-          <p:cNvPr id="3" name="Rounded Rectangle 2">
-            <a:hlinkClick r:id="rId2"/>
-          </p:cNvPr>
-          <p:cNvSpPr/>
-          <p:nvPr/>
-        </p:nvSpPr>
-        <p:spPr>
-          <a:xfrm>
-            <a:off x="365760" y="731520"/>
-            <a:ext cx="2200046" cy="365760"/>
-          </a:xfrm>
-          <a:prstGeom prst="roundRect">
-            <a:avLst/>
-          </a:prstGeom>
-          <a:solidFill>
-            <a:srgbClr val="E8EEF7"/>
-          </a:solidFill>
-          <a:ln>
-            <a:solidFill>
-              <a:srgbClr val="1F3A5F"/>
-            </a:solidFill>
-          </a:ln>
-        </p:spPr>
-        <p:style>
-          <a:lnRef idx="1">
-            <a:schemeClr val="accent1"/>
-          </a:lnRef>
-          <a:fillRef idx="3">
-            <a:schemeClr val="accent1"/>
-          </a:fillRef>
-          <a:effectRef idx="2">
-            <a:schemeClr val="accent1"/>
-          </a:effectRef>
-          <a:fontRef idx="minor">
-            <a:schemeClr val="lt1"/>
-          </a:fontRef>
-        </p:style>
-        <p:txBody>
-          <a:bodyPr rtlCol="0" anchor="ctr" lIns="45720" rIns="45720"/>
-          <a:lstStyle/>
-          <a:p>
-            <a:pPr algn="ctr"/>
-            <a:r>
-              <a:rPr sz="900">
+              <a:rPr sz="4000" b="1">
                 <a:solidFill>
                   <a:srgbClr val="1F3A5F"/>
                 </a:solidFill>
               </a:rPr>
-              <a:t>Gram 1: FR TIE Bomber, Category 3, Tatooine</a:t>
-            </a:r>
-          </a:p>
-        </p:txBody>
-      </p:sp>
-      <p:sp>
-        <p:nvSpPr>
-          <p:cNvPr id="4" name="TextBox 3"/>
+              <a:t>Welcome to Instructor Progress Final Assessment Grams</a:t>
+            </a:r>
+          </a:p>
+        </p:txBody>
+      </p:sp>
+      <p:sp>
+        <p:nvSpPr>
+          <p:cNvPr id="3" name="TextBox 2"/>
           <p:cNvSpPr txBox="1"/>
           <p:nvPr/>
         </p:nvSpPr>
         <p:spPr>
           <a:xfrm>
-            <a:off x="365760" y="1115568"/>
-            <a:ext cx="2200046" cy="1447800"/>
+            <a:off x="914400" y="3840480"/>
+            <a:ext cx="10360152" cy="731520"/>
           </a:xfrm>
           <a:prstGeom prst="rect">
             <a:avLst/>
@@ -3213,1412 +3143,19 @@
           <a:noFill/>
         </p:spPr>
         <p:txBody>
-          <a:bodyPr wrap="square">
+          <a:bodyPr wrap="none">
             <a:spAutoFit/>
           </a:bodyPr>
           <a:lstStyle/>
           <a:p>
-            <a:r>
-              <a:rPr sz="800">
-                <a:hlinkClick r:id="rId3"/>
-              </a:rPr>
-              <a:t>Lofar 1</a:t>
-            </a:r>
-          </a:p>
-        </p:txBody>
-      </p:sp>
-      <p:sp>
-        <p:nvSpPr>
-          <p:cNvPr id="5" name="Rounded Rectangle 4">
-            <a:hlinkClick r:id="rId4"/>
-          </p:cNvPr>
-          <p:cNvSpPr/>
-          <p:nvPr/>
-        </p:nvSpPr>
-        <p:spPr>
-          <a:xfrm>
-            <a:off x="2657246" y="731520"/>
-            <a:ext cx="2200046" cy="365760"/>
-          </a:xfrm>
-          <a:prstGeom prst="roundRect">
-            <a:avLst/>
-          </a:prstGeom>
-          <a:solidFill>
-            <a:srgbClr val="E8EEF7"/>
-          </a:solidFill>
-          <a:ln>
-            <a:solidFill>
-              <a:srgbClr val="1F3A5F"/>
-            </a:solidFill>
-          </a:ln>
-        </p:spPr>
-        <p:style>
-          <a:lnRef idx="1">
-            <a:schemeClr val="accent1"/>
-          </a:lnRef>
-          <a:fillRef idx="3">
-            <a:schemeClr val="accent1"/>
-          </a:fillRef>
-          <a:effectRef idx="2">
-            <a:schemeClr val="accent1"/>
-          </a:effectRef>
-          <a:fontRef idx="minor">
-            <a:schemeClr val="lt1"/>
-          </a:fontRef>
-        </p:style>
-        <p:txBody>
-          <a:bodyPr rtlCol="0" anchor="ctr" lIns="45720" rIns="45720"/>
-          <a:lstStyle/>
-          <a:p>
             <a:pPr algn="ctr"/>
             <a:r>
-              <a:rPr sz="900">
+              <a:rPr sz="2400">
                 <a:solidFill>
                   <a:srgbClr val="1F3A5F"/>
                 </a:solidFill>
               </a:rPr>
-              <a:t>Gram 2: FR Sovereign-class, Category 1, Tatooine</a:t>
-            </a:r>
-          </a:p>
-        </p:txBody>
-      </p:sp>
-      <p:sp>
-        <p:nvSpPr>
-          <p:cNvPr id="6" name="TextBox 5"/>
-          <p:cNvSpPr txBox="1"/>
-          <p:nvPr/>
-        </p:nvSpPr>
-        <p:spPr>
-          <a:xfrm>
-            <a:off x="2657246" y="1115568"/>
-            <a:ext cx="2200046" cy="1447800"/>
-          </a:xfrm>
-          <a:prstGeom prst="rect">
-            <a:avLst/>
-          </a:prstGeom>
-          <a:noFill/>
-        </p:spPr>
-        <p:txBody>
-          <a:bodyPr wrap="square">
-            <a:spAutoFit/>
-          </a:bodyPr>
-          <a:lstStyle/>
-          <a:p>
-            <a:r>
-              <a:rPr sz="800">
-                <a:hlinkClick r:id="rId5"/>
-              </a:rPr>
-              <a:t>Lofar 1</a:t>
-            </a:r>
-          </a:p>
-          <a:p>
-            <a:r>
-              <a:rPr sz="800">
-                <a:hlinkClick r:id="rId6"/>
-              </a:rPr>
-              <a:t>Lofar 2</a:t>
-            </a:r>
-          </a:p>
-          <a:p>
-            <a:r>
-              <a:rPr sz="800">
-                <a:hlinkClick r:id="rId7"/>
-              </a:rPr>
-              <a:t>Lofar 3</a:t>
-            </a:r>
-          </a:p>
-        </p:txBody>
-      </p:sp>
-      <p:sp>
-        <p:nvSpPr>
-          <p:cNvPr id="7" name="Rounded Rectangle 6">
-            <a:hlinkClick r:id="rId8"/>
-          </p:cNvPr>
-          <p:cNvSpPr/>
-          <p:nvPr/>
-        </p:nvSpPr>
-        <p:spPr>
-          <a:xfrm>
-            <a:off x="4948732" y="731520"/>
-            <a:ext cx="2200046" cy="365760"/>
-          </a:xfrm>
-          <a:prstGeom prst="roundRect">
-            <a:avLst/>
-          </a:prstGeom>
-          <a:solidFill>
-            <a:srgbClr val="E8EEF7"/>
-          </a:solidFill>
-          <a:ln>
-            <a:solidFill>
-              <a:srgbClr val="1F3A5F"/>
-            </a:solidFill>
-          </a:ln>
-        </p:spPr>
-        <p:style>
-          <a:lnRef idx="1">
-            <a:schemeClr val="accent1"/>
-          </a:lnRef>
-          <a:fillRef idx="3">
-            <a:schemeClr val="accent1"/>
-          </a:fillRef>
-          <a:effectRef idx="2">
-            <a:schemeClr val="accent1"/>
-          </a:effectRef>
-          <a:fontRef idx="minor">
-            <a:schemeClr val="lt1"/>
-          </a:fontRef>
-        </p:style>
-        <p:txBody>
-          <a:bodyPr rtlCol="0" anchor="ctr" lIns="45720" rIns="45720"/>
-          <a:lstStyle/>
-          <a:p>
-            <a:pPr algn="ctr"/>
-            <a:r>
-              <a:rPr sz="900">
-                <a:solidFill>
-                  <a:srgbClr val="1F3A5F"/>
-                </a:solidFill>
-              </a:rPr>
-              <a:t>Gram 3: FR TIE Fighter, Category 4, Mustafar</a:t>
-            </a:r>
-          </a:p>
-        </p:txBody>
-      </p:sp>
-      <p:sp>
-        <p:nvSpPr>
-          <p:cNvPr id="8" name="TextBox 7"/>
-          <p:cNvSpPr txBox="1"/>
-          <p:nvPr/>
-        </p:nvSpPr>
-        <p:spPr>
-          <a:xfrm>
-            <a:off x="4948732" y="1115568"/>
-            <a:ext cx="2200046" cy="1447800"/>
-          </a:xfrm>
-          <a:prstGeom prst="rect">
-            <a:avLst/>
-          </a:prstGeom>
-          <a:noFill/>
-        </p:spPr>
-        <p:txBody>
-          <a:bodyPr wrap="square">
-            <a:spAutoFit/>
-          </a:bodyPr>
-          <a:lstStyle/>
-          <a:p>
-            <a:r>
-              <a:rPr sz="800">
-                <a:hlinkClick r:id="rId9"/>
-              </a:rPr>
-              <a:t>Lofar 1</a:t>
-            </a:r>
-          </a:p>
-          <a:p>
-            <a:r>
-              <a:rPr sz="800">
-                <a:hlinkClick r:id="rId10"/>
-              </a:rPr>
-              <a:t>Lofar 2</a:t>
-            </a:r>
-          </a:p>
-          <a:p>
-            <a:r>
-              <a:rPr sz="800">
-                <a:hlinkClick r:id="rId11"/>
-              </a:rPr>
-              <a:t>Lofar 3</a:t>
-            </a:r>
-          </a:p>
-        </p:txBody>
-      </p:sp>
-      <p:sp>
-        <p:nvSpPr>
-          <p:cNvPr id="9" name="Rounded Rectangle 8">
-            <a:hlinkClick r:id="rId12"/>
-          </p:cNvPr>
-          <p:cNvSpPr/>
-          <p:nvPr/>
-        </p:nvSpPr>
-        <p:spPr>
-          <a:xfrm>
-            <a:off x="7240219" y="731520"/>
-            <a:ext cx="2200046" cy="365760"/>
-          </a:xfrm>
-          <a:prstGeom prst="roundRect">
-            <a:avLst/>
-          </a:prstGeom>
-          <a:solidFill>
-            <a:srgbClr val="E8EEF7"/>
-          </a:solidFill>
-          <a:ln>
-            <a:solidFill>
-              <a:srgbClr val="1F3A5F"/>
-            </a:solidFill>
-          </a:ln>
-        </p:spPr>
-        <p:style>
-          <a:lnRef idx="1">
-            <a:schemeClr val="accent1"/>
-          </a:lnRef>
-          <a:fillRef idx="3">
-            <a:schemeClr val="accent1"/>
-          </a:fillRef>
-          <a:effectRef idx="2">
-            <a:schemeClr val="accent1"/>
-          </a:effectRef>
-          <a:fontRef idx="minor">
-            <a:schemeClr val="lt1"/>
-          </a:fontRef>
-        </p:style>
-        <p:txBody>
-          <a:bodyPr rtlCol="0" anchor="ctr" lIns="45720" rIns="45720"/>
-          <a:lstStyle/>
-          <a:p>
-            <a:pPr algn="ctr"/>
-            <a:r>
-              <a:rPr sz="900">
-                <a:solidFill>
-                  <a:srgbClr val="1F3A5F"/>
-                </a:solidFill>
-              </a:rPr>
-              <a:t>Gram 4: FR Intrepid-class, Category 4, Mustafar</a:t>
-            </a:r>
-          </a:p>
-        </p:txBody>
-      </p:sp>
-      <p:sp>
-        <p:nvSpPr>
-          <p:cNvPr id="10" name="TextBox 9"/>
-          <p:cNvSpPr txBox="1"/>
-          <p:nvPr/>
-        </p:nvSpPr>
-        <p:spPr>
-          <a:xfrm>
-            <a:off x="7240219" y="1115568"/>
-            <a:ext cx="2200046" cy="1447800"/>
-          </a:xfrm>
-          <a:prstGeom prst="rect">
-            <a:avLst/>
-          </a:prstGeom>
-          <a:noFill/>
-        </p:spPr>
-        <p:txBody>
-          <a:bodyPr wrap="square">
-            <a:spAutoFit/>
-          </a:bodyPr>
-          <a:lstStyle/>
-          <a:p>
-            <a:r>
-              <a:rPr sz="800">
-                <a:hlinkClick r:id="rId13"/>
-              </a:rPr>
-              <a:t>Lofar 1</a:t>
-            </a:r>
-          </a:p>
-          <a:p>
-            <a:r>
-              <a:rPr sz="800">
-                <a:hlinkClick r:id="rId14"/>
-              </a:rPr>
-              <a:t>Lofar 2</a:t>
-            </a:r>
-          </a:p>
-          <a:p>
-            <a:r>
-              <a:rPr sz="800">
-                <a:hlinkClick r:id="rId15"/>
-              </a:rPr>
-              <a:t>Lofar 3</a:t>
-            </a:r>
-          </a:p>
-        </p:txBody>
-      </p:sp>
-      <p:sp>
-        <p:nvSpPr>
-          <p:cNvPr id="11" name="Rounded Rectangle 10">
-            <a:hlinkClick r:id="rId16"/>
-          </p:cNvPr>
-          <p:cNvSpPr/>
-          <p:nvPr/>
-        </p:nvSpPr>
-        <p:spPr>
-          <a:xfrm>
-            <a:off x="9531705" y="731520"/>
-            <a:ext cx="2200046" cy="365760"/>
-          </a:xfrm>
-          <a:prstGeom prst="roundRect">
-            <a:avLst/>
-          </a:prstGeom>
-          <a:solidFill>
-            <a:srgbClr val="E8EEF7"/>
-          </a:solidFill>
-          <a:ln>
-            <a:solidFill>
-              <a:srgbClr val="1F3A5F"/>
-            </a:solidFill>
-          </a:ln>
-        </p:spPr>
-        <p:style>
-          <a:lnRef idx="1">
-            <a:schemeClr val="accent1"/>
-          </a:lnRef>
-          <a:fillRef idx="3">
-            <a:schemeClr val="accent1"/>
-          </a:fillRef>
-          <a:effectRef idx="2">
-            <a:schemeClr val="accent1"/>
-          </a:effectRef>
-          <a:fontRef idx="minor">
-            <a:schemeClr val="lt1"/>
-          </a:fontRef>
-        </p:style>
-        <p:txBody>
-          <a:bodyPr rtlCol="0" anchor="ctr" lIns="45720" rIns="45720"/>
-          <a:lstStyle/>
-          <a:p>
-            <a:pPr algn="ctr"/>
-            <a:r>
-              <a:rPr sz="900">
-                <a:solidFill>
-                  <a:srgbClr val="1F3A5F"/>
-                </a:solidFill>
-              </a:rPr>
-              <a:t>Gram 7: FR Discovery, Category 1, Dagobah</a:t>
-            </a:r>
-          </a:p>
-        </p:txBody>
-      </p:sp>
-      <p:sp>
-        <p:nvSpPr>
-          <p:cNvPr id="12" name="TextBox 11"/>
-          <p:cNvSpPr txBox="1"/>
-          <p:nvPr/>
-        </p:nvSpPr>
-        <p:spPr>
-          <a:xfrm>
-            <a:off x="9531705" y="1115568"/>
-            <a:ext cx="2200046" cy="1447800"/>
-          </a:xfrm>
-          <a:prstGeom prst="rect">
-            <a:avLst/>
-          </a:prstGeom>
-          <a:noFill/>
-        </p:spPr>
-        <p:txBody>
-          <a:bodyPr wrap="square">
-            <a:spAutoFit/>
-          </a:bodyPr>
-          <a:lstStyle/>
-          <a:p>
-            <a:r>
-              <a:rPr sz="800">
-                <a:hlinkClick r:id="rId17"/>
-              </a:rPr>
-              <a:t>Lofar 1</a:t>
-            </a:r>
-          </a:p>
-        </p:txBody>
-      </p:sp>
-      <p:sp>
-        <p:nvSpPr>
-          <p:cNvPr id="13" name="Rounded Rectangle 12">
-            <a:hlinkClick r:id="rId18"/>
-          </p:cNvPr>
-          <p:cNvSpPr/>
-          <p:nvPr/>
-        </p:nvSpPr>
-        <p:spPr>
-          <a:xfrm>
-            <a:off x="365760" y="2682240"/>
-            <a:ext cx="2200046" cy="365760"/>
-          </a:xfrm>
-          <a:prstGeom prst="roundRect">
-            <a:avLst/>
-          </a:prstGeom>
-          <a:solidFill>
-            <a:srgbClr val="E8EEF7"/>
-          </a:solidFill>
-          <a:ln>
-            <a:solidFill>
-              <a:srgbClr val="1F3A5F"/>
-            </a:solidFill>
-          </a:ln>
-        </p:spPr>
-        <p:style>
-          <a:lnRef idx="1">
-            <a:schemeClr val="accent1"/>
-          </a:lnRef>
-          <a:fillRef idx="3">
-            <a:schemeClr val="accent1"/>
-          </a:fillRef>
-          <a:effectRef idx="2">
-            <a:schemeClr val="accent1"/>
-          </a:effectRef>
-          <a:fontRef idx="minor">
-            <a:schemeClr val="lt1"/>
-          </a:fontRef>
-        </p:style>
-        <p:txBody>
-          <a:bodyPr rtlCol="0" anchor="ctr" lIns="45720" rIns="45720"/>
-          <a:lstStyle/>
-          <a:p>
-            <a:pPr algn="ctr"/>
-            <a:r>
-              <a:rPr sz="900">
-                <a:solidFill>
-                  <a:srgbClr val="1F3A5F"/>
-                </a:solidFill>
-              </a:rPr>
-              <a:t>Gram 8: Miranda-class contact bearing 288, codename Dank</a:t>
-            </a:r>
-          </a:p>
-        </p:txBody>
-      </p:sp>
-      <p:sp>
-        <p:nvSpPr>
-          <p:cNvPr id="14" name="TextBox 13"/>
-          <p:cNvSpPr txBox="1"/>
-          <p:nvPr/>
-        </p:nvSpPr>
-        <p:spPr>
-          <a:xfrm>
-            <a:off x="365760" y="3066288"/>
-            <a:ext cx="2200046" cy="1447800"/>
-          </a:xfrm>
-          <a:prstGeom prst="rect">
-            <a:avLst/>
-          </a:prstGeom>
-          <a:noFill/>
-        </p:spPr>
-        <p:txBody>
-          <a:bodyPr wrap="square">
-            <a:spAutoFit/>
-          </a:bodyPr>
-          <a:lstStyle/>
-          <a:p>
-            <a:r>
-              <a:rPr sz="800">
-                <a:hlinkClick r:id="rId19"/>
-              </a:rPr>
-              <a:t>Lofar 1</a:t>
-            </a:r>
-          </a:p>
-          <a:p>
-            <a:r>
-              <a:rPr sz="800">
-                <a:hlinkClick r:id="rId20"/>
-              </a:rPr>
-              <a:t>Lofar 2</a:t>
-            </a:r>
-          </a:p>
-          <a:p>
-            <a:r>
-              <a:rPr sz="800">
-                <a:hlinkClick r:id="rId21"/>
-              </a:rPr>
-              <a:t>Lofar 3</a:t>
-            </a:r>
-          </a:p>
-          <a:p>
-            <a:r>
-              <a:rPr sz="800">
-                <a:hlinkClick r:id="rId22"/>
-              </a:rPr>
-              <a:t>Lofar 4</a:t>
-            </a:r>
-          </a:p>
-        </p:txBody>
-      </p:sp>
-      <p:sp>
-        <p:nvSpPr>
-          <p:cNvPr id="15" name="Rounded Rectangle 14">
-            <a:hlinkClick r:id="rId23"/>
-          </p:cNvPr>
-          <p:cNvSpPr/>
-          <p:nvPr/>
-        </p:nvSpPr>
-        <p:spPr>
-          <a:xfrm>
-            <a:off x="2657246" y="2682240"/>
-            <a:ext cx="2200046" cy="365760"/>
-          </a:xfrm>
-          <a:prstGeom prst="roundRect">
-            <a:avLst/>
-          </a:prstGeom>
-          <a:solidFill>
-            <a:srgbClr val="E8EEF7"/>
-          </a:solidFill>
-          <a:ln>
-            <a:solidFill>
-              <a:srgbClr val="1F3A5F"/>
-            </a:solidFill>
-          </a:ln>
-        </p:spPr>
-        <p:style>
-          <a:lnRef idx="1">
-            <a:schemeClr val="accent1"/>
-          </a:lnRef>
-          <a:fillRef idx="3">
-            <a:schemeClr val="accent1"/>
-          </a:fillRef>
-          <a:effectRef idx="2">
-            <a:schemeClr val="accent1"/>
-          </a:effectRef>
-          <a:fontRef idx="minor">
-            <a:schemeClr val="lt1"/>
-          </a:fontRef>
-        </p:style>
-        <p:txBody>
-          <a:bodyPr rtlCol="0" anchor="ctr" lIns="45720" rIns="45720"/>
-          <a:lstStyle/>
-          <a:p>
-            <a:pPr algn="ctr"/>
-            <a:r>
-              <a:rPr sz="900">
-                <a:solidFill>
-                  <a:srgbClr val="1F3A5F"/>
-                </a:solidFill>
-              </a:rPr>
-              <a:t>Gram 9: Enterprise contact bearing 084, codename Yavin</a:t>
-            </a:r>
-          </a:p>
-        </p:txBody>
-      </p:sp>
-      <p:sp>
-        <p:nvSpPr>
-          <p:cNvPr id="16" name="TextBox 15"/>
-          <p:cNvSpPr txBox="1"/>
-          <p:nvPr/>
-        </p:nvSpPr>
-        <p:spPr>
-          <a:xfrm>
-            <a:off x="2657246" y="3066288"/>
-            <a:ext cx="2200046" cy="1447800"/>
-          </a:xfrm>
-          <a:prstGeom prst="rect">
-            <a:avLst/>
-          </a:prstGeom>
-          <a:noFill/>
-        </p:spPr>
-        <p:txBody>
-          <a:bodyPr wrap="square">
-            <a:spAutoFit/>
-          </a:bodyPr>
-          <a:lstStyle/>
-          <a:p>
-            <a:r>
-              <a:rPr sz="800">
-                <a:hlinkClick r:id="rId24"/>
-              </a:rPr>
-              <a:t>Lofar 1</a:t>
-            </a:r>
-          </a:p>
-          <a:p>
-            <a:r>
-              <a:rPr sz="800">
-                <a:hlinkClick r:id="rId25"/>
-              </a:rPr>
-              <a:t>Lofar 2</a:t>
-            </a:r>
-          </a:p>
-        </p:txBody>
-      </p:sp>
-      <p:sp>
-        <p:nvSpPr>
-          <p:cNvPr id="17" name="Rounded Rectangle 16">
-            <a:hlinkClick r:id="rId26"/>
-          </p:cNvPr>
-          <p:cNvSpPr/>
-          <p:nvPr/>
-        </p:nvSpPr>
-        <p:spPr>
-          <a:xfrm>
-            <a:off x="4948732" y="2682240"/>
-            <a:ext cx="2200046" cy="365760"/>
-          </a:xfrm>
-          <a:prstGeom prst="roundRect">
-            <a:avLst/>
-          </a:prstGeom>
-          <a:solidFill>
-            <a:srgbClr val="E8EEF7"/>
-          </a:solidFill>
-          <a:ln>
-            <a:solidFill>
-              <a:srgbClr val="1F3A5F"/>
-            </a:solidFill>
-          </a:ln>
-        </p:spPr>
-        <p:style>
-          <a:lnRef idx="1">
-            <a:schemeClr val="accent1"/>
-          </a:lnRef>
-          <a:fillRef idx="3">
-            <a:schemeClr val="accent1"/>
-          </a:fillRef>
-          <a:effectRef idx="2">
-            <a:schemeClr val="accent1"/>
-          </a:effectRef>
-          <a:fontRef idx="minor">
-            <a:schemeClr val="lt1"/>
-          </a:fontRef>
-        </p:style>
-        <p:txBody>
-          <a:bodyPr rtlCol="0" anchor="ctr" lIns="45720" rIns="45720"/>
-          <a:lstStyle/>
-          <a:p>
-            <a:pPr algn="ctr"/>
-            <a:r>
-              <a:rPr sz="900">
-                <a:solidFill>
-                  <a:srgbClr val="1F3A5F"/>
-                </a:solidFill>
-              </a:rPr>
-              <a:t>Gram 10: FR A-wing, Category 3, Risa</a:t>
-            </a:r>
-          </a:p>
-        </p:txBody>
-      </p:sp>
-      <p:sp>
-        <p:nvSpPr>
-          <p:cNvPr id="18" name="TextBox 17"/>
-          <p:cNvSpPr txBox="1"/>
-          <p:nvPr/>
-        </p:nvSpPr>
-        <p:spPr>
-          <a:xfrm>
-            <a:off x="4948732" y="3066288"/>
-            <a:ext cx="2200046" cy="1447800"/>
-          </a:xfrm>
-          <a:prstGeom prst="rect">
-            <a:avLst/>
-          </a:prstGeom>
-          <a:noFill/>
-        </p:spPr>
-        <p:txBody>
-          <a:bodyPr wrap="square">
-            <a:spAutoFit/>
-          </a:bodyPr>
-          <a:lstStyle/>
-          <a:p>
-            <a:r>
-              <a:rPr sz="800">
-                <a:hlinkClick r:id="rId27"/>
-              </a:rPr>
-              <a:t>Lofar 1</a:t>
-            </a:r>
-          </a:p>
-        </p:txBody>
-      </p:sp>
-      <p:sp>
-        <p:nvSpPr>
-          <p:cNvPr id="19" name="Rounded Rectangle 18">
-            <a:hlinkClick r:id="rId28"/>
-          </p:cNvPr>
-          <p:cNvSpPr/>
-          <p:nvPr/>
-        </p:nvSpPr>
-        <p:spPr>
-          <a:xfrm>
-            <a:off x="7240219" y="2682240"/>
-            <a:ext cx="2200046" cy="365760"/>
-          </a:xfrm>
-          <a:prstGeom prst="roundRect">
-            <a:avLst/>
-          </a:prstGeom>
-          <a:solidFill>
-            <a:srgbClr val="E8EEF7"/>
-          </a:solidFill>
-          <a:ln>
-            <a:solidFill>
-              <a:srgbClr val="1F3A5F"/>
-            </a:solidFill>
-          </a:ln>
-        </p:spPr>
-        <p:style>
-          <a:lnRef idx="1">
-            <a:schemeClr val="accent1"/>
-          </a:lnRef>
-          <a:fillRef idx="3">
-            <a:schemeClr val="accent1"/>
-          </a:fillRef>
-          <a:effectRef idx="2">
-            <a:schemeClr val="accent1"/>
-          </a:effectRef>
-          <a:fontRef idx="minor">
-            <a:schemeClr val="lt1"/>
-          </a:fontRef>
-        </p:style>
-        <p:txBody>
-          <a:bodyPr rtlCol="0" anchor="ctr" lIns="45720" rIns="45720"/>
-          <a:lstStyle/>
-          <a:p>
-            <a:pPr algn="ctr"/>
-            <a:r>
-              <a:rPr sz="900">
-                <a:solidFill>
-                  <a:srgbClr val="1F3A5F"/>
-                </a:solidFill>
-              </a:rPr>
-              <a:t>Gram 11: FR Star Destroyer, Category 1, Vulcan</a:t>
-            </a:r>
-          </a:p>
-        </p:txBody>
-      </p:sp>
-      <p:sp>
-        <p:nvSpPr>
-          <p:cNvPr id="20" name="TextBox 19"/>
-          <p:cNvSpPr txBox="1"/>
-          <p:nvPr/>
-        </p:nvSpPr>
-        <p:spPr>
-          <a:xfrm>
-            <a:off x="7240219" y="3066288"/>
-            <a:ext cx="2200046" cy="1447800"/>
-          </a:xfrm>
-          <a:prstGeom prst="rect">
-            <a:avLst/>
-          </a:prstGeom>
-          <a:noFill/>
-        </p:spPr>
-        <p:txBody>
-          <a:bodyPr wrap="square">
-            <a:spAutoFit/>
-          </a:bodyPr>
-          <a:lstStyle/>
-          <a:p>
-            <a:r>
-              <a:rPr sz="800">
-                <a:hlinkClick r:id="rId29"/>
-              </a:rPr>
-              <a:t>Lofar 1</a:t>
-            </a:r>
-          </a:p>
-        </p:txBody>
-      </p:sp>
-      <p:sp>
-        <p:nvSpPr>
-          <p:cNvPr id="21" name="Rounded Rectangle 20">
-            <a:hlinkClick r:id="rId30"/>
-          </p:cNvPr>
-          <p:cNvSpPr/>
-          <p:nvPr/>
-        </p:nvSpPr>
-        <p:spPr>
-          <a:xfrm>
-            <a:off x="9531705" y="2682240"/>
-            <a:ext cx="2200046" cy="365760"/>
-          </a:xfrm>
-          <a:prstGeom prst="roundRect">
-            <a:avLst/>
-          </a:prstGeom>
-          <a:solidFill>
-            <a:srgbClr val="E8EEF7"/>
-          </a:solidFill>
-          <a:ln>
-            <a:solidFill>
-              <a:srgbClr val="1F3A5F"/>
-            </a:solidFill>
-          </a:ln>
-        </p:spPr>
-        <p:style>
-          <a:lnRef idx="1">
-            <a:schemeClr val="accent1"/>
-          </a:lnRef>
-          <a:fillRef idx="3">
-            <a:schemeClr val="accent1"/>
-          </a:fillRef>
-          <a:effectRef idx="2">
-            <a:schemeClr val="accent1"/>
-          </a:effectRef>
-          <a:fontRef idx="minor">
-            <a:schemeClr val="lt1"/>
-          </a:fontRef>
-        </p:style>
-        <p:txBody>
-          <a:bodyPr rtlCol="0" anchor="ctr" lIns="45720" rIns="45720"/>
-          <a:lstStyle/>
-          <a:p>
-            <a:pPr algn="ctr"/>
-            <a:r>
-              <a:rPr sz="900">
-                <a:solidFill>
-                  <a:srgbClr val="1F3A5F"/>
-                </a:solidFill>
-              </a:rPr>
-              <a:t>Gram 12: Venator-class contact bearing 330, codename Dank</a:t>
-            </a:r>
-          </a:p>
-        </p:txBody>
-      </p:sp>
-      <p:sp>
-        <p:nvSpPr>
-          <p:cNvPr id="22" name="TextBox 21"/>
-          <p:cNvSpPr txBox="1"/>
-          <p:nvPr/>
-        </p:nvSpPr>
-        <p:spPr>
-          <a:xfrm>
-            <a:off x="9531705" y="3066288"/>
-            <a:ext cx="2200046" cy="1447800"/>
-          </a:xfrm>
-          <a:prstGeom prst="rect">
-            <a:avLst/>
-          </a:prstGeom>
-          <a:noFill/>
-        </p:spPr>
-        <p:txBody>
-          <a:bodyPr wrap="square">
-            <a:spAutoFit/>
-          </a:bodyPr>
-          <a:lstStyle/>
-          <a:p>
-            <a:r>
-              <a:rPr sz="800">
-                <a:hlinkClick r:id="rId31"/>
-              </a:rPr>
-              <a:t>Lofar 1</a:t>
-            </a:r>
-          </a:p>
-          <a:p>
-            <a:r>
-              <a:rPr sz="800">
-                <a:hlinkClick r:id="rId32"/>
-              </a:rPr>
-              <a:t>Lofar 2</a:t>
-            </a:r>
-          </a:p>
-          <a:p>
-            <a:r>
-              <a:rPr sz="800">
-                <a:hlinkClick r:id="rId33"/>
-              </a:rPr>
-              <a:t>Lofar 3</a:t>
-            </a:r>
-          </a:p>
-          <a:p>
-            <a:r>
-              <a:rPr sz="800">
-                <a:hlinkClick r:id="rId34"/>
-              </a:rPr>
-              <a:t>Lofar 4</a:t>
-            </a:r>
-          </a:p>
-        </p:txBody>
-      </p:sp>
-      <p:sp>
-        <p:nvSpPr>
-          <p:cNvPr id="23" name="Rounded Rectangle 22">
-            <a:hlinkClick r:id="rId35"/>
-          </p:cNvPr>
-          <p:cNvSpPr/>
-          <p:nvPr/>
-        </p:nvSpPr>
-        <p:spPr>
-          <a:xfrm>
-            <a:off x="365760" y="4632960"/>
-            <a:ext cx="2200046" cy="365760"/>
-          </a:xfrm>
-          <a:prstGeom prst="roundRect">
-            <a:avLst/>
-          </a:prstGeom>
-          <a:solidFill>
-            <a:srgbClr val="E8EEF7"/>
-          </a:solidFill>
-          <a:ln>
-            <a:solidFill>
-              <a:srgbClr val="1F3A5F"/>
-            </a:solidFill>
-          </a:ln>
-        </p:spPr>
-        <p:style>
-          <a:lnRef idx="1">
-            <a:schemeClr val="accent1"/>
-          </a:lnRef>
-          <a:fillRef idx="3">
-            <a:schemeClr val="accent1"/>
-          </a:fillRef>
-          <a:effectRef idx="2">
-            <a:schemeClr val="accent1"/>
-          </a:effectRef>
-          <a:fontRef idx="minor">
-            <a:schemeClr val="lt1"/>
-          </a:fontRef>
-        </p:style>
-        <p:txBody>
-          <a:bodyPr rtlCol="0" anchor="ctr" lIns="45720" rIns="45720"/>
-          <a:lstStyle/>
-          <a:p>
-            <a:pPr algn="ctr"/>
-            <a:r>
-              <a:rPr sz="900">
-                <a:solidFill>
-                  <a:srgbClr val="1F3A5F"/>
-                </a:solidFill>
-              </a:rPr>
-              <a:t>Gram 13: FR Outrider, Category 1, Coruscant</a:t>
-            </a:r>
-          </a:p>
-        </p:txBody>
-      </p:sp>
-      <p:sp>
-        <p:nvSpPr>
-          <p:cNvPr id="24" name="TextBox 23"/>
-          <p:cNvSpPr txBox="1"/>
-          <p:nvPr/>
-        </p:nvSpPr>
-        <p:spPr>
-          <a:xfrm>
-            <a:off x="365760" y="5017008"/>
-            <a:ext cx="2200046" cy="1447800"/>
-          </a:xfrm>
-          <a:prstGeom prst="rect">
-            <a:avLst/>
-          </a:prstGeom>
-          <a:noFill/>
-        </p:spPr>
-        <p:txBody>
-          <a:bodyPr wrap="square">
-            <a:spAutoFit/>
-          </a:bodyPr>
-          <a:lstStyle/>
-          <a:p>
-            <a:r>
-              <a:rPr sz="800">
-                <a:hlinkClick r:id="rId36"/>
-              </a:rPr>
-              <a:t>Lofar 1</a:t>
-            </a:r>
-          </a:p>
-          <a:p>
-            <a:r>
-              <a:rPr sz="800">
-                <a:hlinkClick r:id="rId37"/>
-              </a:rPr>
-              <a:t>Lofar 2</a:t>
-            </a:r>
-          </a:p>
-          <a:p>
-            <a:r>
-              <a:rPr sz="800">
-                <a:hlinkClick r:id="rId38"/>
-              </a:rPr>
-              <a:t>Lofar 3</a:t>
-            </a:r>
-          </a:p>
-        </p:txBody>
-      </p:sp>
-      <p:sp>
-        <p:nvSpPr>
-          <p:cNvPr id="25" name="Rounded Rectangle 24">
-            <a:hlinkClick r:id="rId39"/>
-          </p:cNvPr>
-          <p:cNvSpPr/>
-          <p:nvPr/>
-        </p:nvSpPr>
-        <p:spPr>
-          <a:xfrm>
-            <a:off x="2657246" y="4632960"/>
-            <a:ext cx="2200046" cy="365760"/>
-          </a:xfrm>
-          <a:prstGeom prst="roundRect">
-            <a:avLst/>
-          </a:prstGeom>
-          <a:solidFill>
-            <a:srgbClr val="E8EEF7"/>
-          </a:solidFill>
-          <a:ln>
-            <a:solidFill>
-              <a:srgbClr val="1F3A5F"/>
-            </a:solidFill>
-          </a:ln>
-        </p:spPr>
-        <p:style>
-          <a:lnRef idx="1">
-            <a:schemeClr val="accent1"/>
-          </a:lnRef>
-          <a:fillRef idx="3">
-            <a:schemeClr val="accent1"/>
-          </a:fillRef>
-          <a:effectRef idx="2">
-            <a:schemeClr val="accent1"/>
-          </a:effectRef>
-          <a:fontRef idx="minor">
-            <a:schemeClr val="lt1"/>
-          </a:fontRef>
-        </p:style>
-        <p:txBody>
-          <a:bodyPr rtlCol="0" anchor="ctr" lIns="45720" rIns="45720"/>
-          <a:lstStyle/>
-          <a:p>
-            <a:pPr algn="ctr"/>
-            <a:r>
-              <a:rPr sz="900">
-                <a:solidFill>
-                  <a:srgbClr val="1F3A5F"/>
-                </a:solidFill>
-              </a:rPr>
-              <a:t>Gram 14: Cerritos contact bearing 210, codename Betazed</a:t>
-            </a:r>
-          </a:p>
-        </p:txBody>
-      </p:sp>
-      <p:sp>
-        <p:nvSpPr>
-          <p:cNvPr id="26" name="TextBox 25"/>
-          <p:cNvSpPr txBox="1"/>
-          <p:nvPr/>
-        </p:nvSpPr>
-        <p:spPr>
-          <a:xfrm>
-            <a:off x="2657246" y="5017008"/>
-            <a:ext cx="2200046" cy="1447800"/>
-          </a:xfrm>
-          <a:prstGeom prst="rect">
-            <a:avLst/>
-          </a:prstGeom>
-          <a:noFill/>
-        </p:spPr>
-        <p:txBody>
-          <a:bodyPr wrap="square">
-            <a:spAutoFit/>
-          </a:bodyPr>
-          <a:lstStyle/>
-          <a:p>
-            <a:r>
-              <a:rPr sz="800">
-                <a:hlinkClick r:id="rId40"/>
-              </a:rPr>
-              <a:t>Lofar 1</a:t>
-            </a:r>
-          </a:p>
-          <a:p>
-            <a:r>
-              <a:rPr sz="800">
-                <a:hlinkClick r:id="rId41"/>
-              </a:rPr>
-              <a:t>Lofar 2</a:t>
-            </a:r>
-          </a:p>
-          <a:p>
-            <a:r>
-              <a:rPr sz="800">
-                <a:hlinkClick r:id="rId42"/>
-              </a:rPr>
-              <a:t>Lofar 3</a:t>
-            </a:r>
-          </a:p>
-          <a:p>
-            <a:r>
-              <a:rPr sz="800">
-                <a:hlinkClick r:id="rId43"/>
-              </a:rPr>
-              <a:t>Lofar 4</a:t>
-            </a:r>
-          </a:p>
-        </p:txBody>
-      </p:sp>
-      <p:sp>
-        <p:nvSpPr>
-          <p:cNvPr id="27" name="Rounded Rectangle 26">
-            <a:hlinkClick r:id="rId44"/>
-          </p:cNvPr>
-          <p:cNvSpPr/>
-          <p:nvPr/>
-        </p:nvSpPr>
-        <p:spPr>
-          <a:xfrm>
-            <a:off x="4948732" y="4632960"/>
-            <a:ext cx="2200046" cy="365760"/>
-          </a:xfrm>
-          <a:prstGeom prst="roundRect">
-            <a:avLst/>
-          </a:prstGeom>
-          <a:solidFill>
-            <a:srgbClr val="E8EEF7"/>
-          </a:solidFill>
-          <a:ln>
-            <a:solidFill>
-              <a:srgbClr val="1F3A5F"/>
-            </a:solidFill>
-          </a:ln>
-        </p:spPr>
-        <p:style>
-          <a:lnRef idx="1">
-            <a:schemeClr val="accent1"/>
-          </a:lnRef>
-          <a:fillRef idx="3">
-            <a:schemeClr val="accent1"/>
-          </a:fillRef>
-          <a:effectRef idx="2">
-            <a:schemeClr val="accent1"/>
-          </a:effectRef>
-          <a:fontRef idx="minor">
-            <a:schemeClr val="lt1"/>
-          </a:fontRef>
-        </p:style>
-        <p:txBody>
-          <a:bodyPr rtlCol="0" anchor="ctr" lIns="45720" rIns="45720"/>
-          <a:lstStyle/>
-          <a:p>
-            <a:pPr algn="ctr"/>
-            <a:r>
-              <a:rPr sz="900">
-                <a:solidFill>
-                  <a:srgbClr val="1F3A5F"/>
-                </a:solidFill>
-              </a:rPr>
-              <a:t>Gram 15: FR Voyager, Category 1, Gandalf</a:t>
-            </a:r>
-          </a:p>
-        </p:txBody>
-      </p:sp>
-      <p:sp>
-        <p:nvSpPr>
-          <p:cNvPr id="28" name="TextBox 27"/>
-          <p:cNvSpPr txBox="1"/>
-          <p:nvPr/>
-        </p:nvSpPr>
-        <p:spPr>
-          <a:xfrm>
-            <a:off x="4948732" y="5017008"/>
-            <a:ext cx="2200046" cy="1447800"/>
-          </a:xfrm>
-          <a:prstGeom prst="rect">
-            <a:avLst/>
-          </a:prstGeom>
-          <a:noFill/>
-        </p:spPr>
-        <p:txBody>
-          <a:bodyPr wrap="square">
-            <a:spAutoFit/>
-          </a:bodyPr>
-          <a:lstStyle/>
-          <a:p>
-            <a:r>
-              <a:rPr sz="800">
-                <a:hlinkClick r:id="rId45"/>
-              </a:rPr>
-              <a:t>Lofar 1</a:t>
-            </a:r>
-          </a:p>
-          <a:p>
-            <a:r>
-              <a:rPr sz="800">
-                <a:hlinkClick r:id="rId46"/>
-              </a:rPr>
-              <a:t>Lofar 2</a:t>
-            </a:r>
-          </a:p>
-        </p:txBody>
-      </p:sp>
-      <p:sp>
-        <p:nvSpPr>
-          <p:cNvPr id="29" name="Rounded Rectangle 28">
-            <a:hlinkClick r:id="rId47"/>
-          </p:cNvPr>
-          <p:cNvSpPr/>
-          <p:nvPr/>
-        </p:nvSpPr>
-        <p:spPr>
-          <a:xfrm>
-            <a:off x="7240219" y="4632960"/>
-            <a:ext cx="2200046" cy="365760"/>
-          </a:xfrm>
-          <a:prstGeom prst="roundRect">
-            <a:avLst/>
-          </a:prstGeom>
-          <a:solidFill>
-            <a:srgbClr val="E8EEF7"/>
-          </a:solidFill>
-          <a:ln>
-            <a:solidFill>
-              <a:srgbClr val="1F3A5F"/>
-            </a:solidFill>
-          </a:ln>
-        </p:spPr>
-        <p:style>
-          <a:lnRef idx="1">
-            <a:schemeClr val="accent1"/>
-          </a:lnRef>
-          <a:fillRef idx="3">
-            <a:schemeClr val="accent1"/>
-          </a:fillRef>
-          <a:effectRef idx="2">
-            <a:schemeClr val="accent1"/>
-          </a:effectRef>
-          <a:fontRef idx="minor">
-            <a:schemeClr val="lt1"/>
-          </a:fontRef>
-        </p:style>
-        <p:txBody>
-          <a:bodyPr rtlCol="0" anchor="ctr" lIns="45720" rIns="45720"/>
-          <a:lstStyle/>
-          <a:p>
-            <a:pPr algn="ctr"/>
-            <a:r>
-              <a:rPr sz="900">
-                <a:solidFill>
-                  <a:srgbClr val="1F3A5F"/>
-                </a:solidFill>
-              </a:rPr>
-              <a:t>Gram 16: FR Intrepid-class, Category 2, Tatooine</a:t>
-            </a:r>
-          </a:p>
-        </p:txBody>
-      </p:sp>
-      <p:sp>
-        <p:nvSpPr>
-          <p:cNvPr id="30" name="TextBox 29"/>
-          <p:cNvSpPr txBox="1"/>
-          <p:nvPr/>
-        </p:nvSpPr>
-        <p:spPr>
-          <a:xfrm>
-            <a:off x="7240219" y="5017008"/>
-            <a:ext cx="2200046" cy="1447800"/>
-          </a:xfrm>
-          <a:prstGeom prst="rect">
-            <a:avLst/>
-          </a:prstGeom>
-          <a:noFill/>
-        </p:spPr>
-        <p:txBody>
-          <a:bodyPr wrap="square">
-            <a:spAutoFit/>
-          </a:bodyPr>
-          <a:lstStyle/>
-          <a:p>
-            <a:r>
-              <a:rPr sz="800">
-                <a:hlinkClick r:id="rId48"/>
-              </a:rPr>
-              <a:t>Lofar 1</a:t>
-            </a:r>
-          </a:p>
-          <a:p>
-            <a:r>
-              <a:rPr sz="800">
-                <a:hlinkClick r:id="rId49"/>
-              </a:rPr>
-              <a:t>Lofar 2</a:t>
-            </a:r>
-          </a:p>
-          <a:p>
-            <a:r>
-              <a:rPr sz="800">
-                <a:hlinkClick r:id="rId50"/>
-              </a:rPr>
-              <a:t>Lofar 3</a:t>
-            </a:r>
-          </a:p>
-        </p:txBody>
-      </p:sp>
-      <p:sp>
-        <p:nvSpPr>
-          <p:cNvPr id="31" name="Rounded Rectangle 30">
-            <a:hlinkClick r:id="rId51"/>
-          </p:cNvPr>
-          <p:cNvSpPr/>
-          <p:nvPr/>
-        </p:nvSpPr>
-        <p:spPr>
-          <a:xfrm>
-            <a:off x="9531705" y="4632960"/>
-            <a:ext cx="2200046" cy="365760"/>
-          </a:xfrm>
-          <a:prstGeom prst="roundRect">
-            <a:avLst/>
-          </a:prstGeom>
-          <a:solidFill>
-            <a:srgbClr val="E8EEF7"/>
-          </a:solidFill>
-          <a:ln>
-            <a:solidFill>
-              <a:srgbClr val="1F3A5F"/>
-            </a:solidFill>
-          </a:ln>
-        </p:spPr>
-        <p:style>
-          <a:lnRef idx="1">
-            <a:schemeClr val="accent1"/>
-          </a:lnRef>
-          <a:fillRef idx="3">
-            <a:schemeClr val="accent1"/>
-          </a:fillRef>
-          <a:effectRef idx="2">
-            <a:schemeClr val="accent1"/>
-          </a:effectRef>
-          <a:fontRef idx="minor">
-            <a:schemeClr val="lt1"/>
-          </a:fontRef>
-        </p:style>
-        <p:txBody>
-          <a:bodyPr rtlCol="0" anchor="ctr" lIns="45720" rIns="45720"/>
-          <a:lstStyle/>
-          <a:p>
-            <a:pPr algn="ctr"/>
-            <a:r>
-              <a:rPr sz="900">
-                <a:solidFill>
-                  <a:srgbClr val="1F3A5F"/>
-                </a:solidFill>
-              </a:rPr>
-              <a:t>Gram 18: FR B-wing, Category 3, Mustafar</a:t>
-            </a:r>
-          </a:p>
-        </p:txBody>
-      </p:sp>
-      <p:sp>
-        <p:nvSpPr>
-          <p:cNvPr id="32" name="TextBox 31"/>
-          <p:cNvSpPr txBox="1"/>
-          <p:nvPr/>
-        </p:nvSpPr>
-        <p:spPr>
-          <a:xfrm>
-            <a:off x="9531705" y="5017008"/>
-            <a:ext cx="2200046" cy="1447800"/>
-          </a:xfrm>
-          <a:prstGeom prst="rect">
-            <a:avLst/>
-          </a:prstGeom>
-          <a:noFill/>
-        </p:spPr>
-        <p:txBody>
-          <a:bodyPr wrap="square">
-            <a:spAutoFit/>
-          </a:bodyPr>
-          <a:lstStyle/>
-          <a:p>
-            <a:r>
-              <a:rPr sz="800">
-                <a:hlinkClick r:id="rId52"/>
-              </a:rPr>
-              <a:t>Lofar 1</a:t>
-            </a:r>
-          </a:p>
-          <a:p>
-            <a:r>
-              <a:rPr sz="800">
-                <a:hlinkClick r:id="rId53"/>
-              </a:rPr>
-              <a:t>Lofar 2</a:t>
-            </a:r>
-          </a:p>
-          <a:p>
-            <a:r>
-              <a:rPr sz="800">
-                <a:hlinkClick r:id="rId54"/>
-              </a:rPr>
-              <a:t>Lofar 3</a:t>
-            </a:r>
-          </a:p>
-          <a:p>
-            <a:r>
-              <a:rPr sz="800">
-                <a:hlinkClick r:id="rId55"/>
-              </a:rPr>
-              <a:t>Lofar 4</a:t>
+              <a:t>Instructor Version</a:t>
             </a:r>
           </a:p>
         </p:txBody>
@@ -4687,7 +3224,7 @@
                   <a:srgbClr val="FFFFFF"/>
                 </a:solidFill>
               </a:rPr>
-              <a:t>Instructor Progress Final Assessment Grams — Page 2 of 3</a:t>
+              <a:t>Instructor Progress Final Assessment Grams — Page 1 of 3</a:t>
             </a:r>
           </a:p>
         </p:txBody>
@@ -4742,7 +3279,7 @@
                   <a:srgbClr val="1F3A5F"/>
                 </a:solidFill>
               </a:rPr>
-              <a:t>Gram 19: FR X-wing, Category 3, Dagobah</a:t>
+              <a:t>Gram 1: FR TIE Bomber, Category 3, Tatooine</a:t>
             </a:r>
           </a:p>
         </p:txBody>
@@ -4776,20 +3313,12 @@
               <a:t>Lofar 1</a:t>
             </a:r>
           </a:p>
-          <a:p>
-            <a:r>
-              <a:rPr sz="800">
-                <a:hlinkClick r:id="rId4"/>
-              </a:rPr>
-              <a:t>Lofar 2</a:t>
-            </a:r>
-          </a:p>
         </p:txBody>
       </p:sp>
       <p:sp>
         <p:nvSpPr>
           <p:cNvPr id="5" name="Rounded Rectangle 4">
-            <a:hlinkClick r:id="rId5"/>
+            <a:hlinkClick r:id="rId4"/>
           </p:cNvPr>
           <p:cNvSpPr/>
           <p:nvPr/>
@@ -4836,7 +3365,7 @@
                   <a:srgbClr val="1F3A5F"/>
                 </a:solidFill>
               </a:rPr>
-              <a:t>Gram 22: FR Razor Crest, Category 4, Dank</a:t>
+              <a:t>Gram 2: FR Sovereign-class, Category 1, Tatooine</a:t>
             </a:r>
           </a:p>
         </p:txBody>
@@ -4865,9 +3394,25 @@
           <a:p>
             <a:r>
               <a:rPr sz="800">
+                <a:hlinkClick r:id="rId5"/>
+              </a:rPr>
+              <a:t>Lofar 1</a:t>
+            </a:r>
+          </a:p>
+          <a:p>
+            <a:r>
+              <a:rPr sz="800">
                 <a:hlinkClick r:id="rId6"/>
               </a:rPr>
-              <a:t>Lofar 1</a:t>
+              <a:t>Lofar 2</a:t>
+            </a:r>
+          </a:p>
+          <a:p>
+            <a:r>
+              <a:rPr sz="800">
+                <a:hlinkClick r:id="rId7"/>
+              </a:rPr>
+              <a:t>Lofar 3</a:t>
             </a:r>
           </a:p>
         </p:txBody>
@@ -4875,7 +3420,7 @@
       <p:sp>
         <p:nvSpPr>
           <p:cNvPr id="7" name="Rounded Rectangle 6">
-            <a:hlinkClick r:id="rId7"/>
+            <a:hlinkClick r:id="rId8"/>
           </p:cNvPr>
           <p:cNvSpPr/>
           <p:nvPr/>
@@ -4922,7 +3467,7 @@
                   <a:srgbClr val="1F3A5F"/>
                 </a:solidFill>
               </a:rPr>
-              <a:t>Gram 23: FR Outrider, Category 3, Cardassia</a:t>
+              <a:t>Gram 3: FR TIE Fighter, Category 4, Mustafar</a:t>
             </a:r>
           </a:p>
         </p:txBody>
@@ -4951,7 +3496,7 @@
           <a:p>
             <a:r>
               <a:rPr sz="800">
-                <a:hlinkClick r:id="rId8"/>
+                <a:hlinkClick r:id="rId9"/>
               </a:rPr>
               <a:t>Lofar 1</a:t>
             </a:r>
@@ -4959,7 +3504,7 @@
           <a:p>
             <a:r>
               <a:rPr sz="800">
-                <a:hlinkClick r:id="rId9"/>
+                <a:hlinkClick r:id="rId10"/>
               </a:rPr>
               <a:t>Lofar 2</a:t>
             </a:r>
@@ -4967,7 +3512,7 @@
           <a:p>
             <a:r>
               <a:rPr sz="800">
-                <a:hlinkClick r:id="rId10"/>
+                <a:hlinkClick r:id="rId11"/>
               </a:rPr>
               <a:t>Lofar 3</a:t>
             </a:r>
@@ -4977,7 +3522,7 @@
       <p:sp>
         <p:nvSpPr>
           <p:cNvPr id="9" name="Rounded Rectangle 8">
-            <a:hlinkClick r:id="rId11"/>
+            <a:hlinkClick r:id="rId12"/>
           </p:cNvPr>
           <p:cNvSpPr/>
           <p:nvPr/>
@@ -5024,7 +3569,7 @@
                   <a:srgbClr val="1F3A5F"/>
                 </a:solidFill>
               </a:rPr>
-              <a:t>Gram 25: FR Ghost, Category 3, Trill</a:t>
+              <a:t>Gram 4: FR Intrepid-class, Category 4, Mustafar</a:t>
             </a:r>
           </a:p>
         </p:txBody>
@@ -5053,7 +3598,7 @@
           <a:p>
             <a:r>
               <a:rPr sz="800">
-                <a:hlinkClick r:id="rId12"/>
+                <a:hlinkClick r:id="rId13"/>
               </a:rPr>
               <a:t>Lofar 1</a:t>
             </a:r>
@@ -5061,7 +3606,7 @@
           <a:p>
             <a:r>
               <a:rPr sz="800">
-                <a:hlinkClick r:id="rId13"/>
+                <a:hlinkClick r:id="rId14"/>
               </a:rPr>
               <a:t>Lofar 2</a:t>
             </a:r>
@@ -5069,7 +3614,7 @@
           <a:p>
             <a:r>
               <a:rPr sz="800">
-                <a:hlinkClick r:id="rId14"/>
+                <a:hlinkClick r:id="rId15"/>
               </a:rPr>
               <a:t>Lofar 3</a:t>
             </a:r>
@@ -5079,7 +3624,7 @@
       <p:sp>
         <p:nvSpPr>
           <p:cNvPr id="11" name="Rounded Rectangle 10">
-            <a:hlinkClick r:id="rId15"/>
+            <a:hlinkClick r:id="rId16"/>
           </p:cNvPr>
           <p:cNvSpPr/>
           <p:nvPr/>
@@ -5126,7 +3671,7 @@
                   <a:srgbClr val="1F3A5F"/>
                 </a:solidFill>
               </a:rPr>
-              <a:t>Gram 26: FR Ghost, Category 1, Trill</a:t>
+              <a:t>Gram 7: FR Discovery, Category 1, Dagobah</a:t>
             </a:r>
           </a:p>
         </p:txBody>
@@ -5155,7 +3700,7 @@
           <a:p>
             <a:r>
               <a:rPr sz="800">
-                <a:hlinkClick r:id="rId16"/>
+                <a:hlinkClick r:id="rId17"/>
               </a:rPr>
               <a:t>Lofar 1</a:t>
             </a:r>
@@ -5165,7 +3710,7 @@
       <p:sp>
         <p:nvSpPr>
           <p:cNvPr id="13" name="Rounded Rectangle 12">
-            <a:hlinkClick r:id="rId17"/>
+            <a:hlinkClick r:id="rId18"/>
           </p:cNvPr>
           <p:cNvSpPr/>
           <p:nvPr/>
@@ -5212,7 +3757,7 @@
                   <a:srgbClr val="1F3A5F"/>
                 </a:solidFill>
               </a:rPr>
-              <a:t>Gram 27: Cerritos contact bearing 270, codename Vulcan</a:t>
+              <a:t>Gram 8: Miranda-class contact bearing 288, codename Dank</a:t>
             </a:r>
           </a:p>
         </p:txBody>
@@ -5241,7 +3786,7 @@
           <a:p>
             <a:r>
               <a:rPr sz="800">
-                <a:hlinkClick r:id="rId18"/>
+                <a:hlinkClick r:id="rId19"/>
               </a:rPr>
               <a:t>Lofar 1</a:t>
             </a:r>
@@ -5249,7 +3794,7 @@
           <a:p>
             <a:r>
               <a:rPr sz="800">
-                <a:hlinkClick r:id="rId19"/>
+                <a:hlinkClick r:id="rId20"/>
               </a:rPr>
               <a:t>Lofar 2</a:t>
             </a:r>
@@ -5257,17 +3802,25 @@
           <a:p>
             <a:r>
               <a:rPr sz="800">
-                <a:hlinkClick r:id="rId20"/>
+                <a:hlinkClick r:id="rId21"/>
               </a:rPr>
               <a:t>Lofar 3</a:t>
             </a:r>
           </a:p>
+          <a:p>
+            <a:r>
+              <a:rPr sz="800">
+                <a:hlinkClick r:id="rId22"/>
+              </a:rPr>
+              <a:t>Lofar 4</a:t>
+            </a:r>
+          </a:p>
         </p:txBody>
       </p:sp>
       <p:sp>
         <p:nvSpPr>
           <p:cNvPr id="15" name="Rounded Rectangle 14">
-            <a:hlinkClick r:id="rId21"/>
+            <a:hlinkClick r:id="rId23"/>
           </p:cNvPr>
           <p:cNvSpPr/>
           <p:nvPr/>
@@ -5314,7 +3867,7 @@
                   <a:srgbClr val="1F3A5F"/>
                 </a:solidFill>
               </a:rPr>
-              <a:t>Gram 28: Defiant contact bearing 357, codename Vulcan</a:t>
+              <a:t>Gram 9: Enterprise contact bearing 084, codename Yavin</a:t>
             </a:r>
           </a:p>
         </p:txBody>
@@ -5343,7 +3896,7 @@
           <a:p>
             <a:r>
               <a:rPr sz="800">
-                <a:hlinkClick r:id="rId22"/>
+                <a:hlinkClick r:id="rId24"/>
               </a:rPr>
               <a:t>Lofar 1</a:t>
             </a:r>
@@ -5351,7 +3904,7 @@
           <a:p>
             <a:r>
               <a:rPr sz="800">
-                <a:hlinkClick r:id="rId23"/>
+                <a:hlinkClick r:id="rId25"/>
               </a:rPr>
               <a:t>Lofar 2</a:t>
             </a:r>
@@ -5361,7 +3914,7 @@
       <p:sp>
         <p:nvSpPr>
           <p:cNvPr id="17" name="Rounded Rectangle 16">
-            <a:hlinkClick r:id="rId24"/>
+            <a:hlinkClick r:id="rId26"/>
           </p:cNvPr>
           <p:cNvSpPr/>
           <p:nvPr/>
@@ -5408,7 +3961,7 @@
                   <a:srgbClr val="1F3A5F"/>
                 </a:solidFill>
               </a:rPr>
-              <a:t>Gram 29: Imperial-class contact bearing 080, codename Gandalf</a:t>
+              <a:t>Gram 10: FR A-wing, Category 3, Risa</a:t>
             </a:r>
           </a:p>
         </p:txBody>
@@ -5437,7 +3990,7 @@
           <a:p>
             <a:r>
               <a:rPr sz="800">
-                <a:hlinkClick r:id="rId25"/>
+                <a:hlinkClick r:id="rId27"/>
               </a:rPr>
               <a:t>Lofar 1</a:t>
             </a:r>
@@ -5447,7 +4000,7 @@
       <p:sp>
         <p:nvSpPr>
           <p:cNvPr id="19" name="Rounded Rectangle 18">
-            <a:hlinkClick r:id="rId26"/>
+            <a:hlinkClick r:id="rId28"/>
           </p:cNvPr>
           <p:cNvSpPr/>
           <p:nvPr/>
@@ -5494,7 +4047,7 @@
                   <a:srgbClr val="1F3A5F"/>
                 </a:solidFill>
               </a:rPr>
-              <a:t>Gram 30: Excelsior contact bearing 009, codename Cardassia</a:t>
+              <a:t>Gram 11: FR Star Destroyer, Category 1, Vulcan</a:t>
             </a:r>
           </a:p>
         </p:txBody>
@@ -5523,7 +4076,7 @@
           <a:p>
             <a:r>
               <a:rPr sz="800">
-                <a:hlinkClick r:id="rId27"/>
+                <a:hlinkClick r:id="rId29"/>
               </a:rPr>
               <a:t>Lofar 1</a:t>
             </a:r>
@@ -5533,7 +4086,7 @@
       <p:sp>
         <p:nvSpPr>
           <p:cNvPr id="21" name="Rounded Rectangle 20">
-            <a:hlinkClick r:id="rId28"/>
+            <a:hlinkClick r:id="rId30"/>
           </p:cNvPr>
           <p:cNvSpPr/>
           <p:nvPr/>
@@ -5580,7 +4133,7 @@
                   <a:srgbClr val="1F3A5F"/>
                 </a:solidFill>
               </a:rPr>
-              <a:t>Gram 31: FR Rebel One, Category 1, Endor</a:t>
+              <a:t>Gram 12: Venator-class contact bearing 330, codename Dank</a:t>
             </a:r>
           </a:p>
         </p:txBody>
@@ -5609,7 +4162,7 @@
           <a:p>
             <a:r>
               <a:rPr sz="800">
-                <a:hlinkClick r:id="rId29"/>
+                <a:hlinkClick r:id="rId31"/>
               </a:rPr>
               <a:t>Lofar 1</a:t>
             </a:r>
@@ -5617,7 +4170,7 @@
           <a:p>
             <a:r>
               <a:rPr sz="800">
-                <a:hlinkClick r:id="rId30"/>
+                <a:hlinkClick r:id="rId32"/>
               </a:rPr>
               <a:t>Lofar 2</a:t>
             </a:r>
@@ -5625,7 +4178,7 @@
           <a:p>
             <a:r>
               <a:rPr sz="800">
-                <a:hlinkClick r:id="rId31"/>
+                <a:hlinkClick r:id="rId33"/>
               </a:rPr>
               <a:t>Lofar 3</a:t>
             </a:r>
@@ -5633,7 +4186,7 @@
           <a:p>
             <a:r>
               <a:rPr sz="800">
-                <a:hlinkClick r:id="rId32"/>
+                <a:hlinkClick r:id="rId34"/>
               </a:rPr>
               <a:t>Lofar 4</a:t>
             </a:r>
@@ -5643,7 +4196,7 @@
       <p:sp>
         <p:nvSpPr>
           <p:cNvPr id="23" name="Rounded Rectangle 22">
-            <a:hlinkClick r:id="rId33"/>
+            <a:hlinkClick r:id="rId35"/>
           </p:cNvPr>
           <p:cNvSpPr/>
           <p:nvPr/>
@@ -5690,7 +4243,7 @@
                   <a:srgbClr val="1F3A5F"/>
                 </a:solidFill>
               </a:rPr>
-              <a:t>Gram 33: FR Galaxy-class, Category 2, Mustafar</a:t>
+              <a:t>Gram 13: FR Outrider, Category 1, Coruscant</a:t>
             </a:r>
           </a:p>
         </p:txBody>
@@ -5719,7 +4272,7 @@
           <a:p>
             <a:r>
               <a:rPr sz="800">
-                <a:hlinkClick r:id="rId34"/>
+                <a:hlinkClick r:id="rId36"/>
               </a:rPr>
               <a:t>Lofar 1</a:t>
             </a:r>
@@ -5727,7 +4280,7 @@
           <a:p>
             <a:r>
               <a:rPr sz="800">
-                <a:hlinkClick r:id="rId35"/>
+                <a:hlinkClick r:id="rId37"/>
               </a:rPr>
               <a:t>Lofar 2</a:t>
             </a:r>
@@ -5735,7 +4288,7 @@
           <a:p>
             <a:r>
               <a:rPr sz="800">
-                <a:hlinkClick r:id="rId36"/>
+                <a:hlinkClick r:id="rId38"/>
               </a:rPr>
               <a:t>Lofar 3</a:t>
             </a:r>
@@ -5745,7 +4298,7 @@
       <p:sp>
         <p:nvSpPr>
           <p:cNvPr id="25" name="Rounded Rectangle 24">
-            <a:hlinkClick r:id="rId37"/>
+            <a:hlinkClick r:id="rId39"/>
           </p:cNvPr>
           <p:cNvSpPr/>
           <p:nvPr/>
@@ -5792,7 +4345,7 @@
                   <a:srgbClr val="1F3A5F"/>
                 </a:solidFill>
               </a:rPr>
-              <a:t>Gram 34: Reliant contact bearing 192, codename Romulus</a:t>
+              <a:t>Gram 14: Cerritos contact bearing 210, codename Betazed</a:t>
             </a:r>
           </a:p>
         </p:txBody>
@@ -5821,7 +4374,7 @@
           <a:p>
             <a:r>
               <a:rPr sz="800">
-                <a:hlinkClick r:id="rId38"/>
+                <a:hlinkClick r:id="rId40"/>
               </a:rPr>
               <a:t>Lofar 1</a:t>
             </a:r>
@@ -5829,7 +4382,7 @@
           <a:p>
             <a:r>
               <a:rPr sz="800">
-                <a:hlinkClick r:id="rId39"/>
+                <a:hlinkClick r:id="rId41"/>
               </a:rPr>
               <a:t>Lofar 2</a:t>
             </a:r>
@@ -5837,17 +4390,25 @@
           <a:p>
             <a:r>
               <a:rPr sz="800">
-                <a:hlinkClick r:id="rId40"/>
+                <a:hlinkClick r:id="rId42"/>
               </a:rPr>
               <a:t>Lofar 3</a:t>
             </a:r>
           </a:p>
+          <a:p>
+            <a:r>
+              <a:rPr sz="800">
+                <a:hlinkClick r:id="rId43"/>
+              </a:rPr>
+              <a:t>Lofar 4</a:t>
+            </a:r>
+          </a:p>
         </p:txBody>
       </p:sp>
       <p:sp>
         <p:nvSpPr>
           <p:cNvPr id="27" name="Rounded Rectangle 26">
-            <a:hlinkClick r:id="rId41"/>
+            <a:hlinkClick r:id="rId44"/>
           </p:cNvPr>
           <p:cNvSpPr/>
           <p:nvPr/>
@@ -5894,7 +4455,7 @@
                   <a:srgbClr val="1F3A5F"/>
                 </a:solidFill>
               </a:rPr>
-              <a:t>Gram 35: FR Imperial-class, Category 2, Bajor</a:t>
+              <a:t>Gram 15: FR Voyager, Category 1, Gandalf</a:t>
             </a:r>
           </a:p>
         </p:txBody>
@@ -5923,7 +4484,7 @@
           <a:p>
             <a:r>
               <a:rPr sz="800">
-                <a:hlinkClick r:id="rId42"/>
+                <a:hlinkClick r:id="rId45"/>
               </a:rPr>
               <a:t>Lofar 1</a:t>
             </a:r>
@@ -5931,33 +4492,17 @@
           <a:p>
             <a:r>
               <a:rPr sz="800">
-                <a:hlinkClick r:id="rId43"/>
+                <a:hlinkClick r:id="rId46"/>
               </a:rPr>
               <a:t>Lofar 2</a:t>
             </a:r>
           </a:p>
-          <a:p>
-            <a:r>
-              <a:rPr sz="800">
-                <a:hlinkClick r:id="rId44"/>
-              </a:rPr>
-              <a:t>Lofar 3</a:t>
-            </a:r>
-          </a:p>
-          <a:p>
-            <a:r>
-              <a:rPr sz="800">
-                <a:hlinkClick r:id="rId45"/>
-              </a:rPr>
-              <a:t>Lofar 4</a:t>
-            </a:r>
-          </a:p>
         </p:txBody>
       </p:sp>
       <p:sp>
         <p:nvSpPr>
           <p:cNvPr id="29" name="Rounded Rectangle 28">
-            <a:hlinkClick r:id="rId46"/>
+            <a:hlinkClick r:id="rId47"/>
           </p:cNvPr>
           <p:cNvSpPr/>
           <p:nvPr/>
@@ -6004,7 +4549,7 @@
                   <a:srgbClr val="1F3A5F"/>
                 </a:solidFill>
               </a:rPr>
-              <a:t>Gram 36: FR Venator-class, Category 4, Defiant</a:t>
+              <a:t>Gram 16: FR Intrepid-class, Category 2, Tatooine</a:t>
             </a:r>
           </a:p>
         </p:txBody>
@@ -6033,17 +4578,33 @@
           <a:p>
             <a:r>
               <a:rPr sz="800">
-                <a:hlinkClick r:id="rId47"/>
+                <a:hlinkClick r:id="rId48"/>
               </a:rPr>
               <a:t>Lofar 1</a:t>
             </a:r>
           </a:p>
+          <a:p>
+            <a:r>
+              <a:rPr sz="800">
+                <a:hlinkClick r:id="rId49"/>
+              </a:rPr>
+              <a:t>Lofar 2</a:t>
+            </a:r>
+          </a:p>
+          <a:p>
+            <a:r>
+              <a:rPr sz="800">
+                <a:hlinkClick r:id="rId50"/>
+              </a:rPr>
+              <a:t>Lofar 3</a:t>
+            </a:r>
+          </a:p>
         </p:txBody>
       </p:sp>
       <p:sp>
         <p:nvSpPr>
           <p:cNvPr id="31" name="Rounded Rectangle 30">
-            <a:hlinkClick r:id="rId48"/>
+            <a:hlinkClick r:id="rId51"/>
           </p:cNvPr>
           <p:cNvSpPr/>
           <p:nvPr/>
@@ -6090,7 +4651,7 @@
                   <a:srgbClr val="1F3A5F"/>
                 </a:solidFill>
               </a:rPr>
-              <a:t>Gram 37: FR Devastator, Category 2, Tatooine</a:t>
+              <a:t>Gram 18: FR B-wing, Category 3, Mustafar</a:t>
             </a:r>
           </a:p>
         </p:txBody>
@@ -6119,9 +4680,33 @@
           <a:p>
             <a:r>
               <a:rPr sz="800">
-                <a:hlinkClick r:id="rId49"/>
+                <a:hlinkClick r:id="rId52"/>
               </a:rPr>
               <a:t>Lofar 1</a:t>
+            </a:r>
+          </a:p>
+          <a:p>
+            <a:r>
+              <a:rPr sz="800">
+                <a:hlinkClick r:id="rId53"/>
+              </a:rPr>
+              <a:t>Lofar 2</a:t>
+            </a:r>
+          </a:p>
+          <a:p>
+            <a:r>
+              <a:rPr sz="800">
+                <a:hlinkClick r:id="rId54"/>
+              </a:rPr>
+              <a:t>Lofar 3</a:t>
+            </a:r>
+          </a:p>
+          <a:p>
+            <a:r>
+              <a:rPr sz="800">
+                <a:hlinkClick r:id="rId55"/>
+              </a:rPr>
+              <a:t>Lofar 4</a:t>
             </a:r>
           </a:p>
         </p:txBody>
@@ -6190,7 +4775,7 @@
                   <a:srgbClr val="FFFFFF"/>
                 </a:solidFill>
               </a:rPr>
-              <a:t>Instructor Progress Final Assessment Grams — Page 3 of 3</a:t>
+              <a:t>Instructor Progress Final Assessment Grams — Page 2 of 3</a:t>
             </a:r>
           </a:p>
         </p:txBody>
@@ -6245,7 +4830,7 @@
                   <a:srgbClr val="1F3A5F"/>
                 </a:solidFill>
               </a:rPr>
-              <a:t>Gram 38: FR Outrider, Category 3, Coruscant</a:t>
+              <a:t>Gram 19: FR X-wing, Category 3, Dagobah</a:t>
             </a:r>
           </a:p>
         </p:txBody>
@@ -6279,12 +4864,20 @@
               <a:t>Lofar 1</a:t>
             </a:r>
           </a:p>
+          <a:p>
+            <a:r>
+              <a:rPr sz="800">
+                <a:hlinkClick r:id="rId4"/>
+              </a:rPr>
+              <a:t>Lofar 2</a:t>
+            </a:r>
+          </a:p>
         </p:txBody>
       </p:sp>
       <p:sp>
         <p:nvSpPr>
           <p:cNvPr id="5" name="Rounded Rectangle 4">
-            <a:hlinkClick r:id="rId4"/>
+            <a:hlinkClick r:id="rId5"/>
           </p:cNvPr>
           <p:cNvSpPr/>
           <p:nvPr/>
@@ -6331,7 +4924,7 @@
                   <a:srgbClr val="1F3A5F"/>
                 </a:solidFill>
               </a:rPr>
-              <a:t>Gram 39: Galaxy-class contact bearing 083, codename Betazed</a:t>
+              <a:t>Gram 22: FR Razor Crest, Category 4, Dank</a:t>
             </a:r>
           </a:p>
         </p:txBody>
@@ -6360,33 +4953,17 @@
           <a:p>
             <a:r>
               <a:rPr sz="800">
-                <a:hlinkClick r:id="rId5"/>
+                <a:hlinkClick r:id="rId6"/>
               </a:rPr>
               <a:t>Lofar 1</a:t>
             </a:r>
           </a:p>
-          <a:p>
-            <a:r>
-              <a:rPr sz="800">
-                <a:hlinkClick r:id="rId6"/>
-              </a:rPr>
-              <a:t>Lofar 2</a:t>
-            </a:r>
-          </a:p>
-          <a:p>
-            <a:r>
-              <a:rPr sz="800">
-                <a:hlinkClick r:id="rId7"/>
-              </a:rPr>
-              <a:t>Lofar 3</a:t>
-            </a:r>
-          </a:p>
         </p:txBody>
       </p:sp>
       <p:sp>
         <p:nvSpPr>
           <p:cNvPr id="7" name="Rounded Rectangle 6">
-            <a:hlinkClick r:id="rId8"/>
+            <a:hlinkClick r:id="rId7"/>
           </p:cNvPr>
           <p:cNvSpPr/>
           <p:nvPr/>
@@ -6433,7 +5010,7 @@
                   <a:srgbClr val="1F3A5F"/>
                 </a:solidFill>
               </a:rPr>
-              <a:t>Gram 40: FR Corellian Corvette, Category 1, Tantive</a:t>
+              <a:t>Gram 23: FR Outrider, Category 3, Cardassia</a:t>
             </a:r>
           </a:p>
         </p:txBody>
@@ -6462,9 +5039,25 @@
           <a:p>
             <a:r>
               <a:rPr sz="800">
+                <a:hlinkClick r:id="rId8"/>
+              </a:rPr>
+              <a:t>Lofar 1</a:t>
+            </a:r>
+          </a:p>
+          <a:p>
+            <a:r>
+              <a:rPr sz="800">
                 <a:hlinkClick r:id="rId9"/>
               </a:rPr>
-              <a:t>Lofar 1</a:t>
+              <a:t>Lofar 2</a:t>
+            </a:r>
+          </a:p>
+          <a:p>
+            <a:r>
+              <a:rPr sz="800">
+                <a:hlinkClick r:id="rId10"/>
+              </a:rPr>
+              <a:t>Lofar 3</a:t>
             </a:r>
           </a:p>
         </p:txBody>
@@ -6472,7 +5065,7 @@
       <p:sp>
         <p:nvSpPr>
           <p:cNvPr id="9" name="Rounded Rectangle 8">
-            <a:hlinkClick r:id="rId10"/>
+            <a:hlinkClick r:id="rId11"/>
           </p:cNvPr>
           <p:cNvSpPr/>
           <p:nvPr/>
@@ -6519,7 +5112,7 @@
                   <a:srgbClr val="1F3A5F"/>
                 </a:solidFill>
               </a:rPr>
-              <a:t>Gram 41: FR Millennium Falcon, Category 1, Gandalf</a:t>
+              <a:t>Gram 25: FR Ghost, Category 3, Trill</a:t>
             </a:r>
           </a:p>
         </p:txBody>
@@ -6548,7 +5141,7 @@
           <a:p>
             <a:r>
               <a:rPr sz="800">
-                <a:hlinkClick r:id="rId11"/>
+                <a:hlinkClick r:id="rId12"/>
               </a:rPr>
               <a:t>Lofar 1</a:t>
             </a:r>
@@ -6556,17 +5149,25 @@
           <a:p>
             <a:r>
               <a:rPr sz="800">
-                <a:hlinkClick r:id="rId12"/>
+                <a:hlinkClick r:id="rId13"/>
               </a:rPr>
               <a:t>Lofar 2</a:t>
             </a:r>
           </a:p>
+          <a:p>
+            <a:r>
+              <a:rPr sz="800">
+                <a:hlinkClick r:id="rId14"/>
+              </a:rPr>
+              <a:t>Lofar 3</a:t>
+            </a:r>
+          </a:p>
         </p:txBody>
       </p:sp>
       <p:sp>
         <p:nvSpPr>
           <p:cNvPr id="11" name="Rounded Rectangle 10">
-            <a:hlinkClick r:id="rId13"/>
+            <a:hlinkClick r:id="rId15"/>
           </p:cNvPr>
           <p:cNvSpPr/>
           <p:nvPr/>
@@ -6613,7 +5214,7 @@
                   <a:srgbClr val="1F3A5F"/>
                 </a:solidFill>
               </a:rPr>
-              <a:t>Gram 42: FR Venator-class, Category 2, Yavin</a:t>
+              <a:t>Gram 26: FR Ghost, Category 1, Trill</a:t>
             </a:r>
           </a:p>
         </p:txBody>
@@ -6642,25 +5243,17 @@
           <a:p>
             <a:r>
               <a:rPr sz="800">
-                <a:hlinkClick r:id="rId14"/>
+                <a:hlinkClick r:id="rId16"/>
               </a:rPr>
               <a:t>Lofar 1</a:t>
             </a:r>
           </a:p>
-          <a:p>
-            <a:r>
-              <a:rPr sz="800">
-                <a:hlinkClick r:id="rId15"/>
-              </a:rPr>
-              <a:t>Lofar 2</a:t>
-            </a:r>
-          </a:p>
         </p:txBody>
       </p:sp>
       <p:sp>
         <p:nvSpPr>
           <p:cNvPr id="13" name="Rounded Rectangle 12">
-            <a:hlinkClick r:id="rId16"/>
+            <a:hlinkClick r:id="rId17"/>
           </p:cNvPr>
           <p:cNvSpPr/>
           <p:nvPr/>
@@ -6707,7 +5300,7 @@
                   <a:srgbClr val="1F3A5F"/>
                 </a:solidFill>
               </a:rPr>
-              <a:t>Gram 43: FR Excelsior, Category 4, Vulcan</a:t>
+              <a:t>Gram 27: Cerritos contact bearing 270, codename Vulcan</a:t>
             </a:r>
           </a:p>
         </p:txBody>
@@ -6736,7 +5329,7 @@
           <a:p>
             <a:r>
               <a:rPr sz="800">
-                <a:hlinkClick r:id="rId17"/>
+                <a:hlinkClick r:id="rId18"/>
               </a:rPr>
               <a:t>Lofar 1</a:t>
             </a:r>
@@ -6744,7 +5337,7 @@
           <a:p>
             <a:r>
               <a:rPr sz="800">
-                <a:hlinkClick r:id="rId18"/>
+                <a:hlinkClick r:id="rId19"/>
               </a:rPr>
               <a:t>Lofar 2</a:t>
             </a:r>
@@ -6752,17 +5345,9 @@
           <a:p>
             <a:r>
               <a:rPr sz="800">
-                <a:hlinkClick r:id="rId19"/>
+                <a:hlinkClick r:id="rId20"/>
               </a:rPr>
               <a:t>Lofar 3</a:t>
-            </a:r>
-          </a:p>
-          <a:p>
-            <a:r>
-              <a:rPr sz="800">
-                <a:hlinkClick r:id="rId20"/>
-              </a:rPr>
-              <a:t>Lofar 4</a:t>
             </a:r>
           </a:p>
         </p:txBody>
@@ -6817,7 +5402,7 @@
                   <a:srgbClr val="1F3A5F"/>
                 </a:solidFill>
               </a:rPr>
-              <a:t>Gram 44: B-wing contact bearing 024, codename Hoth</a:t>
+              <a:t>Gram 28: Defiant contact bearing 357, codename Vulcan</a:t>
             </a:r>
           </a:p>
         </p:txBody>
@@ -6859,28 +5444,12 @@
               <a:t>Lofar 2</a:t>
             </a:r>
           </a:p>
-          <a:p>
-            <a:r>
-              <a:rPr sz="800">
-                <a:hlinkClick r:id="rId24"/>
-              </a:rPr>
-              <a:t>Lofar 3</a:t>
-            </a:r>
-          </a:p>
-          <a:p>
-            <a:r>
-              <a:rPr sz="800">
-                <a:hlinkClick r:id="rId25"/>
-              </a:rPr>
-              <a:t>Lofar 4</a:t>
-            </a:r>
-          </a:p>
         </p:txBody>
       </p:sp>
       <p:sp>
         <p:nvSpPr>
           <p:cNvPr id="17" name="Rounded Rectangle 16">
-            <a:hlinkClick r:id="rId26"/>
+            <a:hlinkClick r:id="rId24"/>
           </p:cNvPr>
           <p:cNvSpPr/>
           <p:nvPr/>
@@ -6927,7 +5496,7 @@
                   <a:srgbClr val="1F3A5F"/>
                 </a:solidFill>
               </a:rPr>
-              <a:t>Gram 46: Stargazer contact bearing 059, codename Hoth</a:t>
+              <a:t>Gram 29: Imperial-class contact bearing 080, codename Gandalf</a:t>
             </a:r>
           </a:p>
         </p:txBody>
@@ -6956,25 +5525,17 @@
           <a:p>
             <a:r>
               <a:rPr sz="800">
-                <a:hlinkClick r:id="rId27"/>
+                <a:hlinkClick r:id="rId25"/>
               </a:rPr>
               <a:t>Lofar 1</a:t>
             </a:r>
           </a:p>
-          <a:p>
-            <a:r>
-              <a:rPr sz="800">
-                <a:hlinkClick r:id="rId28"/>
-              </a:rPr>
-              <a:t>Lofar 2</a:t>
-            </a:r>
-          </a:p>
         </p:txBody>
       </p:sp>
       <p:sp>
         <p:nvSpPr>
           <p:cNvPr id="19" name="Rounded Rectangle 18">
-            <a:hlinkClick r:id="rId29"/>
+            <a:hlinkClick r:id="rId26"/>
           </p:cNvPr>
           <p:cNvSpPr/>
           <p:nvPr/>
@@ -7021,7 +5582,7 @@
                   <a:srgbClr val="1F3A5F"/>
                 </a:solidFill>
               </a:rPr>
-              <a:t>Gram 47: FR Discovery, Category 4, Risa</a:t>
+              <a:t>Gram 30: Excelsior contact bearing 009, codename Cardassia</a:t>
             </a:r>
           </a:p>
         </p:txBody>
@@ -7050,7 +5611,7 @@
           <a:p>
             <a:r>
               <a:rPr sz="800">
-                <a:hlinkClick r:id="rId30"/>
+                <a:hlinkClick r:id="rId27"/>
               </a:rPr>
               <a:t>Lofar 1</a:t>
             </a:r>
@@ -7060,7 +5621,7 @@
       <p:sp>
         <p:nvSpPr>
           <p:cNvPr id="21" name="Rounded Rectangle 20">
-            <a:hlinkClick r:id="rId31"/>
+            <a:hlinkClick r:id="rId28"/>
           </p:cNvPr>
           <p:cNvSpPr/>
           <p:nvPr/>
@@ -7107,7 +5668,7 @@
                   <a:srgbClr val="1F3A5F"/>
                 </a:solidFill>
               </a:rPr>
-              <a:t>Gram 48: FR Discovery, Category 4, Kronos</a:t>
+              <a:t>Gram 31: FR Rebel One, Category 1, Endor</a:t>
             </a:r>
           </a:p>
         </p:txBody>
@@ -7136,17 +5697,1630 @@
           <a:p>
             <a:r>
               <a:rPr sz="800">
+                <a:hlinkClick r:id="rId29"/>
+              </a:rPr>
+              <a:t>Lofar 1</a:t>
+            </a:r>
+          </a:p>
+          <a:p>
+            <a:r>
+              <a:rPr sz="800">
+                <a:hlinkClick r:id="rId30"/>
+              </a:rPr>
+              <a:t>Lofar 2</a:t>
+            </a:r>
+          </a:p>
+          <a:p>
+            <a:r>
+              <a:rPr sz="800">
+                <a:hlinkClick r:id="rId31"/>
+              </a:rPr>
+              <a:t>Lofar 3</a:t>
+            </a:r>
+          </a:p>
+          <a:p>
+            <a:r>
+              <a:rPr sz="800">
                 <a:hlinkClick r:id="rId32"/>
               </a:rPr>
+              <a:t>Lofar 4</a:t>
+            </a:r>
+          </a:p>
+        </p:txBody>
+      </p:sp>
+      <p:sp>
+        <p:nvSpPr>
+          <p:cNvPr id="23" name="Rounded Rectangle 22">
+            <a:hlinkClick r:id="rId33"/>
+          </p:cNvPr>
+          <p:cNvSpPr/>
+          <p:nvPr/>
+        </p:nvSpPr>
+        <p:spPr>
+          <a:xfrm>
+            <a:off x="365760" y="4632960"/>
+            <a:ext cx="2200046" cy="365760"/>
+          </a:xfrm>
+          <a:prstGeom prst="roundRect">
+            <a:avLst/>
+          </a:prstGeom>
+          <a:solidFill>
+            <a:srgbClr val="E8EEF7"/>
+          </a:solidFill>
+          <a:ln>
+            <a:solidFill>
+              <a:srgbClr val="1F3A5F"/>
+            </a:solidFill>
+          </a:ln>
+        </p:spPr>
+        <p:style>
+          <a:lnRef idx="1">
+            <a:schemeClr val="accent1"/>
+          </a:lnRef>
+          <a:fillRef idx="3">
+            <a:schemeClr val="accent1"/>
+          </a:fillRef>
+          <a:effectRef idx="2">
+            <a:schemeClr val="accent1"/>
+          </a:effectRef>
+          <a:fontRef idx="minor">
+            <a:schemeClr val="lt1"/>
+          </a:fontRef>
+        </p:style>
+        <p:txBody>
+          <a:bodyPr rtlCol="0" anchor="ctr" lIns="45720" rIns="45720"/>
+          <a:lstStyle/>
+          <a:p>
+            <a:pPr algn="ctr"/>
+            <a:r>
+              <a:rPr sz="900">
+                <a:solidFill>
+                  <a:srgbClr val="1F3A5F"/>
+                </a:solidFill>
+              </a:rPr>
+              <a:t>Gram 33: FR Galaxy-class, Category 2, Mustafar</a:t>
+            </a:r>
+          </a:p>
+        </p:txBody>
+      </p:sp>
+      <p:sp>
+        <p:nvSpPr>
+          <p:cNvPr id="24" name="TextBox 23"/>
+          <p:cNvSpPr txBox="1"/>
+          <p:nvPr/>
+        </p:nvSpPr>
+        <p:spPr>
+          <a:xfrm>
+            <a:off x="365760" y="5017008"/>
+            <a:ext cx="2200046" cy="1447800"/>
+          </a:xfrm>
+          <a:prstGeom prst="rect">
+            <a:avLst/>
+          </a:prstGeom>
+          <a:noFill/>
+        </p:spPr>
+        <p:txBody>
+          <a:bodyPr wrap="square">
+            <a:spAutoFit/>
+          </a:bodyPr>
+          <a:lstStyle/>
+          <a:p>
+            <a:r>
+              <a:rPr sz="800">
+                <a:hlinkClick r:id="rId34"/>
+              </a:rPr>
               <a:t>Lofar 1</a:t>
             </a:r>
           </a:p>
           <a:p>
             <a:r>
               <a:rPr sz="800">
+                <a:hlinkClick r:id="rId35"/>
+              </a:rPr>
+              <a:t>Lofar 2</a:t>
+            </a:r>
+          </a:p>
+          <a:p>
+            <a:r>
+              <a:rPr sz="800">
+                <a:hlinkClick r:id="rId36"/>
+              </a:rPr>
+              <a:t>Lofar 3</a:t>
+            </a:r>
+          </a:p>
+        </p:txBody>
+      </p:sp>
+      <p:sp>
+        <p:nvSpPr>
+          <p:cNvPr id="25" name="Rounded Rectangle 24">
+            <a:hlinkClick r:id="rId37"/>
+          </p:cNvPr>
+          <p:cNvSpPr/>
+          <p:nvPr/>
+        </p:nvSpPr>
+        <p:spPr>
+          <a:xfrm>
+            <a:off x="2657246" y="4632960"/>
+            <a:ext cx="2200046" cy="365760"/>
+          </a:xfrm>
+          <a:prstGeom prst="roundRect">
+            <a:avLst/>
+          </a:prstGeom>
+          <a:solidFill>
+            <a:srgbClr val="E8EEF7"/>
+          </a:solidFill>
+          <a:ln>
+            <a:solidFill>
+              <a:srgbClr val="1F3A5F"/>
+            </a:solidFill>
+          </a:ln>
+        </p:spPr>
+        <p:style>
+          <a:lnRef idx="1">
+            <a:schemeClr val="accent1"/>
+          </a:lnRef>
+          <a:fillRef idx="3">
+            <a:schemeClr val="accent1"/>
+          </a:fillRef>
+          <a:effectRef idx="2">
+            <a:schemeClr val="accent1"/>
+          </a:effectRef>
+          <a:fontRef idx="minor">
+            <a:schemeClr val="lt1"/>
+          </a:fontRef>
+        </p:style>
+        <p:txBody>
+          <a:bodyPr rtlCol="0" anchor="ctr" lIns="45720" rIns="45720"/>
+          <a:lstStyle/>
+          <a:p>
+            <a:pPr algn="ctr"/>
+            <a:r>
+              <a:rPr sz="900">
+                <a:solidFill>
+                  <a:srgbClr val="1F3A5F"/>
+                </a:solidFill>
+              </a:rPr>
+              <a:t>Gram 34: Reliant contact bearing 192, codename Romulus</a:t>
+            </a:r>
+          </a:p>
+        </p:txBody>
+      </p:sp>
+      <p:sp>
+        <p:nvSpPr>
+          <p:cNvPr id="26" name="TextBox 25"/>
+          <p:cNvSpPr txBox="1"/>
+          <p:nvPr/>
+        </p:nvSpPr>
+        <p:spPr>
+          <a:xfrm>
+            <a:off x="2657246" y="5017008"/>
+            <a:ext cx="2200046" cy="1447800"/>
+          </a:xfrm>
+          <a:prstGeom prst="rect">
+            <a:avLst/>
+          </a:prstGeom>
+          <a:noFill/>
+        </p:spPr>
+        <p:txBody>
+          <a:bodyPr wrap="square">
+            <a:spAutoFit/>
+          </a:bodyPr>
+          <a:lstStyle/>
+          <a:p>
+            <a:r>
+              <a:rPr sz="800">
+                <a:hlinkClick r:id="rId38"/>
+              </a:rPr>
+              <a:t>Lofar 1</a:t>
+            </a:r>
+          </a:p>
+          <a:p>
+            <a:r>
+              <a:rPr sz="800">
+                <a:hlinkClick r:id="rId39"/>
+              </a:rPr>
+              <a:t>Lofar 2</a:t>
+            </a:r>
+          </a:p>
+          <a:p>
+            <a:r>
+              <a:rPr sz="800">
+                <a:hlinkClick r:id="rId40"/>
+              </a:rPr>
+              <a:t>Lofar 3</a:t>
+            </a:r>
+          </a:p>
+        </p:txBody>
+      </p:sp>
+      <p:sp>
+        <p:nvSpPr>
+          <p:cNvPr id="27" name="Rounded Rectangle 26">
+            <a:hlinkClick r:id="rId41"/>
+          </p:cNvPr>
+          <p:cNvSpPr/>
+          <p:nvPr/>
+        </p:nvSpPr>
+        <p:spPr>
+          <a:xfrm>
+            <a:off x="4948732" y="4632960"/>
+            <a:ext cx="2200046" cy="365760"/>
+          </a:xfrm>
+          <a:prstGeom prst="roundRect">
+            <a:avLst/>
+          </a:prstGeom>
+          <a:solidFill>
+            <a:srgbClr val="E8EEF7"/>
+          </a:solidFill>
+          <a:ln>
+            <a:solidFill>
+              <a:srgbClr val="1F3A5F"/>
+            </a:solidFill>
+          </a:ln>
+        </p:spPr>
+        <p:style>
+          <a:lnRef idx="1">
+            <a:schemeClr val="accent1"/>
+          </a:lnRef>
+          <a:fillRef idx="3">
+            <a:schemeClr val="accent1"/>
+          </a:fillRef>
+          <a:effectRef idx="2">
+            <a:schemeClr val="accent1"/>
+          </a:effectRef>
+          <a:fontRef idx="minor">
+            <a:schemeClr val="lt1"/>
+          </a:fontRef>
+        </p:style>
+        <p:txBody>
+          <a:bodyPr rtlCol="0" anchor="ctr" lIns="45720" rIns="45720"/>
+          <a:lstStyle/>
+          <a:p>
+            <a:pPr algn="ctr"/>
+            <a:r>
+              <a:rPr sz="900">
+                <a:solidFill>
+                  <a:srgbClr val="1F3A5F"/>
+                </a:solidFill>
+              </a:rPr>
+              <a:t>Gram 35: FR Imperial-class, Category 2, Bajor</a:t>
+            </a:r>
+          </a:p>
+        </p:txBody>
+      </p:sp>
+      <p:sp>
+        <p:nvSpPr>
+          <p:cNvPr id="28" name="TextBox 27"/>
+          <p:cNvSpPr txBox="1"/>
+          <p:nvPr/>
+        </p:nvSpPr>
+        <p:spPr>
+          <a:xfrm>
+            <a:off x="4948732" y="5017008"/>
+            <a:ext cx="2200046" cy="1447800"/>
+          </a:xfrm>
+          <a:prstGeom prst="rect">
+            <a:avLst/>
+          </a:prstGeom>
+          <a:noFill/>
+        </p:spPr>
+        <p:txBody>
+          <a:bodyPr wrap="square">
+            <a:spAutoFit/>
+          </a:bodyPr>
+          <a:lstStyle/>
+          <a:p>
+            <a:r>
+              <a:rPr sz="800">
+                <a:hlinkClick r:id="rId42"/>
+              </a:rPr>
+              <a:t>Lofar 1</a:t>
+            </a:r>
+          </a:p>
+          <a:p>
+            <a:r>
+              <a:rPr sz="800">
+                <a:hlinkClick r:id="rId43"/>
+              </a:rPr>
+              <a:t>Lofar 2</a:t>
+            </a:r>
+          </a:p>
+          <a:p>
+            <a:r>
+              <a:rPr sz="800">
+                <a:hlinkClick r:id="rId44"/>
+              </a:rPr>
+              <a:t>Lofar 3</a:t>
+            </a:r>
+          </a:p>
+          <a:p>
+            <a:r>
+              <a:rPr sz="800">
+                <a:hlinkClick r:id="rId45"/>
+              </a:rPr>
+              <a:t>Lofar 4</a:t>
+            </a:r>
+          </a:p>
+        </p:txBody>
+      </p:sp>
+      <p:sp>
+        <p:nvSpPr>
+          <p:cNvPr id="29" name="Rounded Rectangle 28">
+            <a:hlinkClick r:id="rId46"/>
+          </p:cNvPr>
+          <p:cNvSpPr/>
+          <p:nvPr/>
+        </p:nvSpPr>
+        <p:spPr>
+          <a:xfrm>
+            <a:off x="7240219" y="4632960"/>
+            <a:ext cx="2200046" cy="365760"/>
+          </a:xfrm>
+          <a:prstGeom prst="roundRect">
+            <a:avLst/>
+          </a:prstGeom>
+          <a:solidFill>
+            <a:srgbClr val="E8EEF7"/>
+          </a:solidFill>
+          <a:ln>
+            <a:solidFill>
+              <a:srgbClr val="1F3A5F"/>
+            </a:solidFill>
+          </a:ln>
+        </p:spPr>
+        <p:style>
+          <a:lnRef idx="1">
+            <a:schemeClr val="accent1"/>
+          </a:lnRef>
+          <a:fillRef idx="3">
+            <a:schemeClr val="accent1"/>
+          </a:fillRef>
+          <a:effectRef idx="2">
+            <a:schemeClr val="accent1"/>
+          </a:effectRef>
+          <a:fontRef idx="minor">
+            <a:schemeClr val="lt1"/>
+          </a:fontRef>
+        </p:style>
+        <p:txBody>
+          <a:bodyPr rtlCol="0" anchor="ctr" lIns="45720" rIns="45720"/>
+          <a:lstStyle/>
+          <a:p>
+            <a:pPr algn="ctr"/>
+            <a:r>
+              <a:rPr sz="900">
+                <a:solidFill>
+                  <a:srgbClr val="1F3A5F"/>
+                </a:solidFill>
+              </a:rPr>
+              <a:t>Gram 36: FR Venator-class, Category 4, Defiant</a:t>
+            </a:r>
+          </a:p>
+        </p:txBody>
+      </p:sp>
+      <p:sp>
+        <p:nvSpPr>
+          <p:cNvPr id="30" name="TextBox 29"/>
+          <p:cNvSpPr txBox="1"/>
+          <p:nvPr/>
+        </p:nvSpPr>
+        <p:spPr>
+          <a:xfrm>
+            <a:off x="7240219" y="5017008"/>
+            <a:ext cx="2200046" cy="1447800"/>
+          </a:xfrm>
+          <a:prstGeom prst="rect">
+            <a:avLst/>
+          </a:prstGeom>
+          <a:noFill/>
+        </p:spPr>
+        <p:txBody>
+          <a:bodyPr wrap="square">
+            <a:spAutoFit/>
+          </a:bodyPr>
+          <a:lstStyle/>
+          <a:p>
+            <a:r>
+              <a:rPr sz="800">
+                <a:hlinkClick r:id="rId47"/>
+              </a:rPr>
+              <a:t>Lofar 1</a:t>
+            </a:r>
+          </a:p>
+        </p:txBody>
+      </p:sp>
+      <p:sp>
+        <p:nvSpPr>
+          <p:cNvPr id="31" name="Rounded Rectangle 30">
+            <a:hlinkClick r:id="rId48"/>
+          </p:cNvPr>
+          <p:cNvSpPr/>
+          <p:nvPr/>
+        </p:nvSpPr>
+        <p:spPr>
+          <a:xfrm>
+            <a:off x="9531705" y="4632960"/>
+            <a:ext cx="2200046" cy="365760"/>
+          </a:xfrm>
+          <a:prstGeom prst="roundRect">
+            <a:avLst/>
+          </a:prstGeom>
+          <a:solidFill>
+            <a:srgbClr val="E8EEF7"/>
+          </a:solidFill>
+          <a:ln>
+            <a:solidFill>
+              <a:srgbClr val="1F3A5F"/>
+            </a:solidFill>
+          </a:ln>
+        </p:spPr>
+        <p:style>
+          <a:lnRef idx="1">
+            <a:schemeClr val="accent1"/>
+          </a:lnRef>
+          <a:fillRef idx="3">
+            <a:schemeClr val="accent1"/>
+          </a:fillRef>
+          <a:effectRef idx="2">
+            <a:schemeClr val="accent1"/>
+          </a:effectRef>
+          <a:fontRef idx="minor">
+            <a:schemeClr val="lt1"/>
+          </a:fontRef>
+        </p:style>
+        <p:txBody>
+          <a:bodyPr rtlCol="0" anchor="ctr" lIns="45720" rIns="45720"/>
+          <a:lstStyle/>
+          <a:p>
+            <a:pPr algn="ctr"/>
+            <a:r>
+              <a:rPr sz="900">
+                <a:solidFill>
+                  <a:srgbClr val="1F3A5F"/>
+                </a:solidFill>
+              </a:rPr>
+              <a:t>Gram 37: FR Devastator, Category 2, Tatooine</a:t>
+            </a:r>
+          </a:p>
+        </p:txBody>
+      </p:sp>
+      <p:sp>
+        <p:nvSpPr>
+          <p:cNvPr id="32" name="TextBox 31"/>
+          <p:cNvSpPr txBox="1"/>
+          <p:nvPr/>
+        </p:nvSpPr>
+        <p:spPr>
+          <a:xfrm>
+            <a:off x="9531705" y="5017008"/>
+            <a:ext cx="2200046" cy="1447800"/>
+          </a:xfrm>
+          <a:prstGeom prst="rect">
+            <a:avLst/>
+          </a:prstGeom>
+          <a:noFill/>
+        </p:spPr>
+        <p:txBody>
+          <a:bodyPr wrap="square">
+            <a:spAutoFit/>
+          </a:bodyPr>
+          <a:lstStyle/>
+          <a:p>
+            <a:r>
+              <a:rPr sz="800">
+                <a:hlinkClick r:id="rId49"/>
+              </a:rPr>
+              <a:t>Lofar 1</a:t>
+            </a:r>
+          </a:p>
+        </p:txBody>
+      </p:sp>
+    </p:spTree>
+  </p:cSld>
+  <p:clrMapOvr>
+    <a:masterClrMapping/>
+  </p:clrMapOvr>
+</p:sld>
+</file>
+
+<file path=ppt/slides/slide4.xml><?xml version="1.0" encoding="utf-8"?>
+<p:sld xmlns:a="http://schemas.openxmlformats.org/drawingml/2006/main" xmlns:p="http://schemas.openxmlformats.org/presentationml/2006/main" xmlns:r="http://schemas.openxmlformats.org/officeDocument/2006/relationships">
+  <p:cSld>
+    <p:spTree>
+      <p:nvGrpSpPr>
+        <p:cNvPr id="1" name=""/>
+        <p:cNvGrpSpPr/>
+        <p:nvPr/>
+      </p:nvGrpSpPr>
+      <p:grpSpPr/>
+      <p:sp>
+        <p:nvSpPr>
+          <p:cNvPr id="2" name="Rectangle 1"/>
+          <p:cNvSpPr/>
+          <p:nvPr/>
+        </p:nvSpPr>
+        <p:spPr>
+          <a:xfrm>
+            <a:off x="0" y="0"/>
+            <a:ext cx="12188952" cy="548640"/>
+          </a:xfrm>
+          <a:prstGeom prst="rect">
+            <a:avLst/>
+          </a:prstGeom>
+          <a:solidFill>
+            <a:srgbClr val="1F3A5F"/>
+          </a:solidFill>
+          <a:ln>
+            <a:noFill/>
+          </a:ln>
+        </p:spPr>
+        <p:style>
+          <a:lnRef idx="1">
+            <a:schemeClr val="accent1"/>
+          </a:lnRef>
+          <a:fillRef idx="3">
+            <a:schemeClr val="accent1"/>
+          </a:fillRef>
+          <a:effectRef idx="2">
+            <a:schemeClr val="accent1"/>
+          </a:effectRef>
+          <a:fontRef idx="minor">
+            <a:schemeClr val="lt1"/>
+          </a:fontRef>
+        </p:style>
+        <p:txBody>
+          <a:bodyPr rtlCol="0" anchor="ctr" lIns="182880" rIns="182880"/>
+          <a:lstStyle/>
+          <a:p>
+            <a:pPr algn="ctr"/>
+            <a:r>
+              <a:rPr sz="2000" b="1">
+                <a:solidFill>
+                  <a:srgbClr val="FFFFFF"/>
+                </a:solidFill>
+              </a:rPr>
+              <a:t>Instructor Progress Final Assessment Grams — Page 3 of 3</a:t>
+            </a:r>
+          </a:p>
+        </p:txBody>
+      </p:sp>
+      <p:sp>
+        <p:nvSpPr>
+          <p:cNvPr id="3" name="Rounded Rectangle 2">
+            <a:hlinkClick r:id="rId2"/>
+          </p:cNvPr>
+          <p:cNvSpPr/>
+          <p:nvPr/>
+        </p:nvSpPr>
+        <p:spPr>
+          <a:xfrm>
+            <a:off x="365760" y="731520"/>
+            <a:ext cx="2200046" cy="365760"/>
+          </a:xfrm>
+          <a:prstGeom prst="roundRect">
+            <a:avLst/>
+          </a:prstGeom>
+          <a:solidFill>
+            <a:srgbClr val="E8EEF7"/>
+          </a:solidFill>
+          <a:ln>
+            <a:solidFill>
+              <a:srgbClr val="1F3A5F"/>
+            </a:solidFill>
+          </a:ln>
+        </p:spPr>
+        <p:style>
+          <a:lnRef idx="1">
+            <a:schemeClr val="accent1"/>
+          </a:lnRef>
+          <a:fillRef idx="3">
+            <a:schemeClr val="accent1"/>
+          </a:fillRef>
+          <a:effectRef idx="2">
+            <a:schemeClr val="accent1"/>
+          </a:effectRef>
+          <a:fontRef idx="minor">
+            <a:schemeClr val="lt1"/>
+          </a:fontRef>
+        </p:style>
+        <p:txBody>
+          <a:bodyPr rtlCol="0" anchor="ctr" lIns="45720" rIns="45720"/>
+          <a:lstStyle/>
+          <a:p>
+            <a:pPr algn="ctr"/>
+            <a:r>
+              <a:rPr sz="900">
+                <a:solidFill>
+                  <a:srgbClr val="1F3A5F"/>
+                </a:solidFill>
+              </a:rPr>
+              <a:t>Gram 38: FR Outrider, Category 3, Coruscant</a:t>
+            </a:r>
+          </a:p>
+        </p:txBody>
+      </p:sp>
+      <p:sp>
+        <p:nvSpPr>
+          <p:cNvPr id="4" name="TextBox 3"/>
+          <p:cNvSpPr txBox="1"/>
+          <p:nvPr/>
+        </p:nvSpPr>
+        <p:spPr>
+          <a:xfrm>
+            <a:off x="365760" y="1115568"/>
+            <a:ext cx="2200046" cy="1447800"/>
+          </a:xfrm>
+          <a:prstGeom prst="rect">
+            <a:avLst/>
+          </a:prstGeom>
+          <a:noFill/>
+        </p:spPr>
+        <p:txBody>
+          <a:bodyPr wrap="square">
+            <a:spAutoFit/>
+          </a:bodyPr>
+          <a:lstStyle/>
+          <a:p>
+            <a:r>
+              <a:rPr sz="800">
+                <a:hlinkClick r:id="rId3"/>
+              </a:rPr>
+              <a:t>Lofar 1</a:t>
+            </a:r>
+          </a:p>
+        </p:txBody>
+      </p:sp>
+      <p:sp>
+        <p:nvSpPr>
+          <p:cNvPr id="5" name="Rounded Rectangle 4">
+            <a:hlinkClick r:id="rId4"/>
+          </p:cNvPr>
+          <p:cNvSpPr/>
+          <p:nvPr/>
+        </p:nvSpPr>
+        <p:spPr>
+          <a:xfrm>
+            <a:off x="2657246" y="731520"/>
+            <a:ext cx="2200046" cy="365760"/>
+          </a:xfrm>
+          <a:prstGeom prst="roundRect">
+            <a:avLst/>
+          </a:prstGeom>
+          <a:solidFill>
+            <a:srgbClr val="E8EEF7"/>
+          </a:solidFill>
+          <a:ln>
+            <a:solidFill>
+              <a:srgbClr val="1F3A5F"/>
+            </a:solidFill>
+          </a:ln>
+        </p:spPr>
+        <p:style>
+          <a:lnRef idx="1">
+            <a:schemeClr val="accent1"/>
+          </a:lnRef>
+          <a:fillRef idx="3">
+            <a:schemeClr val="accent1"/>
+          </a:fillRef>
+          <a:effectRef idx="2">
+            <a:schemeClr val="accent1"/>
+          </a:effectRef>
+          <a:fontRef idx="minor">
+            <a:schemeClr val="lt1"/>
+          </a:fontRef>
+        </p:style>
+        <p:txBody>
+          <a:bodyPr rtlCol="0" anchor="ctr" lIns="45720" rIns="45720"/>
+          <a:lstStyle/>
+          <a:p>
+            <a:pPr algn="ctr"/>
+            <a:r>
+              <a:rPr sz="900">
+                <a:solidFill>
+                  <a:srgbClr val="1F3A5F"/>
+                </a:solidFill>
+              </a:rPr>
+              <a:t>Gram 39: Galaxy-class contact bearing 083, codename Betazed</a:t>
+            </a:r>
+          </a:p>
+        </p:txBody>
+      </p:sp>
+      <p:sp>
+        <p:nvSpPr>
+          <p:cNvPr id="6" name="TextBox 5"/>
+          <p:cNvSpPr txBox="1"/>
+          <p:nvPr/>
+        </p:nvSpPr>
+        <p:spPr>
+          <a:xfrm>
+            <a:off x="2657246" y="1115568"/>
+            <a:ext cx="2200046" cy="1447800"/>
+          </a:xfrm>
+          <a:prstGeom prst="rect">
+            <a:avLst/>
+          </a:prstGeom>
+          <a:noFill/>
+        </p:spPr>
+        <p:txBody>
+          <a:bodyPr wrap="square">
+            <a:spAutoFit/>
+          </a:bodyPr>
+          <a:lstStyle/>
+          <a:p>
+            <a:r>
+              <a:rPr sz="800">
+                <a:hlinkClick r:id="rId5"/>
+              </a:rPr>
+              <a:t>Lofar 1</a:t>
+            </a:r>
+          </a:p>
+          <a:p>
+            <a:r>
+              <a:rPr sz="800">
+                <a:hlinkClick r:id="rId6"/>
+              </a:rPr>
+              <a:t>Lofar 2</a:t>
+            </a:r>
+          </a:p>
+          <a:p>
+            <a:r>
+              <a:rPr sz="800">
+                <a:hlinkClick r:id="rId7"/>
+              </a:rPr>
+              <a:t>Lofar 3</a:t>
+            </a:r>
+          </a:p>
+        </p:txBody>
+      </p:sp>
+      <p:sp>
+        <p:nvSpPr>
+          <p:cNvPr id="7" name="Rounded Rectangle 6">
+            <a:hlinkClick r:id="rId8"/>
+          </p:cNvPr>
+          <p:cNvSpPr/>
+          <p:nvPr/>
+        </p:nvSpPr>
+        <p:spPr>
+          <a:xfrm>
+            <a:off x="4948732" y="731520"/>
+            <a:ext cx="2200046" cy="365760"/>
+          </a:xfrm>
+          <a:prstGeom prst="roundRect">
+            <a:avLst/>
+          </a:prstGeom>
+          <a:solidFill>
+            <a:srgbClr val="E8EEF7"/>
+          </a:solidFill>
+          <a:ln>
+            <a:solidFill>
+              <a:srgbClr val="1F3A5F"/>
+            </a:solidFill>
+          </a:ln>
+        </p:spPr>
+        <p:style>
+          <a:lnRef idx="1">
+            <a:schemeClr val="accent1"/>
+          </a:lnRef>
+          <a:fillRef idx="3">
+            <a:schemeClr val="accent1"/>
+          </a:fillRef>
+          <a:effectRef idx="2">
+            <a:schemeClr val="accent1"/>
+          </a:effectRef>
+          <a:fontRef idx="minor">
+            <a:schemeClr val="lt1"/>
+          </a:fontRef>
+        </p:style>
+        <p:txBody>
+          <a:bodyPr rtlCol="0" anchor="ctr" lIns="45720" rIns="45720"/>
+          <a:lstStyle/>
+          <a:p>
+            <a:pPr algn="ctr"/>
+            <a:r>
+              <a:rPr sz="900">
+                <a:solidFill>
+                  <a:srgbClr val="1F3A5F"/>
+                </a:solidFill>
+              </a:rPr>
+              <a:t>Gram 40: FR Corellian Corvette, Category 1, Tantive</a:t>
+            </a:r>
+          </a:p>
+        </p:txBody>
+      </p:sp>
+      <p:sp>
+        <p:nvSpPr>
+          <p:cNvPr id="8" name="TextBox 7"/>
+          <p:cNvSpPr txBox="1"/>
+          <p:nvPr/>
+        </p:nvSpPr>
+        <p:spPr>
+          <a:xfrm>
+            <a:off x="4948732" y="1115568"/>
+            <a:ext cx="2200046" cy="1447800"/>
+          </a:xfrm>
+          <a:prstGeom prst="rect">
+            <a:avLst/>
+          </a:prstGeom>
+          <a:noFill/>
+        </p:spPr>
+        <p:txBody>
+          <a:bodyPr wrap="square">
+            <a:spAutoFit/>
+          </a:bodyPr>
+          <a:lstStyle/>
+          <a:p>
+            <a:r>
+              <a:rPr sz="800">
+                <a:hlinkClick r:id="rId9"/>
+              </a:rPr>
+              <a:t>Lofar 1</a:t>
+            </a:r>
+          </a:p>
+        </p:txBody>
+      </p:sp>
+      <p:sp>
+        <p:nvSpPr>
+          <p:cNvPr id="9" name="Rounded Rectangle 8">
+            <a:hlinkClick r:id="rId10"/>
+          </p:cNvPr>
+          <p:cNvSpPr/>
+          <p:nvPr/>
+        </p:nvSpPr>
+        <p:spPr>
+          <a:xfrm>
+            <a:off x="7240219" y="731520"/>
+            <a:ext cx="2200046" cy="365760"/>
+          </a:xfrm>
+          <a:prstGeom prst="roundRect">
+            <a:avLst/>
+          </a:prstGeom>
+          <a:solidFill>
+            <a:srgbClr val="E8EEF7"/>
+          </a:solidFill>
+          <a:ln>
+            <a:solidFill>
+              <a:srgbClr val="1F3A5F"/>
+            </a:solidFill>
+          </a:ln>
+        </p:spPr>
+        <p:style>
+          <a:lnRef idx="1">
+            <a:schemeClr val="accent1"/>
+          </a:lnRef>
+          <a:fillRef idx="3">
+            <a:schemeClr val="accent1"/>
+          </a:fillRef>
+          <a:effectRef idx="2">
+            <a:schemeClr val="accent1"/>
+          </a:effectRef>
+          <a:fontRef idx="minor">
+            <a:schemeClr val="lt1"/>
+          </a:fontRef>
+        </p:style>
+        <p:txBody>
+          <a:bodyPr rtlCol="0" anchor="ctr" lIns="45720" rIns="45720"/>
+          <a:lstStyle/>
+          <a:p>
+            <a:pPr algn="ctr"/>
+            <a:r>
+              <a:rPr sz="900">
+                <a:solidFill>
+                  <a:srgbClr val="1F3A5F"/>
+                </a:solidFill>
+              </a:rPr>
+              <a:t>Gram 41: FR Millennium Falcon, Category 1, Gandalf</a:t>
+            </a:r>
+          </a:p>
+        </p:txBody>
+      </p:sp>
+      <p:sp>
+        <p:nvSpPr>
+          <p:cNvPr id="10" name="TextBox 9"/>
+          <p:cNvSpPr txBox="1"/>
+          <p:nvPr/>
+        </p:nvSpPr>
+        <p:spPr>
+          <a:xfrm>
+            <a:off x="7240219" y="1115568"/>
+            <a:ext cx="2200046" cy="1447800"/>
+          </a:xfrm>
+          <a:prstGeom prst="rect">
+            <a:avLst/>
+          </a:prstGeom>
+          <a:noFill/>
+        </p:spPr>
+        <p:txBody>
+          <a:bodyPr wrap="square">
+            <a:spAutoFit/>
+          </a:bodyPr>
+          <a:lstStyle/>
+          <a:p>
+            <a:r>
+              <a:rPr sz="800">
+                <a:hlinkClick r:id="rId11"/>
+              </a:rPr>
+              <a:t>Lofar 1</a:t>
+            </a:r>
+          </a:p>
+          <a:p>
+            <a:r>
+              <a:rPr sz="800">
+                <a:hlinkClick r:id="rId12"/>
+              </a:rPr>
+              <a:t>Lofar 2</a:t>
+            </a:r>
+          </a:p>
+        </p:txBody>
+      </p:sp>
+      <p:sp>
+        <p:nvSpPr>
+          <p:cNvPr id="11" name="Rounded Rectangle 10">
+            <a:hlinkClick r:id="rId13"/>
+          </p:cNvPr>
+          <p:cNvSpPr/>
+          <p:nvPr/>
+        </p:nvSpPr>
+        <p:spPr>
+          <a:xfrm>
+            <a:off x="9531705" y="731520"/>
+            <a:ext cx="2200046" cy="365760"/>
+          </a:xfrm>
+          <a:prstGeom prst="roundRect">
+            <a:avLst/>
+          </a:prstGeom>
+          <a:solidFill>
+            <a:srgbClr val="E8EEF7"/>
+          </a:solidFill>
+          <a:ln>
+            <a:solidFill>
+              <a:srgbClr val="1F3A5F"/>
+            </a:solidFill>
+          </a:ln>
+        </p:spPr>
+        <p:style>
+          <a:lnRef idx="1">
+            <a:schemeClr val="accent1"/>
+          </a:lnRef>
+          <a:fillRef idx="3">
+            <a:schemeClr val="accent1"/>
+          </a:fillRef>
+          <a:effectRef idx="2">
+            <a:schemeClr val="accent1"/>
+          </a:effectRef>
+          <a:fontRef idx="minor">
+            <a:schemeClr val="lt1"/>
+          </a:fontRef>
+        </p:style>
+        <p:txBody>
+          <a:bodyPr rtlCol="0" anchor="ctr" lIns="45720" rIns="45720"/>
+          <a:lstStyle/>
+          <a:p>
+            <a:pPr algn="ctr"/>
+            <a:r>
+              <a:rPr sz="900">
+                <a:solidFill>
+                  <a:srgbClr val="1F3A5F"/>
+                </a:solidFill>
+              </a:rPr>
+              <a:t>Gram 42: FR Venator-class, Category 2, Yavin</a:t>
+            </a:r>
+          </a:p>
+        </p:txBody>
+      </p:sp>
+      <p:sp>
+        <p:nvSpPr>
+          <p:cNvPr id="12" name="TextBox 11"/>
+          <p:cNvSpPr txBox="1"/>
+          <p:nvPr/>
+        </p:nvSpPr>
+        <p:spPr>
+          <a:xfrm>
+            <a:off x="9531705" y="1115568"/>
+            <a:ext cx="2200046" cy="1447800"/>
+          </a:xfrm>
+          <a:prstGeom prst="rect">
+            <a:avLst/>
+          </a:prstGeom>
+          <a:noFill/>
+        </p:spPr>
+        <p:txBody>
+          <a:bodyPr wrap="square">
+            <a:spAutoFit/>
+          </a:bodyPr>
+          <a:lstStyle/>
+          <a:p>
+            <a:r>
+              <a:rPr sz="800">
+                <a:hlinkClick r:id="rId14"/>
+              </a:rPr>
+              <a:t>Lofar 1</a:t>
+            </a:r>
+          </a:p>
+          <a:p>
+            <a:r>
+              <a:rPr sz="800">
+                <a:hlinkClick r:id="rId15"/>
+              </a:rPr>
+              <a:t>Lofar 2</a:t>
+            </a:r>
+          </a:p>
+        </p:txBody>
+      </p:sp>
+      <p:sp>
+        <p:nvSpPr>
+          <p:cNvPr id="13" name="Rounded Rectangle 12">
+            <a:hlinkClick r:id="rId16"/>
+          </p:cNvPr>
+          <p:cNvSpPr/>
+          <p:nvPr/>
+        </p:nvSpPr>
+        <p:spPr>
+          <a:xfrm>
+            <a:off x="365760" y="2682240"/>
+            <a:ext cx="2200046" cy="365760"/>
+          </a:xfrm>
+          <a:prstGeom prst="roundRect">
+            <a:avLst/>
+          </a:prstGeom>
+          <a:solidFill>
+            <a:srgbClr val="E8EEF7"/>
+          </a:solidFill>
+          <a:ln>
+            <a:solidFill>
+              <a:srgbClr val="1F3A5F"/>
+            </a:solidFill>
+          </a:ln>
+        </p:spPr>
+        <p:style>
+          <a:lnRef idx="1">
+            <a:schemeClr val="accent1"/>
+          </a:lnRef>
+          <a:fillRef idx="3">
+            <a:schemeClr val="accent1"/>
+          </a:fillRef>
+          <a:effectRef idx="2">
+            <a:schemeClr val="accent1"/>
+          </a:effectRef>
+          <a:fontRef idx="minor">
+            <a:schemeClr val="lt1"/>
+          </a:fontRef>
+        </p:style>
+        <p:txBody>
+          <a:bodyPr rtlCol="0" anchor="ctr" lIns="45720" rIns="45720"/>
+          <a:lstStyle/>
+          <a:p>
+            <a:pPr algn="ctr"/>
+            <a:r>
+              <a:rPr sz="900">
+                <a:solidFill>
+                  <a:srgbClr val="1F3A5F"/>
+                </a:solidFill>
+              </a:rPr>
+              <a:t>Gram 43: FR Excelsior, Category 4, Vulcan</a:t>
+            </a:r>
+          </a:p>
+        </p:txBody>
+      </p:sp>
+      <p:sp>
+        <p:nvSpPr>
+          <p:cNvPr id="14" name="TextBox 13"/>
+          <p:cNvSpPr txBox="1"/>
+          <p:nvPr/>
+        </p:nvSpPr>
+        <p:spPr>
+          <a:xfrm>
+            <a:off x="365760" y="3066288"/>
+            <a:ext cx="2200046" cy="1447800"/>
+          </a:xfrm>
+          <a:prstGeom prst="rect">
+            <a:avLst/>
+          </a:prstGeom>
+          <a:noFill/>
+        </p:spPr>
+        <p:txBody>
+          <a:bodyPr wrap="square">
+            <a:spAutoFit/>
+          </a:bodyPr>
+          <a:lstStyle/>
+          <a:p>
+            <a:r>
+              <a:rPr sz="800">
+                <a:hlinkClick r:id="rId17"/>
+              </a:rPr>
+              <a:t>Lofar 1</a:t>
+            </a:r>
+          </a:p>
+          <a:p>
+            <a:r>
+              <a:rPr sz="800">
+                <a:hlinkClick r:id="rId18"/>
+              </a:rPr>
+              <a:t>Lofar 2</a:t>
+            </a:r>
+          </a:p>
+          <a:p>
+            <a:r>
+              <a:rPr sz="800">
+                <a:hlinkClick r:id="rId19"/>
+              </a:rPr>
+              <a:t>Lofar 3</a:t>
+            </a:r>
+          </a:p>
+          <a:p>
+            <a:r>
+              <a:rPr sz="800">
+                <a:hlinkClick r:id="rId20"/>
+              </a:rPr>
+              <a:t>Lofar 4</a:t>
+            </a:r>
+          </a:p>
+        </p:txBody>
+      </p:sp>
+      <p:sp>
+        <p:nvSpPr>
+          <p:cNvPr id="15" name="Rounded Rectangle 14">
+            <a:hlinkClick r:id="rId21"/>
+          </p:cNvPr>
+          <p:cNvSpPr/>
+          <p:nvPr/>
+        </p:nvSpPr>
+        <p:spPr>
+          <a:xfrm>
+            <a:off x="2657246" y="2682240"/>
+            <a:ext cx="2200046" cy="365760"/>
+          </a:xfrm>
+          <a:prstGeom prst="roundRect">
+            <a:avLst/>
+          </a:prstGeom>
+          <a:solidFill>
+            <a:srgbClr val="E8EEF7"/>
+          </a:solidFill>
+          <a:ln>
+            <a:solidFill>
+              <a:srgbClr val="1F3A5F"/>
+            </a:solidFill>
+          </a:ln>
+        </p:spPr>
+        <p:style>
+          <a:lnRef idx="1">
+            <a:schemeClr val="accent1"/>
+          </a:lnRef>
+          <a:fillRef idx="3">
+            <a:schemeClr val="accent1"/>
+          </a:fillRef>
+          <a:effectRef idx="2">
+            <a:schemeClr val="accent1"/>
+          </a:effectRef>
+          <a:fontRef idx="minor">
+            <a:schemeClr val="lt1"/>
+          </a:fontRef>
+        </p:style>
+        <p:txBody>
+          <a:bodyPr rtlCol="0" anchor="ctr" lIns="45720" rIns="45720"/>
+          <a:lstStyle/>
+          <a:p>
+            <a:pPr algn="ctr"/>
+            <a:r>
+              <a:rPr sz="900">
+                <a:solidFill>
+                  <a:srgbClr val="1F3A5F"/>
+                </a:solidFill>
+              </a:rPr>
+              <a:t>Gram 44: B-wing contact bearing 024, codename Hoth</a:t>
+            </a:r>
+          </a:p>
+        </p:txBody>
+      </p:sp>
+      <p:sp>
+        <p:nvSpPr>
+          <p:cNvPr id="16" name="TextBox 15"/>
+          <p:cNvSpPr txBox="1"/>
+          <p:nvPr/>
+        </p:nvSpPr>
+        <p:spPr>
+          <a:xfrm>
+            <a:off x="2657246" y="3066288"/>
+            <a:ext cx="2200046" cy="1447800"/>
+          </a:xfrm>
+          <a:prstGeom prst="rect">
+            <a:avLst/>
+          </a:prstGeom>
+          <a:noFill/>
+        </p:spPr>
+        <p:txBody>
+          <a:bodyPr wrap="square">
+            <a:spAutoFit/>
+          </a:bodyPr>
+          <a:lstStyle/>
+          <a:p>
+            <a:r>
+              <a:rPr sz="800">
+                <a:hlinkClick r:id="rId22"/>
+              </a:rPr>
+              <a:t>Lofar 1</a:t>
+            </a:r>
+          </a:p>
+          <a:p>
+            <a:r>
+              <a:rPr sz="800">
+                <a:hlinkClick r:id="rId23"/>
+              </a:rPr>
+              <a:t>Lofar 2</a:t>
+            </a:r>
+          </a:p>
+          <a:p>
+            <a:r>
+              <a:rPr sz="800">
+                <a:hlinkClick r:id="rId24"/>
+              </a:rPr>
+              <a:t>Lofar 3</a:t>
+            </a:r>
+          </a:p>
+          <a:p>
+            <a:r>
+              <a:rPr sz="800">
+                <a:hlinkClick r:id="rId25"/>
+              </a:rPr>
+              <a:t>Lofar 4</a:t>
+            </a:r>
+          </a:p>
+        </p:txBody>
+      </p:sp>
+      <p:sp>
+        <p:nvSpPr>
+          <p:cNvPr id="17" name="Rounded Rectangle 16">
+            <a:hlinkClick r:id="rId26"/>
+          </p:cNvPr>
+          <p:cNvSpPr/>
+          <p:nvPr/>
+        </p:nvSpPr>
+        <p:spPr>
+          <a:xfrm>
+            <a:off x="4948732" y="2682240"/>
+            <a:ext cx="2200046" cy="365760"/>
+          </a:xfrm>
+          <a:prstGeom prst="roundRect">
+            <a:avLst/>
+          </a:prstGeom>
+          <a:solidFill>
+            <a:srgbClr val="E8EEF7"/>
+          </a:solidFill>
+          <a:ln>
+            <a:solidFill>
+              <a:srgbClr val="1F3A5F"/>
+            </a:solidFill>
+          </a:ln>
+        </p:spPr>
+        <p:style>
+          <a:lnRef idx="1">
+            <a:schemeClr val="accent1"/>
+          </a:lnRef>
+          <a:fillRef idx="3">
+            <a:schemeClr val="accent1"/>
+          </a:fillRef>
+          <a:effectRef idx="2">
+            <a:schemeClr val="accent1"/>
+          </a:effectRef>
+          <a:fontRef idx="minor">
+            <a:schemeClr val="lt1"/>
+          </a:fontRef>
+        </p:style>
+        <p:txBody>
+          <a:bodyPr rtlCol="0" anchor="ctr" lIns="45720" rIns="45720"/>
+          <a:lstStyle/>
+          <a:p>
+            <a:pPr algn="ctr"/>
+            <a:r>
+              <a:rPr sz="900">
+                <a:solidFill>
+                  <a:srgbClr val="1F3A5F"/>
+                </a:solidFill>
+              </a:rPr>
+              <a:t>Gram 46: Stargazer contact bearing 059, codename Hoth</a:t>
+            </a:r>
+          </a:p>
+        </p:txBody>
+      </p:sp>
+      <p:sp>
+        <p:nvSpPr>
+          <p:cNvPr id="18" name="TextBox 17"/>
+          <p:cNvSpPr txBox="1"/>
+          <p:nvPr/>
+        </p:nvSpPr>
+        <p:spPr>
+          <a:xfrm>
+            <a:off x="4948732" y="3066288"/>
+            <a:ext cx="2200046" cy="1447800"/>
+          </a:xfrm>
+          <a:prstGeom prst="rect">
+            <a:avLst/>
+          </a:prstGeom>
+          <a:noFill/>
+        </p:spPr>
+        <p:txBody>
+          <a:bodyPr wrap="square">
+            <a:spAutoFit/>
+          </a:bodyPr>
+          <a:lstStyle/>
+          <a:p>
+            <a:r>
+              <a:rPr sz="800">
+                <a:hlinkClick r:id="rId27"/>
+              </a:rPr>
+              <a:t>Lofar 1</a:t>
+            </a:r>
+          </a:p>
+          <a:p>
+            <a:r>
+              <a:rPr sz="800">
+                <a:hlinkClick r:id="rId28"/>
+              </a:rPr>
+              <a:t>Lofar 2</a:t>
+            </a:r>
+          </a:p>
+        </p:txBody>
+      </p:sp>
+      <p:sp>
+        <p:nvSpPr>
+          <p:cNvPr id="19" name="Rounded Rectangle 18">
+            <a:hlinkClick r:id="rId29"/>
+          </p:cNvPr>
+          <p:cNvSpPr/>
+          <p:nvPr/>
+        </p:nvSpPr>
+        <p:spPr>
+          <a:xfrm>
+            <a:off x="7240219" y="2682240"/>
+            <a:ext cx="2200046" cy="365760"/>
+          </a:xfrm>
+          <a:prstGeom prst="roundRect">
+            <a:avLst/>
+          </a:prstGeom>
+          <a:solidFill>
+            <a:srgbClr val="E8EEF7"/>
+          </a:solidFill>
+          <a:ln>
+            <a:solidFill>
+              <a:srgbClr val="1F3A5F"/>
+            </a:solidFill>
+          </a:ln>
+        </p:spPr>
+        <p:style>
+          <a:lnRef idx="1">
+            <a:schemeClr val="accent1"/>
+          </a:lnRef>
+          <a:fillRef idx="3">
+            <a:schemeClr val="accent1"/>
+          </a:fillRef>
+          <a:effectRef idx="2">
+            <a:schemeClr val="accent1"/>
+          </a:effectRef>
+          <a:fontRef idx="minor">
+            <a:schemeClr val="lt1"/>
+          </a:fontRef>
+        </p:style>
+        <p:txBody>
+          <a:bodyPr rtlCol="0" anchor="ctr" lIns="45720" rIns="45720"/>
+          <a:lstStyle/>
+          <a:p>
+            <a:pPr algn="ctr"/>
+            <a:r>
+              <a:rPr sz="900">
+                <a:solidFill>
+                  <a:srgbClr val="1F3A5F"/>
+                </a:solidFill>
+              </a:rPr>
+              <a:t>Gram 47: FR Discovery, Category 4, Risa</a:t>
+            </a:r>
+          </a:p>
+        </p:txBody>
+      </p:sp>
+      <p:sp>
+        <p:nvSpPr>
+          <p:cNvPr id="20" name="TextBox 19"/>
+          <p:cNvSpPr txBox="1"/>
+          <p:nvPr/>
+        </p:nvSpPr>
+        <p:spPr>
+          <a:xfrm>
+            <a:off x="7240219" y="3066288"/>
+            <a:ext cx="2200046" cy="1447800"/>
+          </a:xfrm>
+          <a:prstGeom prst="rect">
+            <a:avLst/>
+          </a:prstGeom>
+          <a:noFill/>
+        </p:spPr>
+        <p:txBody>
+          <a:bodyPr wrap="square">
+            <a:spAutoFit/>
+          </a:bodyPr>
+          <a:lstStyle/>
+          <a:p>
+            <a:r>
+              <a:rPr sz="800">
+                <a:hlinkClick r:id="rId30"/>
+              </a:rPr>
+              <a:t>Lofar 1</a:t>
+            </a:r>
+          </a:p>
+        </p:txBody>
+      </p:sp>
+      <p:sp>
+        <p:nvSpPr>
+          <p:cNvPr id="21" name="Rounded Rectangle 20">
+            <a:hlinkClick r:id="rId31"/>
+          </p:cNvPr>
+          <p:cNvSpPr/>
+          <p:nvPr/>
+        </p:nvSpPr>
+        <p:spPr>
+          <a:xfrm>
+            <a:off x="9531705" y="2682240"/>
+            <a:ext cx="2200046" cy="365760"/>
+          </a:xfrm>
+          <a:prstGeom prst="roundRect">
+            <a:avLst/>
+          </a:prstGeom>
+          <a:solidFill>
+            <a:srgbClr val="E8EEF7"/>
+          </a:solidFill>
+          <a:ln>
+            <a:solidFill>
+              <a:srgbClr val="1F3A5F"/>
+            </a:solidFill>
+          </a:ln>
+        </p:spPr>
+        <p:style>
+          <a:lnRef idx="1">
+            <a:schemeClr val="accent1"/>
+          </a:lnRef>
+          <a:fillRef idx="3">
+            <a:schemeClr val="accent1"/>
+          </a:fillRef>
+          <a:effectRef idx="2">
+            <a:schemeClr val="accent1"/>
+          </a:effectRef>
+          <a:fontRef idx="minor">
+            <a:schemeClr val="lt1"/>
+          </a:fontRef>
+        </p:style>
+        <p:txBody>
+          <a:bodyPr rtlCol="0" anchor="ctr" lIns="45720" rIns="45720"/>
+          <a:lstStyle/>
+          <a:p>
+            <a:pPr algn="ctr"/>
+            <a:r>
+              <a:rPr sz="900">
+                <a:solidFill>
+                  <a:srgbClr val="1F3A5F"/>
+                </a:solidFill>
+              </a:rPr>
+              <a:t>Gram 48: FR Discovery, Category 4, Kronos</a:t>
+            </a:r>
+          </a:p>
+        </p:txBody>
+      </p:sp>
+      <p:sp>
+        <p:nvSpPr>
+          <p:cNvPr id="22" name="TextBox 21"/>
+          <p:cNvSpPr txBox="1"/>
+          <p:nvPr/>
+        </p:nvSpPr>
+        <p:spPr>
+          <a:xfrm>
+            <a:off x="9531705" y="3066288"/>
+            <a:ext cx="2200046" cy="1447800"/>
+          </a:xfrm>
+          <a:prstGeom prst="rect">
+            <a:avLst/>
+          </a:prstGeom>
+          <a:noFill/>
+        </p:spPr>
+        <p:txBody>
+          <a:bodyPr wrap="square">
+            <a:spAutoFit/>
+          </a:bodyPr>
+          <a:lstStyle/>
+          <a:p>
+            <a:r>
+              <a:rPr sz="800">
+                <a:hlinkClick r:id="rId32"/>
+              </a:rPr>
+              <a:t>Lofar 1</a:t>
+            </a:r>
+          </a:p>
+          <a:p>
+            <a:r>
+              <a:rPr sz="800">
                 <a:hlinkClick r:id="rId33"/>
               </a:rPr>
               <a:t>Lofar 2</a:t>
+            </a:r>
+          </a:p>
+        </p:txBody>
+      </p:sp>
+    </p:spTree>
+  </p:cSld>
+  <p:clrMapOvr>
+    <a:masterClrMapping/>
+  </p:clrMapOvr>
+</p:sld>
+</file>
+
+<file path=ppt/slides/slide5.xml><?xml version="1.0" encoding="utf-8"?>
+<p:sld xmlns:a="http://schemas.openxmlformats.org/drawingml/2006/main" xmlns:p="http://schemas.openxmlformats.org/presentationml/2006/main" xmlns:r="http://schemas.openxmlformats.org/officeDocument/2006/relationships">
+  <p:cSld>
+    <p:spTree>
+      <p:nvGrpSpPr>
+        <p:cNvPr id="1" name=""/>
+        <p:cNvGrpSpPr/>
+        <p:nvPr/>
+      </p:nvGrpSpPr>
+      <p:grpSpPr/>
+      <p:sp>
+        <p:nvSpPr>
+          <p:cNvPr id="2" name="TextBox 1"/>
+          <p:cNvSpPr txBox="1"/>
+          <p:nvPr/>
+        </p:nvSpPr>
+        <p:spPr>
+          <a:xfrm>
+            <a:off x="914400" y="2377440"/>
+            <a:ext cx="10360152" cy="1280160"/>
+          </a:xfrm>
+          <a:prstGeom prst="rect">
+            <a:avLst/>
+          </a:prstGeom>
+          <a:noFill/>
+        </p:spPr>
+        <p:txBody>
+          <a:bodyPr wrap="square">
+            <a:spAutoFit/>
+          </a:bodyPr>
+          <a:lstStyle/>
+          <a:p>
+            <a:pPr algn="ctr"/>
+            <a:r>
+              <a:rPr sz="4000" b="1">
+                <a:solidFill>
+                  <a:srgbClr val="1F3A5F"/>
+                </a:solidFill>
+              </a:rPr>
+              <a:t>End of Instructor Progress Final Assessment Grams</a:t>
+            </a:r>
+          </a:p>
+        </p:txBody>
+      </p:sp>
+      <p:sp>
+        <p:nvSpPr>
+          <p:cNvPr id="3" name="TextBox 2"/>
+          <p:cNvSpPr txBox="1"/>
+          <p:nvPr/>
+        </p:nvSpPr>
+        <p:spPr>
+          <a:xfrm>
+            <a:off x="914400" y="3840480"/>
+            <a:ext cx="10360152" cy="731520"/>
+          </a:xfrm>
+          <a:prstGeom prst="rect">
+            <a:avLst/>
+          </a:prstGeom>
+          <a:noFill/>
+        </p:spPr>
+        <p:txBody>
+          <a:bodyPr wrap="none">
+            <a:spAutoFit/>
+          </a:bodyPr>
+          <a:lstStyle/>
+          <a:p>
+            <a:pPr algn="ctr"/>
+            <a:r>
+              <a:rPr sz="2400">
+                <a:solidFill>
+                  <a:srgbClr val="1F3A5F"/>
+                </a:solidFill>
+              </a:rPr>
+              <a:t>Instructor Version</a:t>
             </a:r>
           </a:p>
         </p:txBody>

</xml_diff>